<commit_message>
Build future-research slides from Directions 1 and 2; number speaker notes
Co-Authored-By: Claude Opus 5.5 <noreply@anthropic.com>
Claude-Session: https://claude.ai/code/session_011AaQxxgQ4HPadVVo3q9mgs
</commit_message>
<xml_diff>
--- a/Liu_postdoc_interview_talk.pptx
+++ b/Liu_postdoc_interview_talk.pptx
@@ -17,9 +17,10 @@
     <p:sldId id="265" r:id="rId11"/>
     <p:sldId id="266" r:id="rId12"/>
     <p:sldId id="267" r:id="rId13"/>
+    <p:sldId id="268" r:id="rId14"/>
   </p:sldIdLst>
   <p:notesMasterIdLst>
-    <p:notesMasterId r:id="rId14"/>
+    <p:notesMasterId r:id="rId15"/>
   </p:notesMasterIdLst>
   <p:sldSz cx="12192000" cy="6858000"/>
   <p:notesSz cx="6858000" cy="12192000"/>
@@ -1175,7 +1176,9 @@
           <a:p>
             <a:r>
               <a:rPr lang="en-US" dirty="0"/>
-              <a:t>[0:00–0:30] Thank you for having me. In the next 13 minutes I will show how my work on event language in adults and children leads to the question I want to pursue in your group: how language helps children learn relations.</a:t>
+              <a:t>1. Thank you for having me.
+2. I will show how my work on event language in adults and children leads to the question I want to pursue in your group.
+3. That question is how language helps children learn relations.</a:t>
             </a:r>
             <a:endParaRPr lang="en-US" dirty="0"/>
           </a:p>
@@ -1263,7 +1266,10 @@
           <a:p>
             <a:r>
               <a:rPr lang="en-US" dirty="0"/>
-              <a:t>[10:00–11:30] Children see a standard event and choose between a relational match, with a new action and object but the same result, and a surface match, with the same action and object but no result. This is a cross-mapping design. Language varies between conditions. If naming the result highlights the relation, children in the result-named condition should choose relational matches more and transfer them to new objects and actions. A result-word-only control separates the relation from the result state itself. Analysis: preregistered Bayesian GLMMs with participants and items as random effects.</a:t>
+              <a:t>1. Learning: children watch a causal event described with the result named, the action only, or no label. Videos follow the method I used in my PhD and child study.
+2. Test, without language: a relational match (rinse a cup clean) against two foils, same action without the result, and same end state without the action.
+3. Measures: relational matching, prediction of what happens next, and transfer to new objects and actions. Ages 3–5, within Mandarin, so language is manipulated rather than confounded with culture.
+4. Prediction: result named &gt; action only ≈ no label, strongest against the same-action foil. Preregistered Bayesian GLMMs, sample size by simulation-based power analysis.</a:t>
             </a:r>
             <a:endParaRPr lang="en-US" dirty="0"/>
           </a:p>
@@ -1351,7 +1357,10 @@
           <a:p>
             <a:r>
               <a:rPr lang="en-US" dirty="0"/>
-              <a:t>[11:30–12:30] Building on the first study: comparison and explanation as learning tools, parent–child interaction as the natural setting where relational talk happens, and a comparison with AI systems, using the same matching and transfer tasks, to ask what children use that models do not. Cross-linguistic comparison comes second, because Mandarin–English differences also involve culture and schooling.</a:t>
+              <a:t>1. Builds on your finding that comparison helps children learn relations (Christie &amp; Gentner, 2010).
+2. 2 × 2 design: one event vs. two aligned events, with or without an explanation prompt (“为什么会干净？”). Result-named language from Direction 1 is held constant.
+3. Transfer to new objects, actions and contexts, varying surface similarity separately from the relation.
+4. Prediction: comparison beats one event, and explanation adds most when surface similarity is low, that is, for far transfer.</a:t>
             </a:r>
             <a:endParaRPr lang="en-US" dirty="0"/>
           </a:p>
@@ -1439,7 +1448,10 @@
           <a:p>
             <a:r>
               <a:rPr lang="en-US" dirty="0"/>
-              <a:t>[12:30–13:30] To sum up: my work connects how language encodes events with how people process and learn them, and I would like to take that into relational learning in children, here. Thank you, and I am happy to take questions.</a:t>
+              <a:t>1. Year 1: Direction 1, two preregistered experiments and one paper.
+2. Year 2: Direction 2, plus pilots on parent–child play and a children vs. AI comparison using the same tasks.
+3. Throughout: publish the thesis papers, apply for funding, and mentor students.
+4. Together these test three learning tools for event relations: naming, comparing and explaining.</a:t>
             </a:r>
             <a:endParaRPr lang="en-US" dirty="0"/>
           </a:p>
@@ -1463,6 +1475,97 @@
             <a:fld id="{F7021451-1387-4CA6-816F-3879F97B5CBC}" type="slidenum">
               <a:rPr lang="en-US"/>
               <a:t>12</a:t>
+            </a:fld>
+            <a:endParaRPr lang="en-US"/>
+          </a:p>
+        </p:txBody>
+      </p:sp>
+    </p:spTree>
+    <p:extLst>
+      <p:ext uri="{BB962C8B-B14F-4D97-AF65-F5344CB8AC3E}">
+        <p14:creationId xmlns:p14="http://schemas.microsoft.com/office/powerpoint/2010/main" val="1024086991"/>
+      </p:ext>
+    </p:extLst>
+  </p:cSld>
+  <p:clrMapOvr>
+    <a:masterClrMapping/>
+  </p:clrMapOvr>
+</p:notes>
+</file>
+
+<file path=ppt/notesSlides/notesSlide13.xml><?xml version="1.0" encoding="utf-8"?>
+<p:notes xmlns:a="http://schemas.openxmlformats.org/drawingml/2006/main" xmlns:r="http://schemas.openxmlformats.org/officeDocument/2006/relationships" xmlns:p="http://schemas.openxmlformats.org/presentationml/2006/main">
+  <p:cSld>
+    <p:spTree>
+      <p:nvGrpSpPr>
+        <p:cNvPr id="1" name=""/>
+        <p:cNvGrpSpPr/>
+        <p:nvPr/>
+      </p:nvGrpSpPr>
+      <p:grpSpPr>
+        <a:xfrm>
+          <a:off x="0" y="0"/>
+          <a:ext cx="0" cy="0"/>
+          <a:chOff x="0" y="0"/>
+          <a:chExt cx="0" cy="0"/>
+        </a:xfrm>
+      </p:grpSpPr>
+      <p:sp>
+        <p:nvSpPr>
+          <p:cNvPr id="2" name="Slide Image Placeholder 1"/>
+          <p:cNvSpPr>
+            <a:spLocks noGrp="1" noRot="1" noChangeAspect="1"/>
+          </p:cNvSpPr>
+          <p:nvPr>
+            <p:ph type="sldImg"/>
+          </p:nvPr>
+        </p:nvSpPr>
+        <p:spPr/>
+      </p:sp>
+      <p:sp>
+        <p:nvSpPr>
+          <p:cNvPr id="3" name="Notes Placeholder 2"/>
+          <p:cNvSpPr>
+            <a:spLocks noGrp="1"/>
+          </p:cNvSpPr>
+          <p:nvPr>
+            <p:ph type="body" idx="1"/>
+          </p:nvPr>
+        </p:nvSpPr>
+        <p:spPr/>
+        <p:txBody>
+          <a:bodyPr/>
+          <a:lstStyle/>
+          <a:p>
+            <a:r>
+              <a:rPr lang="en-US" dirty="0"/>
+              <a:t>1. Methods: video stimuli, child testing, Bayesian modelling.
+2. Projects: I led a field project at CAS and ran a preregistered multi-experiment thesis.
+3. Fit: event language meets relational learning, with Mandarin–English expertise.
+4. Thank you, and I am happy to take questions.</a:t>
+            </a:r>
+            <a:endParaRPr lang="en-US" dirty="0"/>
+          </a:p>
+        </p:txBody>
+      </p:sp>
+      <p:sp>
+        <p:nvSpPr>
+          <p:cNvPr id="4" name="Slide Number Placeholder 3"/>
+          <p:cNvSpPr>
+            <a:spLocks noGrp="1"/>
+          </p:cNvSpPr>
+          <p:nvPr>
+            <p:ph type="sldNum" sz="quarter" idx="10"/>
+          </p:nvPr>
+        </p:nvSpPr>
+        <p:spPr/>
+        <p:txBody>
+          <a:bodyPr/>
+          <a:lstStyle/>
+          <a:p>
+            <a:fld id="{F7021451-1387-4CA6-816F-3879F97B5CBC}" type="slidenum">
+              <a:rPr lang="en-US"/>
+              <a:t>13</a:t>
             </a:fld>
             <a:endParaRPr lang="en-US"/>
           </a:p>
@@ -1527,7 +1630,10 @@
           <a:p>
             <a:r>
               <a:rPr lang="en-US" dirty="0"/>
-              <a:t>[0:30–1:45] Mandarin gives a clean contrast: cā names only the action; cā-gānjìng names the action and the result it brings about. My work asks whether this kind of difference matters for cognition. Three parts: adults in my PhD, children in my collaboration with Yue Ji, and the project I would like to build here.</a:t>
+              <a:t>1. Mandarin gives a clean contrast: cā names only the action; cā-gānjìng names the action and its result.
+2. My work asks whether this kind of difference matters for cognition.
+3. Part one: adults, in my PhD.
+4. Part two: children, with Yue Ji. Part three: the project I would like to build here.</a:t>
             </a:r>
             <a:endParaRPr lang="en-US" dirty="0"/>
           </a:p>
@@ -1615,7 +1721,10 @@
           <a:p>
             <a:r>
               <a:rPr lang="en-US" dirty="0"/>
-              <a:t>[1:45–2:45] Matched videos of the same object being cut or blended. Cutting has a clear endpoint; blending does not, and norming confirmed this. Three steps: how speakers describe the events (20 + 20), whether their processing differs in the same direction (interruption detection 64 + 64; boundary tapping 20 + 20), and whether brief language cues can shift that processing (60 + 60; 36 + 36).</a:t>
+              <a:t>1. Matched videos of the same object being cut or blended.
+2. Cutting has a clear endpoint; blending does not. Norming confirmed this.
+3. Step 1: how speakers describe the events (20 English, 20 Mandarin).
+4. Step 2: whether processing differs in the same direction (interruption detection 64 + 64; boundary tapping 20 + 20). Step 3: whether brief language cues can shift it (60 + 60; 36 + 36).</a:t>
             </a:r>
             <a:endParaRPr lang="en-US" dirty="0"/>
           </a:p>
@@ -1703,7 +1812,10 @@
           <a:p>
             <a:r>
               <a:rPr lang="en-US" dirty="0"/>
-              <a:t>[2:45–4:00] Descriptions show a crossover. English descriptions are more often telic for cutting (79% vs. 51%), Mandarin for blending (44% vs. 17%). Locally, English speakers mark the object with quantized noun phrases, while Mandarin speakers use resultatives for blending. So the two languages make different parts of the same event prominent.</a:t>
+              <a:t>1. Telicity shows a crossover: English is more telic for cutting (79% vs. 51%), Mandarin for blending (44% vs. 17%).
+2. English speakers mark the object with quantized noun phrases (68% vs. 13%).
+3. Mandarin speakers use resultatives for blending (44% vs. 17%).
+4. So the two languages make different parts of the same event prominent.</a:t>
             </a:r>
             <a:endParaRPr lang="en-US" dirty="0"/>
           </a:p>
@@ -1791,7 +1903,10 @@
           <a:p>
             <a:r>
               <a:rPr lang="en-US" dirty="0"/>
-              <a:t>[4:00–5:30] In interruption detection, English speakers were better at catching early interruptions in blending, Mandarin speakers at late ones (three-way interaction χ²(2) = 6.46, p = .040), which mirrors object marking versus result marking. In boundary tapping, English speakers placed the end of cutting events almost at the physical endpoint, Mandarin speakers almost a second later (95% CI [−1455, −268] ms), matching the stronger English telicity for cutting.</a:t>
+              <a:t>1. Interruption detection: English speakers caught early interruptions in blending better, Mandarin speakers late ones (χ²(2) = 6.46, p = .040).
+2. This mirrors object marking versus result marking.
+3. Boundary tapping: English speakers ended cutting events near the physical endpoint, Mandarin speakers almost a second later (95% CI [−1455, −268] ms).
+4. This matches the stronger English telicity for cutting.</a:t>
             </a:r>
             <a:endParaRPr lang="en-US" dirty="0"/>
           </a:p>
@@ -1879,7 +1994,10 @@
           <a:p>
             <a:r>
               <a:rPr lang="en-US" dirty="0"/>
-              <a:t>[5:30–6:30] Part of the cross-linguistic pattern replicated, but the preregistered priming predictions were not supported, and the Bayes factor favours the null for the key interaction. I read this as: the link is real but not produced by a one-off cue. If language shapes event representation, it more likely does so over time, through learning. That is a developmental question.</a:t>
+              <a:t>1. Part of the cross-linguistic pattern replicated.
+2. The preregistered priming predictions were not supported; the Bayes factor favours the null for the key interaction.
+3. So the link is real, but a one-off cue does not produce it.
+4. If language shapes event representation, it more likely does so over time, through learning.</a:t>
             </a:r>
             <a:endParaRPr lang="en-US" dirty="0"/>
           </a:p>
@@ -1967,7 +2085,10 @@
           <a:p>
             <a:r>
               <a:rPr lang="en-US" dirty="0"/>
-              <a:t>[6:30–7:15] Encoding and processing correspond at two levels: words with event phases, predicates with endpoints. But brief cues did not cause shifts, I tested only two event types, and only adults. If language shapes event representations, it should do so through learning, so the next step is children and sustained, meaningful input.</a:t>
+              <a:t>1. Finding: encoding and processing correspond at two levels, words with event phases and predicates with endpoints.
+2. Limit: brief cues did not cause shifts; two event types; adults only.
+3. Open question: if language shapes events, it should do so through learning.
+4. So the next step is children and sustained, meaningful input.</a:t>
             </a:r>
             <a:endParaRPr lang="en-US" dirty="0"/>
           </a:p>
@@ -2055,7 +2176,10 @@
           <a:p>
             <a:r>
               <a:rPr lang="en-US" dirty="0"/>
-              <a:t>[7:15–9:00] Children often reject 'she peeled the lychee' when it is not open, more than adults do. We propose that this depends on the specific action–result relation: peeling is very likely to open a lychee, squeezing less so. Ten matched pairs and 40 videos; 32 four-year-olds, 32 five-year-olds and 40 adults in each experiment. Adult ratings of result likelihood and action typicality are the predictors. [Give the main result here, or say: data are collected and the analysis is in progress.] The point for today: children are already tracking relations between actions and results. I also have a sole-authored corpus paper on superordinate nouns in Mandarin child-directed speech, at minor revision in Language and Cognition.</a:t>
+              <a:t>1. Children often reject “she peeled the lychee” when it is not open, more than adults do.
+2. We propose this depends on the specific action–result relation: peeling very likely opens a lychee, squeezing less so.
+3. Ten matched pairs, 40 videos; 32 four-year-olds, 32 five-year-olds and 40 adults per experiment; adult ratings of likelihood and typicality as predictors.
+4. [Main result here, or: data are collected and analysis is in progress.] Children already track relations between actions and results. I also have a corpus paper on superordinate nouns, at minor revision in Language and Cognition.</a:t>
             </a:r>
             <a:endParaRPr lang="en-US" dirty="0"/>
           </a:p>
@@ -2143,7 +2267,10 @@
           <a:p>
             <a:r>
               <a:rPr lang="en-US" dirty="0"/>
-              <a:t>[9:00–10:00] This is where my work meets yours. Wiping a mirror clean and rinsing a cup clean share no objects or actions, only a causal relation. Your work shows that relational language makes relations explicit and portable. Mandarin resultatives are relational language for events, so they give us a natural test.</a:t>
+              <a:t>1. Wiping a mirror clean and rinsing a cup clean share no object or action, only a causal relation.
+2. Verbs are relational terms, and your work shows that relational language makes relations explicit and portable.
+3. Mandarin resultatives are relational language for events, so they are a natural test case.
+4. Two questions follow: does naming the result help, and do comparison and explanation make it general?</a:t>
             </a:r>
             <a:endParaRPr lang="en-US" dirty="0"/>
           </a:p>
@@ -2823,7 +2950,7 @@
       </p:grpSpPr>
       <p:sp>
         <p:nvSpPr>
-          <p:cNvPr id="2" name="Text 0"/>
+          <p:cNvPr id="3" name="Text 0"/>
           <p:cNvSpPr/>
           <p:nvPr>
             <p:ph idx="100" type="title" hasCustomPrompt="1"/>
@@ -2861,7 +2988,7 @@
       </p:sp>
       <p:sp>
         <p:nvSpPr>
-          <p:cNvPr id="3" name="Text 0"/>
+          <p:cNvPr id="4" name="Text 0"/>
           <p:cNvSpPr/>
           <p:nvPr>
             <p:ph idx="101" type="body" hasCustomPrompt="1"/>
@@ -2899,7 +3026,7 @@
       </p:sp>
       <p:sp>
         <p:nvSpPr>
-          <p:cNvPr id="4" name="Text 0"/>
+          <p:cNvPr id="5" name="Text 0"/>
           <p:cNvSpPr/>
           <p:nvPr>
             <p:ph idx="102" type="body" hasCustomPrompt="1"/>
@@ -3020,7 +3147,7 @@
                   <a:schemeClr val="tx2"/>
                 </a:solidFill>
               </a:rPr>
-              <a:t>Proposed study: Does naming the result help?</a:t>
+              <a:t>Direction 1: Does naming the result help?</a:t>
             </a:r>
             <a:endParaRPr lang="en-US" sz="3000" dirty="0"/>
           </a:p>
@@ -3028,41 +3155,14 @@
       </p:sp>
       <p:sp>
         <p:nvSpPr>
-          <p:cNvPr id="3" name="Shape 1"/>
-          <p:cNvSpPr/>
-          <p:nvPr/>
-        </p:nvSpPr>
-        <p:spPr>
-          <a:xfrm>
-            <a:off x="548640" y="1371600"/>
-            <a:ext cx="2011680" cy="1691640"/>
-          </a:xfrm>
-          <a:prstGeom prst="roundRect">
-            <a:avLst>
-              <a:gd name="adj" fmla="val 5405"/>
-            </a:avLst>
-          </a:prstGeom>
-          <a:solidFill>
-            <a:schemeClr val="bg2"/>
-          </a:solidFill>
-          <a:ln w="25400">
-            <a:solidFill>
-              <a:schemeClr val="accent1"/>
-            </a:solidFill>
-            <a:prstDash val="solid"/>
-          </a:ln>
-        </p:spPr>
-      </p:sp>
-      <p:sp>
-        <p:nvSpPr>
-          <p:cNvPr id="4" name="Text 2"/>
+          <p:cNvPr id="4" name="Text 1"/>
           <p:cNvSpPr txBox="1"/>
           <p:nvPr/>
         </p:nvSpPr>
         <p:spPr>
           <a:xfrm>
-            <a:off x="685800" y="1481328"/>
-            <a:ext cx="1737360" cy="1508760"/>
+            <a:off x="548640" y="1280160"/>
+            <a:ext cx="6309360" cy="411480"/>
           </a:xfrm>
           <a:prstGeom prst="rect">
             <a:avLst/>
@@ -3078,260 +3178,14 @@
               <a:buNone/>
             </a:pPr>
             <a:r>
-              <a:rPr lang="en-US" sz="1800" b="1" dirty="0">
-                <a:solidFill>
-                  <a:schemeClr val="accent1"/>
-                </a:solidFill>
-              </a:rPr>
-              <a:t>Standard</a:t>
-            </a:r>
-            <a:endParaRPr lang="en-US" sz="1800" dirty="0"/>
-          </a:p>
-          <a:p>
-            <a:pPr indent="0" marL="0">
-              <a:buNone/>
-            </a:pPr>
-            <a:r>
-              <a:rPr lang="en-US" sz="1800" dirty="0">
-                <a:solidFill>
-                  <a:schemeClr val="tx1"/>
-                </a:solidFill>
-              </a:rPr>
-              <a:t>Sponge wipes table</a:t>
-            </a:r>
-            <a:endParaRPr lang="en-US" sz="1800" dirty="0"/>
-          </a:p>
-          <a:p>
-            <a:pPr indent="0" marL="0">
-              <a:buNone/>
-            </a:pPr>
-            <a:r>
-              <a:rPr lang="en-US" sz="1800" b="1" dirty="0">
-                <a:solidFill>
-                  <a:schemeClr val="tx1"/>
-                </a:solidFill>
-              </a:rPr>
-              <a:t>Result: clean</a:t>
-            </a:r>
-            <a:endParaRPr lang="en-US" sz="1800" dirty="0"/>
-          </a:p>
-        </p:txBody>
-      </p:sp>
-      <p:sp>
-        <p:nvSpPr>
-          <p:cNvPr id="5" name="Shape 3"/>
-          <p:cNvSpPr/>
-          <p:nvPr/>
-        </p:nvSpPr>
-        <p:spPr>
-          <a:xfrm>
-            <a:off x="2743200" y="1371600"/>
-            <a:ext cx="2011680" cy="1691640"/>
-          </a:xfrm>
-          <a:prstGeom prst="roundRect">
-            <a:avLst>
-              <a:gd name="adj" fmla="val 5405"/>
-            </a:avLst>
-          </a:prstGeom>
-          <a:solidFill>
-            <a:schemeClr val="bg2"/>
-          </a:solidFill>
-          <a:ln w="25400">
-            <a:solidFill>
-              <a:schemeClr val="accent2"/>
-            </a:solidFill>
-            <a:prstDash val="solid"/>
-          </a:ln>
-        </p:spPr>
-      </p:sp>
-      <p:sp>
-        <p:nvSpPr>
-          <p:cNvPr id="6" name="Text 4"/>
-          <p:cNvSpPr txBox="1"/>
-          <p:nvPr/>
-        </p:nvSpPr>
-        <p:spPr>
-          <a:xfrm>
-            <a:off x="2880360" y="1481328"/>
-            <a:ext cx="1737360" cy="1508760"/>
-          </a:xfrm>
-          <a:prstGeom prst="rect">
-            <a:avLst/>
-          </a:prstGeom>
-          <a:noFill/>
-          <a:ln/>
-        </p:spPr>
-        <p:txBody>
-          <a:bodyPr wrap="square" lIns="0" tIns="0" rIns="0" bIns="0" rtlCol="0" anchor="t"/>
-          <a:lstStyle/>
-          <a:p>
-            <a:pPr indent="0" marL="0">
-              <a:buNone/>
-            </a:pPr>
-            <a:r>
-              <a:rPr lang="en-US" sz="1800" b="1" dirty="0">
-                <a:solidFill>
-                  <a:schemeClr val="accent2"/>
-                </a:solidFill>
-              </a:rPr>
-              <a:t>Relational</a:t>
-            </a:r>
-            <a:endParaRPr lang="en-US" sz="1800" dirty="0"/>
-          </a:p>
-          <a:p>
-            <a:pPr indent="0" marL="0">
-              <a:buNone/>
-            </a:pPr>
-            <a:r>
-              <a:rPr lang="en-US" sz="1800" dirty="0">
-                <a:solidFill>
-                  <a:schemeClr val="tx1"/>
-                </a:solidFill>
-              </a:rPr>
-              <a:t>Brush scrubs shoe</a:t>
-            </a:r>
-            <a:endParaRPr lang="en-US" sz="1800" dirty="0"/>
-          </a:p>
-          <a:p>
-            <a:pPr indent="0" marL="0">
-              <a:buNone/>
-            </a:pPr>
-            <a:r>
-              <a:rPr lang="en-US" sz="1800" b="1" dirty="0">
-                <a:solidFill>
-                  <a:schemeClr val="tx1"/>
-                </a:solidFill>
-              </a:rPr>
-              <a:t>Result: clean</a:t>
-            </a:r>
-            <a:endParaRPr lang="en-US" sz="1800" dirty="0"/>
-          </a:p>
-        </p:txBody>
-      </p:sp>
-      <p:sp>
-        <p:nvSpPr>
-          <p:cNvPr id="7" name="Shape 5"/>
-          <p:cNvSpPr/>
-          <p:nvPr/>
-        </p:nvSpPr>
-        <p:spPr>
-          <a:xfrm>
-            <a:off x="4937760" y="1371600"/>
-            <a:ext cx="2011680" cy="1691640"/>
-          </a:xfrm>
-          <a:prstGeom prst="roundRect">
-            <a:avLst>
-              <a:gd name="adj" fmla="val 5405"/>
-            </a:avLst>
-          </a:prstGeom>
-          <a:solidFill>
-            <a:schemeClr val="bg2"/>
-          </a:solidFill>
-          <a:ln w="25400">
-            <a:solidFill>
-              <a:schemeClr val="accent3"/>
-            </a:solidFill>
-            <a:prstDash val="solid"/>
-          </a:ln>
-        </p:spPr>
-      </p:sp>
-      <p:sp>
-        <p:nvSpPr>
-          <p:cNvPr id="8" name="Text 6"/>
-          <p:cNvSpPr txBox="1"/>
-          <p:nvPr/>
-        </p:nvSpPr>
-        <p:spPr>
-          <a:xfrm>
-            <a:off x="5074920" y="1481328"/>
-            <a:ext cx="1737360" cy="1508760"/>
-          </a:xfrm>
-          <a:prstGeom prst="rect">
-            <a:avLst/>
-          </a:prstGeom>
-          <a:noFill/>
-          <a:ln/>
-        </p:spPr>
-        <p:txBody>
-          <a:bodyPr wrap="square" lIns="0" tIns="0" rIns="0" bIns="0" rtlCol="0" anchor="t"/>
-          <a:lstStyle/>
-          <a:p>
-            <a:pPr indent="0" marL="0">
-              <a:buNone/>
-            </a:pPr>
-            <a:r>
-              <a:rPr lang="en-US" sz="1800" b="1" dirty="0">
-                <a:solidFill>
-                  <a:schemeClr val="accent3"/>
-                </a:solidFill>
-              </a:rPr>
-              <a:t>Surface</a:t>
-            </a:r>
-            <a:endParaRPr lang="en-US" sz="1800" dirty="0"/>
-          </a:p>
-          <a:p>
-            <a:pPr indent="0" marL="0">
-              <a:buNone/>
-            </a:pPr>
-            <a:r>
-              <a:rPr lang="en-US" sz="1800" dirty="0">
-                <a:solidFill>
-                  <a:schemeClr val="tx1"/>
-                </a:solidFill>
-              </a:rPr>
-              <a:t>Sponge wipes table</a:t>
-            </a:r>
-            <a:endParaRPr lang="en-US" sz="1800" dirty="0"/>
-          </a:p>
-          <a:p>
-            <a:pPr indent="0" marL="0">
-              <a:buNone/>
-            </a:pPr>
-            <a:r>
-              <a:rPr lang="en-US" sz="1800" b="1" dirty="0">
-                <a:solidFill>
-                  <a:schemeClr val="tx1"/>
-                </a:solidFill>
-              </a:rPr>
-              <a:t>Result: still dirty</a:t>
-            </a:r>
-            <a:endParaRPr lang="en-US" sz="1800" dirty="0"/>
-          </a:p>
-        </p:txBody>
-      </p:sp>
-      <p:sp>
-        <p:nvSpPr>
-          <p:cNvPr id="9" name="Text 7"/>
-          <p:cNvSpPr txBox="1"/>
-          <p:nvPr/>
-        </p:nvSpPr>
-        <p:spPr>
-          <a:xfrm>
-            <a:off x="548640" y="3154680"/>
-            <a:ext cx="6309360" cy="411480"/>
-          </a:xfrm>
-          <a:prstGeom prst="rect">
-            <a:avLst/>
-          </a:prstGeom>
-          <a:noFill/>
-          <a:ln/>
-        </p:spPr>
-        <p:txBody>
-          <a:bodyPr wrap="square" lIns="0" tIns="0" rIns="0" bIns="0" rtlCol="0" anchor="t"/>
-          <a:lstStyle/>
-          <a:p>
-            <a:pPr indent="0" marL="0">
-              <a:buNone/>
-            </a:pPr>
-            <a:r>
-              <a:rPr lang="en-US" sz="1800" i="1" dirty="0">
-                <a:solidFill>
-                  <a:schemeClr val="tx1"/>
-                </a:solidFill>
-              </a:rPr>
-              <a:t>Relation vs. surface similarity</a:t>
-            </a:r>
-            <a:endParaRPr lang="en-US" sz="1800" dirty="0"/>
+              <a:rPr lang="en-US" sz="2200" b="1" dirty="0">
+                <a:solidFill>
+                  <a:schemeClr val="tx2"/>
+                </a:solidFill>
+              </a:rPr>
+              <a:t>1  Watch an event (language varies)</a:t>
+            </a:r>
+            <a:endParaRPr lang="en-US" sz="2200" dirty="0"/>
           </a:p>
         </p:txBody>
       </p:sp>
@@ -3350,7 +3204,7 @@
           </p:nvPr>
         </p:nvGraphicFramePr>
         <p:xfrm>
-          <a:off x="548640" y="3703320"/>
+          <a:off x="548640" y="1783080"/>
           <a:ext cx="6309360" cy="914400"/>
         </p:xfrm>
         <a:graphic>
@@ -3372,130 +3226,6 @@
                       </a:pPr>
                       <a:r>
                         <a:rPr lang="en-US" sz="1800" b="1" dirty="0">
-                          <a:solidFill>
-                            <a:schemeClr val="bg1"/>
-                          </a:solidFill>
-                        </a:rPr>
-                        <a:t>Condition</a:t>
-                      </a:r>
-                      <a:endParaRPr lang="en-US" sz="1800" dirty="0"/>
-                    </a:p>
-                  </a:txBody>
-                  <a:tcPr marL="73152" marR="73152" marT="73152" marB="73152" anchor="ctr">
-                    <a:lnL w="12700" cap="flat" cmpd="sng" algn="ctr">
-                      <a:solidFill>
-                        <a:srgbClr val="C9D6D3"/>
-                      </a:solidFill>
-                      <a:prstDash val="solid"/>
-                      <a:round/>
-                      <a:headEnd type="none" w="med" len="med"/>
-                      <a:tailEnd type="none" w="med" len="med"/>
-                    </a:lnL>
-                    <a:lnR w="12700" cap="flat" cmpd="sng" algn="ctr">
-                      <a:solidFill>
-                        <a:srgbClr val="C9D6D3"/>
-                      </a:solidFill>
-                      <a:prstDash val="solid"/>
-                      <a:round/>
-                      <a:headEnd type="none" w="med" len="med"/>
-                      <a:tailEnd type="none" w="med" len="med"/>
-                    </a:lnR>
-                    <a:lnT w="12700" cap="flat" cmpd="sng" algn="ctr">
-                      <a:solidFill>
-                        <a:srgbClr val="C9D6D3"/>
-                      </a:solidFill>
-                      <a:prstDash val="solid"/>
-                      <a:round/>
-                      <a:headEnd type="none" w="med" len="med"/>
-                      <a:tailEnd type="none" w="med" len="med"/>
-                    </a:lnT>
-                    <a:lnB w="12700" cap="flat" cmpd="sng" algn="ctr">
-                      <a:solidFill>
-                        <a:srgbClr val="C9D6D3"/>
-                      </a:solidFill>
-                      <a:prstDash val="solid"/>
-                      <a:round/>
-                      <a:headEnd type="none" w="med" len="med"/>
-                      <a:tailEnd type="none" w="med" len="med"/>
-                    </a:lnB>
-                    <a:solidFill>
-                      <a:schemeClr val="accent1"/>
-                    </a:solidFill>
-                  </a:tcPr>
-                </a:tc>
-                <a:tc>
-                  <a:txBody>
-                    <a:bodyPr/>
-                    <a:lstStyle/>
-                    <a:p>
-                      <a:pPr indent="0" marL="0">
-                        <a:buNone/>
-                      </a:pPr>
-                      <a:r>
-                        <a:rPr lang="en-US" sz="1800" b="1" dirty="0">
-                          <a:solidFill>
-                            <a:schemeClr val="bg1"/>
-                          </a:solidFill>
-                        </a:rPr>
-                        <a:t>Example</a:t>
-                      </a:r>
-                      <a:endParaRPr lang="en-US" sz="1800" dirty="0"/>
-                    </a:p>
-                  </a:txBody>
-                  <a:tcPr marL="73152" marR="73152" marT="73152" marB="73152" anchor="ctr">
-                    <a:lnL w="12700" cap="flat" cmpd="sng" algn="ctr">
-                      <a:solidFill>
-                        <a:srgbClr val="C9D6D3"/>
-                      </a:solidFill>
-                      <a:prstDash val="solid"/>
-                      <a:round/>
-                      <a:headEnd type="none" w="med" len="med"/>
-                      <a:tailEnd type="none" w="med" len="med"/>
-                    </a:lnL>
-                    <a:lnR w="12700" cap="flat" cmpd="sng" algn="ctr">
-                      <a:solidFill>
-                        <a:srgbClr val="C9D6D3"/>
-                      </a:solidFill>
-                      <a:prstDash val="solid"/>
-                      <a:round/>
-                      <a:headEnd type="none" w="med" len="med"/>
-                      <a:tailEnd type="none" w="med" len="med"/>
-                    </a:lnR>
-                    <a:lnT w="12700" cap="flat" cmpd="sng" algn="ctr">
-                      <a:solidFill>
-                        <a:srgbClr val="C9D6D3"/>
-                      </a:solidFill>
-                      <a:prstDash val="solid"/>
-                      <a:round/>
-                      <a:headEnd type="none" w="med" len="med"/>
-                      <a:tailEnd type="none" w="med" len="med"/>
-                    </a:lnT>
-                    <a:lnB w="12700" cap="flat" cmpd="sng" algn="ctr">
-                      <a:solidFill>
-                        <a:srgbClr val="C9D6D3"/>
-                      </a:solidFill>
-                      <a:prstDash val="solid"/>
-                      <a:round/>
-                      <a:headEnd type="none" w="med" len="med"/>
-                      <a:tailEnd type="none" w="med" len="med"/>
-                    </a:lnB>
-                    <a:solidFill>
-                      <a:schemeClr val="accent1"/>
-                    </a:solidFill>
-                  </a:tcPr>
-                </a:tc>
-              </a:tr>
-              <a:tr h="457200">
-                <a:tc>
-                  <a:txBody>
-                    <a:bodyPr/>
-                    <a:lstStyle/>
-                    <a:p>
-                      <a:pPr indent="0" marL="0">
-                        <a:buNone/>
-                      </a:pPr>
-                      <a:r>
-                        <a:rPr lang="en-US" sz="1800" dirty="0">
                           <a:solidFill>
                             <a:schemeClr val="tx1"/>
                           </a:solidFill>
@@ -3558,7 +3288,7 @@
                             <a:schemeClr val="tx1"/>
                           </a:solidFill>
                         </a:rPr>
-                        <a:t>她把桌子擦干净了</a:t>
+                        <a:t>她把镜子擦干净了</a:t>
                       </a:r>
                       <a:endParaRPr lang="en-US" sz="1800" dirty="0"/>
                     </a:p>
@@ -3613,7 +3343,7 @@
                         <a:buNone/>
                       </a:pPr>
                       <a:r>
-                        <a:rPr lang="en-US" sz="1800" dirty="0">
+                        <a:rPr lang="en-US" sz="1800" b="1" dirty="0">
                           <a:solidFill>
                             <a:schemeClr val="tx1"/>
                           </a:solidFill>
@@ -3676,7 +3406,7 @@
                             <a:schemeClr val="tx1"/>
                           </a:solidFill>
                         </a:rPr>
-                        <a:t>她在擦桌子</a:t>
+                        <a:t>她在擦镜子</a:t>
                       </a:r>
                       <a:endParaRPr lang="en-US" sz="1800" dirty="0"/>
                     </a:p>
@@ -3731,12 +3461,12 @@
                         <a:buNone/>
                       </a:pPr>
                       <a:r>
-                        <a:rPr lang="en-US" sz="1800" dirty="0">
+                        <a:rPr lang="en-US" sz="1800" b="1" dirty="0">
                           <a:solidFill>
                             <a:schemeClr val="tx1"/>
                           </a:solidFill>
                         </a:rPr>
-                        <a:t>Neutral</a:t>
+                        <a:t>No label</a:t>
                       </a:r>
                       <a:endParaRPr lang="en-US" sz="1800" dirty="0"/>
                     </a:p>
@@ -3845,36 +3575,77 @@
       </p:graphicFrame>
       <p:sp>
         <p:nvSpPr>
-          <p:cNvPr id="11" name="Shape 8"/>
+          <p:cNvPr id="6" name="Text 2"/>
+          <p:cNvSpPr txBox="1"/>
+          <p:nvPr/>
+        </p:nvSpPr>
+        <p:spPr>
+          <a:xfrm>
+            <a:off x="548640" y="3337560"/>
+            <a:ext cx="6309360" cy="411480"/>
+          </a:xfrm>
+          <a:prstGeom prst="rect">
+            <a:avLst/>
+          </a:prstGeom>
+          <a:noFill/>
+          <a:ln/>
+        </p:spPr>
+        <p:txBody>
+          <a:bodyPr wrap="square" lIns="0" tIns="0" rIns="0" bIns="0" rtlCol="0" anchor="t"/>
+          <a:lstStyle/>
+          <a:p>
+            <a:pPr indent="0" marL="0">
+              <a:buNone/>
+            </a:pPr>
+            <a:r>
+              <a:rPr lang="en-US" sz="2200" b="1" dirty="0">
+                <a:solidFill>
+                  <a:schemeClr val="tx2"/>
+                </a:solidFill>
+              </a:rPr>
+              <a:t>2  Which one is like it? (no language)</a:t>
+            </a:r>
+            <a:endParaRPr lang="en-US" sz="2200" dirty="0"/>
+          </a:p>
+        </p:txBody>
+      </p:sp>
+      <p:sp>
+        <p:nvSpPr>
+          <p:cNvPr id="7" name="Shape 3"/>
           <p:cNvSpPr/>
           <p:nvPr/>
         </p:nvSpPr>
         <p:spPr>
           <a:xfrm>
-            <a:off x="7223760" y="1371600"/>
-            <a:ext cx="4419295" cy="1965960"/>
+            <a:off x="548640" y="3840480"/>
+            <a:ext cx="1965960" cy="1097280"/>
           </a:xfrm>
           <a:prstGeom prst="roundRect">
             <a:avLst>
-              <a:gd name="adj" fmla="val 4651"/>
+              <a:gd name="adj" fmla="val 8333"/>
             </a:avLst>
           </a:prstGeom>
           <a:solidFill>
             <a:schemeClr val="bg2"/>
           </a:solidFill>
-          <a:ln/>
-        </p:spPr>
-      </p:sp>
-      <p:sp>
-        <p:nvSpPr>
-          <p:cNvPr id="12" name="Text 9"/>
+          <a:ln w="25400">
+            <a:solidFill>
+              <a:schemeClr val="accent2"/>
+            </a:solidFill>
+            <a:prstDash val="solid"/>
+          </a:ln>
+        </p:spPr>
+      </p:sp>
+      <p:sp>
+        <p:nvSpPr>
+          <p:cNvPr id="8" name="Text 4"/>
           <p:cNvSpPr txBox="1"/>
           <p:nvPr/>
         </p:nvSpPr>
         <p:spPr>
           <a:xfrm>
-            <a:off x="7452360" y="1554480"/>
-            <a:ext cx="3962095" cy="1600200"/>
+            <a:off x="685800" y="3950208"/>
+            <a:ext cx="1691640" cy="914400"/>
           </a:xfrm>
           <a:prstGeom prst="rect">
             <a:avLst/>
@@ -3887,26 +3658,20 @@
           <a:lstStyle/>
           <a:p>
             <a:pPr indent="0" marL="0">
-              <a:spcAft>
-                <a:spcPts val="600"/>
-              </a:spcAft>
-              <a:buNone/>
-            </a:pPr>
-            <a:r>
-              <a:rPr lang="en-US" sz="2200" b="1" dirty="0">
-                <a:solidFill>
-                  <a:schemeClr val="tx2"/>
-                </a:solidFill>
-              </a:rPr>
-              <a:t>Who and how</a:t>
-            </a:r>
-            <a:endParaRPr lang="en-US" sz="1800" dirty="0"/>
-          </a:p>
-          <a:p>
-            <a:pPr indent="0" marL="0">
-              <a:spcAft>
-                <a:spcPts val="600"/>
-              </a:spcAft>
+              <a:buNone/>
+            </a:pPr>
+            <a:r>
+              <a:rPr lang="en-US" sz="1800" b="1" dirty="0">
+                <a:solidFill>
+                  <a:schemeClr val="accent2"/>
+                </a:solidFill>
+              </a:rPr>
+              <a:t>Relational</a:t>
+            </a:r>
+            <a:endParaRPr lang="en-US" sz="1800" dirty="0"/>
+          </a:p>
+          <a:p>
+            <a:pPr indent="0" marL="0">
               <a:buNone/>
             </a:pPr>
             <a:r>
@@ -3915,15 +3680,75 @@
                   <a:schemeClr val="tx1"/>
                 </a:solidFill>
               </a:rPr>
-              <a:t>Ages 3–5</a:t>
-            </a:r>
-            <a:endParaRPr lang="en-US" sz="1800" dirty="0"/>
-          </a:p>
-          <a:p>
-            <a:pPr indent="0" marL="0">
-              <a:spcAft>
-                <a:spcPts val="600"/>
-              </a:spcAft>
+              <a:t>冲杯子，干净了</a:t>
+            </a:r>
+            <a:endParaRPr lang="en-US" sz="1800" dirty="0"/>
+          </a:p>
+        </p:txBody>
+      </p:sp>
+      <p:sp>
+        <p:nvSpPr>
+          <p:cNvPr id="9" name="Shape 5"/>
+          <p:cNvSpPr/>
+          <p:nvPr/>
+        </p:nvSpPr>
+        <p:spPr>
+          <a:xfrm>
+            <a:off x="2720340" y="3840480"/>
+            <a:ext cx="1965960" cy="1097280"/>
+          </a:xfrm>
+          <a:prstGeom prst="roundRect">
+            <a:avLst>
+              <a:gd name="adj" fmla="val 8333"/>
+            </a:avLst>
+          </a:prstGeom>
+          <a:solidFill>
+            <a:schemeClr val="bg2"/>
+          </a:solidFill>
+          <a:ln w="25400">
+            <a:solidFill>
+              <a:schemeClr val="accent3"/>
+            </a:solidFill>
+            <a:prstDash val="solid"/>
+          </a:ln>
+        </p:spPr>
+      </p:sp>
+      <p:sp>
+        <p:nvSpPr>
+          <p:cNvPr id="10" name="Text 6"/>
+          <p:cNvSpPr txBox="1"/>
+          <p:nvPr/>
+        </p:nvSpPr>
+        <p:spPr>
+          <a:xfrm>
+            <a:off x="2857500" y="3950208"/>
+            <a:ext cx="1691640" cy="914400"/>
+          </a:xfrm>
+          <a:prstGeom prst="rect">
+            <a:avLst/>
+          </a:prstGeom>
+          <a:noFill/>
+          <a:ln/>
+        </p:spPr>
+        <p:txBody>
+          <a:bodyPr wrap="square" lIns="0" tIns="0" rIns="0" bIns="0" rtlCol="0" anchor="t"/>
+          <a:lstStyle/>
+          <a:p>
+            <a:pPr indent="0" marL="0">
+              <a:buNone/>
+            </a:pPr>
+            <a:r>
+              <a:rPr lang="en-US" sz="1800" b="1" dirty="0">
+                <a:solidFill>
+                  <a:schemeClr val="accent3"/>
+                </a:solidFill>
+              </a:rPr>
+              <a:t>Same action</a:t>
+            </a:r>
+            <a:endParaRPr lang="en-US" sz="1800" dirty="0"/>
+          </a:p>
+          <a:p>
+            <a:pPr indent="0" marL="0">
               <a:buNone/>
             </a:pPr>
             <a:r>
@@ -3932,21 +3757,98 @@
                   <a:schemeClr val="tx1"/>
                 </a:solidFill>
               </a:rPr>
-              <a:t>Match, predict, transfer</a:t>
-            </a:r>
-            <a:endParaRPr lang="en-US" sz="1800" dirty="0"/>
-          </a:p>
-        </p:txBody>
-      </p:sp>
-      <p:sp>
-        <p:nvSpPr>
-          <p:cNvPr id="13" name="Shape 10"/>
+              <a:t>擦镜子，没干净</a:t>
+            </a:r>
+            <a:endParaRPr lang="en-US" sz="1800" dirty="0"/>
+          </a:p>
+        </p:txBody>
+      </p:sp>
+      <p:sp>
+        <p:nvSpPr>
+          <p:cNvPr id="11" name="Shape 7"/>
           <p:cNvSpPr/>
           <p:nvPr/>
         </p:nvSpPr>
         <p:spPr>
           <a:xfrm>
-            <a:off x="7223760" y="3520440"/>
+            <a:off x="4892040" y="3840480"/>
+            <a:ext cx="1965960" cy="1097280"/>
+          </a:xfrm>
+          <a:prstGeom prst="roundRect">
+            <a:avLst>
+              <a:gd name="adj" fmla="val 8333"/>
+            </a:avLst>
+          </a:prstGeom>
+          <a:solidFill>
+            <a:schemeClr val="bg2"/>
+          </a:solidFill>
+          <a:ln w="25400">
+            <a:solidFill>
+              <a:schemeClr val="accent3"/>
+            </a:solidFill>
+            <a:prstDash val="solid"/>
+          </a:ln>
+        </p:spPr>
+      </p:sp>
+      <p:sp>
+        <p:nvSpPr>
+          <p:cNvPr id="12" name="Text 8"/>
+          <p:cNvSpPr txBox="1"/>
+          <p:nvPr/>
+        </p:nvSpPr>
+        <p:spPr>
+          <a:xfrm>
+            <a:off x="5029200" y="3950208"/>
+            <a:ext cx="1691640" cy="914400"/>
+          </a:xfrm>
+          <a:prstGeom prst="rect">
+            <a:avLst/>
+          </a:prstGeom>
+          <a:noFill/>
+          <a:ln/>
+        </p:spPr>
+        <p:txBody>
+          <a:bodyPr wrap="square" lIns="0" tIns="0" rIns="0" bIns="0" rtlCol="0" anchor="t"/>
+          <a:lstStyle/>
+          <a:p>
+            <a:pPr indent="0" marL="0">
+              <a:buNone/>
+            </a:pPr>
+            <a:r>
+              <a:rPr lang="en-US" sz="1800" b="1" dirty="0">
+                <a:solidFill>
+                  <a:schemeClr val="accent3"/>
+                </a:solidFill>
+              </a:rPr>
+              <a:t>Same end state</a:t>
+            </a:r>
+            <a:endParaRPr lang="en-US" sz="1800" dirty="0"/>
+          </a:p>
+          <a:p>
+            <a:pPr indent="0" marL="0">
+              <a:buNone/>
+            </a:pPr>
+            <a:r>
+              <a:rPr lang="en-US" sz="1800" dirty="0">
+                <a:solidFill>
+                  <a:schemeClr val="tx1"/>
+                </a:solidFill>
+              </a:rPr>
+              <a:t>干净的杯子</a:t>
+            </a:r>
+            <a:endParaRPr lang="en-US" sz="1800" dirty="0"/>
+          </a:p>
+        </p:txBody>
+      </p:sp>
+      <p:sp>
+        <p:nvSpPr>
+          <p:cNvPr id="13" name="Shape 9"/>
+          <p:cNvSpPr/>
+          <p:nvPr/>
+        </p:nvSpPr>
+        <p:spPr>
+          <a:xfrm>
+            <a:off x="7223760" y="1371600"/>
             <a:ext cx="4419295" cy="2057400"/>
           </a:xfrm>
           <a:prstGeom prst="roundRect">
@@ -3962,13 +3864,13 @@
       </p:sp>
       <p:sp>
         <p:nvSpPr>
-          <p:cNvPr id="14" name="Text 11"/>
+          <p:cNvPr id="14" name="Text 10"/>
           <p:cNvSpPr txBox="1"/>
           <p:nvPr/>
         </p:nvSpPr>
         <p:spPr>
           <a:xfrm>
-            <a:off x="7452360" y="3703320"/>
+            <a:off x="7452360" y="1554480"/>
             <a:ext cx="3962095" cy="1691640"/>
           </a:xfrm>
           <a:prstGeom prst="rect">
@@ -3990,10 +3892,10 @@
             <a:r>
               <a:rPr lang="en-US" sz="2200" b="1" dirty="0">
                 <a:solidFill>
-                  <a:schemeClr val="accent2"/>
-                </a:solidFill>
-              </a:rPr>
-              <a:t>Prediction</a:t>
+                  <a:schemeClr val="tx2"/>
+                </a:solidFill>
+              </a:rPr>
+              <a:t>Measures</a:t>
             </a:r>
             <a:endParaRPr lang="en-US" sz="1800" dirty="0"/>
           </a:p>
@@ -4010,7 +3912,7 @@
                   <a:schemeClr val="tx1"/>
                 </a:solidFill>
               </a:rPr>
-              <a:t>Result named &gt; action only ≈ neutral</a:t>
+              <a:t>Match: relational choice</a:t>
             </a:r>
             <a:endParaRPr lang="en-US" sz="1800" dirty="0"/>
           </a:p>
@@ -4027,7 +3929,171 @@
                   <a:schemeClr val="tx1"/>
                 </a:solidFill>
               </a:rPr>
-              <a:t>Control: “桌子干净了”</a:t>
+              <a:t>Predict: what happens next</a:t>
+            </a:r>
+            <a:endParaRPr lang="en-US" sz="1800" dirty="0"/>
+          </a:p>
+          <a:p>
+            <a:pPr indent="0" marL="0">
+              <a:spcAft>
+                <a:spcPts val="600"/>
+              </a:spcAft>
+              <a:buNone/>
+            </a:pPr>
+            <a:r>
+              <a:rPr lang="en-US" sz="1800" dirty="0">
+                <a:solidFill>
+                  <a:schemeClr val="tx1"/>
+                </a:solidFill>
+              </a:rPr>
+              <a:t>Transfer: new objects, actions</a:t>
+            </a:r>
+            <a:endParaRPr lang="en-US" sz="1800" dirty="0"/>
+          </a:p>
+        </p:txBody>
+      </p:sp>
+      <p:sp>
+        <p:nvSpPr>
+          <p:cNvPr id="15" name="Shape 11"/>
+          <p:cNvSpPr/>
+          <p:nvPr/>
+        </p:nvSpPr>
+        <p:spPr>
+          <a:xfrm>
+            <a:off x="7223760" y="3611880"/>
+            <a:ext cx="4419295" cy="1325880"/>
+          </a:xfrm>
+          <a:prstGeom prst="roundRect">
+            <a:avLst>
+              <a:gd name="adj" fmla="val 6897"/>
+            </a:avLst>
+          </a:prstGeom>
+          <a:solidFill>
+            <a:schemeClr val="bg2"/>
+          </a:solidFill>
+          <a:ln/>
+        </p:spPr>
+      </p:sp>
+      <p:sp>
+        <p:nvSpPr>
+          <p:cNvPr id="16" name="Text 12"/>
+          <p:cNvSpPr txBox="1"/>
+          <p:nvPr/>
+        </p:nvSpPr>
+        <p:spPr>
+          <a:xfrm>
+            <a:off x="7452360" y="3794760"/>
+            <a:ext cx="3962095" cy="960120"/>
+          </a:xfrm>
+          <a:prstGeom prst="rect">
+            <a:avLst/>
+          </a:prstGeom>
+          <a:noFill/>
+          <a:ln/>
+        </p:spPr>
+        <p:txBody>
+          <a:bodyPr wrap="square" lIns="0" tIns="0" rIns="0" bIns="0" rtlCol="0" anchor="t"/>
+          <a:lstStyle/>
+          <a:p>
+            <a:pPr indent="0" marL="0">
+              <a:spcAft>
+                <a:spcPts val="600"/>
+              </a:spcAft>
+              <a:buNone/>
+            </a:pPr>
+            <a:r>
+              <a:rPr lang="en-US" sz="2200" b="1" dirty="0">
+                <a:solidFill>
+                  <a:schemeClr val="tx2"/>
+                </a:solidFill>
+              </a:rPr>
+              <a:t>Ages</a:t>
+            </a:r>
+            <a:endParaRPr lang="en-US" sz="1800" dirty="0"/>
+          </a:p>
+          <a:p>
+            <a:pPr indent="0" marL="0">
+              <a:spcAft>
+                <a:spcPts val="600"/>
+              </a:spcAft>
+              <a:buNone/>
+            </a:pPr>
+            <a:r>
+              <a:rPr lang="en-US" sz="1800" dirty="0">
+                <a:solidFill>
+                  <a:schemeClr val="tx1"/>
+                </a:solidFill>
+              </a:rPr>
+              <a:t>3–5, within Mandarin</a:t>
+            </a:r>
+            <a:endParaRPr lang="en-US" sz="1800" dirty="0"/>
+          </a:p>
+        </p:txBody>
+      </p:sp>
+      <p:sp>
+        <p:nvSpPr>
+          <p:cNvPr id="17" name="Shape 13"/>
+          <p:cNvSpPr/>
+          <p:nvPr/>
+        </p:nvSpPr>
+        <p:spPr>
+          <a:xfrm>
+            <a:off x="548640" y="5257800"/>
+            <a:ext cx="11094415" cy="685800"/>
+          </a:xfrm>
+          <a:prstGeom prst="roundRect">
+            <a:avLst>
+              <a:gd name="adj" fmla="val 10667"/>
+            </a:avLst>
+          </a:prstGeom>
+          <a:solidFill>
+            <a:schemeClr val="bg2"/>
+          </a:solidFill>
+          <a:ln/>
+        </p:spPr>
+      </p:sp>
+      <p:sp>
+        <p:nvSpPr>
+          <p:cNvPr id="18" name="Text 14"/>
+          <p:cNvSpPr txBox="1"/>
+          <p:nvPr/>
+        </p:nvSpPr>
+        <p:spPr>
+          <a:xfrm>
+            <a:off x="777240" y="5257800"/>
+            <a:ext cx="10637215" cy="685800"/>
+          </a:xfrm>
+          <a:prstGeom prst="rect">
+            <a:avLst/>
+          </a:prstGeom>
+          <a:noFill/>
+          <a:ln/>
+        </p:spPr>
+        <p:txBody>
+          <a:bodyPr wrap="square" lIns="0" tIns="0" rIns="0" bIns="0" rtlCol="0" anchor="ctr"/>
+          <a:lstStyle/>
+          <a:p>
+            <a:pPr indent="0" marL="0">
+              <a:buNone/>
+            </a:pPr>
+            <a:r>
+              <a:rPr lang="en-US" sz="1800" b="1" dirty="0">
+                <a:solidFill>
+                  <a:schemeClr val="accent2"/>
+                </a:solidFill>
+              </a:rPr>
+              <a:t>Takeaway   </a:t>
+            </a:r>
+            <a:pPr indent="0" marL="0">
+              <a:buNone/>
+            </a:pPr>
+            <a:r>
+              <a:rPr lang="en-US" sz="1800" dirty="0">
+                <a:solidFill>
+                  <a:schemeClr val="tx1"/>
+                </a:solidFill>
+              </a:rPr>
+              <a:t>Prediction: result named &gt; action only ≈ no label, most against action foils.</a:t>
             </a:r>
             <a:endParaRPr lang="en-US" sz="1800" dirty="0"/>
           </a:p>
@@ -4135,7 +4201,7 @@
                   <a:schemeClr val="tx2"/>
                 </a:solidFill>
               </a:rPr>
-              <a:t>Further directions</a:t>
+              <a:t>Direction 2: Do comparison and explanation help?</a:t>
             </a:r>
             <a:endParaRPr lang="en-US" sz="3000" dirty="0"/>
           </a:p>
@@ -4143,74 +4209,708 @@
       </p:sp>
       <p:sp>
         <p:nvSpPr>
-          <p:cNvPr id="3" name="Shape 1"/>
+          <p:cNvPr id="4" name="Text 1"/>
+          <p:cNvSpPr txBox="1"/>
+          <p:nvPr/>
+        </p:nvSpPr>
+        <p:spPr>
+          <a:xfrm>
+            <a:off x="548640" y="1280160"/>
+            <a:ext cx="6309360" cy="411480"/>
+          </a:xfrm>
+          <a:prstGeom prst="rect">
+            <a:avLst/>
+          </a:prstGeom>
+          <a:noFill/>
+          <a:ln/>
+        </p:spPr>
+        <p:txBody>
+          <a:bodyPr wrap="square" lIns="0" tIns="0" rIns="0" bIns="0" rtlCol="0" anchor="t"/>
+          <a:lstStyle/>
+          <a:p>
+            <a:pPr indent="0" marL="0">
+              <a:buNone/>
+            </a:pPr>
+            <a:r>
+              <a:rPr lang="en-US" sz="2200" b="1" dirty="0">
+                <a:solidFill>
+                  <a:schemeClr val="tx2"/>
+                </a:solidFill>
+              </a:rPr>
+              <a:t>1  Learning: 2 × 2 design</a:t>
+            </a:r>
+            <a:endParaRPr lang="en-US" sz="2200" dirty="0"/>
+          </a:p>
+        </p:txBody>
+      </p:sp>
+      <p:graphicFrame>
+        <p:nvGraphicFramePr>
+          <p:cNvPr id="12" name="Table 0"/>
+          <p:cNvGraphicFramePr>
+            <a:graphicFrameLocks noGrp="1"/>
+          </p:cNvGraphicFramePr>
+          <p:nvPr>
+            <p:extLst>
+              <p:ext uri="{D42A27DB-BD31-4B8C-83A1-F6EECF244321}">
+                <p14:modId xmlns:p14="http://schemas.microsoft.com/office/powerpoint/2010/main" val="1579011935"/>
+              </p:ext>
+            </p:extLst>
+          </p:nvPr>
+        </p:nvGraphicFramePr>
+        <p:xfrm>
+          <a:off x="548640" y="1783080"/>
+          <a:ext cx="6309360" cy="914400"/>
+        </p:xfrm>
+        <a:graphic>
+          <a:graphicData uri="http://schemas.openxmlformats.org/drawingml/2006/table">
+            <a:tbl>
+              <a:tblPr/>
+              <a:tblGrid>
+                <a:gridCol w="2286000"/>
+                <a:gridCol w="1828800"/>
+                <a:gridCol w="2194560"/>
+              </a:tblGrid>
+              <a:tr h="502920">
+                <a:tc>
+                  <a:txBody>
+                    <a:bodyPr/>
+                    <a:lstStyle/>
+                    <a:p>
+                      <a:pPr indent="0" marL="0">
+                        <a:buNone/>
+                      </a:pPr>
+                      <a:endParaRPr lang="en-US" sz="1800" dirty="0"/>
+                    </a:p>
+                  </a:txBody>
+                  <a:tcPr marL="73152" marR="73152" marT="73152" marB="73152" anchor="ctr">
+                    <a:lnL w="12700" cap="flat" cmpd="sng" algn="ctr">
+                      <a:solidFill>
+                        <a:srgbClr val="C9D6D3"/>
+                      </a:solidFill>
+                      <a:prstDash val="solid"/>
+                      <a:round/>
+                      <a:headEnd type="none" w="med" len="med"/>
+                      <a:tailEnd type="none" w="med" len="med"/>
+                    </a:lnL>
+                    <a:lnR w="12700" cap="flat" cmpd="sng" algn="ctr">
+                      <a:solidFill>
+                        <a:srgbClr val="C9D6D3"/>
+                      </a:solidFill>
+                      <a:prstDash val="solid"/>
+                      <a:round/>
+                      <a:headEnd type="none" w="med" len="med"/>
+                      <a:tailEnd type="none" w="med" len="med"/>
+                    </a:lnR>
+                    <a:lnT w="12700" cap="flat" cmpd="sng" algn="ctr">
+                      <a:solidFill>
+                        <a:srgbClr val="C9D6D3"/>
+                      </a:solidFill>
+                      <a:prstDash val="solid"/>
+                      <a:round/>
+                      <a:headEnd type="none" w="med" len="med"/>
+                      <a:tailEnd type="none" w="med" len="med"/>
+                    </a:lnT>
+                    <a:lnB w="12700" cap="flat" cmpd="sng" algn="ctr">
+                      <a:solidFill>
+                        <a:srgbClr val="C9D6D3"/>
+                      </a:solidFill>
+                      <a:prstDash val="solid"/>
+                      <a:round/>
+                      <a:headEnd type="none" w="med" len="med"/>
+                      <a:tailEnd type="none" w="med" len="med"/>
+                    </a:lnB>
+                    <a:solidFill>
+                      <a:schemeClr val="accent1"/>
+                    </a:solidFill>
+                  </a:tcPr>
+                </a:tc>
+                <a:tc>
+                  <a:txBody>
+                    <a:bodyPr/>
+                    <a:lstStyle/>
+                    <a:p>
+                      <a:pPr indent="0" marL="0">
+                        <a:buNone/>
+                      </a:pPr>
+                      <a:r>
+                        <a:rPr lang="en-US" sz="1800" b="1" dirty="0">
+                          <a:solidFill>
+                            <a:schemeClr val="bg1"/>
+                          </a:solidFill>
+                        </a:rPr>
+                        <a:t>No prompt</a:t>
+                      </a:r>
+                      <a:endParaRPr lang="en-US" sz="1800" dirty="0"/>
+                    </a:p>
+                  </a:txBody>
+                  <a:tcPr marL="73152" marR="73152" marT="73152" marB="73152" anchor="ctr">
+                    <a:lnL w="12700" cap="flat" cmpd="sng" algn="ctr">
+                      <a:solidFill>
+                        <a:srgbClr val="C9D6D3"/>
+                      </a:solidFill>
+                      <a:prstDash val="solid"/>
+                      <a:round/>
+                      <a:headEnd type="none" w="med" len="med"/>
+                      <a:tailEnd type="none" w="med" len="med"/>
+                    </a:lnL>
+                    <a:lnR w="12700" cap="flat" cmpd="sng" algn="ctr">
+                      <a:solidFill>
+                        <a:srgbClr val="C9D6D3"/>
+                      </a:solidFill>
+                      <a:prstDash val="solid"/>
+                      <a:round/>
+                      <a:headEnd type="none" w="med" len="med"/>
+                      <a:tailEnd type="none" w="med" len="med"/>
+                    </a:lnR>
+                    <a:lnT w="12700" cap="flat" cmpd="sng" algn="ctr">
+                      <a:solidFill>
+                        <a:srgbClr val="C9D6D3"/>
+                      </a:solidFill>
+                      <a:prstDash val="solid"/>
+                      <a:round/>
+                      <a:headEnd type="none" w="med" len="med"/>
+                      <a:tailEnd type="none" w="med" len="med"/>
+                    </a:lnT>
+                    <a:lnB w="12700" cap="flat" cmpd="sng" algn="ctr">
+                      <a:solidFill>
+                        <a:srgbClr val="C9D6D3"/>
+                      </a:solidFill>
+                      <a:prstDash val="solid"/>
+                      <a:round/>
+                      <a:headEnd type="none" w="med" len="med"/>
+                      <a:tailEnd type="none" w="med" len="med"/>
+                    </a:lnB>
+                    <a:solidFill>
+                      <a:schemeClr val="accent1"/>
+                    </a:solidFill>
+                  </a:tcPr>
+                </a:tc>
+                <a:tc>
+                  <a:txBody>
+                    <a:bodyPr/>
+                    <a:lstStyle/>
+                    <a:p>
+                      <a:pPr indent="0" marL="0">
+                        <a:buNone/>
+                      </a:pPr>
+                      <a:r>
+                        <a:rPr lang="en-US" sz="1800" b="1" dirty="0">
+                          <a:solidFill>
+                            <a:schemeClr val="bg1"/>
+                          </a:solidFill>
+                        </a:rPr>
+                        <a:t>“为什么会干净？”</a:t>
+                      </a:r>
+                      <a:endParaRPr lang="en-US" sz="1800" dirty="0"/>
+                    </a:p>
+                  </a:txBody>
+                  <a:tcPr marL="73152" marR="73152" marT="73152" marB="73152" anchor="ctr">
+                    <a:lnL w="12700" cap="flat" cmpd="sng" algn="ctr">
+                      <a:solidFill>
+                        <a:srgbClr val="C9D6D3"/>
+                      </a:solidFill>
+                      <a:prstDash val="solid"/>
+                      <a:round/>
+                      <a:headEnd type="none" w="med" len="med"/>
+                      <a:tailEnd type="none" w="med" len="med"/>
+                    </a:lnL>
+                    <a:lnR w="12700" cap="flat" cmpd="sng" algn="ctr">
+                      <a:solidFill>
+                        <a:srgbClr val="C9D6D3"/>
+                      </a:solidFill>
+                      <a:prstDash val="solid"/>
+                      <a:round/>
+                      <a:headEnd type="none" w="med" len="med"/>
+                      <a:tailEnd type="none" w="med" len="med"/>
+                    </a:lnR>
+                    <a:lnT w="12700" cap="flat" cmpd="sng" algn="ctr">
+                      <a:solidFill>
+                        <a:srgbClr val="C9D6D3"/>
+                      </a:solidFill>
+                      <a:prstDash val="solid"/>
+                      <a:round/>
+                      <a:headEnd type="none" w="med" len="med"/>
+                      <a:tailEnd type="none" w="med" len="med"/>
+                    </a:lnT>
+                    <a:lnB w="12700" cap="flat" cmpd="sng" algn="ctr">
+                      <a:solidFill>
+                        <a:srgbClr val="C9D6D3"/>
+                      </a:solidFill>
+                      <a:prstDash val="solid"/>
+                      <a:round/>
+                      <a:headEnd type="none" w="med" len="med"/>
+                      <a:tailEnd type="none" w="med" len="med"/>
+                    </a:lnB>
+                    <a:solidFill>
+                      <a:schemeClr val="accent1"/>
+                    </a:solidFill>
+                  </a:tcPr>
+                </a:tc>
+              </a:tr>
+              <a:tr h="502920">
+                <a:tc>
+                  <a:txBody>
+                    <a:bodyPr/>
+                    <a:lstStyle/>
+                    <a:p>
+                      <a:pPr indent="0" marL="0">
+                        <a:buNone/>
+                      </a:pPr>
+                      <a:r>
+                        <a:rPr lang="en-US" sz="1800" b="1" dirty="0">
+                          <a:solidFill>
+                            <a:schemeClr val="tx1"/>
+                          </a:solidFill>
+                        </a:rPr>
+                        <a:t>One event</a:t>
+                      </a:r>
+                      <a:endParaRPr lang="en-US" sz="1800" dirty="0"/>
+                    </a:p>
+                  </a:txBody>
+                  <a:tcPr marL="73152" marR="73152" marT="73152" marB="73152" anchor="ctr">
+                    <a:lnL w="12700" cap="flat" cmpd="sng" algn="ctr">
+                      <a:solidFill>
+                        <a:srgbClr val="C9D6D3"/>
+                      </a:solidFill>
+                      <a:prstDash val="solid"/>
+                      <a:round/>
+                      <a:headEnd type="none" w="med" len="med"/>
+                      <a:tailEnd type="none" w="med" len="med"/>
+                    </a:lnL>
+                    <a:lnR w="12700" cap="flat" cmpd="sng" algn="ctr">
+                      <a:solidFill>
+                        <a:srgbClr val="C9D6D3"/>
+                      </a:solidFill>
+                      <a:prstDash val="solid"/>
+                      <a:round/>
+                      <a:headEnd type="none" w="med" len="med"/>
+                      <a:tailEnd type="none" w="med" len="med"/>
+                    </a:lnR>
+                    <a:lnT w="12700" cap="flat" cmpd="sng" algn="ctr">
+                      <a:solidFill>
+                        <a:srgbClr val="C9D6D3"/>
+                      </a:solidFill>
+                      <a:prstDash val="solid"/>
+                      <a:round/>
+                      <a:headEnd type="none" w="med" len="med"/>
+                      <a:tailEnd type="none" w="med" len="med"/>
+                    </a:lnT>
+                    <a:lnB w="12700" cap="flat" cmpd="sng" algn="ctr">
+                      <a:solidFill>
+                        <a:srgbClr val="C9D6D3"/>
+                      </a:solidFill>
+                      <a:prstDash val="solid"/>
+                      <a:round/>
+                      <a:headEnd type="none" w="med" len="med"/>
+                      <a:tailEnd type="none" w="med" len="med"/>
+                    </a:lnB>
+                  </a:tcPr>
+                </a:tc>
+                <a:tc>
+                  <a:txBody>
+                    <a:bodyPr/>
+                    <a:lstStyle/>
+                    <a:p>
+                      <a:pPr indent="0" marL="0">
+                        <a:buNone/>
+                      </a:pPr>
+                      <a:r>
+                        <a:rPr lang="en-US" sz="1800" dirty="0">
+                          <a:solidFill>
+                            <a:schemeClr val="tx1"/>
+                          </a:solidFill>
+                        </a:rPr>
+                        <a:t>Baseline</a:t>
+                      </a:r>
+                      <a:endParaRPr lang="en-US" sz="1800" dirty="0"/>
+                    </a:p>
+                  </a:txBody>
+                  <a:tcPr marL="73152" marR="73152" marT="73152" marB="73152" anchor="ctr">
+                    <a:lnL w="12700" cap="flat" cmpd="sng" algn="ctr">
+                      <a:solidFill>
+                        <a:srgbClr val="C9D6D3"/>
+                      </a:solidFill>
+                      <a:prstDash val="solid"/>
+                      <a:round/>
+                      <a:headEnd type="none" w="med" len="med"/>
+                      <a:tailEnd type="none" w="med" len="med"/>
+                    </a:lnL>
+                    <a:lnR w="12700" cap="flat" cmpd="sng" algn="ctr">
+                      <a:solidFill>
+                        <a:srgbClr val="C9D6D3"/>
+                      </a:solidFill>
+                      <a:prstDash val="solid"/>
+                      <a:round/>
+                      <a:headEnd type="none" w="med" len="med"/>
+                      <a:tailEnd type="none" w="med" len="med"/>
+                    </a:lnR>
+                    <a:lnT w="12700" cap="flat" cmpd="sng" algn="ctr">
+                      <a:solidFill>
+                        <a:srgbClr val="C9D6D3"/>
+                      </a:solidFill>
+                      <a:prstDash val="solid"/>
+                      <a:round/>
+                      <a:headEnd type="none" w="med" len="med"/>
+                      <a:tailEnd type="none" w="med" len="med"/>
+                    </a:lnT>
+                    <a:lnB w="12700" cap="flat" cmpd="sng" algn="ctr">
+                      <a:solidFill>
+                        <a:srgbClr val="C9D6D3"/>
+                      </a:solidFill>
+                      <a:prstDash val="solid"/>
+                      <a:round/>
+                      <a:headEnd type="none" w="med" len="med"/>
+                      <a:tailEnd type="none" w="med" len="med"/>
+                    </a:lnB>
+                  </a:tcPr>
+                </a:tc>
+                <a:tc>
+                  <a:txBody>
+                    <a:bodyPr/>
+                    <a:lstStyle/>
+                    <a:p>
+                      <a:pPr indent="0" marL="0">
+                        <a:buNone/>
+                      </a:pPr>
+                      <a:r>
+                        <a:rPr lang="en-US" sz="1800" dirty="0">
+                          <a:solidFill>
+                            <a:schemeClr val="tx1"/>
+                          </a:solidFill>
+                        </a:rPr>
+                        <a:t>Explain</a:t>
+                      </a:r>
+                      <a:endParaRPr lang="en-US" sz="1800" dirty="0"/>
+                    </a:p>
+                  </a:txBody>
+                  <a:tcPr marL="73152" marR="73152" marT="73152" marB="73152" anchor="ctr">
+                    <a:lnL w="12700" cap="flat" cmpd="sng" algn="ctr">
+                      <a:solidFill>
+                        <a:srgbClr val="C9D6D3"/>
+                      </a:solidFill>
+                      <a:prstDash val="solid"/>
+                      <a:round/>
+                      <a:headEnd type="none" w="med" len="med"/>
+                      <a:tailEnd type="none" w="med" len="med"/>
+                    </a:lnL>
+                    <a:lnR w="12700" cap="flat" cmpd="sng" algn="ctr">
+                      <a:solidFill>
+                        <a:srgbClr val="C9D6D3"/>
+                      </a:solidFill>
+                      <a:prstDash val="solid"/>
+                      <a:round/>
+                      <a:headEnd type="none" w="med" len="med"/>
+                      <a:tailEnd type="none" w="med" len="med"/>
+                    </a:lnR>
+                    <a:lnT w="12700" cap="flat" cmpd="sng" algn="ctr">
+                      <a:solidFill>
+                        <a:srgbClr val="C9D6D3"/>
+                      </a:solidFill>
+                      <a:prstDash val="solid"/>
+                      <a:round/>
+                      <a:headEnd type="none" w="med" len="med"/>
+                      <a:tailEnd type="none" w="med" len="med"/>
+                    </a:lnT>
+                    <a:lnB w="12700" cap="flat" cmpd="sng" algn="ctr">
+                      <a:solidFill>
+                        <a:srgbClr val="C9D6D3"/>
+                      </a:solidFill>
+                      <a:prstDash val="solid"/>
+                      <a:round/>
+                      <a:headEnd type="none" w="med" len="med"/>
+                      <a:tailEnd type="none" w="med" len="med"/>
+                    </a:lnB>
+                  </a:tcPr>
+                </a:tc>
+              </a:tr>
+              <a:tr h="502920">
+                <a:tc>
+                  <a:txBody>
+                    <a:bodyPr/>
+                    <a:lstStyle/>
+                    <a:p>
+                      <a:pPr indent="0" marL="0">
+                        <a:buNone/>
+                      </a:pPr>
+                      <a:r>
+                        <a:rPr lang="en-US" sz="1800" b="1" dirty="0">
+                          <a:solidFill>
+                            <a:schemeClr val="tx1"/>
+                          </a:solidFill>
+                        </a:rPr>
+                        <a:t>Two aligned events</a:t>
+                      </a:r>
+                      <a:endParaRPr lang="en-US" sz="1800" dirty="0"/>
+                    </a:p>
+                  </a:txBody>
+                  <a:tcPr marL="73152" marR="73152" marT="73152" marB="73152" anchor="ctr">
+                    <a:lnL w="12700" cap="flat" cmpd="sng" algn="ctr">
+                      <a:solidFill>
+                        <a:srgbClr val="C9D6D3"/>
+                      </a:solidFill>
+                      <a:prstDash val="solid"/>
+                      <a:round/>
+                      <a:headEnd type="none" w="med" len="med"/>
+                      <a:tailEnd type="none" w="med" len="med"/>
+                    </a:lnL>
+                    <a:lnR w="12700" cap="flat" cmpd="sng" algn="ctr">
+                      <a:solidFill>
+                        <a:srgbClr val="C9D6D3"/>
+                      </a:solidFill>
+                      <a:prstDash val="solid"/>
+                      <a:round/>
+                      <a:headEnd type="none" w="med" len="med"/>
+                      <a:tailEnd type="none" w="med" len="med"/>
+                    </a:lnR>
+                    <a:lnT w="12700" cap="flat" cmpd="sng" algn="ctr">
+                      <a:solidFill>
+                        <a:srgbClr val="C9D6D3"/>
+                      </a:solidFill>
+                      <a:prstDash val="solid"/>
+                      <a:round/>
+                      <a:headEnd type="none" w="med" len="med"/>
+                      <a:tailEnd type="none" w="med" len="med"/>
+                    </a:lnT>
+                    <a:lnB w="12700" cap="flat" cmpd="sng" algn="ctr">
+                      <a:solidFill>
+                        <a:srgbClr val="C9D6D3"/>
+                      </a:solidFill>
+                      <a:prstDash val="solid"/>
+                      <a:round/>
+                      <a:headEnd type="none" w="med" len="med"/>
+                      <a:tailEnd type="none" w="med" len="med"/>
+                    </a:lnB>
+                  </a:tcPr>
+                </a:tc>
+                <a:tc>
+                  <a:txBody>
+                    <a:bodyPr/>
+                    <a:lstStyle/>
+                    <a:p>
+                      <a:pPr indent="0" marL="0">
+                        <a:buNone/>
+                      </a:pPr>
+                      <a:r>
+                        <a:rPr lang="en-US" sz="1800" dirty="0">
+                          <a:solidFill>
+                            <a:schemeClr val="tx1"/>
+                          </a:solidFill>
+                        </a:rPr>
+                        <a:t>Compare</a:t>
+                      </a:r>
+                      <a:endParaRPr lang="en-US" sz="1800" dirty="0"/>
+                    </a:p>
+                  </a:txBody>
+                  <a:tcPr marL="73152" marR="73152" marT="73152" marB="73152" anchor="ctr">
+                    <a:lnL w="12700" cap="flat" cmpd="sng" algn="ctr">
+                      <a:solidFill>
+                        <a:srgbClr val="C9D6D3"/>
+                      </a:solidFill>
+                      <a:prstDash val="solid"/>
+                      <a:round/>
+                      <a:headEnd type="none" w="med" len="med"/>
+                      <a:tailEnd type="none" w="med" len="med"/>
+                    </a:lnL>
+                    <a:lnR w="12700" cap="flat" cmpd="sng" algn="ctr">
+                      <a:solidFill>
+                        <a:srgbClr val="C9D6D3"/>
+                      </a:solidFill>
+                      <a:prstDash val="solid"/>
+                      <a:round/>
+                      <a:headEnd type="none" w="med" len="med"/>
+                      <a:tailEnd type="none" w="med" len="med"/>
+                    </a:lnR>
+                    <a:lnT w="12700" cap="flat" cmpd="sng" algn="ctr">
+                      <a:solidFill>
+                        <a:srgbClr val="C9D6D3"/>
+                      </a:solidFill>
+                      <a:prstDash val="solid"/>
+                      <a:round/>
+                      <a:headEnd type="none" w="med" len="med"/>
+                      <a:tailEnd type="none" w="med" len="med"/>
+                    </a:lnT>
+                    <a:lnB w="12700" cap="flat" cmpd="sng" algn="ctr">
+                      <a:solidFill>
+                        <a:srgbClr val="C9D6D3"/>
+                      </a:solidFill>
+                      <a:prstDash val="solid"/>
+                      <a:round/>
+                      <a:headEnd type="none" w="med" len="med"/>
+                      <a:tailEnd type="none" w="med" len="med"/>
+                    </a:lnB>
+                  </a:tcPr>
+                </a:tc>
+                <a:tc>
+                  <a:txBody>
+                    <a:bodyPr/>
+                    <a:lstStyle/>
+                    <a:p>
+                      <a:pPr indent="0" marL="0">
+                        <a:buNone/>
+                      </a:pPr>
+                      <a:r>
+                        <a:rPr lang="en-US" sz="1800" dirty="0">
+                          <a:solidFill>
+                            <a:schemeClr val="tx1"/>
+                          </a:solidFill>
+                        </a:rPr>
+                        <a:t>Compare + explain</a:t>
+                      </a:r>
+                      <a:endParaRPr lang="en-US" sz="1800" dirty="0"/>
+                    </a:p>
+                  </a:txBody>
+                  <a:tcPr marL="73152" marR="73152" marT="73152" marB="73152" anchor="ctr">
+                    <a:lnL w="12700" cap="flat" cmpd="sng" algn="ctr">
+                      <a:solidFill>
+                        <a:srgbClr val="C9D6D3"/>
+                      </a:solidFill>
+                      <a:prstDash val="solid"/>
+                      <a:round/>
+                      <a:headEnd type="none" w="med" len="med"/>
+                      <a:tailEnd type="none" w="med" len="med"/>
+                    </a:lnL>
+                    <a:lnR w="12700" cap="flat" cmpd="sng" algn="ctr">
+                      <a:solidFill>
+                        <a:srgbClr val="C9D6D3"/>
+                      </a:solidFill>
+                      <a:prstDash val="solid"/>
+                      <a:round/>
+                      <a:headEnd type="none" w="med" len="med"/>
+                      <a:tailEnd type="none" w="med" len="med"/>
+                    </a:lnR>
+                    <a:lnT w="12700" cap="flat" cmpd="sng" algn="ctr">
+                      <a:solidFill>
+                        <a:srgbClr val="C9D6D3"/>
+                      </a:solidFill>
+                      <a:prstDash val="solid"/>
+                      <a:round/>
+                      <a:headEnd type="none" w="med" len="med"/>
+                      <a:tailEnd type="none" w="med" len="med"/>
+                    </a:lnT>
+                    <a:lnB w="12700" cap="flat" cmpd="sng" algn="ctr">
+                      <a:solidFill>
+                        <a:srgbClr val="C9D6D3"/>
+                      </a:solidFill>
+                      <a:prstDash val="solid"/>
+                      <a:round/>
+                      <a:headEnd type="none" w="med" len="med"/>
+                      <a:tailEnd type="none" w="med" len="med"/>
+                    </a:lnB>
+                  </a:tcPr>
+                </a:tc>
+              </a:tr>
+            </a:tbl>
+          </a:graphicData>
+        </a:graphic>
+      </p:graphicFrame>
+      <p:sp>
+        <p:nvSpPr>
+          <p:cNvPr id="6" name="Text 2"/>
+          <p:cNvSpPr txBox="1"/>
+          <p:nvPr/>
+        </p:nvSpPr>
+        <p:spPr>
+          <a:xfrm>
+            <a:off x="548640" y="3520440"/>
+            <a:ext cx="6309360" cy="411480"/>
+          </a:xfrm>
+          <a:prstGeom prst="rect">
+            <a:avLst/>
+          </a:prstGeom>
+          <a:noFill/>
+          <a:ln/>
+        </p:spPr>
+        <p:txBody>
+          <a:bodyPr wrap="square" lIns="0" tIns="0" rIns="0" bIns="0" rtlCol="0" anchor="t"/>
+          <a:lstStyle/>
+          <a:p>
+            <a:pPr indent="0" marL="0">
+              <a:buNone/>
+            </a:pPr>
+            <a:r>
+              <a:rPr lang="en-US" sz="2200" b="1" dirty="0">
+                <a:solidFill>
+                  <a:schemeClr val="tx2"/>
+                </a:solidFill>
+              </a:rPr>
+              <a:t>2  Transfer test</a:t>
+            </a:r>
+            <a:endParaRPr lang="en-US" sz="2200" dirty="0"/>
+          </a:p>
+        </p:txBody>
+      </p:sp>
+      <p:sp>
+        <p:nvSpPr>
+          <p:cNvPr id="7" name="Text 3"/>
+          <p:cNvSpPr txBox="1"/>
+          <p:nvPr/>
+        </p:nvSpPr>
+        <p:spPr>
+          <a:xfrm>
+            <a:off x="548640" y="3977640"/>
+            <a:ext cx="6309360" cy="1097280"/>
+          </a:xfrm>
+          <a:prstGeom prst="rect">
+            <a:avLst/>
+          </a:prstGeom>
+          <a:noFill/>
+          <a:ln/>
+        </p:spPr>
+        <p:txBody>
+          <a:bodyPr wrap="square" lIns="0" tIns="0" rIns="0" bIns="0" rtlCol="0" anchor="t"/>
+          <a:lstStyle/>
+          <a:p>
+            <a:pPr marL="342900" indent="-342900">
+              <a:spcAft>
+                <a:spcPts val="800"/>
+              </a:spcAft>
+              <a:buSzPct val="100000"/>
+              <a:buChar char="•"/>
+            </a:pPr>
+            <a:r>
+              <a:rPr lang="en-US" sz="1800" dirty="0">
+                <a:solidFill>
+                  <a:schemeClr val="tx1"/>
+                </a:solidFill>
+              </a:rPr>
+              <a:t>New objects, actions and contexts</a:t>
+            </a:r>
+            <a:endParaRPr lang="en-US" sz="1800" dirty="0"/>
+          </a:p>
+          <a:p>
+            <a:pPr marL="342900" indent="-342900">
+              <a:spcAft>
+                <a:spcPts val="800"/>
+              </a:spcAft>
+              <a:buSzPct val="100000"/>
+              <a:buChar char="•"/>
+            </a:pPr>
+            <a:r>
+              <a:rPr lang="en-US" sz="1800" dirty="0">
+                <a:solidFill>
+                  <a:schemeClr val="tx1"/>
+                </a:solidFill>
+              </a:rPr>
+              <a:t>Surface similarity varied separately from the relation</a:t>
+            </a:r>
+            <a:endParaRPr lang="en-US" sz="1800" dirty="0"/>
+          </a:p>
+        </p:txBody>
+      </p:sp>
+      <p:sp>
+        <p:nvSpPr>
+          <p:cNvPr id="8" name="Shape 4"/>
           <p:cNvSpPr/>
           <p:nvPr/>
         </p:nvSpPr>
         <p:spPr>
           <a:xfrm>
-            <a:off x="777240" y="1463040"/>
-            <a:ext cx="548640" cy="548640"/>
-          </a:xfrm>
-          <a:prstGeom prst="ellipse">
-            <a:avLst/>
-          </a:prstGeom>
-          <a:solidFill>
-            <a:schemeClr val="accent1"/>
-          </a:solidFill>
-          <a:ln/>
-        </p:spPr>
-      </p:sp>
-      <p:sp>
-        <p:nvSpPr>
-          <p:cNvPr id="4" name="Text 2"/>
-          <p:cNvSpPr txBox="1"/>
-          <p:nvPr/>
-        </p:nvSpPr>
-        <p:spPr>
-          <a:xfrm>
-            <a:off x="777240" y="1463040"/>
-            <a:ext cx="548640" cy="548640"/>
-          </a:xfrm>
-          <a:prstGeom prst="rect">
-            <a:avLst/>
-          </a:prstGeom>
-          <a:noFill/>
-          <a:ln/>
-        </p:spPr>
-        <p:txBody>
-          <a:bodyPr wrap="square" lIns="0" tIns="0" rIns="0" bIns="0" rtlCol="0" anchor="ctr"/>
-          <a:lstStyle/>
-          <a:p>
-            <a:pPr algn="ctr" indent="0" marL="0">
-              <a:buNone/>
-            </a:pPr>
-            <a:r>
-              <a:rPr lang="en-US" sz="2000" b="1" dirty="0">
-                <a:solidFill>
-                  <a:schemeClr val="bg1"/>
-                </a:solidFill>
-              </a:rPr>
-              <a:t>2</a:t>
-            </a:r>
-            <a:endParaRPr lang="en-US" sz="2000" dirty="0"/>
-          </a:p>
-        </p:txBody>
-      </p:sp>
-      <p:sp>
-        <p:nvSpPr>
-          <p:cNvPr id="5" name="Shape 3"/>
-          <p:cNvSpPr/>
-          <p:nvPr/>
-        </p:nvSpPr>
-        <p:spPr>
-          <a:xfrm>
-            <a:off x="548640" y="2194560"/>
-            <a:ext cx="3423818" cy="2377440"/>
+            <a:off x="7223760" y="1371600"/>
+            <a:ext cx="4419295" cy="1828800"/>
           </a:xfrm>
           <a:prstGeom prst="roundRect">
             <a:avLst>
-              <a:gd name="adj" fmla="val 3846"/>
+              <a:gd name="adj" fmla="val 5000"/>
             </a:avLst>
           </a:prstGeom>
           <a:solidFill>
@@ -4221,14 +4921,14 @@
       </p:sp>
       <p:sp>
         <p:nvSpPr>
-          <p:cNvPr id="6" name="Text 4"/>
+          <p:cNvPr id="9" name="Text 5"/>
           <p:cNvSpPr txBox="1"/>
           <p:nvPr/>
         </p:nvSpPr>
         <p:spPr>
           <a:xfrm>
-            <a:off x="777240" y="2377440"/>
-            <a:ext cx="2966618" cy="2011680"/>
+            <a:off x="7452360" y="1554480"/>
+            <a:ext cx="3962095" cy="1463040"/>
           </a:xfrm>
           <a:prstGeom prst="rect">
             <a:avLst/>
@@ -4252,7 +4952,7 @@
                   <a:schemeClr val="tx2"/>
                 </a:solidFill>
               </a:rPr>
-              <a:t>Comparison</a:t>
+              <a:t>Builds on</a:t>
             </a:r>
             <a:endParaRPr lang="en-US" sz="1800" dirty="0"/>
           </a:p>
@@ -4269,82 +4969,43 @@
                   <a:schemeClr val="tx1"/>
                 </a:solidFill>
               </a:rPr>
-              <a:t>Do aligned examples and explanation prompts help children generalize?</a:t>
-            </a:r>
-            <a:endParaRPr lang="en-US" sz="1800" dirty="0"/>
-          </a:p>
-        </p:txBody>
-      </p:sp>
-      <p:sp>
-        <p:nvSpPr>
-          <p:cNvPr id="7" name="Shape 5"/>
+              <a:t>Comparison: Christie &amp; Gentner (2010)</a:t>
+            </a:r>
+            <a:endParaRPr lang="en-US" sz="1800" dirty="0"/>
+          </a:p>
+          <a:p>
+            <a:pPr indent="0" marL="0">
+              <a:spcAft>
+                <a:spcPts val="600"/>
+              </a:spcAft>
+              <a:buNone/>
+            </a:pPr>
+            <a:r>
+              <a:rPr lang="en-US" sz="1800" dirty="0">
+                <a:solidFill>
+                  <a:schemeClr val="tx1"/>
+                </a:solidFill>
+              </a:rPr>
+              <a:t>Direction 1 language</a:t>
+            </a:r>
+            <a:endParaRPr lang="en-US" sz="1800" dirty="0"/>
+          </a:p>
+        </p:txBody>
+      </p:sp>
+      <p:sp>
+        <p:nvSpPr>
+          <p:cNvPr id="10" name="Shape 6"/>
           <p:cNvSpPr/>
           <p:nvPr/>
         </p:nvSpPr>
         <p:spPr>
           <a:xfrm>
-            <a:off x="4612538" y="1463040"/>
-            <a:ext cx="548640" cy="548640"/>
-          </a:xfrm>
-          <a:prstGeom prst="ellipse">
-            <a:avLst/>
-          </a:prstGeom>
-          <a:solidFill>
-            <a:schemeClr val="accent1"/>
-          </a:solidFill>
-          <a:ln/>
-        </p:spPr>
-      </p:sp>
-      <p:sp>
-        <p:nvSpPr>
-          <p:cNvPr id="8" name="Text 6"/>
-          <p:cNvSpPr txBox="1"/>
-          <p:nvPr/>
-        </p:nvSpPr>
-        <p:spPr>
-          <a:xfrm>
-            <a:off x="4612538" y="1463040"/>
-            <a:ext cx="548640" cy="548640"/>
-          </a:xfrm>
-          <a:prstGeom prst="rect">
-            <a:avLst/>
-          </a:prstGeom>
-          <a:noFill/>
-          <a:ln/>
-        </p:spPr>
-        <p:txBody>
-          <a:bodyPr wrap="square" lIns="0" tIns="0" rIns="0" bIns="0" rtlCol="0" anchor="ctr"/>
-          <a:lstStyle/>
-          <a:p>
-            <a:pPr algn="ctr" indent="0" marL="0">
-              <a:buNone/>
-            </a:pPr>
-            <a:r>
-              <a:rPr lang="en-US" sz="2000" b="1" dirty="0">
-                <a:solidFill>
-                  <a:schemeClr val="bg1"/>
-                </a:solidFill>
-              </a:rPr>
-              <a:t>3</a:t>
-            </a:r>
-            <a:endParaRPr lang="en-US" sz="2000" dirty="0"/>
-          </a:p>
-        </p:txBody>
-      </p:sp>
-      <p:sp>
-        <p:nvSpPr>
-          <p:cNvPr id="9" name="Shape 7"/>
-          <p:cNvSpPr/>
-          <p:nvPr/>
-        </p:nvSpPr>
-        <p:spPr>
-          <a:xfrm>
-            <a:off x="4383938" y="2194560"/>
-            <a:ext cx="3423818" cy="2377440"/>
+            <a:off x="7223760" y="3383280"/>
+            <a:ext cx="4419295" cy="1554480"/>
           </a:xfrm>
           <a:prstGeom prst="roundRect">
             <a:avLst>
-              <a:gd name="adj" fmla="val 3846"/>
+              <a:gd name="adj" fmla="val 5882"/>
             </a:avLst>
           </a:prstGeom>
           <a:solidFill>
@@ -4355,14 +5016,14 @@
       </p:sp>
       <p:sp>
         <p:nvSpPr>
-          <p:cNvPr id="10" name="Text 8"/>
+          <p:cNvPr id="11" name="Text 7"/>
           <p:cNvSpPr txBox="1"/>
           <p:nvPr/>
         </p:nvSpPr>
         <p:spPr>
           <a:xfrm>
-            <a:off x="4612538" y="2377440"/>
-            <a:ext cx="2966618" cy="2011680"/>
+            <a:off x="7452360" y="3566160"/>
+            <a:ext cx="3962095" cy="1188720"/>
           </a:xfrm>
           <a:prstGeom prst="rect">
             <a:avLst/>
@@ -4386,7 +5047,7 @@
                   <a:schemeClr val="tx2"/>
                 </a:solidFill>
               </a:rPr>
-              <a:t>Parent–child play</a:t>
+              <a:t>Asks</a:t>
             </a:r>
             <a:endParaRPr lang="en-US" sz="1800" dirty="0"/>
           </a:p>
@@ -4403,155 +5064,21 @@
                   <a:schemeClr val="tx1"/>
                 </a:solidFill>
               </a:rPr>
-              <a:t>How does relational talk shape attention and exploration?</a:t>
-            </a:r>
-            <a:endParaRPr lang="en-US" sz="1800" dirty="0"/>
-          </a:p>
-        </p:txBody>
-      </p:sp>
-      <p:sp>
-        <p:nvSpPr>
-          <p:cNvPr id="11" name="Shape 9"/>
+              <a:t>When do children use the relation, not appearance?</a:t>
+            </a:r>
+            <a:endParaRPr lang="en-US" sz="1800" dirty="0"/>
+          </a:p>
+        </p:txBody>
+      </p:sp>
+      <p:sp>
+        <p:nvSpPr>
+          <p:cNvPr id="12" name="Shape 8"/>
           <p:cNvSpPr/>
           <p:nvPr/>
         </p:nvSpPr>
         <p:spPr>
           <a:xfrm>
-            <a:off x="8447837" y="1463040"/>
-            <a:ext cx="548640" cy="548640"/>
-          </a:xfrm>
-          <a:prstGeom prst="ellipse">
-            <a:avLst/>
-          </a:prstGeom>
-          <a:solidFill>
-            <a:schemeClr val="accent1"/>
-          </a:solidFill>
-          <a:ln/>
-        </p:spPr>
-      </p:sp>
-      <p:sp>
-        <p:nvSpPr>
-          <p:cNvPr id="12" name="Text 10"/>
-          <p:cNvSpPr txBox="1"/>
-          <p:nvPr/>
-        </p:nvSpPr>
-        <p:spPr>
-          <a:xfrm>
-            <a:off x="8447837" y="1463040"/>
-            <a:ext cx="548640" cy="548640"/>
-          </a:xfrm>
-          <a:prstGeom prst="rect">
-            <a:avLst/>
-          </a:prstGeom>
-          <a:noFill/>
-          <a:ln/>
-        </p:spPr>
-        <p:txBody>
-          <a:bodyPr wrap="square" lIns="0" tIns="0" rIns="0" bIns="0" rtlCol="0" anchor="ctr"/>
-          <a:lstStyle/>
-          <a:p>
-            <a:pPr algn="ctr" indent="0" marL="0">
-              <a:buNone/>
-            </a:pPr>
-            <a:r>
-              <a:rPr lang="en-US" sz="2000" b="1" dirty="0">
-                <a:solidFill>
-                  <a:schemeClr val="bg1"/>
-                </a:solidFill>
-              </a:rPr>
-              <a:t>4</a:t>
-            </a:r>
-            <a:endParaRPr lang="en-US" sz="2000" dirty="0"/>
-          </a:p>
-        </p:txBody>
-      </p:sp>
-      <p:sp>
-        <p:nvSpPr>
-          <p:cNvPr id="13" name="Shape 11"/>
-          <p:cNvSpPr/>
-          <p:nvPr/>
-        </p:nvSpPr>
-        <p:spPr>
-          <a:xfrm>
-            <a:off x="8219237" y="2194560"/>
-            <a:ext cx="3423818" cy="2377440"/>
-          </a:xfrm>
-          <a:prstGeom prst="roundRect">
-            <a:avLst>
-              <a:gd name="adj" fmla="val 3846"/>
-            </a:avLst>
-          </a:prstGeom>
-          <a:solidFill>
-            <a:schemeClr val="bg2"/>
-          </a:solidFill>
-          <a:ln/>
-        </p:spPr>
-      </p:sp>
-      <p:sp>
-        <p:nvSpPr>
-          <p:cNvPr id="14" name="Text 12"/>
-          <p:cNvSpPr txBox="1"/>
-          <p:nvPr/>
-        </p:nvSpPr>
-        <p:spPr>
-          <a:xfrm>
-            <a:off x="8447837" y="2377440"/>
-            <a:ext cx="2966618" cy="2011680"/>
-          </a:xfrm>
-          <a:prstGeom prst="rect">
-            <a:avLst/>
-          </a:prstGeom>
-          <a:noFill/>
-          <a:ln/>
-        </p:spPr>
-        <p:txBody>
-          <a:bodyPr wrap="square" lIns="0" tIns="0" rIns="0" bIns="0" rtlCol="0" anchor="t"/>
-          <a:lstStyle/>
-          <a:p>
-            <a:pPr indent="0" marL="0">
-              <a:spcAft>
-                <a:spcPts val="600"/>
-              </a:spcAft>
-              <a:buNone/>
-            </a:pPr>
-            <a:r>
-              <a:rPr lang="en-US" sz="2200" b="1" dirty="0">
-                <a:solidFill>
-                  <a:schemeClr val="tx2"/>
-                </a:solidFill>
-              </a:rPr>
-              <a:t>Children and AI</a:t>
-            </a:r>
-            <a:endParaRPr lang="en-US" sz="1800" dirty="0"/>
-          </a:p>
-          <a:p>
-            <a:pPr indent="0" marL="0">
-              <a:spcAft>
-                <a:spcPts val="600"/>
-              </a:spcAft>
-              <a:buNone/>
-            </a:pPr>
-            <a:r>
-              <a:rPr lang="en-US" sz="1800" dirty="0">
-                <a:solidFill>
-                  <a:schemeClr val="tx1"/>
-                </a:solidFill>
-              </a:rPr>
-              <a:t>Same tasks for children and models: which cues drive transfer?</a:t>
-            </a:r>
-            <a:endParaRPr lang="en-US" sz="1800" dirty="0"/>
-          </a:p>
-        </p:txBody>
-      </p:sp>
-      <p:sp>
-        <p:nvSpPr>
-          <p:cNvPr id="15" name="Shape 13"/>
-          <p:cNvSpPr/>
-          <p:nvPr/>
-        </p:nvSpPr>
-        <p:spPr>
-          <a:xfrm>
-            <a:off x="548640" y="4892040"/>
+            <a:off x="548640" y="5257800"/>
             <a:ext cx="11094415" cy="685800"/>
           </a:xfrm>
           <a:prstGeom prst="roundRect">
@@ -4567,13 +5094,13 @@
       </p:sp>
       <p:sp>
         <p:nvSpPr>
-          <p:cNvPr id="16" name="Text 14"/>
+          <p:cNvPr id="13" name="Text 9"/>
           <p:cNvSpPr txBox="1"/>
           <p:nvPr/>
         </p:nvSpPr>
         <p:spPr>
           <a:xfrm>
-            <a:off x="777240" y="4892040"/>
+            <a:off x="777240" y="5257800"/>
             <a:ext cx="10637215" cy="685800"/>
           </a:xfrm>
           <a:prstGeom prst="rect">
@@ -4606,7 +5133,7 @@
                   <a:schemeClr val="tx1"/>
                 </a:solidFill>
               </a:rPr>
-              <a:t>Within-language manipulations first; cross-linguistic evidence second.</a:t>
+              <a:t>Prediction: comparison &gt; one event; explanation adds most for far transfer.</a:t>
             </a:r>
             <a:endParaRPr lang="en-US" sz="1800" dirty="0"/>
           </a:p>
@@ -4685,6 +5212,687 @@
       <p:sp>
         <p:nvSpPr>
           <p:cNvPr id="2" name="Text 0"/>
+          <p:cNvSpPr/>
+          <p:nvPr>
+            <p:ph idx="100" type="title" hasCustomPrompt="1"/>
+          </p:nvPr>
+        </p:nvSpPr>
+        <p:spPr>
+          <a:xfrm>
+            <a:off x="548640" y="365760"/>
+            <a:ext cx="11094415" cy="731520"/>
+          </a:xfrm>
+          <a:prstGeom prst="rect">
+            <a:avLst/>
+          </a:prstGeom>
+          <a:noFill/>
+          <a:ln/>
+        </p:spPr>
+        <p:txBody>
+          <a:bodyPr wrap="square" lIns="0" tIns="0" rIns="0" bIns="0" rtlCol="0" anchor="ctr"/>
+          <a:lstStyle/>
+          <a:p>
+            <a:pPr algn="l" indent="0" marL="0">
+              <a:buNone/>
+            </a:pPr>
+            <a:r>
+              <a:rPr lang="en-US" sz="3000" b="1" dirty="0">
+                <a:solidFill>
+                  <a:schemeClr val="tx2"/>
+                </a:solidFill>
+              </a:rPr>
+              <a:t>A two-year plan</a:t>
+            </a:r>
+            <a:endParaRPr lang="en-US" sz="3000" dirty="0"/>
+          </a:p>
+        </p:txBody>
+      </p:sp>
+      <p:sp>
+        <p:nvSpPr>
+          <p:cNvPr id="4" name="Shape 1"/>
+          <p:cNvSpPr/>
+          <p:nvPr/>
+        </p:nvSpPr>
+        <p:spPr>
+          <a:xfrm>
+            <a:off x="777240" y="1463040"/>
+            <a:ext cx="548640" cy="548640"/>
+          </a:xfrm>
+          <a:prstGeom prst="ellipse">
+            <a:avLst/>
+          </a:prstGeom>
+          <a:solidFill>
+            <a:schemeClr val="accent1"/>
+          </a:solidFill>
+          <a:ln/>
+        </p:spPr>
+      </p:sp>
+      <p:sp>
+        <p:nvSpPr>
+          <p:cNvPr id="5" name="Text 2"/>
+          <p:cNvSpPr txBox="1"/>
+          <p:nvPr/>
+        </p:nvSpPr>
+        <p:spPr>
+          <a:xfrm>
+            <a:off x="777240" y="1463040"/>
+            <a:ext cx="548640" cy="548640"/>
+          </a:xfrm>
+          <a:prstGeom prst="rect">
+            <a:avLst/>
+          </a:prstGeom>
+          <a:noFill/>
+          <a:ln/>
+        </p:spPr>
+        <p:txBody>
+          <a:bodyPr wrap="square" lIns="0" tIns="0" rIns="0" bIns="0" rtlCol="0" anchor="ctr"/>
+          <a:lstStyle/>
+          <a:p>
+            <a:pPr algn="ctr" indent="0" marL="0">
+              <a:buNone/>
+            </a:pPr>
+            <a:r>
+              <a:rPr lang="en-US" sz="2000" b="1" dirty="0">
+                <a:solidFill>
+                  <a:schemeClr val="bg1"/>
+                </a:solidFill>
+              </a:rPr>
+              <a:t>1</a:t>
+            </a:r>
+            <a:endParaRPr lang="en-US" sz="2000" dirty="0"/>
+          </a:p>
+        </p:txBody>
+      </p:sp>
+      <p:sp>
+        <p:nvSpPr>
+          <p:cNvPr id="6" name="Shape 3"/>
+          <p:cNvSpPr/>
+          <p:nvPr/>
+        </p:nvSpPr>
+        <p:spPr>
+          <a:xfrm>
+            <a:off x="548640" y="2194560"/>
+            <a:ext cx="3423818" cy="2377440"/>
+          </a:xfrm>
+          <a:prstGeom prst="roundRect">
+            <a:avLst>
+              <a:gd name="adj" fmla="val 3846"/>
+            </a:avLst>
+          </a:prstGeom>
+          <a:solidFill>
+            <a:schemeClr val="bg2"/>
+          </a:solidFill>
+          <a:ln/>
+        </p:spPr>
+      </p:sp>
+      <p:sp>
+        <p:nvSpPr>
+          <p:cNvPr id="7" name="Text 4"/>
+          <p:cNvSpPr txBox="1"/>
+          <p:nvPr/>
+        </p:nvSpPr>
+        <p:spPr>
+          <a:xfrm>
+            <a:off x="777240" y="2377440"/>
+            <a:ext cx="2966618" cy="2011680"/>
+          </a:xfrm>
+          <a:prstGeom prst="rect">
+            <a:avLst/>
+          </a:prstGeom>
+          <a:noFill/>
+          <a:ln/>
+        </p:spPr>
+        <p:txBody>
+          <a:bodyPr wrap="square" lIns="0" tIns="0" rIns="0" bIns="0" rtlCol="0" anchor="t"/>
+          <a:lstStyle/>
+          <a:p>
+            <a:pPr indent="0" marL="0">
+              <a:spcAft>
+                <a:spcPts val="600"/>
+              </a:spcAft>
+              <a:buNone/>
+            </a:pPr>
+            <a:r>
+              <a:rPr lang="en-US" sz="2200" b="1" dirty="0">
+                <a:solidFill>
+                  <a:schemeClr val="tx2"/>
+                </a:solidFill>
+              </a:rPr>
+              <a:t>Year 1</a:t>
+            </a:r>
+            <a:endParaRPr lang="en-US" sz="1800" dirty="0"/>
+          </a:p>
+          <a:p>
+            <a:pPr indent="0" marL="0">
+              <a:spcAft>
+                <a:spcPts val="600"/>
+              </a:spcAft>
+              <a:buNone/>
+            </a:pPr>
+            <a:r>
+              <a:rPr lang="en-US" sz="1800" dirty="0">
+                <a:solidFill>
+                  <a:schemeClr val="tx1"/>
+                </a:solidFill>
+              </a:rPr>
+              <a:t>Direction 1</a:t>
+            </a:r>
+            <a:endParaRPr lang="en-US" sz="1800" dirty="0"/>
+          </a:p>
+          <a:p>
+            <a:pPr indent="0" marL="0">
+              <a:spcAft>
+                <a:spcPts val="600"/>
+              </a:spcAft>
+              <a:buNone/>
+            </a:pPr>
+            <a:r>
+              <a:rPr lang="en-US" sz="1800" dirty="0">
+                <a:solidFill>
+                  <a:schemeClr val="tx1"/>
+                </a:solidFill>
+              </a:rPr>
+              <a:t>Two preregistered experiments</a:t>
+            </a:r>
+            <a:endParaRPr lang="en-US" sz="1800" dirty="0"/>
+          </a:p>
+          <a:p>
+            <a:pPr indent="0" marL="0">
+              <a:spcAft>
+                <a:spcPts val="600"/>
+              </a:spcAft>
+              <a:buNone/>
+            </a:pPr>
+            <a:r>
+              <a:rPr lang="en-US" sz="1800" dirty="0">
+                <a:solidFill>
+                  <a:schemeClr val="tx1"/>
+                </a:solidFill>
+              </a:rPr>
+              <a:t>One paper</a:t>
+            </a:r>
+            <a:endParaRPr lang="en-US" sz="1800" dirty="0"/>
+          </a:p>
+        </p:txBody>
+      </p:sp>
+      <p:sp>
+        <p:nvSpPr>
+          <p:cNvPr id="8" name="Shape 5"/>
+          <p:cNvSpPr/>
+          <p:nvPr/>
+        </p:nvSpPr>
+        <p:spPr>
+          <a:xfrm>
+            <a:off x="4612538" y="1463040"/>
+            <a:ext cx="548640" cy="548640"/>
+          </a:xfrm>
+          <a:prstGeom prst="ellipse">
+            <a:avLst/>
+          </a:prstGeom>
+          <a:solidFill>
+            <a:schemeClr val="accent1"/>
+          </a:solidFill>
+          <a:ln/>
+        </p:spPr>
+      </p:sp>
+      <p:sp>
+        <p:nvSpPr>
+          <p:cNvPr id="9" name="Text 6"/>
+          <p:cNvSpPr txBox="1"/>
+          <p:nvPr/>
+        </p:nvSpPr>
+        <p:spPr>
+          <a:xfrm>
+            <a:off x="4612538" y="1463040"/>
+            <a:ext cx="548640" cy="548640"/>
+          </a:xfrm>
+          <a:prstGeom prst="rect">
+            <a:avLst/>
+          </a:prstGeom>
+          <a:noFill/>
+          <a:ln/>
+        </p:spPr>
+        <p:txBody>
+          <a:bodyPr wrap="square" lIns="0" tIns="0" rIns="0" bIns="0" rtlCol="0" anchor="ctr"/>
+          <a:lstStyle/>
+          <a:p>
+            <a:pPr algn="ctr" indent="0" marL="0">
+              <a:buNone/>
+            </a:pPr>
+            <a:r>
+              <a:rPr lang="en-US" sz="2000" b="1" dirty="0">
+                <a:solidFill>
+                  <a:schemeClr val="bg1"/>
+                </a:solidFill>
+              </a:rPr>
+              <a:t>2</a:t>
+            </a:r>
+            <a:endParaRPr lang="en-US" sz="2000" dirty="0"/>
+          </a:p>
+        </p:txBody>
+      </p:sp>
+      <p:sp>
+        <p:nvSpPr>
+          <p:cNvPr id="10" name="Shape 7"/>
+          <p:cNvSpPr/>
+          <p:nvPr/>
+        </p:nvSpPr>
+        <p:spPr>
+          <a:xfrm>
+            <a:off x="4383938" y="2194560"/>
+            <a:ext cx="3423818" cy="2377440"/>
+          </a:xfrm>
+          <a:prstGeom prst="roundRect">
+            <a:avLst>
+              <a:gd name="adj" fmla="val 3846"/>
+            </a:avLst>
+          </a:prstGeom>
+          <a:solidFill>
+            <a:schemeClr val="bg2"/>
+          </a:solidFill>
+          <a:ln/>
+        </p:spPr>
+      </p:sp>
+      <p:sp>
+        <p:nvSpPr>
+          <p:cNvPr id="11" name="Text 8"/>
+          <p:cNvSpPr txBox="1"/>
+          <p:nvPr/>
+        </p:nvSpPr>
+        <p:spPr>
+          <a:xfrm>
+            <a:off x="4612538" y="2377440"/>
+            <a:ext cx="2966618" cy="2011680"/>
+          </a:xfrm>
+          <a:prstGeom prst="rect">
+            <a:avLst/>
+          </a:prstGeom>
+          <a:noFill/>
+          <a:ln/>
+        </p:spPr>
+        <p:txBody>
+          <a:bodyPr wrap="square" lIns="0" tIns="0" rIns="0" bIns="0" rtlCol="0" anchor="t"/>
+          <a:lstStyle/>
+          <a:p>
+            <a:pPr indent="0" marL="0">
+              <a:spcAft>
+                <a:spcPts val="600"/>
+              </a:spcAft>
+              <a:buNone/>
+            </a:pPr>
+            <a:r>
+              <a:rPr lang="en-US" sz="2200" b="1" dirty="0">
+                <a:solidFill>
+                  <a:schemeClr val="tx2"/>
+                </a:solidFill>
+              </a:rPr>
+              <a:t>Year 2</a:t>
+            </a:r>
+            <a:endParaRPr lang="en-US" sz="1800" dirty="0"/>
+          </a:p>
+          <a:p>
+            <a:pPr indent="0" marL="0">
+              <a:spcAft>
+                <a:spcPts val="600"/>
+              </a:spcAft>
+              <a:buNone/>
+            </a:pPr>
+            <a:r>
+              <a:rPr lang="en-US" sz="1800" dirty="0">
+                <a:solidFill>
+                  <a:schemeClr val="tx1"/>
+                </a:solidFill>
+              </a:rPr>
+              <a:t>Direction 2</a:t>
+            </a:r>
+            <a:endParaRPr lang="en-US" sz="1800" dirty="0"/>
+          </a:p>
+          <a:p>
+            <a:pPr indent="0" marL="0">
+              <a:spcAft>
+                <a:spcPts val="600"/>
+              </a:spcAft>
+              <a:buNone/>
+            </a:pPr>
+            <a:r>
+              <a:rPr lang="en-US" sz="1800" dirty="0">
+                <a:solidFill>
+                  <a:schemeClr val="tx1"/>
+                </a:solidFill>
+              </a:rPr>
+              <a:t>Pilot: parent–child play</a:t>
+            </a:r>
+            <a:endParaRPr lang="en-US" sz="1800" dirty="0"/>
+          </a:p>
+          <a:p>
+            <a:pPr indent="0" marL="0">
+              <a:spcAft>
+                <a:spcPts val="600"/>
+              </a:spcAft>
+              <a:buNone/>
+            </a:pPr>
+            <a:r>
+              <a:rPr lang="en-US" sz="1800" dirty="0">
+                <a:solidFill>
+                  <a:schemeClr val="tx1"/>
+                </a:solidFill>
+              </a:rPr>
+              <a:t>Pilot: children vs. AI</a:t>
+            </a:r>
+            <a:endParaRPr lang="en-US" sz="1800" dirty="0"/>
+          </a:p>
+        </p:txBody>
+      </p:sp>
+      <p:sp>
+        <p:nvSpPr>
+          <p:cNvPr id="12" name="Shape 9"/>
+          <p:cNvSpPr/>
+          <p:nvPr/>
+        </p:nvSpPr>
+        <p:spPr>
+          <a:xfrm>
+            <a:off x="8447837" y="1463040"/>
+            <a:ext cx="548640" cy="548640"/>
+          </a:xfrm>
+          <a:prstGeom prst="ellipse">
+            <a:avLst/>
+          </a:prstGeom>
+          <a:solidFill>
+            <a:schemeClr val="accent2"/>
+          </a:solidFill>
+          <a:ln/>
+        </p:spPr>
+      </p:sp>
+      <p:sp>
+        <p:nvSpPr>
+          <p:cNvPr id="13" name="Text 10"/>
+          <p:cNvSpPr txBox="1"/>
+          <p:nvPr/>
+        </p:nvSpPr>
+        <p:spPr>
+          <a:xfrm>
+            <a:off x="8447837" y="1463040"/>
+            <a:ext cx="548640" cy="548640"/>
+          </a:xfrm>
+          <a:prstGeom prst="rect">
+            <a:avLst/>
+          </a:prstGeom>
+          <a:noFill/>
+          <a:ln/>
+        </p:spPr>
+        <p:txBody>
+          <a:bodyPr wrap="square" lIns="0" tIns="0" rIns="0" bIns="0" rtlCol="0" anchor="ctr"/>
+          <a:lstStyle/>
+          <a:p>
+            <a:pPr algn="ctr" indent="0" marL="0">
+              <a:buNone/>
+            </a:pPr>
+            <a:r>
+              <a:rPr lang="en-US" sz="2000" b="1" dirty="0">
+                <a:solidFill>
+                  <a:schemeClr val="bg1"/>
+                </a:solidFill>
+              </a:rPr>
+              <a:t>3</a:t>
+            </a:r>
+            <a:endParaRPr lang="en-US" sz="2000" dirty="0"/>
+          </a:p>
+        </p:txBody>
+      </p:sp>
+      <p:sp>
+        <p:nvSpPr>
+          <p:cNvPr id="14" name="Shape 11"/>
+          <p:cNvSpPr/>
+          <p:nvPr/>
+        </p:nvSpPr>
+        <p:spPr>
+          <a:xfrm>
+            <a:off x="8219237" y="2194560"/>
+            <a:ext cx="3423818" cy="2377440"/>
+          </a:xfrm>
+          <a:prstGeom prst="roundRect">
+            <a:avLst>
+              <a:gd name="adj" fmla="val 3846"/>
+            </a:avLst>
+          </a:prstGeom>
+          <a:solidFill>
+            <a:schemeClr val="bg2"/>
+          </a:solidFill>
+          <a:ln/>
+        </p:spPr>
+      </p:sp>
+      <p:sp>
+        <p:nvSpPr>
+          <p:cNvPr id="15" name="Text 12"/>
+          <p:cNvSpPr txBox="1"/>
+          <p:nvPr/>
+        </p:nvSpPr>
+        <p:spPr>
+          <a:xfrm>
+            <a:off x="8447837" y="2377440"/>
+            <a:ext cx="2966618" cy="2011680"/>
+          </a:xfrm>
+          <a:prstGeom prst="rect">
+            <a:avLst/>
+          </a:prstGeom>
+          <a:noFill/>
+          <a:ln/>
+        </p:spPr>
+        <p:txBody>
+          <a:bodyPr wrap="square" lIns="0" tIns="0" rIns="0" bIns="0" rtlCol="0" anchor="t"/>
+          <a:lstStyle/>
+          <a:p>
+            <a:pPr indent="0" marL="0">
+              <a:spcAft>
+                <a:spcPts val="600"/>
+              </a:spcAft>
+              <a:buNone/>
+            </a:pPr>
+            <a:r>
+              <a:rPr lang="en-US" sz="2200" b="1" dirty="0">
+                <a:solidFill>
+                  <a:schemeClr val="tx2"/>
+                </a:solidFill>
+              </a:rPr>
+              <a:t>Throughout</a:t>
+            </a:r>
+            <a:endParaRPr lang="en-US" sz="1800" dirty="0"/>
+          </a:p>
+          <a:p>
+            <a:pPr indent="0" marL="0">
+              <a:spcAft>
+                <a:spcPts val="600"/>
+              </a:spcAft>
+              <a:buNone/>
+            </a:pPr>
+            <a:r>
+              <a:rPr lang="en-US" sz="1800" dirty="0">
+                <a:solidFill>
+                  <a:schemeClr val="tx1"/>
+                </a:solidFill>
+              </a:rPr>
+              <a:t>Thesis papers</a:t>
+            </a:r>
+            <a:endParaRPr lang="en-US" sz="1800" dirty="0"/>
+          </a:p>
+          <a:p>
+            <a:pPr indent="0" marL="0">
+              <a:spcAft>
+                <a:spcPts val="600"/>
+              </a:spcAft>
+              <a:buNone/>
+            </a:pPr>
+            <a:r>
+              <a:rPr lang="en-US" sz="1800" dirty="0">
+                <a:solidFill>
+                  <a:schemeClr val="tx1"/>
+                </a:solidFill>
+              </a:rPr>
+              <a:t>Grant applications</a:t>
+            </a:r>
+            <a:endParaRPr lang="en-US" sz="1800" dirty="0"/>
+          </a:p>
+          <a:p>
+            <a:pPr indent="0" marL="0">
+              <a:spcAft>
+                <a:spcPts val="600"/>
+              </a:spcAft>
+              <a:buNone/>
+            </a:pPr>
+            <a:r>
+              <a:rPr lang="en-US" sz="1800" dirty="0">
+                <a:solidFill>
+                  <a:schemeClr val="tx1"/>
+                </a:solidFill>
+              </a:rPr>
+              <a:t>Mentoring students</a:t>
+            </a:r>
+            <a:endParaRPr lang="en-US" sz="1800" dirty="0"/>
+          </a:p>
+        </p:txBody>
+      </p:sp>
+      <p:sp>
+        <p:nvSpPr>
+          <p:cNvPr id="16" name="Shape 13"/>
+          <p:cNvSpPr/>
+          <p:nvPr/>
+        </p:nvSpPr>
+        <p:spPr>
+          <a:xfrm>
+            <a:off x="548640" y="4892040"/>
+            <a:ext cx="11094415" cy="685800"/>
+          </a:xfrm>
+          <a:prstGeom prst="roundRect">
+            <a:avLst>
+              <a:gd name="adj" fmla="val 10667"/>
+            </a:avLst>
+          </a:prstGeom>
+          <a:solidFill>
+            <a:schemeClr val="bg2"/>
+          </a:solidFill>
+          <a:ln/>
+        </p:spPr>
+      </p:sp>
+      <p:sp>
+        <p:nvSpPr>
+          <p:cNvPr id="17" name="Text 14"/>
+          <p:cNvSpPr txBox="1"/>
+          <p:nvPr/>
+        </p:nvSpPr>
+        <p:spPr>
+          <a:xfrm>
+            <a:off x="777240" y="4892040"/>
+            <a:ext cx="10637215" cy="685800"/>
+          </a:xfrm>
+          <a:prstGeom prst="rect">
+            <a:avLst/>
+          </a:prstGeom>
+          <a:noFill/>
+          <a:ln/>
+        </p:spPr>
+        <p:txBody>
+          <a:bodyPr wrap="square" lIns="0" tIns="0" rIns="0" bIns="0" rtlCol="0" anchor="ctr"/>
+          <a:lstStyle/>
+          <a:p>
+            <a:pPr indent="0" marL="0">
+              <a:buNone/>
+            </a:pPr>
+            <a:r>
+              <a:rPr lang="en-US" sz="1800" b="1" dirty="0">
+                <a:solidFill>
+                  <a:schemeClr val="accent2"/>
+                </a:solidFill>
+              </a:rPr>
+              <a:t>Takeaway   </a:t>
+            </a:r>
+            <a:pPr indent="0" marL="0">
+              <a:buNone/>
+            </a:pPr>
+            <a:r>
+              <a:rPr lang="en-US" sz="1800" dirty="0">
+                <a:solidFill>
+                  <a:schemeClr val="tx1"/>
+                </a:solidFill>
+              </a:rPr>
+              <a:t>Three learning tools for event relations: naming, comparing, explaining.</a:t>
+            </a:r>
+            <a:endParaRPr lang="en-US" sz="1800" dirty="0"/>
+          </a:p>
+        </p:txBody>
+      </p:sp>
+      <p:sp>
+        <p:nvSpPr>
+          <p:cNvPr id="25" name="Slide Number Placeholder 0"/>
+          <p:cNvSpPr>
+            <a:spLocks noGrp="1"/>
+          </p:cNvSpPr>
+          <p:nvPr>
+            <p:ph type="sldNum" sz="quarter" idx="4294967295"/>
+          </p:nvPr>
+        </p:nvSpPr>
+        <p:spPr>
+          <a:xfrm>
+            <a:off x="11002975" y="6355080"/>
+            <a:ext cx="640080" cy="365760"/>
+          </a:xfrm>
+          <a:prstGeom prst="rect">
+            <a:avLst/>
+          </a:prstGeom>
+          <a:extLst>
+            <a:ext uri="{C572A759-6A51-4108-AA02-DFA0A04FC94B}">
+              <ma14:wrappingTextBoxFlag xmlns:ma14="http://schemas.microsoft.com/office/mac/drawingml/2011/main" val="0"/>
+            </a:ext>
+          </a:extLst>
+        </p:spPr>
+        <p:txBody>
+          <a:bodyPr/>
+          <a:lstStyle>
+            <a:lvl1pPr>
+              <a:defRPr sz="1800">
+                <a:solidFill>
+                  <a:schemeClr val="accent3"/>
+                </a:solidFill>
+              </a:defRPr>
+            </a:lvl1pPr>
+          </a:lstStyle>
+          <a:p>
+            <a:pPr algn="r"/>
+            <a:fld id="{F7021451-1387-4CA6-816F-3879F97B5CBC}" type="slidenum">
+              <a:rPr b="0" lang="en-US"/>
+              <a:t>12</a:t>
+            </a:fld>
+            <a:endParaRPr lang="en-US"/>
+          </a:p>
+        </p:txBody>
+      </p:sp>
+    </p:spTree>
+  </p:cSld>
+  <p:clrMapOvr>
+    <a:masterClrMapping/>
+  </p:clrMapOvr>
+</p:sld>
+</file>
+
+<file path=ppt/slides/slide13.xml><?xml version="1.0" encoding="utf-8"?>
+<p:sld xmlns:a="http://schemas.openxmlformats.org/drawingml/2006/main" xmlns:r="http://schemas.openxmlformats.org/officeDocument/2006/relationships" xmlns:p="http://schemas.openxmlformats.org/presentationml/2006/main">
+  <p:cSld name="Slide 13">
+    <p:spTree>
+      <p:nvGrpSpPr>
+        <p:cNvPr id="1" name=""/>
+        <p:cNvGrpSpPr/>
+        <p:nvPr/>
+      </p:nvGrpSpPr>
+      <p:grpSpPr>
+        <a:xfrm>
+          <a:off x="0" y="0"/>
+          <a:ext cx="0" cy="0"/>
+          <a:chOff x="0" y="0"/>
+          <a:chExt cx="0" cy="0"/>
+        </a:xfrm>
+      </p:grpSpPr>
+      <p:sp>
+        <p:nvSpPr>
+          <p:cNvPr id="3" name="Text 0"/>
           <p:cNvSpPr txBox="1"/>
           <p:nvPr/>
         </p:nvSpPr>
@@ -4720,7 +5928,7 @@
       </p:sp>
       <p:sp>
         <p:nvSpPr>
-          <p:cNvPr id="3" name="Text 1"/>
+          <p:cNvPr id="4" name="Text 1"/>
           <p:cNvSpPr txBox="1"/>
           <p:nvPr/>
         </p:nvSpPr>
@@ -4810,7 +6018,7 @@
       </p:sp>
       <p:sp>
         <p:nvSpPr>
-          <p:cNvPr id="4" name="Text 2"/>
+          <p:cNvPr id="5" name="Text 2"/>
           <p:cNvSpPr txBox="1"/>
           <p:nvPr/>
         </p:nvSpPr>
@@ -4900,7 +6108,7 @@
       </p:sp>
       <p:sp>
         <p:nvSpPr>
-          <p:cNvPr id="5" name="Text 3"/>
+          <p:cNvPr id="6" name="Text 3"/>
           <p:cNvSpPr txBox="1"/>
           <p:nvPr/>
         </p:nvSpPr>
@@ -4990,7 +6198,7 @@
       </p:sp>
       <p:sp>
         <p:nvSpPr>
-          <p:cNvPr id="6" name="Text 4"/>
+          <p:cNvPr id="7" name="Text 4"/>
           <p:cNvSpPr txBox="1"/>
           <p:nvPr/>
         </p:nvSpPr>
@@ -5193,7 +6401,7 @@
       </p:sp>
       <p:sp>
         <p:nvSpPr>
-          <p:cNvPr id="3" name="Shape 1"/>
+          <p:cNvPr id="4" name="Shape 1"/>
           <p:cNvSpPr/>
           <p:nvPr/>
         </p:nvSpPr>
@@ -5215,7 +6423,7 @@
       </p:sp>
       <p:sp>
         <p:nvSpPr>
-          <p:cNvPr id="4" name="Text 2"/>
+          <p:cNvPr id="5" name="Text 2"/>
           <p:cNvSpPr txBox="1"/>
           <p:nvPr/>
         </p:nvSpPr>
@@ -5251,7 +6459,7 @@
       </p:sp>
       <p:sp>
         <p:nvSpPr>
-          <p:cNvPr id="5" name="Text 3"/>
+          <p:cNvPr id="6" name="Text 3"/>
           <p:cNvSpPr txBox="1"/>
           <p:nvPr/>
         </p:nvSpPr>
@@ -5301,7 +6509,7 @@
       </p:sp>
       <p:sp>
         <p:nvSpPr>
-          <p:cNvPr id="6" name="Text 4"/>
+          <p:cNvPr id="7" name="Text 4"/>
           <p:cNvSpPr txBox="1"/>
           <p:nvPr/>
         </p:nvSpPr>
@@ -5351,7 +6559,7 @@
       </p:sp>
       <p:sp>
         <p:nvSpPr>
-          <p:cNvPr id="7" name="Text 5"/>
+          <p:cNvPr id="8" name="Text 5"/>
           <p:cNvSpPr txBox="1"/>
           <p:nvPr/>
         </p:nvSpPr>
@@ -5387,7 +6595,7 @@
       </p:sp>
       <p:sp>
         <p:nvSpPr>
-          <p:cNvPr id="8" name="Shape 6"/>
+          <p:cNvPr id="9" name="Shape 6"/>
           <p:cNvSpPr/>
           <p:nvPr/>
         </p:nvSpPr>
@@ -5407,7 +6615,7 @@
       </p:sp>
       <p:sp>
         <p:nvSpPr>
-          <p:cNvPr id="9" name="Text 7"/>
+          <p:cNvPr id="10" name="Text 7"/>
           <p:cNvSpPr txBox="1"/>
           <p:nvPr/>
         </p:nvSpPr>
@@ -5443,7 +6651,7 @@
       </p:sp>
       <p:sp>
         <p:nvSpPr>
-          <p:cNvPr id="10" name="Text 8"/>
+          <p:cNvPr id="11" name="Text 8"/>
           <p:cNvSpPr txBox="1"/>
           <p:nvPr/>
         </p:nvSpPr>
@@ -5493,7 +6701,7 @@
       </p:sp>
       <p:sp>
         <p:nvSpPr>
-          <p:cNvPr id="11" name="Shape 9"/>
+          <p:cNvPr id="12" name="Shape 9"/>
           <p:cNvSpPr/>
           <p:nvPr/>
         </p:nvSpPr>
@@ -5513,7 +6721,7 @@
       </p:sp>
       <p:sp>
         <p:nvSpPr>
-          <p:cNvPr id="12" name="Text 10"/>
+          <p:cNvPr id="13" name="Text 10"/>
           <p:cNvSpPr txBox="1"/>
           <p:nvPr/>
         </p:nvSpPr>
@@ -5549,7 +6757,7 @@
       </p:sp>
       <p:sp>
         <p:nvSpPr>
-          <p:cNvPr id="13" name="Text 11"/>
+          <p:cNvPr id="14" name="Text 11"/>
           <p:cNvSpPr txBox="1"/>
           <p:nvPr/>
         </p:nvSpPr>
@@ -5599,7 +6807,7 @@
       </p:sp>
       <p:sp>
         <p:nvSpPr>
-          <p:cNvPr id="14" name="Shape 12"/>
+          <p:cNvPr id="15" name="Shape 12"/>
           <p:cNvSpPr/>
           <p:nvPr/>
         </p:nvSpPr>
@@ -5619,7 +6827,7 @@
       </p:sp>
       <p:sp>
         <p:nvSpPr>
-          <p:cNvPr id="15" name="Text 13"/>
+          <p:cNvPr id="16" name="Text 13"/>
           <p:cNvSpPr txBox="1"/>
           <p:nvPr/>
         </p:nvSpPr>
@@ -5655,7 +6863,7 @@
       </p:sp>
       <p:sp>
         <p:nvSpPr>
-          <p:cNvPr id="16" name="Text 14"/>
+          <p:cNvPr id="17" name="Text 14"/>
           <p:cNvSpPr txBox="1"/>
           <p:nvPr/>
         </p:nvSpPr>
@@ -5813,7 +7021,7 @@
       </p:sp>
       <p:pic>
         <p:nvPicPr>
-          <p:cNvPr id="3" name="Image 0" descr="/tmp/claude-0/-home-user-claude/12fa8dee-b419-5de1-b9d8-ad8a73869b32/scratchpad/frames.jpg">    </p:cNvPr>
+          <p:cNvPr id="4" name="Image 0" descr="/tmp/claude-0/-home-user-claude/12fa8dee-b419-5de1-b9d8-ad8a73869b32/scratchpad/frames.jpg">    </p:cNvPr>
           <p:cNvPicPr>
             <a:picLocks noChangeAspect="1"/>
           </p:cNvPicPr>
@@ -5837,7 +7045,7 @@
       </p:pic>
       <p:sp>
         <p:nvSpPr>
-          <p:cNvPr id="4" name="Text 1"/>
+          <p:cNvPr id="5" name="Text 1"/>
           <p:cNvSpPr txBox="1"/>
           <p:nvPr/>
         </p:nvSpPr>
@@ -5873,7 +7081,7 @@
       </p:sp>
       <p:sp>
         <p:nvSpPr>
-          <p:cNvPr id="5" name="Text 2"/>
+          <p:cNvPr id="6" name="Text 2"/>
           <p:cNvSpPr txBox="1"/>
           <p:nvPr/>
         </p:nvSpPr>
@@ -5957,7 +7165,7 @@
       </p:sp>
       <p:sp>
         <p:nvSpPr>
-          <p:cNvPr id="6" name="Shape 3"/>
+          <p:cNvPr id="7" name="Shape 3"/>
           <p:cNvSpPr/>
           <p:nvPr/>
         </p:nvSpPr>
@@ -5979,7 +7187,7 @@
       </p:sp>
       <p:sp>
         <p:nvSpPr>
-          <p:cNvPr id="7" name="Text 4"/>
+          <p:cNvPr id="8" name="Text 4"/>
           <p:cNvSpPr txBox="1"/>
           <p:nvPr/>
         </p:nvSpPr>
@@ -6052,7 +7260,7 @@
       </p:sp>
       <p:sp>
         <p:nvSpPr>
-          <p:cNvPr id="8" name="Shape 5"/>
+          <p:cNvPr id="9" name="Shape 5"/>
           <p:cNvSpPr/>
           <p:nvPr/>
         </p:nvSpPr>
@@ -6072,7 +7280,7 @@
       </p:sp>
       <p:sp>
         <p:nvSpPr>
-          <p:cNvPr id="9" name="Shape 6"/>
+          <p:cNvPr id="10" name="Shape 6"/>
           <p:cNvSpPr/>
           <p:nvPr/>
         </p:nvSpPr>
@@ -6094,7 +7302,7 @@
       </p:sp>
       <p:sp>
         <p:nvSpPr>
-          <p:cNvPr id="10" name="Text 7"/>
+          <p:cNvPr id="11" name="Text 7"/>
           <p:cNvSpPr txBox="1"/>
           <p:nvPr/>
         </p:nvSpPr>
@@ -6184,7 +7392,7 @@
       </p:sp>
       <p:sp>
         <p:nvSpPr>
-          <p:cNvPr id="11" name="Shape 8"/>
+          <p:cNvPr id="12" name="Shape 8"/>
           <p:cNvSpPr/>
           <p:nvPr/>
         </p:nvSpPr>
@@ -6204,7 +7412,7 @@
       </p:sp>
       <p:sp>
         <p:nvSpPr>
-          <p:cNvPr id="12" name="Shape 9"/>
+          <p:cNvPr id="13" name="Shape 9"/>
           <p:cNvSpPr/>
           <p:nvPr/>
         </p:nvSpPr>
@@ -6226,7 +7434,7 @@
       </p:sp>
       <p:sp>
         <p:nvSpPr>
-          <p:cNvPr id="13" name="Text 10"/>
+          <p:cNvPr id="14" name="Text 10"/>
           <p:cNvSpPr txBox="1"/>
           <p:nvPr/>
         </p:nvSpPr>
@@ -6407,7 +7615,7 @@
       </p:sp>
       <p:graphicFrame>
         <p:nvGraphicFramePr>
-          <p:cNvPr id="3" name="Chart 0" descr=""/>
+          <p:cNvPr id="4" name="Chart 0" descr=""/>
           <p:cNvGraphicFramePr/>
           <p:nvPr/>
         </p:nvGraphicFramePr>
@@ -6423,7 +7631,7 @@
       </p:graphicFrame>
       <p:sp>
         <p:nvSpPr>
-          <p:cNvPr id="4" name="Shape 1"/>
+          <p:cNvPr id="5" name="Shape 1"/>
           <p:cNvSpPr/>
           <p:nvPr/>
         </p:nvSpPr>
@@ -6443,7 +7651,7 @@
       </p:sp>
       <p:sp>
         <p:nvSpPr>
-          <p:cNvPr id="5" name="Text 2"/>
+          <p:cNvPr id="6" name="Text 2"/>
           <p:cNvSpPr txBox="1"/>
           <p:nvPr/>
         </p:nvSpPr>
@@ -6479,7 +7687,7 @@
       </p:sp>
       <p:sp>
         <p:nvSpPr>
-          <p:cNvPr id="6" name="Shape 3"/>
+          <p:cNvPr id="7" name="Shape 3"/>
           <p:cNvSpPr/>
           <p:nvPr/>
         </p:nvSpPr>
@@ -6499,7 +7707,7 @@
       </p:sp>
       <p:sp>
         <p:nvSpPr>
-          <p:cNvPr id="7" name="Text 4"/>
+          <p:cNvPr id="8" name="Text 4"/>
           <p:cNvSpPr txBox="1"/>
           <p:nvPr/>
         </p:nvSpPr>
@@ -6535,7 +7743,7 @@
       </p:sp>
       <p:sp>
         <p:nvSpPr>
-          <p:cNvPr id="8" name="Shape 5"/>
+          <p:cNvPr id="9" name="Shape 5"/>
           <p:cNvSpPr/>
           <p:nvPr/>
         </p:nvSpPr>
@@ -6557,7 +7765,7 @@
       </p:sp>
       <p:sp>
         <p:nvSpPr>
-          <p:cNvPr id="9" name="Text 6"/>
+          <p:cNvPr id="10" name="Text 6"/>
           <p:cNvSpPr txBox="1"/>
           <p:nvPr/>
         </p:nvSpPr>
@@ -6613,7 +7821,7 @@
       </p:sp>
       <p:sp>
         <p:nvSpPr>
-          <p:cNvPr id="10" name="Shape 7"/>
+          <p:cNvPr id="11" name="Shape 7"/>
           <p:cNvSpPr/>
           <p:nvPr/>
         </p:nvSpPr>
@@ -6635,7 +7843,7 @@
       </p:sp>
       <p:sp>
         <p:nvSpPr>
-          <p:cNvPr id="11" name="Text 8"/>
+          <p:cNvPr id="12" name="Text 8"/>
           <p:cNvSpPr txBox="1"/>
           <p:nvPr/>
         </p:nvSpPr>
@@ -6691,7 +7899,7 @@
       </p:sp>
       <p:sp>
         <p:nvSpPr>
-          <p:cNvPr id="12" name="Shape 9"/>
+          <p:cNvPr id="13" name="Shape 9"/>
           <p:cNvSpPr/>
           <p:nvPr/>
         </p:nvSpPr>
@@ -6713,7 +7921,7 @@
       </p:sp>
       <p:sp>
         <p:nvSpPr>
-          <p:cNvPr id="13" name="Text 10"/>
+          <p:cNvPr id="14" name="Text 10"/>
           <p:cNvSpPr txBox="1"/>
           <p:nvPr/>
         </p:nvSpPr>
@@ -6868,7 +8076,7 @@
       </p:sp>
       <p:graphicFrame>
         <p:nvGraphicFramePr>
-          <p:cNvPr id="3" name="Chart 0" descr=""/>
+          <p:cNvPr id="4" name="Chart 0" descr=""/>
           <p:cNvGraphicFramePr/>
           <p:nvPr/>
         </p:nvGraphicFramePr>
@@ -6884,7 +8092,7 @@
       </p:graphicFrame>
       <p:sp>
         <p:nvSpPr>
-          <p:cNvPr id="4" name="Shape 1"/>
+          <p:cNvPr id="5" name="Shape 1"/>
           <p:cNvSpPr/>
           <p:nvPr/>
         </p:nvSpPr>
@@ -6904,7 +8112,7 @@
       </p:sp>
       <p:sp>
         <p:nvSpPr>
-          <p:cNvPr id="5" name="Text 2"/>
+          <p:cNvPr id="6" name="Text 2"/>
           <p:cNvSpPr txBox="1"/>
           <p:nvPr/>
         </p:nvSpPr>
@@ -6940,7 +8148,7 @@
       </p:sp>
       <p:sp>
         <p:nvSpPr>
-          <p:cNvPr id="6" name="Shape 3"/>
+          <p:cNvPr id="7" name="Shape 3"/>
           <p:cNvSpPr/>
           <p:nvPr/>
         </p:nvSpPr>
@@ -6960,7 +8168,7 @@
       </p:sp>
       <p:sp>
         <p:nvSpPr>
-          <p:cNvPr id="7" name="Text 4"/>
+          <p:cNvPr id="8" name="Text 4"/>
           <p:cNvSpPr txBox="1"/>
           <p:nvPr/>
         </p:nvSpPr>
@@ -6996,7 +8204,7 @@
       </p:sp>
       <p:sp>
         <p:nvSpPr>
-          <p:cNvPr id="8" name="Text 5"/>
+          <p:cNvPr id="9" name="Text 5"/>
           <p:cNvSpPr txBox="1"/>
           <p:nvPr/>
         </p:nvSpPr>
@@ -7032,7 +8240,7 @@
       </p:sp>
       <p:sp>
         <p:nvSpPr>
-          <p:cNvPr id="9" name="Text 6"/>
+          <p:cNvPr id="10" name="Text 6"/>
           <p:cNvSpPr txBox="1"/>
           <p:nvPr/>
         </p:nvSpPr>
@@ -7068,7 +8276,7 @@
       </p:sp>
       <p:sp>
         <p:nvSpPr>
-          <p:cNvPr id="10" name="Text 7"/>
+          <p:cNvPr id="11" name="Text 7"/>
           <p:cNvSpPr txBox="1"/>
           <p:nvPr/>
         </p:nvSpPr>
@@ -7104,7 +8312,7 @@
       </p:sp>
       <p:sp>
         <p:nvSpPr>
-          <p:cNvPr id="11" name="Text 8"/>
+          <p:cNvPr id="12" name="Text 8"/>
           <p:cNvSpPr txBox="1"/>
           <p:nvPr/>
         </p:nvSpPr>
@@ -7140,7 +8348,7 @@
       </p:sp>
       <p:sp>
         <p:nvSpPr>
-          <p:cNvPr id="12" name="Text 9"/>
+          <p:cNvPr id="13" name="Text 9"/>
           <p:cNvSpPr txBox="1"/>
           <p:nvPr/>
         </p:nvSpPr>
@@ -7176,7 +8384,7 @@
       </p:sp>
       <p:sp>
         <p:nvSpPr>
-          <p:cNvPr id="13" name="Text 10"/>
+          <p:cNvPr id="14" name="Text 10"/>
           <p:cNvSpPr txBox="1"/>
           <p:nvPr/>
         </p:nvSpPr>
@@ -7212,7 +8420,7 @@
       </p:sp>
       <p:sp>
         <p:nvSpPr>
-          <p:cNvPr id="14" name="Text 11"/>
+          <p:cNvPr id="15" name="Text 11"/>
           <p:cNvSpPr txBox="1"/>
           <p:nvPr/>
         </p:nvSpPr>
@@ -7248,7 +8456,7 @@
       </p:sp>
       <p:sp>
         <p:nvSpPr>
-          <p:cNvPr id="15" name="Shape 12"/>
+          <p:cNvPr id="16" name="Shape 12"/>
           <p:cNvSpPr/>
           <p:nvPr/>
         </p:nvSpPr>
@@ -7270,7 +8478,7 @@
       </p:sp>
       <p:sp>
         <p:nvSpPr>
-          <p:cNvPr id="16" name="Text 13"/>
+          <p:cNvPr id="17" name="Text 13"/>
           <p:cNvSpPr txBox="1"/>
           <p:nvPr/>
         </p:nvSpPr>
@@ -7425,7 +8633,7 @@
       </p:sp>
       <p:sp>
         <p:nvSpPr>
-          <p:cNvPr id="3" name="Shape 1"/>
+          <p:cNvPr id="4" name="Shape 1"/>
           <p:cNvSpPr/>
           <p:nvPr/>
         </p:nvSpPr>
@@ -7447,7 +8655,7 @@
       </p:sp>
       <p:sp>
         <p:nvSpPr>
-          <p:cNvPr id="4" name="Text 2"/>
+          <p:cNvPr id="5" name="Text 2"/>
           <p:cNvSpPr txBox="1"/>
           <p:nvPr/>
         </p:nvSpPr>
@@ -7537,7 +8745,7 @@
       </p:sp>
       <p:sp>
         <p:nvSpPr>
-          <p:cNvPr id="5" name="Shape 3"/>
+          <p:cNvPr id="6" name="Shape 3"/>
           <p:cNvSpPr/>
           <p:nvPr/>
         </p:nvSpPr>
@@ -7559,7 +8767,7 @@
       </p:sp>
       <p:sp>
         <p:nvSpPr>
-          <p:cNvPr id="6" name="Text 4"/>
+          <p:cNvPr id="7" name="Text 4"/>
           <p:cNvSpPr txBox="1"/>
           <p:nvPr/>
         </p:nvSpPr>
@@ -7649,7 +8857,7 @@
       </p:sp>
       <p:sp>
         <p:nvSpPr>
-          <p:cNvPr id="7" name="Shape 5"/>
+          <p:cNvPr id="8" name="Shape 5"/>
           <p:cNvSpPr/>
           <p:nvPr/>
         </p:nvSpPr>
@@ -7671,7 +8879,7 @@
       </p:sp>
       <p:sp>
         <p:nvSpPr>
-          <p:cNvPr id="8" name="Text 6"/>
+          <p:cNvPr id="9" name="Text 6"/>
           <p:cNvSpPr txBox="1"/>
           <p:nvPr/>
         </p:nvSpPr>
@@ -7826,7 +9034,7 @@
       </p:sp>
       <p:sp>
         <p:nvSpPr>
-          <p:cNvPr id="3" name="Shape 1"/>
+          <p:cNvPr id="4" name="Shape 1"/>
           <p:cNvSpPr/>
           <p:nvPr/>
         </p:nvSpPr>
@@ -7846,7 +9054,7 @@
       </p:sp>
       <p:sp>
         <p:nvSpPr>
-          <p:cNvPr id="4" name="Text 2"/>
+          <p:cNvPr id="5" name="Text 2"/>
           <p:cNvSpPr txBox="1"/>
           <p:nvPr/>
         </p:nvSpPr>
@@ -7882,7 +9090,7 @@
       </p:sp>
       <p:sp>
         <p:nvSpPr>
-          <p:cNvPr id="5" name="Text 3"/>
+          <p:cNvPr id="6" name="Text 3"/>
           <p:cNvSpPr txBox="1"/>
           <p:nvPr/>
         </p:nvSpPr>
@@ -7938,7 +9146,7 @@
       </p:sp>
       <p:sp>
         <p:nvSpPr>
-          <p:cNvPr id="6" name="Shape 4"/>
+          <p:cNvPr id="7" name="Shape 4"/>
           <p:cNvSpPr/>
           <p:nvPr/>
         </p:nvSpPr>
@@ -7958,7 +9166,7 @@
       </p:sp>
       <p:sp>
         <p:nvSpPr>
-          <p:cNvPr id="7" name="Text 5"/>
+          <p:cNvPr id="8" name="Text 5"/>
           <p:cNvSpPr txBox="1"/>
           <p:nvPr/>
         </p:nvSpPr>
@@ -7994,7 +9202,7 @@
       </p:sp>
       <p:sp>
         <p:nvSpPr>
-          <p:cNvPr id="8" name="Text 6"/>
+          <p:cNvPr id="9" name="Text 6"/>
           <p:cNvSpPr txBox="1"/>
           <p:nvPr/>
         </p:nvSpPr>
@@ -8050,7 +9258,7 @@
       </p:sp>
       <p:sp>
         <p:nvSpPr>
-          <p:cNvPr id="9" name="Shape 7"/>
+          <p:cNvPr id="10" name="Shape 7"/>
           <p:cNvSpPr/>
           <p:nvPr/>
         </p:nvSpPr>
@@ -8070,7 +9278,7 @@
       </p:sp>
       <p:sp>
         <p:nvSpPr>
-          <p:cNvPr id="10" name="Text 8"/>
+          <p:cNvPr id="11" name="Text 8"/>
           <p:cNvSpPr txBox="1"/>
           <p:nvPr/>
         </p:nvSpPr>
@@ -8106,7 +9314,7 @@
       </p:sp>
       <p:sp>
         <p:nvSpPr>
-          <p:cNvPr id="11" name="Text 9"/>
+          <p:cNvPr id="12" name="Text 9"/>
           <p:cNvSpPr txBox="1"/>
           <p:nvPr/>
         </p:nvSpPr>
@@ -8162,7 +9370,7 @@
       </p:sp>
       <p:sp>
         <p:nvSpPr>
-          <p:cNvPr id="12" name="Shape 10"/>
+          <p:cNvPr id="13" name="Shape 10"/>
           <p:cNvSpPr/>
           <p:nvPr/>
         </p:nvSpPr>
@@ -8184,7 +9392,7 @@
       </p:sp>
       <p:sp>
         <p:nvSpPr>
-          <p:cNvPr id="13" name="Text 11"/>
+          <p:cNvPr id="14" name="Text 11"/>
           <p:cNvSpPr txBox="1"/>
           <p:nvPr/>
         </p:nvSpPr>
@@ -8339,7 +9547,7 @@
       </p:sp>
       <p:sp>
         <p:nvSpPr>
-          <p:cNvPr id="3" name="Text 1"/>
+          <p:cNvPr id="4" name="Text 1"/>
           <p:cNvSpPr txBox="1"/>
           <p:nvPr/>
         </p:nvSpPr>
@@ -8433,7 +9641,7 @@
       </p:sp>
       <p:sp>
         <p:nvSpPr>
-          <p:cNvPr id="4" name="Text 2"/>
+          <p:cNvPr id="5" name="Text 2"/>
           <p:cNvSpPr txBox="1"/>
           <p:nvPr/>
         </p:nvSpPr>
@@ -8469,7 +9677,7 @@
       </p:sp>
       <p:sp>
         <p:nvSpPr>
-          <p:cNvPr id="5" name="Text 3"/>
+          <p:cNvPr id="6" name="Text 3"/>
           <p:cNvSpPr txBox="1"/>
           <p:nvPr/>
         </p:nvSpPr>
@@ -8519,7 +9727,7 @@
       </p:sp>
       <p:sp>
         <p:nvSpPr>
-          <p:cNvPr id="6" name="Text 4"/>
+          <p:cNvPr id="7" name="Text 4"/>
           <p:cNvSpPr txBox="1"/>
           <p:nvPr/>
         </p:nvSpPr>
@@ -8569,7 +9777,7 @@
       </p:sp>
       <p:sp>
         <p:nvSpPr>
-          <p:cNvPr id="7" name="Shape 5"/>
+          <p:cNvPr id="8" name="Shape 5"/>
           <p:cNvSpPr/>
           <p:nvPr/>
         </p:nvSpPr>
@@ -8591,7 +9799,7 @@
       </p:sp>
       <p:sp>
         <p:nvSpPr>
-          <p:cNvPr id="8" name="Text 6"/>
+          <p:cNvPr id="9" name="Text 6"/>
           <p:cNvSpPr txBox="1"/>
           <p:nvPr/>
         </p:nvSpPr>
@@ -8647,7 +9855,7 @@
       </p:sp>
       <p:sp>
         <p:nvSpPr>
-          <p:cNvPr id="9" name="Shape 7"/>
+          <p:cNvPr id="10" name="Shape 7"/>
           <p:cNvSpPr/>
           <p:nvPr/>
         </p:nvSpPr>
@@ -8669,7 +9877,7 @@
       </p:sp>
       <p:sp>
         <p:nvSpPr>
-          <p:cNvPr id="10" name="Text 8"/>
+          <p:cNvPr id="11" name="Text 8"/>
           <p:cNvSpPr txBox="1"/>
           <p:nvPr/>
         </p:nvSpPr>
@@ -8833,7 +10041,7 @@
       </p:sp>
       <p:sp>
         <p:nvSpPr>
-          <p:cNvPr id="3" name="Shape 1"/>
+          <p:cNvPr id="4" name="Shape 1"/>
           <p:cNvSpPr/>
           <p:nvPr/>
         </p:nvSpPr>
@@ -8855,7 +10063,7 @@
       </p:sp>
       <p:sp>
         <p:nvSpPr>
-          <p:cNvPr id="4" name="Text 2"/>
+          <p:cNvPr id="5" name="Text 2"/>
           <p:cNvSpPr txBox="1"/>
           <p:nvPr/>
         </p:nvSpPr>
@@ -8891,7 +10099,7 @@
       </p:sp>
       <p:sp>
         <p:nvSpPr>
-          <p:cNvPr id="5" name="Text 3"/>
+          <p:cNvPr id="6" name="Text 3"/>
           <p:cNvSpPr txBox="1"/>
           <p:nvPr/>
         </p:nvSpPr>
@@ -8927,7 +10135,7 @@
       </p:sp>
       <p:sp>
         <p:nvSpPr>
-          <p:cNvPr id="6" name="Shape 4"/>
+          <p:cNvPr id="7" name="Shape 4"/>
           <p:cNvSpPr/>
           <p:nvPr/>
         </p:nvSpPr>
@@ -8949,7 +10157,7 @@
       </p:sp>
       <p:sp>
         <p:nvSpPr>
-          <p:cNvPr id="7" name="Text 5"/>
+          <p:cNvPr id="8" name="Text 5"/>
           <p:cNvSpPr txBox="1"/>
           <p:nvPr/>
         </p:nvSpPr>
@@ -8985,7 +10193,7 @@
       </p:sp>
       <p:sp>
         <p:nvSpPr>
-          <p:cNvPr id="8" name="Shape 6"/>
+          <p:cNvPr id="9" name="Shape 6"/>
           <p:cNvSpPr/>
           <p:nvPr/>
         </p:nvSpPr>
@@ -9005,7 +10213,7 @@
       </p:sp>
       <p:sp>
         <p:nvSpPr>
-          <p:cNvPr id="9" name="Shape 7"/>
+          <p:cNvPr id="10" name="Shape 7"/>
           <p:cNvSpPr/>
           <p:nvPr/>
         </p:nvSpPr>
@@ -9027,7 +10235,7 @@
       </p:sp>
       <p:sp>
         <p:nvSpPr>
-          <p:cNvPr id="10" name="Text 8"/>
+          <p:cNvPr id="11" name="Text 8"/>
           <p:cNvSpPr txBox="1"/>
           <p:nvPr/>
         </p:nvSpPr>
@@ -9063,7 +10271,7 @@
       </p:sp>
       <p:sp>
         <p:nvSpPr>
-          <p:cNvPr id="11" name="Shape 9"/>
+          <p:cNvPr id="12" name="Shape 9"/>
           <p:cNvSpPr/>
           <p:nvPr/>
         </p:nvSpPr>
@@ -9085,7 +10293,7 @@
       </p:sp>
       <p:sp>
         <p:nvSpPr>
-          <p:cNvPr id="12" name="Text 10"/>
+          <p:cNvPr id="13" name="Text 10"/>
           <p:cNvSpPr txBox="1"/>
           <p:nvPr/>
         </p:nvSpPr>
@@ -9121,7 +10329,7 @@
       </p:sp>
       <p:sp>
         <p:nvSpPr>
-          <p:cNvPr id="13" name="Text 11"/>
+          <p:cNvPr id="14" name="Text 11"/>
           <p:cNvSpPr txBox="1"/>
           <p:nvPr/>
         </p:nvSpPr>
@@ -9157,7 +10365,7 @@
       </p:sp>
       <p:sp>
         <p:nvSpPr>
-          <p:cNvPr id="14" name="Shape 12"/>
+          <p:cNvPr id="15" name="Shape 12"/>
           <p:cNvSpPr/>
           <p:nvPr/>
         </p:nvSpPr>
@@ -9179,7 +10387,7 @@
       </p:sp>
       <p:sp>
         <p:nvSpPr>
-          <p:cNvPr id="15" name="Text 13"/>
+          <p:cNvPr id="16" name="Text 13"/>
           <p:cNvSpPr txBox="1"/>
           <p:nvPr/>
         </p:nvSpPr>
@@ -9215,7 +10423,7 @@
       </p:sp>
       <p:sp>
         <p:nvSpPr>
-          <p:cNvPr id="16" name="Shape 14"/>
+          <p:cNvPr id="17" name="Shape 14"/>
           <p:cNvSpPr/>
           <p:nvPr/>
         </p:nvSpPr>
@@ -9235,7 +10443,7 @@
       </p:sp>
       <p:sp>
         <p:nvSpPr>
-          <p:cNvPr id="17" name="Shape 15"/>
+          <p:cNvPr id="18" name="Shape 15"/>
           <p:cNvSpPr/>
           <p:nvPr/>
         </p:nvSpPr>
@@ -9257,7 +10465,7 @@
       </p:sp>
       <p:sp>
         <p:nvSpPr>
-          <p:cNvPr id="18" name="Text 16"/>
+          <p:cNvPr id="19" name="Text 16"/>
           <p:cNvSpPr txBox="1"/>
           <p:nvPr/>
         </p:nvSpPr>
@@ -9293,7 +10501,7 @@
       </p:sp>
       <p:sp>
         <p:nvSpPr>
-          <p:cNvPr id="19" name="Text 17"/>
+          <p:cNvPr id="20" name="Text 17"/>
           <p:cNvSpPr txBox="1"/>
           <p:nvPr/>
         </p:nvSpPr>
@@ -9329,7 +10537,7 @@
       </p:sp>
       <p:sp>
         <p:nvSpPr>
-          <p:cNvPr id="20" name="Text 18"/>
+          <p:cNvPr id="21" name="Text 18"/>
           <p:cNvSpPr txBox="1"/>
           <p:nvPr/>
         </p:nvSpPr>
@@ -9405,7 +10613,7 @@
       </p:sp>
       <p:sp>
         <p:nvSpPr>
-          <p:cNvPr id="21" name="Shape 19"/>
+          <p:cNvPr id="22" name="Shape 19"/>
           <p:cNvSpPr/>
           <p:nvPr/>
         </p:nvSpPr>
@@ -9427,7 +10635,7 @@
       </p:sp>
       <p:sp>
         <p:nvSpPr>
-          <p:cNvPr id="22" name="Text 20"/>
+          <p:cNvPr id="23" name="Text 20"/>
           <p:cNvSpPr txBox="1"/>
           <p:nvPr/>
         </p:nvSpPr>
@@ -9466,7 +10674,7 @@
                   <a:schemeClr val="tx1"/>
                 </a:solidFill>
               </a:rPr>
-              <a:t>Does naming the result help children transfer the relation?</a:t>
+              <a:t>Does naming help? Do comparison and explanation make it general?</a:t>
             </a:r>
             <a:endParaRPr lang="en-US" sz="1800" dirty="0"/>
           </a:p>

</xml_diff>

<commit_message>
Center Direction 3 on the lexical vs. predicate distinction
Co-Authored-By: Claude Opus 5.5 <noreply@anthropic.com>
Claude-Session: https://claude.ai/code/session_011AaQxxgQ4HPadVVo3q9mgs
</commit_message>
<xml_diff>
--- a/Liu_postdoc_interview_talk.pptx
+++ b/Liu_postdoc_interview_talk.pptx
@@ -145,7 +145,7 @@
                 </a:solidFill>
                 <a:latin typeface="+mn-lt"/>
               </a:rPr>
-              <a:t>Telic (endpoint) descriptions</a:t>
+              <a:t>Predicate level: telic descriptions</a:t>
             </a:r>
           </a:p>
         </c:rich>
@@ -1357,10 +1357,10 @@
           <a:p>
             <a:r>
               <a:rPr lang="en-US" dirty="0"/>
-              <a:t>1. This follows Rognan, Grigoroglou and Bhattasali (CogSci 2026), who used masked language models as psycholinguistic test subjects for event order across English, Norwegian and Greek.
-2. I would use matched monolingual models (English BERT and Chinese BERT, then larger LLMs) and cloze items built from my human stimuli: which result complement a model predicts in 他把橙子搅[MASK]了, and which determiner in “She cut [MASK] orange”.
-3. A second test targets culmination: in 他切了橙子，但是[MASK], does the model allow the result to be cancelled, as Mandarin speakers do, and does it not in English?
-4. Model scores are compared with three human benchmarks: my Exp 1 descriptions, the adult result-likelihood ratings, and children’s judgments. Where models match adults, text is enough; where children differ from models, that shows what experience adds.</a:t>
+              <a:t>1. The main contribution of my thesis is separating two levels of event encoding: local lexical cues (quantized nouns, resultatives) and whole-predicate telicity. Direction 3 asks whether language models separate them too.
+2. Following Rognan, Grigoroglou and Bhattasali (CogSci 2026), I would treat matched monolingual models, English BERT and Chinese BERT, as test subjects in cloze tasks built from my stimuli, then extend to multilingual models and larger LLMs.
+3. Lexical level: which determiner the model predicts in “She cut [MASK] orange”, and which result complement in 他把橙子搅[MASK]了, for cutting versus blending verbs. Predicate level: “in” versus “for” in “cut an orange [MASK] two seconds”, and whether the model allows cancellation in 他切了橙子，但是[MASK].
+4. Key test: does the predicate-level choice flip when the lexical cue flips (an orange vs. oranges; 切开 vs. 切)? If models match humans at the lexical level but not the predicate level, they rely on surface statistics rather than event structure. Model scores are compared with my Exp 1 descriptions and the adult and child data.</a:t>
             </a:r>
             <a:endParaRPr lang="en-US" dirty="0"/>
           </a:p>
@@ -1815,7 +1815,7 @@
               <a:t>1. Telicity shows a crossover: English is more telic for cutting (79% vs. 51%), Mandarin for blending (44% vs. 17%).
 2. English speakers mark the object with quantized noun phrases (68% vs. 13%).
 3. Mandarin speakers use resultatives for blending (44% vs. 17%).
-4. So the two languages make different parts of the same event prominent.</a:t>
+4. So the languages differ at two levels: the lexical level and the whole predicate. This two-level distinction is the main contribution of the thesis.</a:t>
             </a:r>
             <a:endParaRPr lang="en-US" dirty="0"/>
           </a:p>
@@ -2179,7 +2179,7 @@
               <a:t>1. The thesis shows a correspondence between language and event processing in adults, but not where it comes from.
 2. Question 1: when do these differences emerge in development? That is Direction 1.
 3. Question 2: brief primes did not work, so can sustained language change processing? That is Direction 2.
-4. Question 3: is linguistic input alone enough to produce these patterns? Language models let us test that, Direction 3.</a:t>
+4. Question 3: does text alone yield both levels of event encoding? Language models let us test that, Direction 3.</a:t>
             </a:r>
             <a:endParaRPr lang="en-US" dirty="0"/>
           </a:p>
@@ -4082,7 +4082,7 @@
                   <a:schemeClr val="tx2"/>
                 </a:solidFill>
               </a:rPr>
-              <a:t>Direction 3: Can language models learn these patterns?</a:t>
+              <a:t>Direction 3: Do language models separate the two levels?</a:t>
             </a:r>
             <a:endParaRPr lang="en-US" sz="3000" dirty="0"/>
           </a:p>
@@ -4097,7 +4097,7 @@
         <p:spPr>
           <a:xfrm>
             <a:off x="548640" y="1280160"/>
-            <a:ext cx="6309360" cy="411480"/>
+            <a:ext cx="11094415" cy="411480"/>
           </a:xfrm>
           <a:prstGeom prst="rect">
             <a:avLst/>
@@ -4113,14 +4113,14 @@
               <a:buNone/>
             </a:pPr>
             <a:r>
-              <a:rPr lang="en-US" sz="2200" b="1" dirty="0">
+              <a:rPr lang="en-US" sz="1800" b="1" dirty="0">
                 <a:solidFill>
                   <a:schemeClr val="tx2"/>
                 </a:solidFill>
               </a:rPr>
-              <a:t>Models as test subjects (Rognan et al., 2026)</a:t>
-            </a:r>
-            <a:endParaRPr lang="en-US" sz="2200" dirty="0"/>
+              <a:t>Cloze tests in matched English and Chinese BERT (Rognan et al., 2026)</a:t>
+            </a:r>
+            <a:endParaRPr lang="en-US" sz="1800" dirty="0"/>
           </a:p>
         </p:txBody>
       </p:sp>
@@ -4132,402 +4132,12 @@
         </p:nvSpPr>
         <p:spPr>
           <a:xfrm>
-            <a:off x="548640" y="1828800"/>
-            <a:ext cx="548640" cy="548640"/>
-          </a:xfrm>
-          <a:prstGeom prst="ellipse">
-            <a:avLst/>
-          </a:prstGeom>
-          <a:solidFill>
-            <a:schemeClr val="accent1"/>
-          </a:solidFill>
-          <a:ln/>
-        </p:spPr>
-      </p:sp>
-      <p:sp>
-        <p:nvSpPr>
-          <p:cNvPr id="6" name="Text 3"/>
-          <p:cNvSpPr txBox="1"/>
-          <p:nvPr/>
-        </p:nvSpPr>
-        <p:spPr>
-          <a:xfrm>
-            <a:off x="548640" y="1828800"/>
-            <a:ext cx="548640" cy="548640"/>
-          </a:xfrm>
-          <a:prstGeom prst="rect">
-            <a:avLst/>
-          </a:prstGeom>
-          <a:noFill/>
-          <a:ln/>
-        </p:spPr>
-        <p:txBody>
-          <a:bodyPr wrap="square" lIns="0" tIns="0" rIns="0" bIns="0" rtlCol="0" anchor="ctr"/>
-          <a:lstStyle/>
-          <a:p>
-            <a:pPr algn="ctr" indent="0" marL="0">
-              <a:buNone/>
-            </a:pPr>
-            <a:r>
-              <a:rPr lang="en-US" sz="2000" b="1" dirty="0">
-                <a:solidFill>
-                  <a:schemeClr val="bg1"/>
-                </a:solidFill>
-              </a:rPr>
-              <a:t>1</a:t>
-            </a:r>
-            <a:endParaRPr lang="en-US" sz="2000" dirty="0"/>
-          </a:p>
-        </p:txBody>
-      </p:sp>
-      <p:sp>
-        <p:nvSpPr>
-          <p:cNvPr id="7" name="Text 4"/>
-          <p:cNvSpPr txBox="1"/>
-          <p:nvPr/>
-        </p:nvSpPr>
-        <p:spPr>
-          <a:xfrm>
-            <a:off x="1280160" y="1828800"/>
-            <a:ext cx="5577840" cy="548640"/>
-          </a:xfrm>
-          <a:prstGeom prst="rect">
-            <a:avLst/>
-          </a:prstGeom>
-          <a:noFill/>
-          <a:ln/>
-        </p:spPr>
-        <p:txBody>
-          <a:bodyPr wrap="square" lIns="0" tIns="0" rIns="0" bIns="0" rtlCol="0" anchor="ctr"/>
-          <a:lstStyle/>
-          <a:p>
-            <a:pPr indent="0" marL="0">
-              <a:buNone/>
-            </a:pPr>
-            <a:r>
-              <a:rPr lang="en-US" sz="1800" dirty="0">
-                <a:solidFill>
-                  <a:schemeClr val="tx1"/>
-                </a:solidFill>
-              </a:rPr>
-              <a:t>Matched English and Chinese BERT, then larger LLMs</a:t>
-            </a:r>
-            <a:endParaRPr lang="en-US" sz="1800" dirty="0"/>
-          </a:p>
-        </p:txBody>
-      </p:sp>
-      <p:sp>
-        <p:nvSpPr>
-          <p:cNvPr id="8" name="Shape 5"/>
-          <p:cNvSpPr/>
-          <p:nvPr/>
-        </p:nvSpPr>
-        <p:spPr>
-          <a:xfrm>
-            <a:off x="548640" y="2606040"/>
-            <a:ext cx="548640" cy="548640"/>
-          </a:xfrm>
-          <a:prstGeom prst="ellipse">
-            <a:avLst/>
-          </a:prstGeom>
-          <a:solidFill>
-            <a:schemeClr val="accent1"/>
-          </a:solidFill>
-          <a:ln/>
-        </p:spPr>
-      </p:sp>
-      <p:sp>
-        <p:nvSpPr>
-          <p:cNvPr id="9" name="Text 6"/>
-          <p:cNvSpPr txBox="1"/>
-          <p:nvPr/>
-        </p:nvSpPr>
-        <p:spPr>
-          <a:xfrm>
-            <a:off x="548640" y="2606040"/>
-            <a:ext cx="548640" cy="548640"/>
-          </a:xfrm>
-          <a:prstGeom prst="rect">
-            <a:avLst/>
-          </a:prstGeom>
-          <a:noFill/>
-          <a:ln/>
-        </p:spPr>
-        <p:txBody>
-          <a:bodyPr wrap="square" lIns="0" tIns="0" rIns="0" bIns="0" rtlCol="0" anchor="ctr"/>
-          <a:lstStyle/>
-          <a:p>
-            <a:pPr algn="ctr" indent="0" marL="0">
-              <a:buNone/>
-            </a:pPr>
-            <a:r>
-              <a:rPr lang="en-US" sz="2000" b="1" dirty="0">
-                <a:solidFill>
-                  <a:schemeClr val="bg1"/>
-                </a:solidFill>
-              </a:rPr>
-              <a:t>2</a:t>
-            </a:r>
-            <a:endParaRPr lang="en-US" sz="2000" dirty="0"/>
-          </a:p>
-        </p:txBody>
-      </p:sp>
-      <p:sp>
-        <p:nvSpPr>
-          <p:cNvPr id="10" name="Text 7"/>
-          <p:cNvSpPr txBox="1"/>
-          <p:nvPr/>
-        </p:nvSpPr>
-        <p:spPr>
-          <a:xfrm>
-            <a:off x="1280160" y="2606040"/>
-            <a:ext cx="5577840" cy="548640"/>
-          </a:xfrm>
-          <a:prstGeom prst="rect">
-            <a:avLst/>
-          </a:prstGeom>
-          <a:noFill/>
-          <a:ln/>
-        </p:spPr>
-        <p:txBody>
-          <a:bodyPr wrap="square" lIns="0" tIns="0" rIns="0" bIns="0" rtlCol="0" anchor="ctr"/>
-          <a:lstStyle/>
-          <a:p>
-            <a:pPr indent="0" marL="0">
-              <a:buNone/>
-            </a:pPr>
-            <a:r>
-              <a:rPr lang="en-US" sz="1800" b="1" dirty="0">
-                <a:solidFill>
-                  <a:schemeClr val="tx1"/>
-                </a:solidFill>
-              </a:rPr>
-              <a:t>Encoding: </a:t>
-            </a:r>
-            <a:pPr indent="0" marL="0">
-              <a:buNone/>
-            </a:pPr>
-            <a:r>
-              <a:rPr lang="en-US" sz="1800" dirty="0">
-                <a:solidFill>
-                  <a:schemeClr val="tx1"/>
-                </a:solidFill>
-              </a:rPr>
-              <a:t>他把橙子搅[MASK]了</a:t>
-            </a:r>
-            <a:endParaRPr lang="en-US" sz="1800" dirty="0"/>
-          </a:p>
-        </p:txBody>
-      </p:sp>
-      <p:sp>
-        <p:nvSpPr>
-          <p:cNvPr id="11" name="Shape 8"/>
-          <p:cNvSpPr/>
-          <p:nvPr/>
-        </p:nvSpPr>
-        <p:spPr>
-          <a:xfrm>
-            <a:off x="548640" y="3383280"/>
-            <a:ext cx="548640" cy="548640"/>
-          </a:xfrm>
-          <a:prstGeom prst="ellipse">
-            <a:avLst/>
-          </a:prstGeom>
-          <a:solidFill>
-            <a:schemeClr val="accent1"/>
-          </a:solidFill>
-          <a:ln/>
-        </p:spPr>
-      </p:sp>
-      <p:sp>
-        <p:nvSpPr>
-          <p:cNvPr id="12" name="Text 9"/>
-          <p:cNvSpPr txBox="1"/>
-          <p:nvPr/>
-        </p:nvSpPr>
-        <p:spPr>
-          <a:xfrm>
-            <a:off x="548640" y="3383280"/>
-            <a:ext cx="548640" cy="548640"/>
-          </a:xfrm>
-          <a:prstGeom prst="rect">
-            <a:avLst/>
-          </a:prstGeom>
-          <a:noFill/>
-          <a:ln/>
-        </p:spPr>
-        <p:txBody>
-          <a:bodyPr wrap="square" lIns="0" tIns="0" rIns="0" bIns="0" rtlCol="0" anchor="ctr"/>
-          <a:lstStyle/>
-          <a:p>
-            <a:pPr algn="ctr" indent="0" marL="0">
-              <a:buNone/>
-            </a:pPr>
-            <a:r>
-              <a:rPr lang="en-US" sz="2000" b="1" dirty="0">
-                <a:solidFill>
-                  <a:schemeClr val="bg1"/>
-                </a:solidFill>
-              </a:rPr>
-              <a:t>3</a:t>
-            </a:r>
-            <a:endParaRPr lang="en-US" sz="2000" dirty="0"/>
-          </a:p>
-        </p:txBody>
-      </p:sp>
-      <p:sp>
-        <p:nvSpPr>
-          <p:cNvPr id="13" name="Text 10"/>
-          <p:cNvSpPr txBox="1"/>
-          <p:nvPr/>
-        </p:nvSpPr>
-        <p:spPr>
-          <a:xfrm>
-            <a:off x="1280160" y="3383280"/>
-            <a:ext cx="5577840" cy="548640"/>
-          </a:xfrm>
-          <a:prstGeom prst="rect">
-            <a:avLst/>
-          </a:prstGeom>
-          <a:noFill/>
-          <a:ln/>
-        </p:spPr>
-        <p:txBody>
-          <a:bodyPr wrap="square" lIns="0" tIns="0" rIns="0" bIns="0" rtlCol="0" anchor="ctr"/>
-          <a:lstStyle/>
-          <a:p>
-            <a:pPr indent="0" marL="0">
-              <a:buNone/>
-            </a:pPr>
-            <a:r>
-              <a:rPr lang="en-US" sz="1800" b="1" dirty="0">
-                <a:solidFill>
-                  <a:schemeClr val="tx1"/>
-                </a:solidFill>
-              </a:rPr>
-              <a:t>Culmination: </a:t>
-            </a:r>
-            <a:pPr indent="0" marL="0">
-              <a:buNone/>
-            </a:pPr>
-            <a:r>
-              <a:rPr lang="en-US" sz="1800" dirty="0">
-                <a:solidFill>
-                  <a:schemeClr val="tx1"/>
-                </a:solidFill>
-              </a:rPr>
-              <a:t>他切了橙子，但是[MASK]</a:t>
-            </a:r>
-            <a:endParaRPr lang="en-US" sz="1800" dirty="0"/>
-          </a:p>
-        </p:txBody>
-      </p:sp>
-      <p:sp>
-        <p:nvSpPr>
-          <p:cNvPr id="14" name="Shape 11"/>
-          <p:cNvSpPr/>
-          <p:nvPr/>
-        </p:nvSpPr>
-        <p:spPr>
-          <a:xfrm>
-            <a:off x="548640" y="4160520"/>
-            <a:ext cx="548640" cy="548640"/>
-          </a:xfrm>
-          <a:prstGeom prst="ellipse">
-            <a:avLst/>
-          </a:prstGeom>
-          <a:solidFill>
-            <a:schemeClr val="accent1"/>
-          </a:solidFill>
-          <a:ln/>
-        </p:spPr>
-      </p:sp>
-      <p:sp>
-        <p:nvSpPr>
-          <p:cNvPr id="15" name="Text 12"/>
-          <p:cNvSpPr txBox="1"/>
-          <p:nvPr/>
-        </p:nvSpPr>
-        <p:spPr>
-          <a:xfrm>
-            <a:off x="548640" y="4160520"/>
-            <a:ext cx="548640" cy="548640"/>
-          </a:xfrm>
-          <a:prstGeom prst="rect">
-            <a:avLst/>
-          </a:prstGeom>
-          <a:noFill/>
-          <a:ln/>
-        </p:spPr>
-        <p:txBody>
-          <a:bodyPr wrap="square" lIns="0" tIns="0" rIns="0" bIns="0" rtlCol="0" anchor="ctr"/>
-          <a:lstStyle/>
-          <a:p>
-            <a:pPr algn="ctr" indent="0" marL="0">
-              <a:buNone/>
-            </a:pPr>
-            <a:r>
-              <a:rPr lang="en-US" sz="2000" b="1" dirty="0">
-                <a:solidFill>
-                  <a:schemeClr val="bg1"/>
-                </a:solidFill>
-              </a:rPr>
-              <a:t>4</a:t>
-            </a:r>
-            <a:endParaRPr lang="en-US" sz="2000" dirty="0"/>
-          </a:p>
-        </p:txBody>
-      </p:sp>
-      <p:sp>
-        <p:nvSpPr>
-          <p:cNvPr id="16" name="Text 13"/>
-          <p:cNvSpPr txBox="1"/>
-          <p:nvPr/>
-        </p:nvSpPr>
-        <p:spPr>
-          <a:xfrm>
-            <a:off x="1280160" y="4160520"/>
-            <a:ext cx="5577840" cy="548640"/>
-          </a:xfrm>
-          <a:prstGeom prst="rect">
-            <a:avLst/>
-          </a:prstGeom>
-          <a:noFill/>
-          <a:ln/>
-        </p:spPr>
-        <p:txBody>
-          <a:bodyPr wrap="square" lIns="0" tIns="0" rIns="0" bIns="0" rtlCol="0" anchor="ctr"/>
-          <a:lstStyle/>
-          <a:p>
-            <a:pPr indent="0" marL="0">
-              <a:buNone/>
-            </a:pPr>
-            <a:r>
-              <a:rPr lang="en-US" sz="1800" dirty="0">
-                <a:solidFill>
-                  <a:schemeClr val="tx1"/>
-                </a:solidFill>
-              </a:rPr>
-              <a:t>Compare with my human data</a:t>
-            </a:r>
-            <a:endParaRPr lang="en-US" sz="1800" dirty="0"/>
-          </a:p>
-        </p:txBody>
-      </p:sp>
-      <p:sp>
-        <p:nvSpPr>
-          <p:cNvPr id="17" name="Shape 14"/>
-          <p:cNvSpPr/>
-          <p:nvPr/>
-        </p:nvSpPr>
-        <p:spPr>
-          <a:xfrm>
-            <a:off x="7223760" y="1371600"/>
-            <a:ext cx="4419295" cy="1783080"/>
+            <a:off x="548640" y="1783080"/>
+            <a:ext cx="5341468" cy="2148840"/>
           </a:xfrm>
           <a:prstGeom prst="roundRect">
             <a:avLst>
-              <a:gd name="adj" fmla="val 5128"/>
+              <a:gd name="adj" fmla="val 4255"/>
             </a:avLst>
           </a:prstGeom>
           <a:solidFill>
@@ -4538,14 +4148,14 @@
       </p:sp>
       <p:sp>
         <p:nvSpPr>
-          <p:cNvPr id="18" name="Text 15"/>
+          <p:cNvPr id="6" name="Text 3"/>
           <p:cNvSpPr txBox="1"/>
           <p:nvPr/>
         </p:nvSpPr>
         <p:spPr>
           <a:xfrm>
-            <a:off x="7452360" y="1554480"/>
-            <a:ext cx="3962095" cy="1417320"/>
+            <a:off x="777240" y="1965960"/>
+            <a:ext cx="4884268" cy="1783080"/>
           </a:xfrm>
           <a:prstGeom prst="rect">
             <a:avLst/>
@@ -4569,7 +4179,7 @@
                   <a:schemeClr val="tx2"/>
                 </a:solidFill>
               </a:rPr>
-              <a:t>Human benchmarks</a:t>
+              <a:t>Lexical level</a:t>
             </a:r>
             <a:endParaRPr lang="en-US" sz="1800" dirty="0"/>
           </a:p>
@@ -4586,7 +4196,7 @@
                   <a:schemeClr val="tx1"/>
                 </a:solidFill>
               </a:rPr>
-              <a:t>Exp 1 descriptions</a:t>
+              <a:t>She cut [MASK] orange.</a:t>
             </a:r>
             <a:endParaRPr lang="en-US" sz="1800" dirty="0"/>
           </a:p>
@@ -4603,7 +4213,7 @@
                   <a:schemeClr val="tx1"/>
                 </a:solidFill>
               </a:rPr>
-              <a:t>Adult result ratings</a:t>
+              <a:t>他把橙子搅[MASK]了</a:t>
             </a:r>
             <a:endParaRPr lang="en-US" sz="1800" dirty="0"/>
           </a:p>
@@ -4620,26 +4230,26 @@
                   <a:schemeClr val="tx1"/>
                 </a:solidFill>
               </a:rPr>
-              <a:t>Children’s judgments</a:t>
-            </a:r>
-            <a:endParaRPr lang="en-US" sz="1800" dirty="0"/>
-          </a:p>
-        </p:txBody>
-      </p:sp>
-      <p:sp>
-        <p:nvSpPr>
-          <p:cNvPr id="19" name="Shape 16"/>
+              <a:t>Score: a vs. some; result complement</a:t>
+            </a:r>
+            <a:endParaRPr lang="en-US" sz="1800" dirty="0"/>
+          </a:p>
+        </p:txBody>
+      </p:sp>
+      <p:sp>
+        <p:nvSpPr>
+          <p:cNvPr id="7" name="Shape 4"/>
           <p:cNvSpPr/>
           <p:nvPr/>
         </p:nvSpPr>
         <p:spPr>
           <a:xfrm>
-            <a:off x="7223760" y="3337560"/>
-            <a:ext cx="4419295" cy="1600200"/>
+            <a:off x="6301588" y="1783080"/>
+            <a:ext cx="5341468" cy="2148840"/>
           </a:xfrm>
           <a:prstGeom prst="roundRect">
             <a:avLst>
-              <a:gd name="adj" fmla="val 5714"/>
+              <a:gd name="adj" fmla="val 4255"/>
             </a:avLst>
           </a:prstGeom>
           <a:solidFill>
@@ -4650,14 +4260,14 @@
       </p:sp>
       <p:sp>
         <p:nvSpPr>
-          <p:cNvPr id="20" name="Text 17"/>
+          <p:cNvPr id="8" name="Text 5"/>
           <p:cNvSpPr txBox="1"/>
           <p:nvPr/>
         </p:nvSpPr>
         <p:spPr>
           <a:xfrm>
-            <a:off x="7452360" y="3520440"/>
-            <a:ext cx="3962095" cy="1234440"/>
+            <a:off x="6530188" y="1965960"/>
+            <a:ext cx="4884268" cy="1783080"/>
           </a:xfrm>
           <a:prstGeom prst="rect">
             <a:avLst/>
@@ -4678,10 +4288,10 @@
             <a:r>
               <a:rPr lang="en-US" sz="2200" b="1" dirty="0">
                 <a:solidFill>
-                  <a:schemeClr val="accent2"/>
-                </a:solidFill>
-              </a:rPr>
-              <a:t>Asks</a:t>
+                  <a:schemeClr val="tx2"/>
+                </a:solidFill>
+              </a:rPr>
+              <a:t>Predicate level</a:t>
             </a:r>
             <a:endParaRPr lang="en-US" sz="1800" dirty="0"/>
           </a:p>
@@ -4698,15 +4308,123 @@
                   <a:schemeClr val="tx1"/>
                 </a:solidFill>
               </a:rPr>
-              <a:t>Is text enough for language-specific event knowledge?</a:t>
-            </a:r>
-            <a:endParaRPr lang="en-US" sz="1800" dirty="0"/>
-          </a:p>
-        </p:txBody>
-      </p:sp>
-      <p:sp>
-        <p:nvSpPr>
-          <p:cNvPr id="21" name="Shape 18"/>
+              <a:t>cut an orange [MASK] two seconds</a:t>
+            </a:r>
+            <a:endParaRPr lang="en-US" sz="1800" dirty="0"/>
+          </a:p>
+          <a:p>
+            <a:pPr indent="0" marL="0">
+              <a:spcAft>
+                <a:spcPts val="600"/>
+              </a:spcAft>
+              <a:buNone/>
+            </a:pPr>
+            <a:r>
+              <a:rPr lang="en-US" sz="1800" dirty="0">
+                <a:solidFill>
+                  <a:schemeClr val="tx1"/>
+                </a:solidFill>
+              </a:rPr>
+              <a:t>他切了橙子，但是[MASK]</a:t>
+            </a:r>
+            <a:endParaRPr lang="en-US" sz="1800" dirty="0"/>
+          </a:p>
+          <a:p>
+            <a:pPr indent="0" marL="0">
+              <a:spcAft>
+                <a:spcPts val="600"/>
+              </a:spcAft>
+              <a:buNone/>
+            </a:pPr>
+            <a:r>
+              <a:rPr lang="en-US" sz="1800" dirty="0">
+                <a:solidFill>
+                  <a:schemeClr val="tx1"/>
+                </a:solidFill>
+              </a:rPr>
+              <a:t>Score: in vs. for; cancellation</a:t>
+            </a:r>
+            <a:endParaRPr lang="en-US" sz="1800" dirty="0"/>
+          </a:p>
+        </p:txBody>
+      </p:sp>
+      <p:sp>
+        <p:nvSpPr>
+          <p:cNvPr id="9" name="Shape 6"/>
+          <p:cNvSpPr/>
+          <p:nvPr/>
+        </p:nvSpPr>
+        <p:spPr>
+          <a:xfrm>
+            <a:off x="548640" y="4114800"/>
+            <a:ext cx="11094415" cy="914400"/>
+          </a:xfrm>
+          <a:prstGeom prst="roundRect">
+            <a:avLst>
+              <a:gd name="adj" fmla="val 10000"/>
+            </a:avLst>
+          </a:prstGeom>
+          <a:solidFill>
+            <a:schemeClr val="bg1"/>
+          </a:solidFill>
+          <a:ln w="25400">
+            <a:solidFill>
+              <a:schemeClr val="accent2"/>
+            </a:solidFill>
+            <a:prstDash val="solid"/>
+          </a:ln>
+        </p:spPr>
+      </p:sp>
+      <p:sp>
+        <p:nvSpPr>
+          <p:cNvPr id="10" name="Text 7"/>
+          <p:cNvSpPr txBox="1"/>
+          <p:nvPr/>
+        </p:nvSpPr>
+        <p:spPr>
+          <a:xfrm>
+            <a:off x="777240" y="4160520"/>
+            <a:ext cx="10637215" cy="822960"/>
+          </a:xfrm>
+          <a:prstGeom prst="rect">
+            <a:avLst/>
+          </a:prstGeom>
+          <a:noFill/>
+          <a:ln/>
+        </p:spPr>
+        <p:txBody>
+          <a:bodyPr wrap="square" lIns="0" tIns="0" rIns="0" bIns="0" rtlCol="0" anchor="ctr"/>
+          <a:lstStyle/>
+          <a:p>
+            <a:pPr indent="0" marL="0">
+              <a:buNone/>
+            </a:pPr>
+            <a:r>
+              <a:rPr lang="en-US" sz="1800" b="1" dirty="0">
+                <a:solidFill>
+                  <a:schemeClr val="accent2"/>
+                </a:solidFill>
+              </a:rPr>
+              <a:t>Key test   </a:t>
+            </a:r>
+            <a:pPr indent="0" marL="0">
+              <a:buNone/>
+            </a:pPr>
+            <a:r>
+              <a:rPr lang="en-US" sz="1800" dirty="0">
+                <a:solidFill>
+                  <a:schemeClr val="tx1"/>
+                </a:solidFill>
+              </a:rPr>
+              <a:t>Does the predicate choice flip when the lexical cue flips? (an orange vs. oranges; 切开 vs. 切)</a:t>
+            </a:r>
+            <a:endParaRPr lang="en-US" sz="1800" dirty="0"/>
+          </a:p>
+        </p:txBody>
+      </p:sp>
+      <p:sp>
+        <p:nvSpPr>
+          <p:cNvPr id="11" name="Shape 8"/>
           <p:cNvSpPr/>
           <p:nvPr/>
         </p:nvSpPr>
@@ -4728,7 +4446,7 @@
       </p:sp>
       <p:sp>
         <p:nvSpPr>
-          <p:cNvPr id="22" name="Text 19"/>
+          <p:cNvPr id="12" name="Text 9"/>
           <p:cNvSpPr txBox="1"/>
           <p:nvPr/>
         </p:nvSpPr>
@@ -4767,7 +4485,7 @@
                   <a:schemeClr val="tx1"/>
                 </a:solidFill>
               </a:rPr>
-              <a:t>Where models diverge from children shows what experience adds to text.</a:t>
+              <a:t>Human-like lexical but not predicate patterns = surface statistics, not event structure.</a:t>
             </a:r>
             <a:endParaRPr lang="en-US" sz="1800" dirty="0"/>
           </a:p>
@@ -7224,7 +6942,7 @@
                   <a:schemeClr val="tx2"/>
                 </a:solidFill>
               </a:rPr>
-              <a:t>Exp 1: The languages encode the same events differently</a:t>
+              <a:t>Exp 1: Languages differ at the lexical and predicate levels</a:t>
             </a:r>
             <a:endParaRPr lang="en-US" sz="3000" dirty="0"/>
           </a:p>
@@ -7413,7 +7131,7 @@
                   <a:schemeClr val="tx2"/>
                 </a:solidFill>
               </a:rPr>
-              <a:t>Quantized NPs (“an apple”)</a:t>
+              <a:t>Lexical: quantized NPs</a:t>
             </a:r>
             <a:endParaRPr lang="en-US" sz="1800" dirty="0"/>
           </a:p>
@@ -7491,7 +7209,7 @@
                   <a:schemeClr val="tx2"/>
                 </a:solidFill>
               </a:rPr>
-              <a:t>Resultatives in blending</a:t>
+              <a:t>Lexical: resultatives (blending)</a:t>
             </a:r>
             <a:endParaRPr lang="en-US" sz="1800" dirty="0"/>
           </a:p>
@@ -7577,7 +7295,7 @@
                   <a:schemeClr val="tx1"/>
                 </a:solidFill>
               </a:rPr>
-              <a:t>English marks the object and cutting endpoints; Mandarin marks result states.</a:t>
+              <a:t>The two languages differ at both levels, in different ways.</a:t>
             </a:r>
             <a:endParaRPr lang="en-US" sz="1800" dirty="0"/>
           </a:p>
@@ -8134,7 +7852,7 @@
                   <a:schemeClr val="tx1"/>
                 </a:solidFill>
               </a:rPr>
-              <a:t>Word-level contrasts match event phases; telicity matches endpoints.</a:t>
+              <a:t>Lexical level matches event phases; predicate level matches endpoints.</a:t>
             </a:r>
             <a:endParaRPr lang="en-US" sz="1800" dirty="0"/>
           </a:p>
@@ -9623,7 +9341,7 @@
                   <a:schemeClr val="tx2"/>
                 </a:solidFill>
               </a:rPr>
-              <a:t>Is linguistic input alone enough?</a:t>
+              <a:t>Does text alone yield both levels?</a:t>
             </a:r>
             <a:endParaRPr lang="en-US" sz="2200" dirty="0"/>
           </a:p>

</xml_diff>

<commit_message>
Use new event pairs and crossed two-level designs in Directions 1 and 2
Co-Authored-By: Claude Opus 5.5 <noreply@anthropic.com>
Claude-Session: https://claude.ai/code/session_011AaQxxgQ4HPadVVo3q9mgs
</commit_message>
<xml_diff>
--- a/Liu_postdoc_interview_talk.pptx
+++ b/Liu_postdoc_interview_talk.pptx
@@ -1266,10 +1266,10 @@
           <a:p>
             <a:r>
               <a:rPr lang="en-US" dirty="0"/>
-              <a:t>1. In the thesis, brief lexical and phrasal primes did not shift processing (BF₀₁ ≈ 1000). My own conclusion was to test sustained, task-relevant language instead.
-2. Design: pre-test, three training sessions, post-test. Mandarin children watch events described with result language (切开了, 搅碎了), action language (切一切, 搅一搅), or no language.
-3. Tests: boundary tapping and interruption detection on new videos, plus transfer to new event types such as peeling and folding.
-4. Prediction: result training moves endpoints toward the result state. Transfer to new event types would show that children learned “result” as a relation across events, which links to your work on relational learning.</a:t>
+              <a:t>1. In the thesis, brief primes did not shift processing. Direction 2 tests sustained training, keeping the two-level logic of Experiments 4 and 5 but crossing it.
+2. Mandarin children are trained at one level, lexical cues (一颗, 切成两块) or predicate cues (切开 vs. 切一切), and tested on both tasks, interruption detection for phases and boundary tapping for endpoints.
+3. Following the thesis conclusions: three sessions in which children use the words in the task, a check that they understood the cue, and counterbalanced baseline order.
+4. Prediction: each training shifts only its own level. Training on one event family (撕 / 揉) and testing on another (掰 / 压) asks whether children learned an abstract endpoint relation rather than a word.</a:t>
             </a:r>
             <a:endParaRPr lang="en-US" dirty="0"/>
           </a:p>
@@ -1448,8 +1448,8 @@
           <a:p>
             <a:r>
               <a:rPr lang="en-US" dirty="0"/>
-              <a:t>1. Year 1: the model study, which is fast and builds on existing stimuli, and the Mandarin child sample for Direction 1.
-2. Year 2: the English sample and follow-up for Direction 1, and the training study for Direction 2.
+              <a:t>1. Year 1: replicate Experiments 1–3 with adults on the new event pairs, which generalizes the thesis and validates materials for children; run the model study in parallel.
+2. Year 2: Direction 1 with children, and the training study for Direction 2.
 3. Throughout: publish the thesis papers, apply for funding, and mentor students.
 4. Together these move from correspondence to development, learning and input.</a:t>
             </a:r>
@@ -2267,10 +2267,10 @@
           <a:p>
             <a:r>
               <a:rPr lang="en-US" dirty="0"/>
-              <a:t>1. Mandarin- and English-speaking children aged 3–6 see the same cutting and blending videos as the adults in my thesis; the English sample can build on the center’s cross-cultural partners.
-2. Each child first describes the events, which gives an individual encoding profile: resultatives, quantized nouns, telic descriptions.
-3. Processing is measured with a child-friendly boundary task (“tap when it’s done”) and anticipatory looking to the end state, which also works for the youngest children.
-4. Key tests: the age at which group differences appear; whether a child’s own resultative use predicts endpoint placement beyond age and vocabulary; and a 6-month follow-up with a cross-lagged model to see whether language change comes before processing change.</a:t>
+              <a:t>1. New event pairs address the main limit of the thesis: only cutting and blending, with instrument and motion confounded. Each pair is hands-only, on the same object, one with a clear endpoint and one gradual, for example tearing paper in half versus crumpling it. Each pair is normed and described by adults first, to confirm that the lexical and predicate contrasts fall on different events.
+2. Mandarin- and English-speaking children aged 3–6; the English sample can build on the center’s cross-cultural partners.
+3. Each child describes the events, which gives an individual profile at both levels: resultatives and quantized nouns at the lexical level, telic descriptions at the predicate level. Processing uses child-friendly versions of my two tasks: press when the video “hiccups” for phases, press when it is “done” for endpoints; eye-tracking for the youngest children.
+4. Crossed prediction: a child’s lexical encoding should predict phase sensitivity but not endpoints; predicate telicity should predict endpoints but not phases. That is a double dissociation at the individual level, which the thesis could not test. A 6-month follow-up asks whether language change comes before processing change.</a:t>
             </a:r>
             <a:endParaRPr lang="en-US" dirty="0"/>
           </a:p>
@@ -3147,7 +3147,7 @@
                   <a:schemeClr val="tx2"/>
                 </a:solidFill>
               </a:rPr>
-              <a:t>Direction 2: Can sustained language change processing?</a:t>
+              <a:t>Direction 2: Can sustained training shift each level?</a:t>
             </a:r>
             <a:endParaRPr lang="en-US" sz="3000" dirty="0"/>
           </a:p>
@@ -3183,7 +3183,7 @@
                   <a:schemeClr val="tx2"/>
                 </a:solidFill>
               </a:rPr>
-              <a:t>Pre-test  ·  3 training sessions  ·  Post-test</a:t>
+              <a:t>Training level × test task</a:t>
             </a:r>
             <a:endParaRPr lang="en-US" sz="2200" dirty="0"/>
           </a:p>
@@ -3204,7 +3204,7 @@
           </p:nvPr>
         </p:nvGraphicFramePr>
         <p:xfrm>
-          <a:off x="548640" y="1828800"/>
+          <a:off x="548640" y="1783080"/>
           <a:ext cx="6309360" cy="914400"/>
         </p:xfrm>
         <a:graphic>
@@ -3212,10 +3212,11 @@
             <a:tbl>
               <a:tblPr/>
               <a:tblGrid>
-                <a:gridCol w="2377440"/>
-                <a:gridCol w="3931920"/>
+                <a:gridCol w="3200400"/>
+                <a:gridCol w="1554480"/>
+                <a:gridCol w="1554480"/>
               </a:tblGrid>
-              <a:tr h="457200">
+              <a:tr h="502920">
                 <a:tc>
                   <a:txBody>
                     <a:bodyPr/>
@@ -3230,7 +3231,7 @@
                             <a:schemeClr val="bg1"/>
                           </a:solidFill>
                         </a:rPr>
-                        <a:t>Training language</a:t>
+                        <a:t>Training</a:t>
                       </a:r>
                       <a:endParaRPr lang="en-US" sz="1800" dirty="0"/>
                     </a:p>
@@ -3291,7 +3292,68 @@
                             <a:schemeClr val="bg1"/>
                           </a:solidFill>
                         </a:rPr>
-                        <a:t>Example</a:t>
+                        <a:t>Phases</a:t>
+                      </a:r>
+                      <a:endParaRPr lang="en-US" sz="1800" dirty="0"/>
+                    </a:p>
+                  </a:txBody>
+                  <a:tcPr marL="73152" marR="73152" marT="73152" marB="73152" anchor="ctr">
+                    <a:lnL w="12700" cap="flat" cmpd="sng" algn="ctr">
+                      <a:solidFill>
+                        <a:srgbClr val="C9D6D3"/>
+                      </a:solidFill>
+                      <a:prstDash val="solid"/>
+                      <a:round/>
+                      <a:headEnd type="none" w="med" len="med"/>
+                      <a:tailEnd type="none" w="med" len="med"/>
+                    </a:lnL>
+                    <a:lnR w="12700" cap="flat" cmpd="sng" algn="ctr">
+                      <a:solidFill>
+                        <a:srgbClr val="C9D6D3"/>
+                      </a:solidFill>
+                      <a:prstDash val="solid"/>
+                      <a:round/>
+                      <a:headEnd type="none" w="med" len="med"/>
+                      <a:tailEnd type="none" w="med" len="med"/>
+                    </a:lnR>
+                    <a:lnT w="12700" cap="flat" cmpd="sng" algn="ctr">
+                      <a:solidFill>
+                        <a:srgbClr val="C9D6D3"/>
+                      </a:solidFill>
+                      <a:prstDash val="solid"/>
+                      <a:round/>
+                      <a:headEnd type="none" w="med" len="med"/>
+                      <a:tailEnd type="none" w="med" len="med"/>
+                    </a:lnT>
+                    <a:lnB w="12700" cap="flat" cmpd="sng" algn="ctr">
+                      <a:solidFill>
+                        <a:srgbClr val="C9D6D3"/>
+                      </a:solidFill>
+                      <a:prstDash val="solid"/>
+                      <a:round/>
+                      <a:headEnd type="none" w="med" len="med"/>
+                      <a:tailEnd type="none" w="med" len="med"/>
+                    </a:lnB>
+                    <a:solidFill>
+                      <a:schemeClr val="accent1"/>
+                    </a:solidFill>
+                  </a:tcPr>
+                </a:tc>
+                <a:tc>
+                  <a:txBody>
+                    <a:bodyPr/>
+                    <a:lstStyle/>
+                    <a:p>
+                      <a:pPr indent="0" marL="0">
+                        <a:buNone/>
+                      </a:pPr>
+                      <a:r>
+                        <a:rPr lang="en-US" sz="1800" b="1" dirty="0">
+                          <a:solidFill>
+                            <a:schemeClr val="bg1"/>
+                          </a:solidFill>
+                        </a:rPr>
+                        <a:t>Endpoints</a:t>
                       </a:r>
                       <a:endParaRPr lang="en-US" sz="1800" dirty="0"/>
                     </a:p>
@@ -3339,7 +3401,7 @@
                   </a:tcPr>
                 </a:tc>
               </a:tr>
-              <a:tr h="457200">
+              <a:tr h="502920">
                 <a:tc>
                   <a:txBody>
                     <a:bodyPr/>
@@ -3354,7 +3416,65 @@
                             <a:schemeClr val="tx1"/>
                           </a:solidFill>
                         </a:rPr>
-                        <a:t>Result</a:t>
+                        <a:t>Lexical: 一颗 · 切成两块</a:t>
+                      </a:r>
+                      <a:endParaRPr lang="en-US" sz="1800" dirty="0"/>
+                    </a:p>
+                  </a:txBody>
+                  <a:tcPr marL="73152" marR="73152" marT="73152" marB="73152" anchor="ctr">
+                    <a:lnL w="12700" cap="flat" cmpd="sng" algn="ctr">
+                      <a:solidFill>
+                        <a:srgbClr val="C9D6D3"/>
+                      </a:solidFill>
+                      <a:prstDash val="solid"/>
+                      <a:round/>
+                      <a:headEnd type="none" w="med" len="med"/>
+                      <a:tailEnd type="none" w="med" len="med"/>
+                    </a:lnL>
+                    <a:lnR w="12700" cap="flat" cmpd="sng" algn="ctr">
+                      <a:solidFill>
+                        <a:srgbClr val="C9D6D3"/>
+                      </a:solidFill>
+                      <a:prstDash val="solid"/>
+                      <a:round/>
+                      <a:headEnd type="none" w="med" len="med"/>
+                      <a:tailEnd type="none" w="med" len="med"/>
+                    </a:lnR>
+                    <a:lnT w="12700" cap="flat" cmpd="sng" algn="ctr">
+                      <a:solidFill>
+                        <a:srgbClr val="C9D6D3"/>
+                      </a:solidFill>
+                      <a:prstDash val="solid"/>
+                      <a:round/>
+                      <a:headEnd type="none" w="med" len="med"/>
+                      <a:tailEnd type="none" w="med" len="med"/>
+                    </a:lnT>
+                    <a:lnB w="12700" cap="flat" cmpd="sng" algn="ctr">
+                      <a:solidFill>
+                        <a:srgbClr val="C9D6D3"/>
+                      </a:solidFill>
+                      <a:prstDash val="solid"/>
+                      <a:round/>
+                      <a:headEnd type="none" w="med" len="med"/>
+                      <a:tailEnd type="none" w="med" len="med"/>
+                    </a:lnB>
+                  </a:tcPr>
+                </a:tc>
+                <a:tc>
+                  <a:txBody>
+                    <a:bodyPr/>
+                    <a:lstStyle/>
+                    <a:p>
+                      <a:pPr indent="0" marL="0">
+                        <a:buNone/>
+                      </a:pPr>
+                      <a:r>
+                        <a:rPr lang="en-US" sz="1800" b="1" dirty="0">
+                          <a:solidFill>
+                            <a:schemeClr val="accent2"/>
+                          </a:solidFill>
+                        </a:rPr>
+                        <a:t>Shift</a:t>
                       </a:r>
                       <a:endParaRPr lang="en-US" sz="1800" dirty="0"/>
                     </a:p>
@@ -3409,10 +3529,10 @@
                       <a:r>
                         <a:rPr lang="en-US" sz="1800" dirty="0">
                           <a:solidFill>
-                            <a:schemeClr val="tx1"/>
+                            <a:schemeClr val="accent3"/>
                           </a:solidFill>
                         </a:rPr>
-                        <a:t>切开了 · 搅碎了</a:t>
+                        <a:t>No shift</a:t>
                       </a:r>
                       <a:endParaRPr lang="en-US" sz="1800" dirty="0"/>
                     </a:p>
@@ -3457,7 +3577,7 @@
                   </a:tcPr>
                 </a:tc>
               </a:tr>
-              <a:tr h="457200">
+              <a:tr h="502920">
                 <a:tc>
                   <a:txBody>
                     <a:bodyPr/>
@@ -3472,7 +3592,7 @@
                             <a:schemeClr val="tx1"/>
                           </a:solidFill>
                         </a:rPr>
-                        <a:t>Action</a:t>
+                        <a:t>Predicate: 切开 · 切一切</a:t>
                       </a:r>
                       <a:endParaRPr lang="en-US" sz="1800" dirty="0"/>
                     </a:p>
@@ -3527,70 +3647,10 @@
                       <a:r>
                         <a:rPr lang="en-US" sz="1800" dirty="0">
                           <a:solidFill>
-                            <a:schemeClr val="tx1"/>
+                            <a:schemeClr val="accent3"/>
                           </a:solidFill>
                         </a:rPr>
-                        <a:t>切一切 · 搅一搅</a:t>
-                      </a:r>
-                      <a:endParaRPr lang="en-US" sz="1800" dirty="0"/>
-                    </a:p>
-                  </a:txBody>
-                  <a:tcPr marL="73152" marR="73152" marT="73152" marB="73152" anchor="ctr">
-                    <a:lnL w="12700" cap="flat" cmpd="sng" algn="ctr">
-                      <a:solidFill>
-                        <a:srgbClr val="C9D6D3"/>
-                      </a:solidFill>
-                      <a:prstDash val="solid"/>
-                      <a:round/>
-                      <a:headEnd type="none" w="med" len="med"/>
-                      <a:tailEnd type="none" w="med" len="med"/>
-                    </a:lnL>
-                    <a:lnR w="12700" cap="flat" cmpd="sng" algn="ctr">
-                      <a:solidFill>
-                        <a:srgbClr val="C9D6D3"/>
-                      </a:solidFill>
-                      <a:prstDash val="solid"/>
-                      <a:round/>
-                      <a:headEnd type="none" w="med" len="med"/>
-                      <a:tailEnd type="none" w="med" len="med"/>
-                    </a:lnR>
-                    <a:lnT w="12700" cap="flat" cmpd="sng" algn="ctr">
-                      <a:solidFill>
-                        <a:srgbClr val="C9D6D3"/>
-                      </a:solidFill>
-                      <a:prstDash val="solid"/>
-                      <a:round/>
-                      <a:headEnd type="none" w="med" len="med"/>
-                      <a:tailEnd type="none" w="med" len="med"/>
-                    </a:lnT>
-                    <a:lnB w="12700" cap="flat" cmpd="sng" algn="ctr">
-                      <a:solidFill>
-                        <a:srgbClr val="C9D6D3"/>
-                      </a:solidFill>
-                      <a:prstDash val="solid"/>
-                      <a:round/>
-                      <a:headEnd type="none" w="med" len="med"/>
-                      <a:tailEnd type="none" w="med" len="med"/>
-                    </a:lnB>
-                  </a:tcPr>
-                </a:tc>
-              </a:tr>
-              <a:tr h="457200">
-                <a:tc>
-                  <a:txBody>
-                    <a:bodyPr/>
-                    <a:lstStyle/>
-                    <a:p>
-                      <a:pPr indent="0" marL="0">
-                        <a:buNone/>
-                      </a:pPr>
-                      <a:r>
-                        <a:rPr lang="en-US" sz="1800" b="1" dirty="0">
-                          <a:solidFill>
-                            <a:schemeClr val="tx1"/>
-                          </a:solidFill>
-                        </a:rPr>
-                        <a:t>None</a:t>
+                        <a:t>No shift</a:t>
                       </a:r>
                       <a:endParaRPr lang="en-US" sz="1800" dirty="0"/>
                     </a:p>
@@ -3643,12 +3703,12 @@
                         <a:buNone/>
                       </a:pPr>
                       <a:r>
-                        <a:rPr lang="en-US" sz="1800" dirty="0">
+                        <a:rPr lang="en-US" sz="1800" b="1" dirty="0">
                           <a:solidFill>
-                            <a:schemeClr val="tx1"/>
+                            <a:schemeClr val="accent2"/>
                           </a:solidFill>
                         </a:rPr>
-                        <a:t>Same videos, no words</a:t>
+                        <a:t>Shift</a:t>
                       </a:r>
                       <a:endParaRPr lang="en-US" sz="1800" dirty="0"/>
                     </a:p>
@@ -3705,8 +3765,8 @@
         </p:nvSpPr>
         <p:spPr>
           <a:xfrm>
-            <a:off x="548640" y="3931920"/>
-            <a:ext cx="6309360" cy="1097280"/>
+            <a:off x="548640" y="3566160"/>
+            <a:ext cx="6309360" cy="1280160"/>
           </a:xfrm>
           <a:prstGeom prst="rect">
             <a:avLst/>
@@ -3720,7 +3780,7 @@
           <a:p>
             <a:pPr marL="342900" indent="-342900">
               <a:spcAft>
-                <a:spcPts val="800"/>
+                <a:spcPts val="1000"/>
               </a:spcAft>
               <a:buSzPct val="100000"/>
               <a:buChar char="•"/>
@@ -3731,14 +3791,14 @@
                   <a:schemeClr val="tx1"/>
                 </a:solidFill>
               </a:rPr>
-              <a:t>Test: boundary tapping and interruption detection</a:t>
+              <a:t>Three sessions; children use the words in the task</a:t>
             </a:r>
             <a:endParaRPr lang="en-US" sz="1800" dirty="0"/>
           </a:p>
           <a:p>
             <a:pPr marL="342900" indent="-342900">
               <a:spcAft>
-                <a:spcPts val="800"/>
+                <a:spcPts val="1000"/>
               </a:spcAft>
               <a:buSzPct val="100000"/>
               <a:buChar char="•"/>
@@ -3749,7 +3809,7 @@
                   <a:schemeClr val="tx1"/>
                 </a:solidFill>
               </a:rPr>
-              <a:t>Transfer to new event types (peel, fold)</a:t>
+              <a:t>Train on 撕 / 揉, test on 掰 / 压 (transfer)</a:t>
             </a:r>
             <a:endParaRPr lang="en-US" sz="1800" dirty="0"/>
           </a:p>
@@ -3764,11 +3824,11 @@
         <p:spPr>
           <a:xfrm>
             <a:off x="7223760" y="1371600"/>
-            <a:ext cx="4419295" cy="1600200"/>
+            <a:ext cx="4419295" cy="3566160"/>
           </a:xfrm>
           <a:prstGeom prst="roundRect">
             <a:avLst>
-              <a:gd name="adj" fmla="val 5714"/>
+              <a:gd name="adj" fmla="val 2564"/>
             </a:avLst>
           </a:prstGeom>
           <a:solidFill>
@@ -3786,7 +3846,7 @@
         <p:spPr>
           <a:xfrm>
             <a:off x="7452360" y="1554480"/>
-            <a:ext cx="3962095" cy="1234440"/>
+            <a:ext cx="3962095" cy="3200400"/>
           </a:xfrm>
           <a:prstGeom prst="rect">
             <a:avLst/>
@@ -3810,7 +3870,7 @@
                   <a:schemeClr val="tx2"/>
                 </a:solidFill>
               </a:rPr>
-              <a:t>Builds on</a:t>
+              <a:t>Fixes from the thesis</a:t>
             </a:r>
             <a:endParaRPr lang="en-US" sz="1800" dirty="0"/>
           </a:p>
@@ -3827,54 +3887,10 @@
                   <a:schemeClr val="tx1"/>
                 </a:solidFill>
               </a:rPr>
-              <a:t>Brief primes: no shift (BF₀₁ ≈ 1000)</a:t>
-            </a:r>
-            <a:endParaRPr lang="en-US" sz="1800" dirty="0"/>
-          </a:p>
-        </p:txBody>
-      </p:sp>
-      <p:sp>
-        <p:nvSpPr>
-          <p:cNvPr id="9" name="Shape 5"/>
-          <p:cNvSpPr/>
-          <p:nvPr/>
-        </p:nvSpPr>
-        <p:spPr>
-          <a:xfrm>
-            <a:off x="7223760" y="3154680"/>
-            <a:ext cx="4419295" cy="1783080"/>
-          </a:xfrm>
-          <a:prstGeom prst="roundRect">
-            <a:avLst>
-              <a:gd name="adj" fmla="val 5128"/>
-            </a:avLst>
-          </a:prstGeom>
-          <a:solidFill>
-            <a:schemeClr val="bg2"/>
-          </a:solidFill>
-          <a:ln/>
-        </p:spPr>
-      </p:sp>
-      <p:sp>
-        <p:nvSpPr>
-          <p:cNvPr id="10" name="Text 6"/>
-          <p:cNvSpPr txBox="1"/>
-          <p:nvPr/>
-        </p:nvSpPr>
-        <p:spPr>
-          <a:xfrm>
-            <a:off x="7452360" y="3337560"/>
-            <a:ext cx="3962095" cy="1417320"/>
-          </a:xfrm>
-          <a:prstGeom prst="rect">
-            <a:avLst/>
-          </a:prstGeom>
-          <a:noFill/>
-          <a:ln/>
-        </p:spPr>
-        <p:txBody>
-          <a:bodyPr wrap="square" lIns="0" tIns="0" rIns="0" bIns="0" rtlCol="0" anchor="t"/>
-          <a:lstStyle/>
+              <a:t>Sustained, task-relevant cues instead of brief primes</a:t>
+            </a:r>
+            <a:endParaRPr lang="en-US" sz="1800" dirty="0"/>
+          </a:p>
           <a:p>
             <a:pPr indent="0" marL="0">
               <a:spcAft>
@@ -3883,12 +3899,12 @@
               <a:buNone/>
             </a:pPr>
             <a:r>
-              <a:rPr lang="en-US" sz="2200" b="1" dirty="0">
-                <a:solidFill>
-                  <a:schemeClr val="accent2"/>
-                </a:solidFill>
-              </a:rPr>
-              <a:t>Prediction</a:t>
+              <a:rPr lang="en-US" sz="1800" dirty="0">
+                <a:solidFill>
+                  <a:schemeClr val="tx1"/>
+                </a:solidFill>
+              </a:rPr>
+              <a:t>Check that children understood the cue</a:t>
             </a:r>
             <a:endParaRPr lang="en-US" sz="1800" dirty="0"/>
           </a:p>
@@ -3905,15 +3921,15 @@
                   <a:schemeClr val="tx1"/>
                 </a:solidFill>
               </a:rPr>
-              <a:t>Result training moves endpoints and transfers to new events</a:t>
-            </a:r>
-            <a:endParaRPr lang="en-US" sz="1800" dirty="0"/>
-          </a:p>
-        </p:txBody>
-      </p:sp>
-      <p:sp>
-        <p:nvSpPr>
-          <p:cNvPr id="11" name="Shape 7"/>
+              <a:t>Counterbalanced baseline order</a:t>
+            </a:r>
+            <a:endParaRPr lang="en-US" sz="1800" dirty="0"/>
+          </a:p>
+        </p:txBody>
+      </p:sp>
+      <p:sp>
+        <p:nvSpPr>
+          <p:cNvPr id="9" name="Shape 5"/>
           <p:cNvSpPr/>
           <p:nvPr/>
         </p:nvSpPr>
@@ -3935,7 +3951,7 @@
       </p:sp>
       <p:sp>
         <p:nvSpPr>
-          <p:cNvPr id="12" name="Text 8"/>
+          <p:cNvPr id="10" name="Text 6"/>
           <p:cNvSpPr txBox="1"/>
           <p:nvPr/>
         </p:nvSpPr>
@@ -3974,7 +3990,7 @@
                   <a:schemeClr val="tx1"/>
                 </a:solidFill>
               </a:rPr>
-              <a:t>Transfer would show children learned “result” as a relation, not a word.</a:t>
+              <a:t>Each training should shift only its own level, and transfer to new events.</a:t>
             </a:r>
             <a:endParaRPr lang="en-US" sz="1800" dirty="0"/>
           </a:p>
@@ -4727,7 +4743,7 @@
                   <a:schemeClr val="tx1"/>
                 </a:solidFill>
               </a:rPr>
-              <a:t>Direction 3: model study</a:t>
+              <a:t>New events: adult replication</a:t>
             </a:r>
             <a:endParaRPr lang="en-US" sz="1800" dirty="0"/>
           </a:p>
@@ -4744,7 +4760,7 @@
                   <a:schemeClr val="tx1"/>
                 </a:solidFill>
               </a:rPr>
-              <a:t>Direction 1: Mandarin children</a:t>
+              <a:t>Direction 3: model study</a:t>
             </a:r>
             <a:endParaRPr lang="en-US" sz="1800" dirty="0"/>
           </a:p>
@@ -4895,7 +4911,7 @@
                   <a:schemeClr val="tx1"/>
                 </a:solidFill>
               </a:rPr>
-              <a:t>Direction 1: English sample, follow-up</a:t>
+              <a:t>Direction 1: children</a:t>
             </a:r>
             <a:endParaRPr lang="en-US" sz="1800" dirty="0"/>
           </a:p>
@@ -9587,7 +9603,7 @@
                   <a:schemeClr val="tx2"/>
                 </a:solidFill>
               </a:rPr>
-              <a:t>Direction 1: When does language shape event processing?</a:t>
+              <a:t>Direction 1: Two levels in children’s event processing</a:t>
             </a:r>
             <a:endParaRPr lang="en-US" sz="3000" dirty="0"/>
           </a:p>
@@ -9595,49 +9611,13 @@
       </p:sp>
       <p:sp>
         <p:nvSpPr>
-          <p:cNvPr id="4" name="Text 1"/>
-          <p:cNvSpPr txBox="1"/>
-          <p:nvPr/>
-        </p:nvSpPr>
-        <p:spPr>
-          <a:xfrm>
-            <a:off x="548640" y="1280160"/>
-            <a:ext cx="6309360" cy="411480"/>
-          </a:xfrm>
-          <a:prstGeom prst="rect">
-            <a:avLst/>
-          </a:prstGeom>
-          <a:noFill/>
-          <a:ln/>
-        </p:spPr>
-        <p:txBody>
-          <a:bodyPr wrap="square" lIns="0" tIns="0" rIns="0" bIns="0" rtlCol="0" anchor="t"/>
-          <a:lstStyle/>
-          <a:p>
-            <a:pPr indent="0" marL="0">
-              <a:buNone/>
-            </a:pPr>
-            <a:r>
-              <a:rPr lang="en-US" sz="2200" b="1" dirty="0">
-                <a:solidFill>
-                  <a:schemeClr val="tx2"/>
-                </a:solidFill>
-              </a:rPr>
-              <a:t>Design</a:t>
-            </a:r>
-            <a:endParaRPr lang="en-US" sz="2200" dirty="0"/>
-          </a:p>
-        </p:txBody>
-      </p:sp>
-      <p:sp>
-        <p:nvSpPr>
-          <p:cNvPr id="5" name="Shape 2"/>
+          <p:cNvPr id="4" name="Shape 1"/>
           <p:cNvSpPr/>
           <p:nvPr/>
         </p:nvSpPr>
         <p:spPr>
           <a:xfrm>
-            <a:off x="548640" y="1828800"/>
+            <a:off x="548640" y="1371600"/>
             <a:ext cx="548640" cy="548640"/>
           </a:xfrm>
           <a:prstGeom prst="ellipse">
@@ -9651,14 +9631,50 @@
       </p:sp>
       <p:sp>
         <p:nvSpPr>
+          <p:cNvPr id="5" name="Text 2"/>
+          <p:cNvSpPr txBox="1"/>
+          <p:nvPr/>
+        </p:nvSpPr>
+        <p:spPr>
+          <a:xfrm>
+            <a:off x="548640" y="1371600"/>
+            <a:ext cx="548640" cy="548640"/>
+          </a:xfrm>
+          <a:prstGeom prst="rect">
+            <a:avLst/>
+          </a:prstGeom>
+          <a:noFill/>
+          <a:ln/>
+        </p:spPr>
+        <p:txBody>
+          <a:bodyPr wrap="square" lIns="0" tIns="0" rIns="0" bIns="0" rtlCol="0" anchor="ctr"/>
+          <a:lstStyle/>
+          <a:p>
+            <a:pPr algn="ctr" indent="0" marL="0">
+              <a:buNone/>
+            </a:pPr>
+            <a:r>
+              <a:rPr lang="en-US" sz="2000" b="1" dirty="0">
+                <a:solidFill>
+                  <a:schemeClr val="bg1"/>
+                </a:solidFill>
+              </a:rPr>
+              <a:t>1</a:t>
+            </a:r>
+            <a:endParaRPr lang="en-US" sz="2000" dirty="0"/>
+          </a:p>
+        </p:txBody>
+      </p:sp>
+      <p:sp>
+        <p:nvSpPr>
           <p:cNvPr id="6" name="Text 3"/>
           <p:cNvSpPr txBox="1"/>
           <p:nvPr/>
         </p:nvSpPr>
         <p:spPr>
           <a:xfrm>
-            <a:off x="548640" y="1828800"/>
-            <a:ext cx="548640" cy="548640"/>
+            <a:off x="1280160" y="1280160"/>
+            <a:ext cx="5577840" cy="731520"/>
           </a:xfrm>
           <a:prstGeom prst="rect">
             <a:avLst/>
@@ -9670,42 +9686,6 @@
           <a:bodyPr wrap="square" lIns="0" tIns="0" rIns="0" bIns="0" rtlCol="0" anchor="ctr"/>
           <a:lstStyle/>
           <a:p>
-            <a:pPr algn="ctr" indent="0" marL="0">
-              <a:buNone/>
-            </a:pPr>
-            <a:r>
-              <a:rPr lang="en-US" sz="2000" b="1" dirty="0">
-                <a:solidFill>
-                  <a:schemeClr val="bg1"/>
-                </a:solidFill>
-              </a:rPr>
-              <a:t>1</a:t>
-            </a:r>
-            <a:endParaRPr lang="en-US" sz="2000" dirty="0"/>
-          </a:p>
-        </p:txBody>
-      </p:sp>
-      <p:sp>
-        <p:nvSpPr>
-          <p:cNvPr id="7" name="Text 4"/>
-          <p:cNvSpPr txBox="1"/>
-          <p:nvPr/>
-        </p:nvSpPr>
-        <p:spPr>
-          <a:xfrm>
-            <a:off x="1280160" y="1828800"/>
-            <a:ext cx="5577840" cy="548640"/>
-          </a:xfrm>
-          <a:prstGeom prst="rect">
-            <a:avLst/>
-          </a:prstGeom>
-          <a:noFill/>
-          <a:ln/>
-        </p:spPr>
-        <p:txBody>
-          <a:bodyPr wrap="square" lIns="0" tIns="0" rIns="0" bIns="0" rtlCol="0" anchor="ctr"/>
-          <a:lstStyle/>
-          <a:p>
             <a:pPr indent="0" marL="0">
               <a:buNone/>
             </a:pPr>
@@ -9715,21 +9695,21 @@
                   <a:schemeClr val="tx1"/>
                 </a:solidFill>
               </a:rPr>
-              <a:t>Mandarin and English children, ages 3–6</a:t>
-            </a:r>
-            <a:endParaRPr lang="en-US" sz="1800" dirty="0"/>
-          </a:p>
-        </p:txBody>
-      </p:sp>
-      <p:sp>
-        <p:nvSpPr>
-          <p:cNvPr id="8" name="Shape 5"/>
+              <a:t>New hands-only event pairs (撕开 vs. 揉皱)</a:t>
+            </a:r>
+            <a:endParaRPr lang="en-US" sz="1800" dirty="0"/>
+          </a:p>
+        </p:txBody>
+      </p:sp>
+      <p:sp>
+        <p:nvSpPr>
+          <p:cNvPr id="7" name="Shape 4"/>
           <p:cNvSpPr/>
           <p:nvPr/>
         </p:nvSpPr>
         <p:spPr>
           <a:xfrm>
-            <a:off x="548640" y="2606040"/>
+            <a:off x="548640" y="2240280"/>
             <a:ext cx="548640" cy="548640"/>
           </a:xfrm>
           <a:prstGeom prst="ellipse">
@@ -9743,14 +9723,50 @@
       </p:sp>
       <p:sp>
         <p:nvSpPr>
+          <p:cNvPr id="8" name="Text 5"/>
+          <p:cNvSpPr txBox="1"/>
+          <p:nvPr/>
+        </p:nvSpPr>
+        <p:spPr>
+          <a:xfrm>
+            <a:off x="548640" y="2240280"/>
+            <a:ext cx="548640" cy="548640"/>
+          </a:xfrm>
+          <a:prstGeom prst="rect">
+            <a:avLst/>
+          </a:prstGeom>
+          <a:noFill/>
+          <a:ln/>
+        </p:spPr>
+        <p:txBody>
+          <a:bodyPr wrap="square" lIns="0" tIns="0" rIns="0" bIns="0" rtlCol="0" anchor="ctr"/>
+          <a:lstStyle/>
+          <a:p>
+            <a:pPr algn="ctr" indent="0" marL="0">
+              <a:buNone/>
+            </a:pPr>
+            <a:r>
+              <a:rPr lang="en-US" sz="2000" b="1" dirty="0">
+                <a:solidFill>
+                  <a:schemeClr val="bg1"/>
+                </a:solidFill>
+              </a:rPr>
+              <a:t>2</a:t>
+            </a:r>
+            <a:endParaRPr lang="en-US" sz="2000" dirty="0"/>
+          </a:p>
+        </p:txBody>
+      </p:sp>
+      <p:sp>
+        <p:nvSpPr>
           <p:cNvPr id="9" name="Text 6"/>
           <p:cNvSpPr txBox="1"/>
           <p:nvPr/>
         </p:nvSpPr>
         <p:spPr>
           <a:xfrm>
-            <a:off x="548640" y="2606040"/>
-            <a:ext cx="548640" cy="548640"/>
+            <a:off x="1280160" y="2148840"/>
+            <a:ext cx="5577840" cy="731520"/>
           </a:xfrm>
           <a:prstGeom prst="rect">
             <a:avLst/>
@@ -9762,42 +9778,6 @@
           <a:bodyPr wrap="square" lIns="0" tIns="0" rIns="0" bIns="0" rtlCol="0" anchor="ctr"/>
           <a:lstStyle/>
           <a:p>
-            <a:pPr algn="ctr" indent="0" marL="0">
-              <a:buNone/>
-            </a:pPr>
-            <a:r>
-              <a:rPr lang="en-US" sz="2000" b="1" dirty="0">
-                <a:solidFill>
-                  <a:schemeClr val="bg1"/>
-                </a:solidFill>
-              </a:rPr>
-              <a:t>2</a:t>
-            </a:r>
-            <a:endParaRPr lang="en-US" sz="2000" dirty="0"/>
-          </a:p>
-        </p:txBody>
-      </p:sp>
-      <p:sp>
-        <p:nvSpPr>
-          <p:cNvPr id="10" name="Text 7"/>
-          <p:cNvSpPr txBox="1"/>
-          <p:nvPr/>
-        </p:nvSpPr>
-        <p:spPr>
-          <a:xfrm>
-            <a:off x="1280160" y="2606040"/>
-            <a:ext cx="5577840" cy="548640"/>
-          </a:xfrm>
-          <a:prstGeom prst="rect">
-            <a:avLst/>
-          </a:prstGeom>
-          <a:noFill/>
-          <a:ln/>
-        </p:spPr>
-        <p:txBody>
-          <a:bodyPr wrap="square" lIns="0" tIns="0" rIns="0" bIns="0" rtlCol="0" anchor="ctr"/>
-          <a:lstStyle/>
-          <a:p>
             <a:pPr indent="0" marL="0">
               <a:buNone/>
             </a:pPr>
@@ -9807,21 +9787,21 @@
                   <a:schemeClr val="tx1"/>
                 </a:solidFill>
               </a:rPr>
-              <a:t>Same cutting and blending videos</a:t>
-            </a:r>
-            <a:endParaRPr lang="en-US" sz="1800" dirty="0"/>
-          </a:p>
-        </p:txBody>
-      </p:sp>
-      <p:sp>
-        <p:nvSpPr>
-          <p:cNvPr id="11" name="Shape 8"/>
+              <a:t>Mandarin and English children, ages 3–6</a:t>
+            </a:r>
+            <a:endParaRPr lang="en-US" sz="1800" dirty="0"/>
+          </a:p>
+        </p:txBody>
+      </p:sp>
+      <p:sp>
+        <p:nvSpPr>
+          <p:cNvPr id="10" name="Shape 7"/>
           <p:cNvSpPr/>
           <p:nvPr/>
         </p:nvSpPr>
         <p:spPr>
           <a:xfrm>
-            <a:off x="548640" y="3383280"/>
+            <a:off x="548640" y="3108960"/>
             <a:ext cx="548640" cy="548640"/>
           </a:xfrm>
           <a:prstGeom prst="ellipse">
@@ -9835,14 +9815,50 @@
       </p:sp>
       <p:sp>
         <p:nvSpPr>
+          <p:cNvPr id="11" name="Text 8"/>
+          <p:cNvSpPr txBox="1"/>
+          <p:nvPr/>
+        </p:nvSpPr>
+        <p:spPr>
+          <a:xfrm>
+            <a:off x="548640" y="3108960"/>
+            <a:ext cx="548640" cy="548640"/>
+          </a:xfrm>
+          <a:prstGeom prst="rect">
+            <a:avLst/>
+          </a:prstGeom>
+          <a:noFill/>
+          <a:ln/>
+        </p:spPr>
+        <p:txBody>
+          <a:bodyPr wrap="square" lIns="0" tIns="0" rIns="0" bIns="0" rtlCol="0" anchor="ctr"/>
+          <a:lstStyle/>
+          <a:p>
+            <a:pPr algn="ctr" indent="0" marL="0">
+              <a:buNone/>
+            </a:pPr>
+            <a:r>
+              <a:rPr lang="en-US" sz="2000" b="1" dirty="0">
+                <a:solidFill>
+                  <a:schemeClr val="bg1"/>
+                </a:solidFill>
+              </a:rPr>
+              <a:t>3</a:t>
+            </a:r>
+            <a:endParaRPr lang="en-US" sz="2000" dirty="0"/>
+          </a:p>
+        </p:txBody>
+      </p:sp>
+      <p:sp>
+        <p:nvSpPr>
           <p:cNvPr id="12" name="Text 9"/>
           <p:cNvSpPr txBox="1"/>
           <p:nvPr/>
         </p:nvSpPr>
         <p:spPr>
           <a:xfrm>
-            <a:off x="548640" y="3383280"/>
-            <a:ext cx="548640" cy="548640"/>
+            <a:off x="1280160" y="3017520"/>
+            <a:ext cx="5577840" cy="731520"/>
           </a:xfrm>
           <a:prstGeom prst="rect">
             <a:avLst/>
@@ -9854,42 +9870,6 @@
           <a:bodyPr wrap="square" lIns="0" tIns="0" rIns="0" bIns="0" rtlCol="0" anchor="ctr"/>
           <a:lstStyle/>
           <a:p>
-            <a:pPr algn="ctr" indent="0" marL="0">
-              <a:buNone/>
-            </a:pPr>
-            <a:r>
-              <a:rPr lang="en-US" sz="2000" b="1" dirty="0">
-                <a:solidFill>
-                  <a:schemeClr val="bg1"/>
-                </a:solidFill>
-              </a:rPr>
-              <a:t>3</a:t>
-            </a:r>
-            <a:endParaRPr lang="en-US" sz="2000" dirty="0"/>
-          </a:p>
-        </p:txBody>
-      </p:sp>
-      <p:sp>
-        <p:nvSpPr>
-          <p:cNvPr id="13" name="Text 10"/>
-          <p:cNvSpPr txBox="1"/>
-          <p:nvPr/>
-        </p:nvSpPr>
-        <p:spPr>
-          <a:xfrm>
-            <a:off x="1280160" y="3383280"/>
-            <a:ext cx="5577840" cy="548640"/>
-          </a:xfrm>
-          <a:prstGeom prst="rect">
-            <a:avLst/>
-          </a:prstGeom>
-          <a:noFill/>
-          <a:ln/>
-        </p:spPr>
-        <p:txBody>
-          <a:bodyPr wrap="square" lIns="0" tIns="0" rIns="0" bIns="0" rtlCol="0" anchor="ctr"/>
-          <a:lstStyle/>
-          <a:p>
             <a:pPr indent="0" marL="0">
               <a:buNone/>
             </a:pPr>
@@ -9899,21 +9879,21 @@
                   <a:schemeClr val="tx1"/>
                 </a:solidFill>
               </a:rPr>
-              <a:t>Describe the events: each child’s encoding</a:t>
-            </a:r>
-            <a:endParaRPr lang="en-US" sz="1800" dirty="0"/>
-          </a:p>
-        </p:txBody>
-      </p:sp>
-      <p:sp>
-        <p:nvSpPr>
-          <p:cNvPr id="14" name="Shape 11"/>
+              <a:t>Describe: each child’s lexical and predicate encoding</a:t>
+            </a:r>
+            <a:endParaRPr lang="en-US" sz="1800" dirty="0"/>
+          </a:p>
+        </p:txBody>
+      </p:sp>
+      <p:sp>
+        <p:nvSpPr>
+          <p:cNvPr id="13" name="Shape 10"/>
           <p:cNvSpPr/>
           <p:nvPr/>
         </p:nvSpPr>
         <p:spPr>
           <a:xfrm>
-            <a:off x="548640" y="4160520"/>
+            <a:off x="548640" y="3977640"/>
             <a:ext cx="548640" cy="548640"/>
           </a:xfrm>
           <a:prstGeom prst="ellipse">
@@ -9927,14 +9907,50 @@
       </p:sp>
       <p:sp>
         <p:nvSpPr>
+          <p:cNvPr id="14" name="Text 11"/>
+          <p:cNvSpPr txBox="1"/>
+          <p:nvPr/>
+        </p:nvSpPr>
+        <p:spPr>
+          <a:xfrm>
+            <a:off x="548640" y="3977640"/>
+            <a:ext cx="548640" cy="548640"/>
+          </a:xfrm>
+          <a:prstGeom prst="rect">
+            <a:avLst/>
+          </a:prstGeom>
+          <a:noFill/>
+          <a:ln/>
+        </p:spPr>
+        <p:txBody>
+          <a:bodyPr wrap="square" lIns="0" tIns="0" rIns="0" bIns="0" rtlCol="0" anchor="ctr"/>
+          <a:lstStyle/>
+          <a:p>
+            <a:pPr algn="ctr" indent="0" marL="0">
+              <a:buNone/>
+            </a:pPr>
+            <a:r>
+              <a:rPr lang="en-US" sz="2000" b="1" dirty="0">
+                <a:solidFill>
+                  <a:schemeClr val="bg1"/>
+                </a:solidFill>
+              </a:rPr>
+              <a:t>4</a:t>
+            </a:r>
+            <a:endParaRPr lang="en-US" sz="2000" dirty="0"/>
+          </a:p>
+        </p:txBody>
+      </p:sp>
+      <p:sp>
+        <p:nvSpPr>
           <p:cNvPr id="15" name="Text 12"/>
           <p:cNvSpPr txBox="1"/>
           <p:nvPr/>
         </p:nvSpPr>
         <p:spPr>
           <a:xfrm>
-            <a:off x="548640" y="4160520"/>
-            <a:ext cx="548640" cy="548640"/>
+            <a:off x="1280160" y="3886200"/>
+            <a:ext cx="5577840" cy="731520"/>
           </a:xfrm>
           <a:prstGeom prst="rect">
             <a:avLst/>
@@ -9946,18 +9962,18 @@
           <a:bodyPr wrap="square" lIns="0" tIns="0" rIns="0" bIns="0" rtlCol="0" anchor="ctr"/>
           <a:lstStyle/>
           <a:p>
-            <a:pPr algn="ctr" indent="0" marL="0">
-              <a:buNone/>
-            </a:pPr>
-            <a:r>
-              <a:rPr lang="en-US" sz="2000" b="1" dirty="0">
-                <a:solidFill>
-                  <a:schemeClr val="bg1"/>
-                </a:solidFill>
-              </a:rPr>
-              <a:t>4</a:t>
-            </a:r>
-            <a:endParaRPr lang="en-US" sz="2000" dirty="0"/>
+            <a:pPr indent="0" marL="0">
+              <a:buNone/>
+            </a:pPr>
+            <a:r>
+              <a:rPr lang="en-US" sz="1800" dirty="0">
+                <a:solidFill>
+                  <a:schemeClr val="tx1"/>
+                </a:solidFill>
+              </a:rPr>
+              <a:t>“Hiccup” detection (phases) and “done” tapping (endpoints)</a:t>
+            </a:r>
+            <a:endParaRPr lang="en-US" sz="1800" dirty="0"/>
           </a:p>
         </p:txBody>
       </p:sp>
@@ -9969,8 +9985,8 @@
         </p:nvSpPr>
         <p:spPr>
           <a:xfrm>
-            <a:off x="1280160" y="4160520"/>
-            <a:ext cx="5577840" cy="548640"/>
+            <a:off x="7223760" y="1280160"/>
+            <a:ext cx="4419295" cy="411480"/>
           </a:xfrm>
           <a:prstGeom prst="rect">
             <a:avLst/>
@@ -9979,7 +9995,611 @@
           <a:ln/>
         </p:spPr>
         <p:txBody>
-          <a:bodyPr wrap="square" lIns="0" tIns="0" rIns="0" bIns="0" rtlCol="0" anchor="ctr"/>
+          <a:bodyPr wrap="square" lIns="0" tIns="0" rIns="0" bIns="0" rtlCol="0" anchor="t"/>
+          <a:lstStyle/>
+          <a:p>
+            <a:pPr indent="0" marL="0">
+              <a:buNone/>
+            </a:pPr>
+            <a:r>
+              <a:rPr lang="en-US" sz="2200" b="1" dirty="0">
+                <a:solidFill>
+                  <a:schemeClr val="accent2"/>
+                </a:solidFill>
+              </a:rPr>
+              <a:t>Crossed prediction</a:t>
+            </a:r>
+            <a:endParaRPr lang="en-US" sz="2200" dirty="0"/>
+          </a:p>
+        </p:txBody>
+      </p:sp>
+      <p:graphicFrame>
+        <p:nvGraphicFramePr>
+          <p:cNvPr id="10" name="Table 0"/>
+          <p:cNvGraphicFramePr>
+            <a:graphicFrameLocks noGrp="1"/>
+          </p:cNvGraphicFramePr>
+          <p:nvPr>
+            <p:extLst>
+              <p:ext uri="{D42A27DB-BD31-4B8C-83A1-F6EECF244321}">
+                <p14:modId xmlns:p14="http://schemas.microsoft.com/office/powerpoint/2010/main" val="1579011935"/>
+              </p:ext>
+            </p:extLst>
+          </p:nvPr>
+        </p:nvGraphicFramePr>
+        <p:xfrm>
+          <a:off x="7223760" y="1828800"/>
+          <a:ext cx="4419295" cy="914400"/>
+        </p:xfrm>
+        <a:graphic>
+          <a:graphicData uri="http://schemas.openxmlformats.org/drawingml/2006/table">
+            <a:tbl>
+              <a:tblPr/>
+              <a:tblGrid>
+                <a:gridCol w="1874520"/>
+                <a:gridCol w="1234440"/>
+                <a:gridCol w="1310335"/>
+              </a:tblGrid>
+              <a:tr h="502920">
+                <a:tc>
+                  <a:txBody>
+                    <a:bodyPr/>
+                    <a:lstStyle/>
+                    <a:p>
+                      <a:pPr algn="ctr" indent="0" marL="0">
+                        <a:buNone/>
+                      </a:pPr>
+                      <a:r>
+                        <a:rPr lang="en-US" sz="1800" b="1" dirty="0">
+                          <a:solidFill>
+                            <a:schemeClr val="bg1"/>
+                          </a:solidFill>
+                        </a:rPr>
+                        <a:t>Child’s encoding</a:t>
+                      </a:r>
+                      <a:endParaRPr lang="en-US" sz="1800" dirty="0"/>
+                    </a:p>
+                  </a:txBody>
+                  <a:tcPr marL="73152" marR="73152" marT="73152" marB="73152" anchor="ctr">
+                    <a:lnL w="12700" cap="flat" cmpd="sng" algn="ctr">
+                      <a:solidFill>
+                        <a:srgbClr val="C9D6D3"/>
+                      </a:solidFill>
+                      <a:prstDash val="solid"/>
+                      <a:round/>
+                      <a:headEnd type="none" w="med" len="med"/>
+                      <a:tailEnd type="none" w="med" len="med"/>
+                    </a:lnL>
+                    <a:lnR w="12700" cap="flat" cmpd="sng" algn="ctr">
+                      <a:solidFill>
+                        <a:srgbClr val="C9D6D3"/>
+                      </a:solidFill>
+                      <a:prstDash val="solid"/>
+                      <a:round/>
+                      <a:headEnd type="none" w="med" len="med"/>
+                      <a:tailEnd type="none" w="med" len="med"/>
+                    </a:lnR>
+                    <a:lnT w="12700" cap="flat" cmpd="sng" algn="ctr">
+                      <a:solidFill>
+                        <a:srgbClr val="C9D6D3"/>
+                      </a:solidFill>
+                      <a:prstDash val="solid"/>
+                      <a:round/>
+                      <a:headEnd type="none" w="med" len="med"/>
+                      <a:tailEnd type="none" w="med" len="med"/>
+                    </a:lnT>
+                    <a:lnB w="12700" cap="flat" cmpd="sng" algn="ctr">
+                      <a:solidFill>
+                        <a:srgbClr val="C9D6D3"/>
+                      </a:solidFill>
+                      <a:prstDash val="solid"/>
+                      <a:round/>
+                      <a:headEnd type="none" w="med" len="med"/>
+                      <a:tailEnd type="none" w="med" len="med"/>
+                    </a:lnB>
+                    <a:solidFill>
+                      <a:schemeClr val="accent1"/>
+                    </a:solidFill>
+                  </a:tcPr>
+                </a:tc>
+                <a:tc>
+                  <a:txBody>
+                    <a:bodyPr/>
+                    <a:lstStyle/>
+                    <a:p>
+                      <a:pPr algn="ctr" indent="0" marL="0">
+                        <a:buNone/>
+                      </a:pPr>
+                      <a:r>
+                        <a:rPr lang="en-US" sz="1800" b="1" dirty="0">
+                          <a:solidFill>
+                            <a:schemeClr val="bg1"/>
+                          </a:solidFill>
+                        </a:rPr>
+                        <a:t>Phases</a:t>
+                      </a:r>
+                      <a:endParaRPr lang="en-US" sz="1800" dirty="0"/>
+                    </a:p>
+                  </a:txBody>
+                  <a:tcPr marL="73152" marR="73152" marT="73152" marB="73152" anchor="ctr">
+                    <a:lnL w="12700" cap="flat" cmpd="sng" algn="ctr">
+                      <a:solidFill>
+                        <a:srgbClr val="C9D6D3"/>
+                      </a:solidFill>
+                      <a:prstDash val="solid"/>
+                      <a:round/>
+                      <a:headEnd type="none" w="med" len="med"/>
+                      <a:tailEnd type="none" w="med" len="med"/>
+                    </a:lnL>
+                    <a:lnR w="12700" cap="flat" cmpd="sng" algn="ctr">
+                      <a:solidFill>
+                        <a:srgbClr val="C9D6D3"/>
+                      </a:solidFill>
+                      <a:prstDash val="solid"/>
+                      <a:round/>
+                      <a:headEnd type="none" w="med" len="med"/>
+                      <a:tailEnd type="none" w="med" len="med"/>
+                    </a:lnR>
+                    <a:lnT w="12700" cap="flat" cmpd="sng" algn="ctr">
+                      <a:solidFill>
+                        <a:srgbClr val="C9D6D3"/>
+                      </a:solidFill>
+                      <a:prstDash val="solid"/>
+                      <a:round/>
+                      <a:headEnd type="none" w="med" len="med"/>
+                      <a:tailEnd type="none" w="med" len="med"/>
+                    </a:lnT>
+                    <a:lnB w="12700" cap="flat" cmpd="sng" algn="ctr">
+                      <a:solidFill>
+                        <a:srgbClr val="C9D6D3"/>
+                      </a:solidFill>
+                      <a:prstDash val="solid"/>
+                      <a:round/>
+                      <a:headEnd type="none" w="med" len="med"/>
+                      <a:tailEnd type="none" w="med" len="med"/>
+                    </a:lnB>
+                    <a:solidFill>
+                      <a:schemeClr val="accent1"/>
+                    </a:solidFill>
+                  </a:tcPr>
+                </a:tc>
+                <a:tc>
+                  <a:txBody>
+                    <a:bodyPr/>
+                    <a:lstStyle/>
+                    <a:p>
+                      <a:pPr algn="ctr" indent="0" marL="0">
+                        <a:buNone/>
+                      </a:pPr>
+                      <a:r>
+                        <a:rPr lang="en-US" sz="1800" b="1" dirty="0">
+                          <a:solidFill>
+                            <a:schemeClr val="bg1"/>
+                          </a:solidFill>
+                        </a:rPr>
+                        <a:t>Endpoints</a:t>
+                      </a:r>
+                      <a:endParaRPr lang="en-US" sz="1800" dirty="0"/>
+                    </a:p>
+                  </a:txBody>
+                  <a:tcPr marL="73152" marR="73152" marT="73152" marB="73152" anchor="ctr">
+                    <a:lnL w="12700" cap="flat" cmpd="sng" algn="ctr">
+                      <a:solidFill>
+                        <a:srgbClr val="C9D6D3"/>
+                      </a:solidFill>
+                      <a:prstDash val="solid"/>
+                      <a:round/>
+                      <a:headEnd type="none" w="med" len="med"/>
+                      <a:tailEnd type="none" w="med" len="med"/>
+                    </a:lnL>
+                    <a:lnR w="12700" cap="flat" cmpd="sng" algn="ctr">
+                      <a:solidFill>
+                        <a:srgbClr val="C9D6D3"/>
+                      </a:solidFill>
+                      <a:prstDash val="solid"/>
+                      <a:round/>
+                      <a:headEnd type="none" w="med" len="med"/>
+                      <a:tailEnd type="none" w="med" len="med"/>
+                    </a:lnR>
+                    <a:lnT w="12700" cap="flat" cmpd="sng" algn="ctr">
+                      <a:solidFill>
+                        <a:srgbClr val="C9D6D3"/>
+                      </a:solidFill>
+                      <a:prstDash val="solid"/>
+                      <a:round/>
+                      <a:headEnd type="none" w="med" len="med"/>
+                      <a:tailEnd type="none" w="med" len="med"/>
+                    </a:lnT>
+                    <a:lnB w="12700" cap="flat" cmpd="sng" algn="ctr">
+                      <a:solidFill>
+                        <a:srgbClr val="C9D6D3"/>
+                      </a:solidFill>
+                      <a:prstDash val="solid"/>
+                      <a:round/>
+                      <a:headEnd type="none" w="med" len="med"/>
+                      <a:tailEnd type="none" w="med" len="med"/>
+                    </a:lnB>
+                    <a:solidFill>
+                      <a:schemeClr val="accent1"/>
+                    </a:solidFill>
+                  </a:tcPr>
+                </a:tc>
+              </a:tr>
+              <a:tr h="502920">
+                <a:tc>
+                  <a:txBody>
+                    <a:bodyPr/>
+                    <a:lstStyle/>
+                    <a:p>
+                      <a:pPr algn="ctr" indent="0" marL="0">
+                        <a:buNone/>
+                      </a:pPr>
+                      <a:r>
+                        <a:rPr lang="en-US" sz="1800" b="1" dirty="0">
+                          <a:solidFill>
+                            <a:schemeClr val="tx1"/>
+                          </a:solidFill>
+                        </a:rPr>
+                        <a:t>Lexical</a:t>
+                      </a:r>
+                      <a:endParaRPr lang="en-US" sz="1800" dirty="0"/>
+                    </a:p>
+                  </a:txBody>
+                  <a:tcPr marL="73152" marR="73152" marT="73152" marB="73152" anchor="ctr">
+                    <a:lnL w="12700" cap="flat" cmpd="sng" algn="ctr">
+                      <a:solidFill>
+                        <a:srgbClr val="C9D6D3"/>
+                      </a:solidFill>
+                      <a:prstDash val="solid"/>
+                      <a:round/>
+                      <a:headEnd type="none" w="med" len="med"/>
+                      <a:tailEnd type="none" w="med" len="med"/>
+                    </a:lnL>
+                    <a:lnR w="12700" cap="flat" cmpd="sng" algn="ctr">
+                      <a:solidFill>
+                        <a:srgbClr val="C9D6D3"/>
+                      </a:solidFill>
+                      <a:prstDash val="solid"/>
+                      <a:round/>
+                      <a:headEnd type="none" w="med" len="med"/>
+                      <a:tailEnd type="none" w="med" len="med"/>
+                    </a:lnR>
+                    <a:lnT w="12700" cap="flat" cmpd="sng" algn="ctr">
+                      <a:solidFill>
+                        <a:srgbClr val="C9D6D3"/>
+                      </a:solidFill>
+                      <a:prstDash val="solid"/>
+                      <a:round/>
+                      <a:headEnd type="none" w="med" len="med"/>
+                      <a:tailEnd type="none" w="med" len="med"/>
+                    </a:lnT>
+                    <a:lnB w="12700" cap="flat" cmpd="sng" algn="ctr">
+                      <a:solidFill>
+                        <a:srgbClr val="C9D6D3"/>
+                      </a:solidFill>
+                      <a:prstDash val="solid"/>
+                      <a:round/>
+                      <a:headEnd type="none" w="med" len="med"/>
+                      <a:tailEnd type="none" w="med" len="med"/>
+                    </a:lnB>
+                  </a:tcPr>
+                </a:tc>
+                <a:tc>
+                  <a:txBody>
+                    <a:bodyPr/>
+                    <a:lstStyle/>
+                    <a:p>
+                      <a:pPr algn="ctr" indent="0" marL="0">
+                        <a:buNone/>
+                      </a:pPr>
+                      <a:r>
+                        <a:rPr lang="en-US" sz="1800" b="1" dirty="0">
+                          <a:solidFill>
+                            <a:schemeClr val="accent2"/>
+                          </a:solidFill>
+                        </a:rPr>
+                        <a:t>Yes</a:t>
+                      </a:r>
+                      <a:endParaRPr lang="en-US" sz="1800" dirty="0"/>
+                    </a:p>
+                  </a:txBody>
+                  <a:tcPr marL="73152" marR="73152" marT="73152" marB="73152" anchor="ctr">
+                    <a:lnL w="12700" cap="flat" cmpd="sng" algn="ctr">
+                      <a:solidFill>
+                        <a:srgbClr val="C9D6D3"/>
+                      </a:solidFill>
+                      <a:prstDash val="solid"/>
+                      <a:round/>
+                      <a:headEnd type="none" w="med" len="med"/>
+                      <a:tailEnd type="none" w="med" len="med"/>
+                    </a:lnL>
+                    <a:lnR w="12700" cap="flat" cmpd="sng" algn="ctr">
+                      <a:solidFill>
+                        <a:srgbClr val="C9D6D3"/>
+                      </a:solidFill>
+                      <a:prstDash val="solid"/>
+                      <a:round/>
+                      <a:headEnd type="none" w="med" len="med"/>
+                      <a:tailEnd type="none" w="med" len="med"/>
+                    </a:lnR>
+                    <a:lnT w="12700" cap="flat" cmpd="sng" algn="ctr">
+                      <a:solidFill>
+                        <a:srgbClr val="C9D6D3"/>
+                      </a:solidFill>
+                      <a:prstDash val="solid"/>
+                      <a:round/>
+                      <a:headEnd type="none" w="med" len="med"/>
+                      <a:tailEnd type="none" w="med" len="med"/>
+                    </a:lnT>
+                    <a:lnB w="12700" cap="flat" cmpd="sng" algn="ctr">
+                      <a:solidFill>
+                        <a:srgbClr val="C9D6D3"/>
+                      </a:solidFill>
+                      <a:prstDash val="solid"/>
+                      <a:round/>
+                      <a:headEnd type="none" w="med" len="med"/>
+                      <a:tailEnd type="none" w="med" len="med"/>
+                    </a:lnB>
+                  </a:tcPr>
+                </a:tc>
+                <a:tc>
+                  <a:txBody>
+                    <a:bodyPr/>
+                    <a:lstStyle/>
+                    <a:p>
+                      <a:pPr algn="ctr" indent="0" marL="0">
+                        <a:buNone/>
+                      </a:pPr>
+                      <a:r>
+                        <a:rPr lang="en-US" sz="1800" dirty="0">
+                          <a:solidFill>
+                            <a:schemeClr val="accent3"/>
+                          </a:solidFill>
+                        </a:rPr>
+                        <a:t>No</a:t>
+                      </a:r>
+                      <a:endParaRPr lang="en-US" sz="1800" dirty="0"/>
+                    </a:p>
+                  </a:txBody>
+                  <a:tcPr marL="73152" marR="73152" marT="73152" marB="73152" anchor="ctr">
+                    <a:lnL w="12700" cap="flat" cmpd="sng" algn="ctr">
+                      <a:solidFill>
+                        <a:srgbClr val="C9D6D3"/>
+                      </a:solidFill>
+                      <a:prstDash val="solid"/>
+                      <a:round/>
+                      <a:headEnd type="none" w="med" len="med"/>
+                      <a:tailEnd type="none" w="med" len="med"/>
+                    </a:lnL>
+                    <a:lnR w="12700" cap="flat" cmpd="sng" algn="ctr">
+                      <a:solidFill>
+                        <a:srgbClr val="C9D6D3"/>
+                      </a:solidFill>
+                      <a:prstDash val="solid"/>
+                      <a:round/>
+                      <a:headEnd type="none" w="med" len="med"/>
+                      <a:tailEnd type="none" w="med" len="med"/>
+                    </a:lnR>
+                    <a:lnT w="12700" cap="flat" cmpd="sng" algn="ctr">
+                      <a:solidFill>
+                        <a:srgbClr val="C9D6D3"/>
+                      </a:solidFill>
+                      <a:prstDash val="solid"/>
+                      <a:round/>
+                      <a:headEnd type="none" w="med" len="med"/>
+                      <a:tailEnd type="none" w="med" len="med"/>
+                    </a:lnT>
+                    <a:lnB w="12700" cap="flat" cmpd="sng" algn="ctr">
+                      <a:solidFill>
+                        <a:srgbClr val="C9D6D3"/>
+                      </a:solidFill>
+                      <a:prstDash val="solid"/>
+                      <a:round/>
+                      <a:headEnd type="none" w="med" len="med"/>
+                      <a:tailEnd type="none" w="med" len="med"/>
+                    </a:lnB>
+                  </a:tcPr>
+                </a:tc>
+              </a:tr>
+              <a:tr h="502920">
+                <a:tc>
+                  <a:txBody>
+                    <a:bodyPr/>
+                    <a:lstStyle/>
+                    <a:p>
+                      <a:pPr algn="ctr" indent="0" marL="0">
+                        <a:buNone/>
+                      </a:pPr>
+                      <a:r>
+                        <a:rPr lang="en-US" sz="1800" b="1" dirty="0">
+                          <a:solidFill>
+                            <a:schemeClr val="tx1"/>
+                          </a:solidFill>
+                        </a:rPr>
+                        <a:t>Predicate</a:t>
+                      </a:r>
+                      <a:endParaRPr lang="en-US" sz="1800" dirty="0"/>
+                    </a:p>
+                  </a:txBody>
+                  <a:tcPr marL="73152" marR="73152" marT="73152" marB="73152" anchor="ctr">
+                    <a:lnL w="12700" cap="flat" cmpd="sng" algn="ctr">
+                      <a:solidFill>
+                        <a:srgbClr val="C9D6D3"/>
+                      </a:solidFill>
+                      <a:prstDash val="solid"/>
+                      <a:round/>
+                      <a:headEnd type="none" w="med" len="med"/>
+                      <a:tailEnd type="none" w="med" len="med"/>
+                    </a:lnL>
+                    <a:lnR w="12700" cap="flat" cmpd="sng" algn="ctr">
+                      <a:solidFill>
+                        <a:srgbClr val="C9D6D3"/>
+                      </a:solidFill>
+                      <a:prstDash val="solid"/>
+                      <a:round/>
+                      <a:headEnd type="none" w="med" len="med"/>
+                      <a:tailEnd type="none" w="med" len="med"/>
+                    </a:lnR>
+                    <a:lnT w="12700" cap="flat" cmpd="sng" algn="ctr">
+                      <a:solidFill>
+                        <a:srgbClr val="C9D6D3"/>
+                      </a:solidFill>
+                      <a:prstDash val="solid"/>
+                      <a:round/>
+                      <a:headEnd type="none" w="med" len="med"/>
+                      <a:tailEnd type="none" w="med" len="med"/>
+                    </a:lnT>
+                    <a:lnB w="12700" cap="flat" cmpd="sng" algn="ctr">
+                      <a:solidFill>
+                        <a:srgbClr val="C9D6D3"/>
+                      </a:solidFill>
+                      <a:prstDash val="solid"/>
+                      <a:round/>
+                      <a:headEnd type="none" w="med" len="med"/>
+                      <a:tailEnd type="none" w="med" len="med"/>
+                    </a:lnB>
+                  </a:tcPr>
+                </a:tc>
+                <a:tc>
+                  <a:txBody>
+                    <a:bodyPr/>
+                    <a:lstStyle/>
+                    <a:p>
+                      <a:pPr algn="ctr" indent="0" marL="0">
+                        <a:buNone/>
+                      </a:pPr>
+                      <a:r>
+                        <a:rPr lang="en-US" sz="1800" dirty="0">
+                          <a:solidFill>
+                            <a:schemeClr val="accent3"/>
+                          </a:solidFill>
+                        </a:rPr>
+                        <a:t>No</a:t>
+                      </a:r>
+                      <a:endParaRPr lang="en-US" sz="1800" dirty="0"/>
+                    </a:p>
+                  </a:txBody>
+                  <a:tcPr marL="73152" marR="73152" marT="73152" marB="73152" anchor="ctr">
+                    <a:lnL w="12700" cap="flat" cmpd="sng" algn="ctr">
+                      <a:solidFill>
+                        <a:srgbClr val="C9D6D3"/>
+                      </a:solidFill>
+                      <a:prstDash val="solid"/>
+                      <a:round/>
+                      <a:headEnd type="none" w="med" len="med"/>
+                      <a:tailEnd type="none" w="med" len="med"/>
+                    </a:lnL>
+                    <a:lnR w="12700" cap="flat" cmpd="sng" algn="ctr">
+                      <a:solidFill>
+                        <a:srgbClr val="C9D6D3"/>
+                      </a:solidFill>
+                      <a:prstDash val="solid"/>
+                      <a:round/>
+                      <a:headEnd type="none" w="med" len="med"/>
+                      <a:tailEnd type="none" w="med" len="med"/>
+                    </a:lnR>
+                    <a:lnT w="12700" cap="flat" cmpd="sng" algn="ctr">
+                      <a:solidFill>
+                        <a:srgbClr val="C9D6D3"/>
+                      </a:solidFill>
+                      <a:prstDash val="solid"/>
+                      <a:round/>
+                      <a:headEnd type="none" w="med" len="med"/>
+                      <a:tailEnd type="none" w="med" len="med"/>
+                    </a:lnT>
+                    <a:lnB w="12700" cap="flat" cmpd="sng" algn="ctr">
+                      <a:solidFill>
+                        <a:srgbClr val="C9D6D3"/>
+                      </a:solidFill>
+                      <a:prstDash val="solid"/>
+                      <a:round/>
+                      <a:headEnd type="none" w="med" len="med"/>
+                      <a:tailEnd type="none" w="med" len="med"/>
+                    </a:lnB>
+                  </a:tcPr>
+                </a:tc>
+                <a:tc>
+                  <a:txBody>
+                    <a:bodyPr/>
+                    <a:lstStyle/>
+                    <a:p>
+                      <a:pPr algn="ctr" indent="0" marL="0">
+                        <a:buNone/>
+                      </a:pPr>
+                      <a:r>
+                        <a:rPr lang="en-US" sz="1800" b="1" dirty="0">
+                          <a:solidFill>
+                            <a:schemeClr val="accent2"/>
+                          </a:solidFill>
+                        </a:rPr>
+                        <a:t>Yes</a:t>
+                      </a:r>
+                      <a:endParaRPr lang="en-US" sz="1800" dirty="0"/>
+                    </a:p>
+                  </a:txBody>
+                  <a:tcPr marL="73152" marR="73152" marT="73152" marB="73152" anchor="ctr">
+                    <a:lnL w="12700" cap="flat" cmpd="sng" algn="ctr">
+                      <a:solidFill>
+                        <a:srgbClr val="C9D6D3"/>
+                      </a:solidFill>
+                      <a:prstDash val="solid"/>
+                      <a:round/>
+                      <a:headEnd type="none" w="med" len="med"/>
+                      <a:tailEnd type="none" w="med" len="med"/>
+                    </a:lnL>
+                    <a:lnR w="12700" cap="flat" cmpd="sng" algn="ctr">
+                      <a:solidFill>
+                        <a:srgbClr val="C9D6D3"/>
+                      </a:solidFill>
+                      <a:prstDash val="solid"/>
+                      <a:round/>
+                      <a:headEnd type="none" w="med" len="med"/>
+                      <a:tailEnd type="none" w="med" len="med"/>
+                    </a:lnR>
+                    <a:lnT w="12700" cap="flat" cmpd="sng" algn="ctr">
+                      <a:solidFill>
+                        <a:srgbClr val="C9D6D3"/>
+                      </a:solidFill>
+                      <a:prstDash val="solid"/>
+                      <a:round/>
+                      <a:headEnd type="none" w="med" len="med"/>
+                      <a:tailEnd type="none" w="med" len="med"/>
+                    </a:lnT>
+                    <a:lnB w="12700" cap="flat" cmpd="sng" algn="ctr">
+                      <a:solidFill>
+                        <a:srgbClr val="C9D6D3"/>
+                      </a:solidFill>
+                      <a:prstDash val="solid"/>
+                      <a:round/>
+                      <a:headEnd type="none" w="med" len="med"/>
+                      <a:tailEnd type="none" w="med" len="med"/>
+                    </a:lnB>
+                  </a:tcPr>
+                </a:tc>
+              </a:tr>
+            </a:tbl>
+          </a:graphicData>
+        </a:graphic>
+      </p:graphicFrame>
+      <p:sp>
+        <p:nvSpPr>
+          <p:cNvPr id="18" name="Text 14"/>
+          <p:cNvSpPr txBox="1"/>
+          <p:nvPr/>
+        </p:nvSpPr>
+        <p:spPr>
+          <a:xfrm>
+            <a:off x="7223760" y="3566160"/>
+            <a:ext cx="4419295" cy="914400"/>
+          </a:xfrm>
+          <a:prstGeom prst="rect">
+            <a:avLst/>
+          </a:prstGeom>
+          <a:noFill/>
+          <a:ln/>
+        </p:spPr>
+        <p:txBody>
+          <a:bodyPr wrap="square" lIns="0" tIns="0" rIns="0" bIns="0" rtlCol="0" anchor="t"/>
           <a:lstStyle/>
           <a:p>
             <a:pPr indent="0" marL="0">
@@ -9991,127 +10611,15 @@
                   <a:schemeClr val="tx1"/>
                 </a:solidFill>
               </a:rPr>
-              <a:t>Tap “when it’s done” and anticipatory looking</a:t>
-            </a:r>
-            <a:endParaRPr lang="en-US" sz="1800" dirty="0"/>
-          </a:p>
-        </p:txBody>
-      </p:sp>
-      <p:sp>
-        <p:nvSpPr>
-          <p:cNvPr id="17" name="Shape 14"/>
-          <p:cNvSpPr/>
-          <p:nvPr/>
-        </p:nvSpPr>
-        <p:spPr>
-          <a:xfrm>
-            <a:off x="7223760" y="1371600"/>
-            <a:ext cx="4419295" cy="3566160"/>
-          </a:xfrm>
-          <a:prstGeom prst="roundRect">
-            <a:avLst>
-              <a:gd name="adj" fmla="val 2564"/>
-            </a:avLst>
-          </a:prstGeom>
-          <a:solidFill>
-            <a:schemeClr val="bg2"/>
-          </a:solidFill>
-          <a:ln/>
-        </p:spPr>
-      </p:sp>
-      <p:sp>
-        <p:nvSpPr>
-          <p:cNvPr id="18" name="Text 15"/>
-          <p:cNvSpPr txBox="1"/>
-          <p:nvPr/>
-        </p:nvSpPr>
-        <p:spPr>
-          <a:xfrm>
-            <a:off x="7452360" y="1554480"/>
-            <a:ext cx="3962095" cy="3200400"/>
-          </a:xfrm>
-          <a:prstGeom prst="rect">
-            <a:avLst/>
-          </a:prstGeom>
-          <a:noFill/>
-          <a:ln/>
-        </p:spPr>
-        <p:txBody>
-          <a:bodyPr wrap="square" lIns="0" tIns="0" rIns="0" bIns="0" rtlCol="0" anchor="t"/>
-          <a:lstStyle/>
-          <a:p>
-            <a:pPr indent="0" marL="0">
-              <a:spcAft>
-                <a:spcPts val="600"/>
-              </a:spcAft>
-              <a:buNone/>
-            </a:pPr>
-            <a:r>
-              <a:rPr lang="en-US" sz="2200" b="1" dirty="0">
-                <a:solidFill>
-                  <a:schemeClr val="accent2"/>
-                </a:solidFill>
-              </a:rPr>
-              <a:t>Key tests</a:t>
-            </a:r>
-            <a:endParaRPr lang="en-US" sz="1800" dirty="0"/>
-          </a:p>
-          <a:p>
-            <a:pPr indent="0" marL="0">
-              <a:spcAft>
-                <a:spcPts val="600"/>
-              </a:spcAft>
-              <a:buNone/>
-            </a:pPr>
-            <a:r>
-              <a:rPr lang="en-US" sz="1800" dirty="0">
-                <a:solidFill>
-                  <a:schemeClr val="tx1"/>
-                </a:solidFill>
-              </a:rPr>
-              <a:t>Age when group differences appear</a:t>
-            </a:r>
-            <a:endParaRPr lang="en-US" sz="1800" dirty="0"/>
-          </a:p>
-          <a:p>
-            <a:pPr indent="0" marL="0">
-              <a:spcAft>
-                <a:spcPts val="600"/>
-              </a:spcAft>
-              <a:buNone/>
-            </a:pPr>
-            <a:r>
-              <a:rPr lang="en-US" sz="1800" dirty="0">
-                <a:solidFill>
-                  <a:schemeClr val="tx1"/>
-                </a:solidFill>
-              </a:rPr>
-              <a:t>Does a child’s own resultative use predict endpoints?</a:t>
-            </a:r>
-            <a:endParaRPr lang="en-US" sz="1800" dirty="0"/>
-          </a:p>
-          <a:p>
-            <a:pPr indent="0" marL="0">
-              <a:spcAft>
-                <a:spcPts val="600"/>
-              </a:spcAft>
-              <a:buNone/>
-            </a:pPr>
-            <a:r>
-              <a:rPr lang="en-US" sz="1800" dirty="0">
-                <a:solidFill>
-                  <a:schemeClr val="tx1"/>
-                </a:solidFill>
-              </a:rPr>
-              <a:t>6-month follow-up: does language come first?</a:t>
-            </a:r>
-            <a:endParaRPr lang="en-US" sz="1800" dirty="0"/>
-          </a:p>
-        </p:txBody>
-      </p:sp>
-      <p:sp>
-        <p:nvSpPr>
-          <p:cNvPr id="19" name="Shape 16"/>
+              <a:t>Plus a 6-month follow-up: does language change first?</a:t>
+            </a:r>
+            <a:endParaRPr lang="en-US" sz="1800" dirty="0"/>
+          </a:p>
+        </p:txBody>
+      </p:sp>
+      <p:sp>
+        <p:nvSpPr>
+          <p:cNvPr id="19" name="Shape 15"/>
           <p:cNvSpPr/>
           <p:nvPr/>
         </p:nvSpPr>
@@ -10133,7 +10641,7 @@
       </p:sp>
       <p:sp>
         <p:nvSpPr>
-          <p:cNvPr id="20" name="Text 17"/>
+          <p:cNvPr id="20" name="Text 16"/>
           <p:cNvSpPr txBox="1"/>
           <p:nvPr/>
         </p:nvSpPr>
@@ -10172,7 +10680,7 @@
                   <a:schemeClr val="tx1"/>
                 </a:solidFill>
               </a:rPr>
-              <a:t>Developmental timing tests the causal role that brief primes could not.</a:t>
+              <a:t>A double dissociation within children, the test the thesis could not run.</a:t>
             </a:r>
             <a:endParaRPr lang="en-US" sz="1800" dirty="0"/>
           </a:p>

</xml_diff>

<commit_message>
Frame Study 3 around the fixed-form vs. shared-function test
Co-Authored-By: Claude Opus 5.5 <noreply@anthropic.com>
Claude-Session: https://claude.ai/code/session_011AaQxxgQ4HPadVVo3q9mgs
</commit_message>
<xml_diff>
--- a/Liu_postdoc_interview_talk.pptx
+++ b/Liu_postdoc_interview_talk.pptx
@@ -1057,10 +1057,10 @@
           <a:p>
             <a:r>
               <a:rPr lang="en-US" dirty="0"/>
-              <a:t>1. This is a sole-authored corpus study, now at minor revision in Language and Cognition.
-2. It asks whether Mandarin parents use superordinate nouns like 动物 and 水果 in the same informative contexts as English parents, even though Mandarin has no obligatory plural.
-3. Across 11 Mandarin CHILDES corpora, superordinates are over-represented in all four available contexts: quantifiers, wh-phrases, “kind of”, and “another”.
-4. In both languages, corpus frequency predicts age of acquisition, while the contextual cues add little. Like my other work, it asks how linguistic input guides children toward abstraction.</a:t>
+              <a:t>1. This sole-authored corpus study, at minor revision in Language and Cognition, tests the pragmatic-informativeness account of superordinate nouns (Choe &amp; Papafragou). Words like “animal” are under-informative, so in English they appear in contexts that signal generality: plurals, quantifiers, wh-phrases, “kind of”, “another”.
+2. Mandarin has no obligatory plural, so it separates two versions of the account. If the cues are a fixed English form that depends on plurals, the contrast should weaken. If they reflect a shared communicative function, the remaining cues should still carry it.
+3. Across 11 Mandarin CHILDES corpora, all four available contexts were associated with superordinates (odds ratios 2.1 to 8.2), robust to overlapping cues, and a classifier recovered the semantic level above chance (AUC = .73). So the cues reflect a shared function, not a fixed form.
+4. But availability is not use: in both languages, corpus frequency predicted age of acquisition, while cue exposure added little. Whether children actually use these cues needs experiments, the same step from correspondence to learning that runs through my future plans.</a:t>
             </a:r>
             <a:endParaRPr lang="en-US" dirty="0"/>
           </a:p>
@@ -5488,7 +5488,7 @@
                   <a:schemeClr val="tx2"/>
                 </a:solidFill>
               </a:rPr>
-              <a:t>Study 3: Superordinate nouns in Mandarin input</a:t>
+              <a:t>Study 3: Do input cues for categories need plurals?</a:t>
             </a:r>
             <a:endParaRPr lang="en-US" sz="3000" dirty="0"/>
           </a:p>
@@ -5538,7 +5538,7 @@
                   <a:schemeClr val="tx1"/>
                 </a:solidFill>
               </a:rPr>
-              <a:t>Do Mandarin parents use 动物 and 水果 in the same contexts as English parents?</a:t>
+              <a:t>English signals broad categories with plurals. Mandarin has none: do the cues survive, and do they aid learning?</a:t>
             </a:r>
             <a:endParaRPr lang="en-US" sz="1800" dirty="0"/>
           </a:p>
@@ -5588,7 +5588,7 @@
                   <a:schemeClr val="tx1"/>
                 </a:solidFill>
               </a:rPr>
-              <a:t>11 Mandarin CHILDES corpora; English comparison; AoA ratings</a:t>
+              <a:t>11 Mandarin CHILDES corpora vs. English; cue exposure and age of acquisition</a:t>
             </a:r>
             <a:endParaRPr lang="en-US" sz="1800" dirty="0"/>
           </a:p>
@@ -5638,7 +5638,7 @@
                   <a:schemeClr val="tx1"/>
                 </a:solidFill>
               </a:rPr>
-              <a:t>Same contexts in both languages; frequency predicts AoA.</a:t>
+              <a:t>Cues survive without plurals, but frequency, not cues, predicts AoA.</a:t>
             </a:r>
             <a:endParaRPr lang="en-US" sz="1800" dirty="0"/>
           </a:p>
@@ -5696,7 +5696,7 @@
                   <a:schemeClr val="tx2"/>
                 </a:solidFill>
               </a:rPr>
-              <a:t>Where superordinates appear</a:t>
+              <a:t>Two tests of the pragmatic account</a:t>
             </a:r>
             <a:endParaRPr lang="en-US" sz="2200" dirty="0"/>
           </a:p>
@@ -5759,7 +5759,7 @@
                   <a:schemeClr val="tx1"/>
                 </a:solidFill>
               </a:rPr>
-              <a:t>Quantifiers, wh-phrases</a:t>
+              <a:t>Fixed form: cues need plurals</a:t>
             </a:r>
             <a:endParaRPr lang="en-US" sz="1800" dirty="0"/>
           </a:p>
@@ -5822,7 +5822,7 @@
                   <a:schemeClr val="tx1"/>
                 </a:solidFill>
               </a:rPr>
-              <a:t>Over-represented</a:t>
+              <a:t>Rejected</a:t>
             </a:r>
             <a:endParaRPr lang="en-US" sz="1800" dirty="0"/>
           </a:p>
@@ -5878,7 +5878,7 @@
                   <a:schemeClr val="tx1"/>
                 </a:solidFill>
               </a:rPr>
-              <a:t>什么动物 “what animals”</a:t>
+              <a:t>All 4 cues survive in Mandarin (OR 2.1–8.2)</a:t>
             </a:r>
             <a:endParaRPr lang="en-US" sz="1800" dirty="0"/>
           </a:p>
@@ -5941,7 +5941,7 @@
                   <a:schemeClr val="tx1"/>
                 </a:solidFill>
               </a:rPr>
-              <a:t>“Kind of”, “another”</a:t>
+              <a:t>Cues speed learning</a:t>
             </a:r>
             <a:endParaRPr lang="en-US" sz="1800" dirty="0"/>
           </a:p>
@@ -6004,7 +6004,7 @@
                   <a:schemeClr val="tx1"/>
                 </a:solidFill>
               </a:rPr>
-              <a:t>Over-represented</a:t>
+              <a:t>Not supported</a:t>
             </a:r>
             <a:endParaRPr lang="en-US" sz="1800" dirty="0"/>
           </a:p>
@@ -6060,7 +6060,7 @@
                   <a:schemeClr val="tx1"/>
                 </a:solidFill>
               </a:rPr>
-              <a:t>各种动物 “every kind of animal”</a:t>
+              <a:t>Frequency predicts AoA; cues add little</a:t>
             </a:r>
             <a:endParaRPr lang="en-US" sz="1800" dirty="0"/>
           </a:p>
@@ -6096,7 +6096,7 @@
                   <a:schemeClr val="accent2"/>
                 </a:solidFill>
               </a:rPr>
-              <a:t>Language and Cognition, minor revision</a:t>
+              <a:t>Available in input; use in learning untested</a:t>
             </a:r>
             <a:endParaRPr lang="en-US" sz="1800" dirty="0"/>
           </a:p>

</xml_diff>

<commit_message>
Frame Study 3 as a replication of the pragmatic account with its two studies
Co-Authored-By: Claude Opus 5.5 <noreply@anthropic.com>
Claude-Session: https://claude.ai/code/session_011AaQxxgQ4HPadVVo3q9mgs
</commit_message>
<xml_diff>
--- a/Liu_postdoc_interview_talk.pptx
+++ b/Liu_postdoc_interview_talk.pptx
@@ -1057,10 +1057,10 @@
           <a:p>
             <a:r>
               <a:rPr lang="en-US" dirty="0"/>
-              <a:t>1. This sole-authored corpus study, at minor revision in Language and Cognition, tests the pragmatic-informativeness account of superordinate nouns (Choe &amp; Papafragou). Words like “animal” are under-informative, so in English they appear in contexts that signal generality: plurals, quantifiers, wh-phrases, “kind of”, “another”.
-2. Mandarin has no obligatory plural, so it separates two versions of the account. If the cues are a fixed English form that depends on plurals, the contrast should weaken. If they reflect a shared communicative function, the remaining cues should still carry it.
-3. Across 11 Mandarin CHILDES corpora, all four available contexts were associated with superordinates (odds ratios 2.1 to 8.2), robust to overlapping cues, and a classifier recovered the semantic level above chance (AUC = .73). So the cues reflect a shared function, not a fixed form.
-4. But availability is not use: in both languages, corpus frequency predicted age of acquisition, while cue exposure added little. Whether children actually use these cues needs experiments, the same step from correspondence to learning that runs through my future plans.</a:t>
+              <a:t>1. This sole-authored paper, at minor revision in Language and Cognition, tests the pragmatic-informativeness account of Choe and Papafragou: superordinate nouns like “animal” are under-informative, so speakers use them in contexts that signal generality, such as quantifiers, wh-phrases, “kind of” and “another”. The account was built on English; Mandarin is a strong test because it lacks obligatory plural marking.
+2. Study 1 replicates their corpus analysis in 11 Mandarin CHILDES corpora: do these contexts separate superordinate from basic-level nouns in Mandarin child-directed speech?
+3. They do. All four Mandarin-available contexts were associated with superordinates (odds ratios 2.1 to 8.2), robust to overlapping cues, and a classifier recovered semantic level from the contexts (AUC = .73). So the account replicates beyond English.
+4. Study 2 asks whether a word’s exposure to these cues predicts its age of acquisition, in Mandarin and English. Corpus frequency did; cue exposure added little. The cues are present in the input, but whether children use them needs experiments.</a:t>
             </a:r>
             <a:endParaRPr lang="en-US" dirty="0"/>
           </a:p>
@@ -5488,7 +5488,7 @@
                   <a:schemeClr val="tx2"/>
                 </a:solidFill>
               </a:rPr>
-              <a:t>Study 3: Do input cues for categories need plurals?</a:t>
+              <a:t>Study 3: A pragmatic account of superordinates in Mandarin</a:t>
             </a:r>
             <a:endParaRPr lang="en-US" sz="3000" dirty="0"/>
           </a:p>
@@ -5538,7 +5538,7 @@
                   <a:schemeClr val="tx1"/>
                 </a:solidFill>
               </a:rPr>
-              <a:t>English signals broad categories with plurals. Mandarin has none: do the cues survive, and do they aid learning?</a:t>
+              <a:t>Does the pragmatic-informativeness account (Choe &amp; Papafragou) hold beyond English?</a:t>
             </a:r>
             <a:endParaRPr lang="en-US" sz="1800" dirty="0"/>
           </a:p>
@@ -5588,7 +5588,7 @@
                   <a:schemeClr val="tx1"/>
                 </a:solidFill>
               </a:rPr>
-              <a:t>11 Mandarin CHILDES corpora vs. English; cue exposure and age of acquisition</a:t>
+              <a:t>Two corpus studies of Mandarin child-directed speech, compared with English</a:t>
             </a:r>
             <a:endParaRPr lang="en-US" sz="1800" dirty="0"/>
           </a:p>
@@ -5638,7 +5638,7 @@
                   <a:schemeClr val="tx1"/>
                 </a:solidFill>
               </a:rPr>
-              <a:t>Cues survive without plurals, but frequency, not cues, predicts AoA.</a:t>
+              <a:t>The account replicates in Mandarin; cues do not predict AoA beyond frequency.</a:t>
             </a:r>
             <a:endParaRPr lang="en-US" sz="1800" dirty="0"/>
           </a:p>
@@ -5696,7 +5696,7 @@
                   <a:schemeClr val="tx2"/>
                 </a:solidFill>
               </a:rPr>
-              <a:t>Two tests of the pragmatic account</a:t>
+              <a:t>Two studies</a:t>
             </a:r>
             <a:endParaRPr lang="en-US" sz="2200" dirty="0"/>
           </a:p>
@@ -5759,7 +5759,7 @@
                   <a:schemeClr val="tx1"/>
                 </a:solidFill>
               </a:rPr>
-              <a:t>Fixed form: cues need plurals</a:t>
+              <a:t>Study 1: context cues in the input</a:t>
             </a:r>
             <a:endParaRPr lang="en-US" sz="1800" dirty="0"/>
           </a:p>
@@ -5822,7 +5822,7 @@
                   <a:schemeClr val="tx1"/>
                 </a:solidFill>
               </a:rPr>
-              <a:t>Rejected</a:t>
+              <a:t>Replicated in Mandarin</a:t>
             </a:r>
             <a:endParaRPr lang="en-US" sz="1800" dirty="0"/>
           </a:p>
@@ -5878,7 +5878,7 @@
                   <a:schemeClr val="tx1"/>
                 </a:solidFill>
               </a:rPr>
-              <a:t>All 4 cues survive in Mandarin (OR 2.1–8.2)</a:t>
+              <a:t>All 4 contexts, OR 2.1–8.2; classifier AUC = .73</a:t>
             </a:r>
             <a:endParaRPr lang="en-US" sz="1800" dirty="0"/>
           </a:p>
@@ -5941,7 +5941,7 @@
                   <a:schemeClr val="tx1"/>
                 </a:solidFill>
               </a:rPr>
-              <a:t>Cues speed learning</a:t>
+              <a:t>Study 2: cues and age of acquisition</a:t>
             </a:r>
             <a:endParaRPr lang="en-US" sz="1800" dirty="0"/>
           </a:p>
@@ -6004,7 +6004,7 @@
                   <a:schemeClr val="tx1"/>
                 </a:solidFill>
               </a:rPr>
-              <a:t>Not supported</a:t>
+              <a:t>Frequency predicts; cues add little</a:t>
             </a:r>
             <a:endParaRPr lang="en-US" sz="1800" dirty="0"/>
           </a:p>
@@ -6060,7 +6060,7 @@
                   <a:schemeClr val="tx1"/>
                 </a:solidFill>
               </a:rPr>
-              <a:t>Frequency predicts AoA; cues add little</a:t>
+              <a:t>Same pattern in Mandarin and English</a:t>
             </a:r>
             <a:endParaRPr lang="en-US" sz="1800" dirty="0"/>
           </a:p>
@@ -6096,7 +6096,7 @@
                   <a:schemeClr val="accent2"/>
                 </a:solidFill>
               </a:rPr>
-              <a:t>Available in input; use in learning untested</a:t>
+              <a:t>Language and Cognition, minor revision</a:t>
             </a:r>
             <a:endParaRPr lang="en-US" sz="1800" dirty="0"/>
           </a:p>

</xml_diff>

<commit_message>
Align all three directions with the lexical/predicate levels; video-language models for Direction 3
Co-Authored-By: Claude Opus 5.5 <noreply@anthropic.com>
Claude-Session: https://claude.ai/code/session_011AaQxxgQ4HPadVVo3q9mgs
</commit_message>
<xml_diff>
--- a/Liu_postdoc_interview_talk.pptx
+++ b/Liu_postdoc_interview_talk.pptx
@@ -1101,28 +1101,28 @@
           <a:p>
             <a:r>
               <a:rPr lang="en-US" dirty="0"/>
-              <a:t>1. All three directions ask how event relations, an action changing an object’s state, are learned, and all build on the two levels from my thesis. They use new hands-only event pairs, such as tearing paper in half versus crumpling it, normed with adults first; this also addresses the thesis limit of only cutting and blending.</a:t>
+              <a:t>1. All three directions ask how event relations, an action changing an object’s state, are learned, and each keeps the two levels from my thesis: lexical cues map onto event phases, predicate telicity onto endpoints. They use new hands-only event pairs, such as tearing paper in half versus crumpling it, normed with adults first; this also addresses the thesis limit of only cutting and blending.</a:t>
             </a:r>
             <a:endParaRPr lang="en-US" dirty="0"/>
           </a:p>
           <a:p>
             <a:r>
               <a:rPr lang="en-US" dirty="0"/>
-              <a:t>2. Direction 1, when children learn event relations: Mandarin- and English-speaking children aged 3–6 describe the events, which gives each child’s lexical and predicate encoding, and do child versions of my tasks: press when the video “hiccups” for phases, press when it is “done” for endpoints. Prediction: a child’s lexical encoding predicts phase sensitivity but not endpoints, and predicate encoding the reverse, a double dissociation within children. A 6-month follow-up asks whether language change comes first.</a:t>
+              <a:t>2. Direction 1, when children learn event relations: Mandarin- and English-speaking children aged 3–6 describe the events, which gives each child’s lexical encoding (quantized nouns, resultatives) and predicate encoding (telic descriptions). They also do child versions of my two tasks: press when the video “hiccups” for phases, press when it is “done” for endpoints. Prediction: a child’s lexical encoding predicts phase sensitivity but not endpoints, and predicate encoding predicts endpoints but not phases. A 6-month follow-up asks whether language change comes first.</a:t>
             </a:r>
             <a:endParaRPr lang="en-US" dirty="0"/>
           </a:p>
           <a:p>
             <a:r>
               <a:rPr lang="en-US" dirty="0"/>
-              <a:t>3. Direction 2, whether language helps children abstract relations: brief primes did not work in the thesis, so children get three training sessions with result words (切开) or action words (切一切), using the words in the task. Prediction: result training shifts where children place endpoints, and the shift transfers to new events, for example from tearing to breaking, which would show they learned a relation, not a word.</a:t>
+              <a:t>3. Direction 2, whether language helps children abstract relations: brief primes did not work in the thesis, so children get three training sessions with either lexical cues (一颗橙子, 切成两块) or predicate cues (切开 vs. 切一切), and are tested on both tasks. Prediction: lexical training shifts phase sensitivity and predicate training shifts endpoints, and the shift transfers to new events, for example from tearing to breaking, which would show they learned a relation, not a word.</a:t>
             </a:r>
             <a:endParaRPr lang="en-US" dirty="0"/>
           </a:p>
           <a:p>
             <a:r>
               <a:rPr lang="en-US" dirty="0"/>
-              <a:t>4. Direction 3, whether language models capture these relations: following Rognan, Grigoroglou and Bhattasali (CogSci 2026), matched English and Chinese BERT models are tested with cloze items at both levels, such as “She cut [MASK] orange” and “cut an orange [MASK] two seconds” (in vs. for). Key test: does the predicate choice flip when the lexical cue flips (an orange vs. oranges)? If not, models rely on surface statistics rather than event structure. Together: how event relations are learned with age, from language, and from text alone.</a:t>
+              <a:t>4. Direction 3, whether language models capture these relations: following Rognan et al. (CogSci 2026), I treat video-language models as participants on my own videos. They describe the events in English and Mandarin, coded exactly like the human data, and judge frame by frame whether the object has changed, which gives phase and endpoint measures comparable to human data. Because the video is fixed, I can change only the language of the prompt: lexical prompts should shift phase judgments and predicate prompts endpoints. This is the clean causal test that brief primes could not give me in people, and comparing models with children shows what hands-on experience adds.</a:t>
             </a:r>
             <a:endParaRPr lang="en-US" dirty="0"/>
           </a:p>
@@ -5951,7 +5951,7 @@
                   <a:schemeClr val="tx1"/>
                 </a:solidFill>
               </a:rPr>
-              <a:t>Children (3–6) describe new events, then tap phases and endpoints</a:t>
+              <a:t>Children (3–6) describe new events and do both of my tasks</a:t>
             </a:r>
             <a:endParaRPr lang="en-US" sz="1800" dirty="0"/>
           </a:p>
@@ -6155,7 +6155,7 @@
                   <a:schemeClr val="tx1"/>
                 </a:solidFill>
               </a:rPr>
-              <a:t>Three sessions with result words (切开) or action words (切一切)</a:t>
+              <a:t>Training with cues</a:t>
             </a:r>
             <a:endParaRPr lang="en-US" sz="1800" dirty="0"/>
           </a:p>
@@ -6167,12 +6167,12 @@
               <a:buNone/>
             </a:pPr>
             <a:r>
-              <a:rPr lang="en-US" sz="1800" b="1" dirty="0">
-                <a:solidFill>
-                  <a:schemeClr val="accent2"/>
-                </a:solidFill>
-              </a:rPr>
-              <a:t>Prediction</a:t>
+              <a:rPr lang="en-US" sz="1800" dirty="0">
+                <a:solidFill>
+                  <a:schemeClr val="tx1"/>
+                </a:solidFill>
+              </a:rPr>
+              <a:t>Lexical: 切成两块</a:t>
             </a:r>
             <a:endParaRPr lang="en-US" sz="1800" dirty="0"/>
           </a:p>
@@ -6189,7 +6189,41 @@
                   <a:schemeClr val="tx1"/>
                 </a:solidFill>
               </a:rPr>
-              <a:t>Endpoints shift and transfer to new events</a:t>
+              <a:t>Predicate: 切开 vs. 切一切</a:t>
+            </a:r>
+            <a:endParaRPr lang="en-US" sz="1800" dirty="0"/>
+          </a:p>
+          <a:p>
+            <a:pPr indent="0" marL="0">
+              <a:spcAft>
+                <a:spcPts val="600"/>
+              </a:spcAft>
+              <a:buNone/>
+            </a:pPr>
+            <a:r>
+              <a:rPr lang="en-US" sz="1800" b="1" dirty="0">
+                <a:solidFill>
+                  <a:schemeClr val="accent2"/>
+                </a:solidFill>
+              </a:rPr>
+              <a:t>Prediction</a:t>
+            </a:r>
+            <a:endParaRPr lang="en-US" sz="1800" dirty="0"/>
+          </a:p>
+          <a:p>
+            <a:pPr indent="0" marL="0">
+              <a:spcAft>
+                <a:spcPts val="600"/>
+              </a:spcAft>
+              <a:buNone/>
+            </a:pPr>
+            <a:r>
+              <a:rPr lang="en-US" sz="1800" dirty="0">
+                <a:solidFill>
+                  <a:schemeClr val="tx1"/>
+                </a:solidFill>
+              </a:rPr>
+              <a:t>Lexical training shifts phases; predicate training, endpoints</a:t>
             </a:r>
             <a:endParaRPr lang="en-US" sz="1800" dirty="0"/>
           </a:p>
@@ -6359,7 +6393,7 @@
                   <a:schemeClr val="tx1"/>
                 </a:solidFill>
               </a:rPr>
-              <a:t>Cloze tests in English and Chinese BERT (Rognan et al., 2026)</a:t>
+              <a:t>Video-language models describe my videos and judge each frame</a:t>
             </a:r>
             <a:endParaRPr lang="en-US" sz="1800" dirty="0"/>
           </a:p>
@@ -6393,54 +6427,9 @@
                   <a:schemeClr val="tx1"/>
                 </a:solidFill>
               </a:rPr>
-              <a:t>Predicate choice flips with the lexical cue (an orange vs. oranges)</a:t>
-            </a:r>
-            <a:endParaRPr lang="en-US" sz="1800" dirty="0"/>
-          </a:p>
-        </p:txBody>
-      </p:sp>
-      <p:sp>
-        <p:nvSpPr>
-          <p:cNvPr id="116" name="Slide Number Placeholder 0"/>
-          <p:cNvSpPr>
-            <a:spLocks noGrp="1"/>
-          </p:cNvSpPr>
-          <p:nvPr>
-            <p:ph type="sldNum" sz="quarter" idx="4294967295"/>
-          </p:nvPr>
-        </p:nvSpPr>
-        <p:spPr>
-          <a:xfrm>
-            <a:off x="11002975" y="6355080"/>
-            <a:ext cx="640080" cy="365760"/>
-          </a:xfrm>
-          <a:prstGeom prst="rect">
-            <a:avLst/>
-          </a:prstGeom>
-          <a:extLst>
-            <a:ext uri="{C572A759-6A51-4108-AA02-DFA0A04FC94B}">
-              <ma14:wrappingTextBoxFlag xmlns:ma14="http://schemas.microsoft.com/office/mac/drawingml/2011/main" val="0"/>
-            </a:ext>
-          </a:extLst>
-        </p:spPr>
-        <p:txBody>
-          <a:bodyPr/>
-          <a:lstStyle>
-            <a:lvl1pPr>
-              <a:defRPr sz="1800">
-                <a:solidFill>
-                  <a:schemeClr val="accent3"/>
-                </a:solidFill>
-              </a:defRPr>
-            </a:lvl1pPr>
-          </a:lstStyle>
-          <a:p>
-            <a:pPr algn="r"/>
-            <a:fld id="{F7021451-1387-4CA6-816F-3879F97B5CBC}" type="slidenum">
-              <a:rPr b="0" lang="en-US"/>
-              <a:t>1</a:t>
-            </a:fld>
-            <a:endParaRPr lang="en-US"/>
+              <a:t>Lexical prompts shift phases; predicate prompts, endpoints</a:t>
+            </a:r>
+            <a:endParaRPr lang="en-US" sz="1800" dirty="0"/>
           </a:p>
         </p:txBody>
       </p:sp>

</xml_diff>

<commit_message>
Detail the two-year plan and base the closing slide on CV strengths
Co-Authored-By: Claude Opus 5.5 <noreply@anthropic.com>
Claude-Session: https://claude.ai/code/session_011AaQxxgQ4HPadVVo3q9mgs
</commit_message>
<xml_diff>
--- a/Liu_postdoc_interview_talk.pptx
+++ b/Liu_postdoc_interview_talk.pptx
@@ -14,8 +14,8 @@
     <p:sldId id="259" r:id="rId7"/>
     <p:sldId id="260" r:id="rId8"/>
     <p:sldId id="261" r:id="rId9"/>
-    <p:sldId id="265" r:id="rId13"/>
-    <p:sldId id="266" r:id="rId14"/>
+    <p:sldId id="265" r:id="rId10"/>
+    <p:sldId id="266" r:id="rId11"/>
   </p:sldIdLst>
   <p:sldSz cx="12192000" cy="6858000"/>
   <p:notesSz cx="6858000" cy="12192000"/>
@@ -545,176 +545,6 @@
 </p:notes>
 </file>
 
-<file path=ppt/notesSlides/notesSlide10.xml><?xml version="1.0" encoding="utf-8"?>
-<p:notes xmlns:a="http://schemas.openxmlformats.org/drawingml/2006/main" xmlns:r="http://schemas.openxmlformats.org/officeDocument/2006/relationships" xmlns:p="http://schemas.openxmlformats.org/presentationml/2006/main">
-  <p:cSld>
-    <p:spTree>
-      <p:nvGrpSpPr>
-        <p:cNvPr id="1" name=""/>
-        <p:cNvGrpSpPr/>
-        <p:nvPr/>
-      </p:nvGrpSpPr>
-      <p:grpSpPr>
-        <a:xfrm>
-          <a:off x="0" y="0"/>
-          <a:ext cx="0" cy="0"/>
-          <a:chOff x="0" y="0"/>
-          <a:chExt cx="0" cy="0"/>
-        </a:xfrm>
-      </p:grpSpPr>
-      <p:sp>
-        <p:nvSpPr>
-          <p:cNvPr id="2" name="Slide Image Placeholder 1"/>
-          <p:cNvSpPr>
-            <a:spLocks noGrp="1" noRot="1" noChangeAspect="1"/>
-          </p:cNvSpPr>
-          <p:nvPr>
-            <p:ph type="sldImg"/>
-          </p:nvPr>
-        </p:nvSpPr>
-        <p:spPr/>
-      </p:sp>
-      <p:sp>
-        <p:nvSpPr>
-          <p:cNvPr id="3" name="Notes Placeholder 2"/>
-          <p:cNvSpPr>
-            <a:spLocks noGrp="1"/>
-          </p:cNvSpPr>
-          <p:nvPr>
-            <p:ph type="body" idx="1"/>
-          </p:nvPr>
-        </p:nvSpPr>
-        <p:spPr/>
-        <p:txBody>
-          <a:bodyPr/>
-          <a:lstStyle/>
-          <a:p>
-            <a:r>
-              <a:rPr lang="en-US" dirty="0"/>
-              <a:t>1. Year 1: replicate Experiments 1–3 with adults on the new event pairs, which generalizes the thesis and validates materials for children; run the model study in parallel.
-2. Year 2: Direction 1 with children, and the training study for Direction 2.
-3. Throughout: publish the thesis papers, apply for funding, and mentor students.
-4. Together these move from correspondence to development, learning and input.</a:t>
-            </a:r>
-            <a:endParaRPr lang="en-US" dirty="0"/>
-          </a:p>
-        </p:txBody>
-      </p:sp>
-      <p:sp>
-        <p:nvSpPr>
-          <p:cNvPr id="4" name="Slide Number Placeholder 3"/>
-          <p:cNvSpPr>
-            <a:spLocks noGrp="1"/>
-          </p:cNvSpPr>
-          <p:nvPr>
-            <p:ph type="sldNum" sz="quarter" idx="10"/>
-          </p:nvPr>
-        </p:nvSpPr>
-        <p:spPr/>
-        <p:txBody>
-          <a:bodyPr/>
-          <a:lstStyle/>
-          <a:p>
-            <a:fld id="{F7021451-1387-4CA6-816F-3879F97B5CBC}" type="slidenum">
-              <a:rPr lang="en-US"/>
-            </a:fld>
-            <a:endParaRPr lang="en-US"/>
-          </a:p>
-        </p:txBody>
-      </p:sp>
-    </p:spTree>
-  </p:cSld>
-  <p:clrMapOvr>
-    <a:masterClrMapping/>
-  </p:clrMapOvr>
-</p:notes>
-</file>
-
-<file path=ppt/notesSlides/notesSlide11.xml><?xml version="1.0" encoding="utf-8"?>
-<p:notes xmlns:a="http://schemas.openxmlformats.org/drawingml/2006/main" xmlns:r="http://schemas.openxmlformats.org/officeDocument/2006/relationships" xmlns:p="http://schemas.openxmlformats.org/presentationml/2006/main">
-  <p:cSld>
-    <p:spTree>
-      <p:nvGrpSpPr>
-        <p:cNvPr id="1" name=""/>
-        <p:cNvGrpSpPr/>
-        <p:nvPr/>
-      </p:nvGrpSpPr>
-      <p:grpSpPr>
-        <a:xfrm>
-          <a:off x="0" y="0"/>
-          <a:ext cx="0" cy="0"/>
-          <a:chOff x="0" y="0"/>
-          <a:chExt cx="0" cy="0"/>
-        </a:xfrm>
-      </p:grpSpPr>
-      <p:sp>
-        <p:nvSpPr>
-          <p:cNvPr id="2" name="Slide Image Placeholder 1"/>
-          <p:cNvSpPr>
-            <a:spLocks noGrp="1" noRot="1" noChangeAspect="1"/>
-          </p:cNvSpPr>
-          <p:nvPr>
-            <p:ph type="sldImg"/>
-          </p:nvPr>
-        </p:nvSpPr>
-        <p:spPr/>
-      </p:sp>
-      <p:sp>
-        <p:nvSpPr>
-          <p:cNvPr id="3" name="Notes Placeholder 2"/>
-          <p:cNvSpPr>
-            <a:spLocks noGrp="1"/>
-          </p:cNvSpPr>
-          <p:nvPr>
-            <p:ph type="body" idx="1"/>
-          </p:nvPr>
-        </p:nvSpPr>
-        <p:spPr/>
-        <p:txBody>
-          <a:bodyPr/>
-          <a:lstStyle/>
-          <a:p>
-            <a:r>
-              <a:rPr lang="en-US" dirty="0"/>
-              <a:t>1. Methods: video stimuli, child testing, Bayesian modelling.
-2. Projects: I led a field project at CAS and ran a preregistered multi-experiment thesis.
-3. Fit: event language in development, Mandarin–English expertise, and both experiments and models.
-4. Thank you, and I am happy to take questions.</a:t>
-            </a:r>
-            <a:endParaRPr lang="en-US" dirty="0"/>
-          </a:p>
-        </p:txBody>
-      </p:sp>
-      <p:sp>
-        <p:nvSpPr>
-          <p:cNvPr id="4" name="Slide Number Placeholder 3"/>
-          <p:cNvSpPr>
-            <a:spLocks noGrp="1"/>
-          </p:cNvSpPr>
-          <p:nvPr>
-            <p:ph type="sldNum" sz="quarter" idx="10"/>
-          </p:nvPr>
-        </p:nvSpPr>
-        <p:spPr/>
-        <p:txBody>
-          <a:bodyPr/>
-          <a:lstStyle/>
-          <a:p>
-            <a:fld id="{F7021451-1387-4CA6-816F-3879F97B5CBC}" type="slidenum">
-              <a:rPr lang="en-US"/>
-            </a:fld>
-            <a:endParaRPr lang="en-US"/>
-          </a:p>
-        </p:txBody>
-      </p:sp>
-    </p:spTree>
-  </p:cSld>
-  <p:clrMapOvr>
-    <a:masterClrMapping/>
-  </p:clrMapOvr>
-</p:notes>
-</file>
-
 <file path=ppt/notesSlides/notesSlide2.xml><?xml version="1.0" encoding="utf-8"?>
 <p:notes xmlns:a="http://schemas.openxmlformats.org/drawingml/2006/main" xmlns:r="http://schemas.openxmlformats.org/officeDocument/2006/relationships" xmlns:p="http://schemas.openxmlformats.org/presentationml/2006/main">
   <p:cSld>
@@ -1123,6 +953,212 @@
             <a:r>
               <a:rPr lang="en-US" dirty="0"/>
               <a:t>4. Direction 3, whether language models capture these relations: following Rognan et al. (CogSci 2026), I treat video-language models as participants on my own videos. They describe the events in English and Mandarin, coded exactly like the human data, and judge frame by frame whether the object has changed, which gives phase and endpoint measures comparable to human data. Because the video is fixed, I can change only the language of the prompt: lexical prompts should shift phase judgments and predicate prompts endpoints. This is the clean causal test that brief primes could not give me in people, and comparing models with children shows what hands-on experience adds.</a:t>
+            </a:r>
+            <a:endParaRPr lang="en-US" dirty="0"/>
+          </a:p>
+        </p:txBody>
+      </p:sp>
+      <p:sp>
+        <p:nvSpPr>
+          <p:cNvPr id="4" name="Slide Number Placeholder 3"/>
+          <p:cNvSpPr>
+            <a:spLocks noGrp="1"/>
+          </p:cNvSpPr>
+          <p:nvPr>
+            <p:ph type="sldNum" sz="quarter" idx="10"/>
+          </p:nvPr>
+        </p:nvSpPr>
+        <p:spPr/>
+        <p:txBody>
+          <a:bodyPr/>
+          <a:lstStyle/>
+          <a:p>
+            <a:fld id="{F7021451-1387-4CA6-816F-3879F97B5CBC}" type="slidenum">
+              <a:rPr lang="en-US"/>
+            </a:fld>
+            <a:endParaRPr lang="en-US"/>
+          </a:p>
+        </p:txBody>
+      </p:sp>
+    </p:spTree>
+  </p:cSld>
+  <p:clrMapOvr>
+    <a:masterClrMapping/>
+  </p:clrMapOvr>
+</p:notes>
+</file>
+
+<file path=ppt/notesSlides/notesSlide7.xml><?xml version="1.0" encoding="utf-8"?>
+<p:notes xmlns:a="http://schemas.openxmlformats.org/drawingml/2006/main" xmlns:r="http://schemas.openxmlformats.org/officeDocument/2006/relationships" xmlns:p="http://schemas.openxmlformats.org/presentationml/2006/main">
+  <p:cSld>
+    <p:spTree>
+      <p:nvGrpSpPr>
+        <p:cNvPr id="1" name=""/>
+        <p:cNvGrpSpPr/>
+        <p:nvPr/>
+      </p:nvGrpSpPr>
+      <p:grpSpPr>
+        <a:xfrm>
+          <a:off x="0" y="0"/>
+          <a:ext cx="0" cy="0"/>
+          <a:chOff x="0" y="0"/>
+          <a:chExt cx="0" cy="0"/>
+        </a:xfrm>
+      </p:grpSpPr>
+      <p:sp>
+        <p:nvSpPr>
+          <p:cNvPr id="2" name="Slide Image Placeholder 1"/>
+          <p:cNvSpPr>
+            <a:spLocks noGrp="1" noRot="1" noChangeAspect="1"/>
+          </p:cNvSpPr>
+          <p:nvPr>
+            <p:ph type="sldImg"/>
+          </p:nvPr>
+        </p:nvSpPr>
+        <p:spPr/>
+      </p:sp>
+      <p:sp>
+        <p:nvSpPr>
+          <p:cNvPr id="3" name="Notes Placeholder 2"/>
+          <p:cNvSpPr>
+            <a:spLocks noGrp="1"/>
+          </p:cNvSpPr>
+          <p:nvPr>
+            <p:ph type="body" idx="1"/>
+          </p:nvPr>
+        </p:nvSpPr>
+        <p:spPr/>
+        <p:txBody>
+          <a:bodyPr/>
+          <a:lstStyle/>
+          <a:p>
+            <a:r>
+              <a:rPr lang="en-US" dirty="0"/>
+              <a:t>1. Year 1 builds and validates. I would film and norm the new hands-only event pairs, and replicate the two-level effects with adults, which generalizes the thesis beyond cutting and blending and gives validated materials for children. The video-language model study (Direction 3) runs in parallel, because it needs only the videos, so it can be published early, for example at CogSci. I would also pilot the child versions of the tasks and complete ethics approval.</a:t>
+            </a:r>
+            <a:endParaRPr lang="en-US" dirty="0"/>
+          </a:p>
+          <a:p>
+            <a:r>
+              <a:rPr lang="en-US" dirty="0"/>
+              <a:t>2. Year 2 tests children with these materials: Direction 1 with Mandarin-speaking children aged 3–6, an English sample through the center’s cross-cultural partners, and the 6-month follow-up; and the Direction 2 training study.</a:t>
+            </a:r>
+            <a:endParaRPr lang="en-US" dirty="0"/>
+          </a:p>
+          <a:p>
+            <a:r>
+              <a:rPr lang="en-US" dirty="0"/>
+              <a:t>3. Throughout, I would publish my thesis and child papers, apply to the China Postdoctoral Science Foundation and the NSFC Young Scientists Fund, and help mentor students in child testing and Bayesian analysis, with materials and data shared openly.</a:t>
+            </a:r>
+            <a:endParaRPr lang="en-US" dirty="0"/>
+          </a:p>
+          <a:p>
+            <a:r>
+              <a:rPr lang="en-US" dirty="0"/>
+              <a:t>4. The expected outputs are an adult paper and a model paper in Year 1, two child papers in Year 2, and two grant applications. The logic is that Year 1 builds validated materials and models, and Year 2 tests children with them.</a:t>
+            </a:r>
+            <a:endParaRPr lang="en-US" dirty="0"/>
+          </a:p>
+        </p:txBody>
+      </p:sp>
+      <p:sp>
+        <p:nvSpPr>
+          <p:cNvPr id="4" name="Slide Number Placeholder 3"/>
+          <p:cNvSpPr>
+            <a:spLocks noGrp="1"/>
+          </p:cNvSpPr>
+          <p:nvPr>
+            <p:ph type="sldNum" sz="quarter" idx="10"/>
+          </p:nvPr>
+        </p:nvSpPr>
+        <p:spPr/>
+        <p:txBody>
+          <a:bodyPr/>
+          <a:lstStyle/>
+          <a:p>
+            <a:fld id="{F7021451-1387-4CA6-816F-3879F97B5CBC}" type="slidenum">
+              <a:rPr lang="en-US"/>
+            </a:fld>
+            <a:endParaRPr lang="en-US"/>
+          </a:p>
+        </p:txBody>
+      </p:sp>
+    </p:spTree>
+  </p:cSld>
+  <p:clrMapOvr>
+    <a:masterClrMapping/>
+  </p:clrMapOvr>
+</p:notes>
+</file>
+
+<file path=ppt/notesSlides/notesSlide8.xml><?xml version="1.0" encoding="utf-8"?>
+<p:notes xmlns:a="http://schemas.openxmlformats.org/drawingml/2006/main" xmlns:r="http://schemas.openxmlformats.org/officeDocument/2006/relationships" xmlns:p="http://schemas.openxmlformats.org/presentationml/2006/main">
+  <p:cSld>
+    <p:spTree>
+      <p:nvGrpSpPr>
+        <p:cNvPr id="1" name=""/>
+        <p:cNvGrpSpPr/>
+        <p:nvPr/>
+      </p:nvGrpSpPr>
+      <p:grpSpPr>
+        <a:xfrm>
+          <a:off x="0" y="0"/>
+          <a:ext cx="0" cy="0"/>
+          <a:chOff x="0" y="0"/>
+          <a:chExt cx="0" cy="0"/>
+        </a:xfrm>
+      </p:grpSpPr>
+      <p:sp>
+        <p:nvSpPr>
+          <p:cNvPr id="2" name="Slide Image Placeholder 1"/>
+          <p:cNvSpPr>
+            <a:spLocks noGrp="1" noRot="1" noChangeAspect="1"/>
+          </p:cNvSpPr>
+          <p:nvPr>
+            <p:ph type="sldImg"/>
+          </p:nvPr>
+        </p:nvSpPr>
+        <p:spPr/>
+      </p:sp>
+      <p:sp>
+        <p:nvSpPr>
+          <p:cNvPr id="3" name="Notes Placeholder 2"/>
+          <p:cNvSpPr>
+            <a:spLocks noGrp="1"/>
+          </p:cNvSpPr>
+          <p:nvPr>
+            <p:ph type="body" idx="1"/>
+          </p:nvPr>
+        </p:nvSpPr>
+        <p:spPr/>
+        <p:txBody>
+          <a:bodyPr/>
+          <a:lstStyle/>
+          <a:p>
+            <a:r>
+              <a:rPr lang="en-US" dirty="0"/>
+              <a:t>1. Research skills: I build event videos and run online processing tasks such as interruption detection and boundary tapping; I have tested 4- and 5-year-olds in kindergartens; I analyse child-directed speech corpora; and I model data with Bayesian GLMMs and SEM in R and Python.</a:t>
+            </a:r>
+            <a:endParaRPr lang="en-US" dirty="0"/>
+          </a:p>
+          <a:p>
+            <a:r>
+              <a:rPr lang="en-US" dirty="0"/>
+              <a:t>2. Track record: a sole-authored paper at minor revision in Language and Cognition, a CogSci 2026 proceedings paper and a talk at HSP 2026 at MIT, a China Scholarship Council scholarship and University of Auckland research funding, and reviewing for CogSci and the Journal of Multilingual and Multicultural Development.</a:t>
+            </a:r>
+            <a:endParaRPr lang="en-US" dirty="0"/>
+          </a:p>
+          <a:p>
+            <a:r>
+              <a:rPr lang="en-US" dirty="0"/>
+              <a:t>3. Teamwork: at the Institute of Psychology, CAS, I led a project on the needs of migrant families, including children, from interviews to questionnaires; I teach experimental methods as a TA; I speak Mandarin, Xiang and English; and I have kindergarten links in Hunan for child recruitment.</a:t>
+            </a:r>
+            <a:endParaRPr lang="en-US" dirty="0"/>
+          </a:p>
+          <a:p>
+            <a:r>
+              <a:rPr lang="en-US" dirty="0"/>
+              <a:t>4. Thank you, and I am happy to take questions.</a:t>
             </a:r>
             <a:endParaRPr lang="en-US" dirty="0"/>
           </a:p>
@@ -1889,1109 +1925,6 @@
 </p:sld>
 </file>
 
-<file path=ppt/slides/slide10.xml><?xml version="1.0" encoding="utf-8"?>
-<p:sld xmlns:a="http://schemas.openxmlformats.org/drawingml/2006/main" xmlns:r="http://schemas.openxmlformats.org/officeDocument/2006/relationships" xmlns:p="http://schemas.openxmlformats.org/presentationml/2006/main">
-  <p:cSld>
-    <p:spTree>
-      <p:nvGrpSpPr>
-        <p:cNvPr id="1" name=""/>
-        <p:cNvGrpSpPr/>
-        <p:nvPr/>
-      </p:nvGrpSpPr>
-      <p:grpSpPr>
-        <a:xfrm>
-          <a:off x="0" y="0"/>
-          <a:ext cx="0" cy="0"/>
-          <a:chOff x="0" y="0"/>
-          <a:chExt cx="0" cy="0"/>
-        </a:xfrm>
-      </p:grpSpPr>
-      <p:sp>
-        <p:nvSpPr>
-          <p:cNvPr id="2" name="Text 0"/>
-          <p:cNvSpPr/>
-          <p:nvPr>
-            <p:ph type="title" idx="100" hasCustomPrompt="1"/>
-          </p:nvPr>
-        </p:nvSpPr>
-        <p:spPr>
-          <a:xfrm>
-            <a:off x="548640" y="365760"/>
-            <a:ext cx="11094415" cy="731520"/>
-          </a:xfrm>
-          <a:prstGeom prst="rect">
-            <a:avLst/>
-          </a:prstGeom>
-          <a:noFill/>
-        </p:spPr>
-        <p:txBody>
-          <a:bodyPr wrap="square" lIns="0" tIns="0" rIns="0" bIns="0" rtlCol="0" anchor="ctr"/>
-          <a:lstStyle/>
-          <a:p>
-            <a:pPr marL="0" indent="0" algn="l">
-              <a:buNone/>
-            </a:pPr>
-            <a:r>
-              <a:rPr lang="en-US" sz="3000" b="1" dirty="0">
-                <a:solidFill>
-                  <a:schemeClr val="tx2"/>
-                </a:solidFill>
-              </a:rPr>
-              <a:t>A two-year plan</a:t>
-            </a:r>
-            <a:endParaRPr lang="en-US" sz="3000" dirty="0"/>
-          </a:p>
-        </p:txBody>
-      </p:sp>
-      <p:sp>
-        <p:nvSpPr>
-          <p:cNvPr id="4" name="Shape 1"/>
-          <p:cNvSpPr/>
-          <p:nvPr/>
-        </p:nvSpPr>
-        <p:spPr>
-          <a:xfrm>
-            <a:off x="777240" y="1463040"/>
-            <a:ext cx="548640" cy="548640"/>
-          </a:xfrm>
-          <a:prstGeom prst="ellipse">
-            <a:avLst/>
-          </a:prstGeom>
-          <a:solidFill>
-            <a:schemeClr val="accent1"/>
-          </a:solidFill>
-        </p:spPr>
-      </p:sp>
-      <p:sp>
-        <p:nvSpPr>
-          <p:cNvPr id="5" name="Text 2"/>
-          <p:cNvSpPr txBox="1"/>
-          <p:nvPr/>
-        </p:nvSpPr>
-        <p:spPr>
-          <a:xfrm>
-            <a:off x="777240" y="1463040"/>
-            <a:ext cx="548640" cy="548640"/>
-          </a:xfrm>
-          <a:prstGeom prst="rect">
-            <a:avLst/>
-          </a:prstGeom>
-          <a:noFill/>
-        </p:spPr>
-        <p:txBody>
-          <a:bodyPr wrap="square" lIns="0" tIns="0" rIns="0" bIns="0" rtlCol="0" anchor="ctr"/>
-          <a:lstStyle/>
-          <a:p>
-            <a:pPr marL="0" indent="0" algn="ctr">
-              <a:buNone/>
-            </a:pPr>
-            <a:r>
-              <a:rPr lang="en-US" sz="2000" b="1" dirty="0">
-                <a:solidFill>
-                  <a:schemeClr val="bg1"/>
-                </a:solidFill>
-              </a:rPr>
-              <a:t>1</a:t>
-            </a:r>
-            <a:endParaRPr lang="en-US" sz="2000" dirty="0"/>
-          </a:p>
-        </p:txBody>
-      </p:sp>
-      <p:sp>
-        <p:nvSpPr>
-          <p:cNvPr id="6" name="Shape 3"/>
-          <p:cNvSpPr/>
-          <p:nvPr/>
-        </p:nvSpPr>
-        <p:spPr>
-          <a:xfrm>
-            <a:off x="548640" y="2194560"/>
-            <a:ext cx="3423818" cy="2377440"/>
-          </a:xfrm>
-          <a:prstGeom prst="roundRect">
-            <a:avLst>
-              <a:gd name="adj" fmla="val 3846"/>
-            </a:avLst>
-          </a:prstGeom>
-          <a:solidFill>
-            <a:schemeClr val="bg2"/>
-          </a:solidFill>
-        </p:spPr>
-      </p:sp>
-      <p:sp>
-        <p:nvSpPr>
-          <p:cNvPr id="7" name="Text 4"/>
-          <p:cNvSpPr txBox="1"/>
-          <p:nvPr/>
-        </p:nvSpPr>
-        <p:spPr>
-          <a:xfrm>
-            <a:off x="777240" y="2377440"/>
-            <a:ext cx="2966618" cy="2011680"/>
-          </a:xfrm>
-          <a:prstGeom prst="rect">
-            <a:avLst/>
-          </a:prstGeom>
-          <a:noFill/>
-        </p:spPr>
-        <p:txBody>
-          <a:bodyPr wrap="square" lIns="0" tIns="0" rIns="0" bIns="0" rtlCol="0" anchor="t"/>
-          <a:lstStyle/>
-          <a:p>
-            <a:pPr marL="0" indent="0">
-              <a:spcAft>
-                <a:spcPts val="600"/>
-              </a:spcAft>
-              <a:buNone/>
-            </a:pPr>
-            <a:r>
-              <a:rPr lang="en-US" sz="2200" b="1" dirty="0">
-                <a:solidFill>
-                  <a:schemeClr val="tx2"/>
-                </a:solidFill>
-              </a:rPr>
-              <a:t>Year 1</a:t>
-            </a:r>
-            <a:endParaRPr lang="en-US" sz="1800" dirty="0"/>
-          </a:p>
-          <a:p>
-            <a:pPr marL="0" indent="0">
-              <a:spcAft>
-                <a:spcPts val="600"/>
-              </a:spcAft>
-              <a:buNone/>
-            </a:pPr>
-            <a:r>
-              <a:rPr lang="en-US" sz="1800" dirty="0">
-                <a:solidFill>
-                  <a:schemeClr val="tx1"/>
-                </a:solidFill>
-              </a:rPr>
-              <a:t>New events: adult replication</a:t>
-            </a:r>
-            <a:endParaRPr lang="en-US" sz="1800" dirty="0"/>
-          </a:p>
-          <a:p>
-            <a:pPr marL="0" indent="0">
-              <a:spcAft>
-                <a:spcPts val="600"/>
-              </a:spcAft>
-              <a:buNone/>
-            </a:pPr>
-            <a:r>
-              <a:rPr lang="en-US" sz="1800" dirty="0">
-                <a:solidFill>
-                  <a:schemeClr val="tx1"/>
-                </a:solidFill>
-              </a:rPr>
-              <a:t>Direction 3: model study</a:t>
-            </a:r>
-            <a:endParaRPr lang="en-US" sz="1800" dirty="0"/>
-          </a:p>
-          <a:p>
-            <a:pPr marL="0" indent="0">
-              <a:spcAft>
-                <a:spcPts val="600"/>
-              </a:spcAft>
-              <a:buNone/>
-            </a:pPr>
-            <a:r>
-              <a:rPr lang="en-US" sz="1800" dirty="0">
-                <a:solidFill>
-                  <a:schemeClr val="tx1"/>
-                </a:solidFill>
-              </a:rPr>
-              <a:t>Two papers</a:t>
-            </a:r>
-            <a:endParaRPr lang="en-US" sz="1800" dirty="0"/>
-          </a:p>
-        </p:txBody>
-      </p:sp>
-      <p:sp>
-        <p:nvSpPr>
-          <p:cNvPr id="8" name="Shape 5"/>
-          <p:cNvSpPr/>
-          <p:nvPr/>
-        </p:nvSpPr>
-        <p:spPr>
-          <a:xfrm>
-            <a:off x="4612538" y="1463040"/>
-            <a:ext cx="548640" cy="548640"/>
-          </a:xfrm>
-          <a:prstGeom prst="ellipse">
-            <a:avLst/>
-          </a:prstGeom>
-          <a:solidFill>
-            <a:schemeClr val="accent1"/>
-          </a:solidFill>
-        </p:spPr>
-      </p:sp>
-      <p:sp>
-        <p:nvSpPr>
-          <p:cNvPr id="9" name="Text 6"/>
-          <p:cNvSpPr txBox="1"/>
-          <p:nvPr/>
-        </p:nvSpPr>
-        <p:spPr>
-          <a:xfrm>
-            <a:off x="4612538" y="1463040"/>
-            <a:ext cx="548640" cy="548640"/>
-          </a:xfrm>
-          <a:prstGeom prst="rect">
-            <a:avLst/>
-          </a:prstGeom>
-          <a:noFill/>
-        </p:spPr>
-        <p:txBody>
-          <a:bodyPr wrap="square" lIns="0" tIns="0" rIns="0" bIns="0" rtlCol="0" anchor="ctr"/>
-          <a:lstStyle/>
-          <a:p>
-            <a:pPr marL="0" indent="0" algn="ctr">
-              <a:buNone/>
-            </a:pPr>
-            <a:r>
-              <a:rPr lang="en-US" sz="2000" b="1" dirty="0">
-                <a:solidFill>
-                  <a:schemeClr val="bg1"/>
-                </a:solidFill>
-              </a:rPr>
-              <a:t>2</a:t>
-            </a:r>
-            <a:endParaRPr lang="en-US" sz="2000" dirty="0"/>
-          </a:p>
-        </p:txBody>
-      </p:sp>
-      <p:sp>
-        <p:nvSpPr>
-          <p:cNvPr id="10" name="Shape 7"/>
-          <p:cNvSpPr/>
-          <p:nvPr/>
-        </p:nvSpPr>
-        <p:spPr>
-          <a:xfrm>
-            <a:off x="4383938" y="2194560"/>
-            <a:ext cx="3423818" cy="2377440"/>
-          </a:xfrm>
-          <a:prstGeom prst="roundRect">
-            <a:avLst>
-              <a:gd name="adj" fmla="val 3846"/>
-            </a:avLst>
-          </a:prstGeom>
-          <a:solidFill>
-            <a:schemeClr val="bg2"/>
-          </a:solidFill>
-        </p:spPr>
-      </p:sp>
-      <p:sp>
-        <p:nvSpPr>
-          <p:cNvPr id="11" name="Text 8"/>
-          <p:cNvSpPr txBox="1"/>
-          <p:nvPr/>
-        </p:nvSpPr>
-        <p:spPr>
-          <a:xfrm>
-            <a:off x="4612538" y="2377440"/>
-            <a:ext cx="2966618" cy="2011680"/>
-          </a:xfrm>
-          <a:prstGeom prst="rect">
-            <a:avLst/>
-          </a:prstGeom>
-          <a:noFill/>
-        </p:spPr>
-        <p:txBody>
-          <a:bodyPr wrap="square" lIns="0" tIns="0" rIns="0" bIns="0" rtlCol="0" anchor="t"/>
-          <a:lstStyle/>
-          <a:p>
-            <a:pPr marL="0" indent="0">
-              <a:spcAft>
-                <a:spcPts val="600"/>
-              </a:spcAft>
-              <a:buNone/>
-            </a:pPr>
-            <a:r>
-              <a:rPr lang="en-US" sz="2200" b="1" dirty="0">
-                <a:solidFill>
-                  <a:schemeClr val="tx2"/>
-                </a:solidFill>
-              </a:rPr>
-              <a:t>Year 2</a:t>
-            </a:r>
-            <a:endParaRPr lang="en-US" sz="1800" dirty="0"/>
-          </a:p>
-          <a:p>
-            <a:pPr marL="0" indent="0">
-              <a:spcAft>
-                <a:spcPts val="600"/>
-              </a:spcAft>
-              <a:buNone/>
-            </a:pPr>
-            <a:r>
-              <a:rPr lang="en-US" sz="1800" dirty="0">
-                <a:solidFill>
-                  <a:schemeClr val="tx1"/>
-                </a:solidFill>
-              </a:rPr>
-              <a:t>Direction 1: children</a:t>
-            </a:r>
-            <a:endParaRPr lang="en-US" sz="1800" dirty="0"/>
-          </a:p>
-          <a:p>
-            <a:pPr marL="0" indent="0">
-              <a:spcAft>
-                <a:spcPts val="600"/>
-              </a:spcAft>
-              <a:buNone/>
-            </a:pPr>
-            <a:r>
-              <a:rPr lang="en-US" sz="1800" dirty="0">
-                <a:solidFill>
-                  <a:schemeClr val="tx1"/>
-                </a:solidFill>
-              </a:rPr>
-              <a:t>Direction 2: training study</a:t>
-            </a:r>
-            <a:endParaRPr lang="en-US" sz="1800" dirty="0"/>
-          </a:p>
-        </p:txBody>
-      </p:sp>
-      <p:sp>
-        <p:nvSpPr>
-          <p:cNvPr id="12" name="Shape 9"/>
-          <p:cNvSpPr/>
-          <p:nvPr/>
-        </p:nvSpPr>
-        <p:spPr>
-          <a:xfrm>
-            <a:off x="8447837" y="1463040"/>
-            <a:ext cx="548640" cy="548640"/>
-          </a:xfrm>
-          <a:prstGeom prst="ellipse">
-            <a:avLst/>
-          </a:prstGeom>
-          <a:solidFill>
-            <a:schemeClr val="accent2"/>
-          </a:solidFill>
-        </p:spPr>
-      </p:sp>
-      <p:sp>
-        <p:nvSpPr>
-          <p:cNvPr id="13" name="Text 10"/>
-          <p:cNvSpPr txBox="1"/>
-          <p:nvPr/>
-        </p:nvSpPr>
-        <p:spPr>
-          <a:xfrm>
-            <a:off x="8447837" y="1463040"/>
-            <a:ext cx="548640" cy="548640"/>
-          </a:xfrm>
-          <a:prstGeom prst="rect">
-            <a:avLst/>
-          </a:prstGeom>
-          <a:noFill/>
-        </p:spPr>
-        <p:txBody>
-          <a:bodyPr wrap="square" lIns="0" tIns="0" rIns="0" bIns="0" rtlCol="0" anchor="ctr"/>
-          <a:lstStyle/>
-          <a:p>
-            <a:pPr marL="0" indent="0" algn="ctr">
-              <a:buNone/>
-            </a:pPr>
-            <a:r>
-              <a:rPr lang="en-US" sz="2000" b="1" dirty="0">
-                <a:solidFill>
-                  <a:schemeClr val="bg1"/>
-                </a:solidFill>
-              </a:rPr>
-              <a:t>3</a:t>
-            </a:r>
-            <a:endParaRPr lang="en-US" sz="2000" dirty="0"/>
-          </a:p>
-        </p:txBody>
-      </p:sp>
-      <p:sp>
-        <p:nvSpPr>
-          <p:cNvPr id="14" name="Shape 11"/>
-          <p:cNvSpPr/>
-          <p:nvPr/>
-        </p:nvSpPr>
-        <p:spPr>
-          <a:xfrm>
-            <a:off x="8219237" y="2194560"/>
-            <a:ext cx="3423818" cy="2377440"/>
-          </a:xfrm>
-          <a:prstGeom prst="roundRect">
-            <a:avLst>
-              <a:gd name="adj" fmla="val 3846"/>
-            </a:avLst>
-          </a:prstGeom>
-          <a:solidFill>
-            <a:schemeClr val="bg2"/>
-          </a:solidFill>
-        </p:spPr>
-      </p:sp>
-      <p:sp>
-        <p:nvSpPr>
-          <p:cNvPr id="15" name="Text 12"/>
-          <p:cNvSpPr txBox="1"/>
-          <p:nvPr/>
-        </p:nvSpPr>
-        <p:spPr>
-          <a:xfrm>
-            <a:off x="8447837" y="2377440"/>
-            <a:ext cx="2966618" cy="2011680"/>
-          </a:xfrm>
-          <a:prstGeom prst="rect">
-            <a:avLst/>
-          </a:prstGeom>
-          <a:noFill/>
-        </p:spPr>
-        <p:txBody>
-          <a:bodyPr wrap="square" lIns="0" tIns="0" rIns="0" bIns="0" rtlCol="0" anchor="t"/>
-          <a:lstStyle/>
-          <a:p>
-            <a:pPr marL="0" indent="0">
-              <a:spcAft>
-                <a:spcPts val="600"/>
-              </a:spcAft>
-              <a:buNone/>
-            </a:pPr>
-            <a:r>
-              <a:rPr lang="en-US" sz="2200" b="1" dirty="0">
-                <a:solidFill>
-                  <a:schemeClr val="tx2"/>
-                </a:solidFill>
-              </a:rPr>
-              <a:t>Throughout</a:t>
-            </a:r>
-            <a:endParaRPr lang="en-US" sz="1800" dirty="0"/>
-          </a:p>
-          <a:p>
-            <a:pPr marL="0" indent="0">
-              <a:spcAft>
-                <a:spcPts val="600"/>
-              </a:spcAft>
-              <a:buNone/>
-            </a:pPr>
-            <a:r>
-              <a:rPr lang="en-US" sz="1800" dirty="0">
-                <a:solidFill>
-                  <a:schemeClr val="tx1"/>
-                </a:solidFill>
-              </a:rPr>
-              <a:t>Thesis papers</a:t>
-            </a:r>
-            <a:endParaRPr lang="en-US" sz="1800" dirty="0"/>
-          </a:p>
-          <a:p>
-            <a:pPr marL="0" indent="0">
-              <a:spcAft>
-                <a:spcPts val="600"/>
-              </a:spcAft>
-              <a:buNone/>
-            </a:pPr>
-            <a:r>
-              <a:rPr lang="en-US" sz="1800" dirty="0">
-                <a:solidFill>
-                  <a:schemeClr val="tx1"/>
-                </a:solidFill>
-              </a:rPr>
-              <a:t>Grant applications</a:t>
-            </a:r>
-            <a:endParaRPr lang="en-US" sz="1800" dirty="0"/>
-          </a:p>
-          <a:p>
-            <a:pPr marL="0" indent="0">
-              <a:spcAft>
-                <a:spcPts val="600"/>
-              </a:spcAft>
-              <a:buNone/>
-            </a:pPr>
-            <a:r>
-              <a:rPr lang="en-US" sz="1800" dirty="0">
-                <a:solidFill>
-                  <a:schemeClr val="tx1"/>
-                </a:solidFill>
-              </a:rPr>
-              <a:t>Mentoring students</a:t>
-            </a:r>
-            <a:endParaRPr lang="en-US" sz="1800" dirty="0"/>
-          </a:p>
-        </p:txBody>
-      </p:sp>
-      <p:sp>
-        <p:nvSpPr>
-          <p:cNvPr id="16" name="Shape 13"/>
-          <p:cNvSpPr/>
-          <p:nvPr/>
-        </p:nvSpPr>
-        <p:spPr>
-          <a:xfrm>
-            <a:off x="548640" y="4892040"/>
-            <a:ext cx="11094415" cy="685800"/>
-          </a:xfrm>
-          <a:prstGeom prst="roundRect">
-            <a:avLst>
-              <a:gd name="adj" fmla="val 10667"/>
-            </a:avLst>
-          </a:prstGeom>
-          <a:solidFill>
-            <a:schemeClr val="bg2"/>
-          </a:solidFill>
-        </p:spPr>
-      </p:sp>
-      <p:sp>
-        <p:nvSpPr>
-          <p:cNvPr id="17" name="Text 14"/>
-          <p:cNvSpPr txBox="1"/>
-          <p:nvPr/>
-        </p:nvSpPr>
-        <p:spPr>
-          <a:xfrm>
-            <a:off x="777240" y="4892040"/>
-            <a:ext cx="10637215" cy="685800"/>
-          </a:xfrm>
-          <a:prstGeom prst="rect">
-            <a:avLst/>
-          </a:prstGeom>
-          <a:noFill/>
-        </p:spPr>
-        <p:txBody>
-          <a:bodyPr wrap="square" lIns="0" tIns="0" rIns="0" bIns="0" rtlCol="0" anchor="ctr"/>
-          <a:lstStyle/>
-          <a:p>
-            <a:pPr marL="0" indent="0">
-              <a:buNone/>
-            </a:pPr>
-            <a:r>
-              <a:rPr lang="en-US" sz="1800" b="1" dirty="0">
-                <a:solidFill>
-                  <a:schemeClr val="accent2"/>
-                </a:solidFill>
-              </a:rPr>
-              <a:t>Takeaway   </a:t>
-            </a:r>
-            <a:r>
-              <a:rPr lang="en-US" sz="1800" dirty="0">
-                <a:solidFill>
-                  <a:schemeClr val="tx1"/>
-                </a:solidFill>
-              </a:rPr>
-              <a:t>From correspondence to development, learning and input.</a:t>
-            </a:r>
-            <a:endParaRPr lang="en-US" sz="1800" dirty="0"/>
-          </a:p>
-        </p:txBody>
-      </p:sp>
-      <p:sp>
-        <p:nvSpPr>
-          <p:cNvPr id="25" name="Slide Number Placeholder 0"/>
-          <p:cNvSpPr>
-            <a:spLocks noGrp="1"/>
-          </p:cNvSpPr>
-          <p:nvPr>
-            <p:ph type="sldNum" sz="quarter" idx="4294967295"/>
-          </p:nvPr>
-        </p:nvSpPr>
-        <p:spPr>
-          <a:xfrm>
-            <a:off x="11002975" y="6355080"/>
-            <a:ext cx="640080" cy="365760"/>
-          </a:xfrm>
-          <a:prstGeom prst="rect">
-            <a:avLst/>
-          </a:prstGeom>
-        </p:spPr>
-        <p:txBody>
-          <a:bodyPr/>
-          <a:lstStyle>
-            <a:lvl1pPr>
-              <a:defRPr sz="1800">
-                <a:solidFill>
-                  <a:schemeClr val="accent3"/>
-                </a:solidFill>
-              </a:defRPr>
-            </a:lvl1pPr>
-          </a:lstStyle>
-          <a:p>
-            <a:pPr algn="r"/>
-            <a:fld id="{F7021451-1387-4CA6-816F-3879F97B5CBC}" type="slidenum">
-              <a:rPr lang="en-US" b="0"/>
-            </a:fld>
-            <a:endParaRPr lang="en-US"/>
-          </a:p>
-        </p:txBody>
-      </p:sp>
-    </p:spTree>
-  </p:cSld>
-  <p:clrMapOvr>
-    <a:masterClrMapping/>
-  </p:clrMapOvr>
-</p:sld>
-</file>
-
-<file path=ppt/slides/slide11.xml><?xml version="1.0" encoding="utf-8"?>
-<p:sld xmlns:a="http://schemas.openxmlformats.org/drawingml/2006/main" xmlns:r="http://schemas.openxmlformats.org/officeDocument/2006/relationships" xmlns:p="http://schemas.openxmlformats.org/presentationml/2006/main">
-  <p:cSld>
-    <p:spTree>
-      <p:nvGrpSpPr>
-        <p:cNvPr id="1" name=""/>
-        <p:cNvGrpSpPr/>
-        <p:nvPr/>
-      </p:nvGrpSpPr>
-      <p:grpSpPr>
-        <a:xfrm>
-          <a:off x="0" y="0"/>
-          <a:ext cx="0" cy="0"/>
-          <a:chOff x="0" y="0"/>
-          <a:chExt cx="0" cy="0"/>
-        </a:xfrm>
-      </p:grpSpPr>
-      <p:sp>
-        <p:nvSpPr>
-          <p:cNvPr id="3" name="Text 0"/>
-          <p:cNvSpPr txBox="1"/>
-          <p:nvPr/>
-        </p:nvSpPr>
-        <p:spPr>
-          <a:xfrm>
-            <a:off x="548640" y="548640"/>
-            <a:ext cx="11094415" cy="731520"/>
-          </a:xfrm>
-          <a:prstGeom prst="rect">
-            <a:avLst/>
-          </a:prstGeom>
-          <a:noFill/>
-        </p:spPr>
-        <p:txBody>
-          <a:bodyPr wrap="square" lIns="0" tIns="0" rIns="0" bIns="0" rtlCol="0" anchor="ctr"/>
-          <a:lstStyle/>
-          <a:p>
-            <a:pPr marL="0" indent="0">
-              <a:buNone/>
-            </a:pPr>
-            <a:r>
-              <a:rPr lang="en-US" sz="3000" b="1" dirty="0">
-                <a:solidFill>
-                  <a:schemeClr val="bg1"/>
-                </a:solidFill>
-              </a:rPr>
-              <a:t>What I would bring</a:t>
-            </a:r>
-            <a:endParaRPr lang="en-US" sz="3000" dirty="0"/>
-          </a:p>
-        </p:txBody>
-      </p:sp>
-      <p:sp>
-        <p:nvSpPr>
-          <p:cNvPr id="4" name="Text 1"/>
-          <p:cNvSpPr txBox="1"/>
-          <p:nvPr/>
-        </p:nvSpPr>
-        <p:spPr>
-          <a:xfrm>
-            <a:off x="548640" y="1600200"/>
-            <a:ext cx="3423818" cy="2377440"/>
-          </a:xfrm>
-          <a:prstGeom prst="rect">
-            <a:avLst/>
-          </a:prstGeom>
-          <a:noFill/>
-        </p:spPr>
-        <p:txBody>
-          <a:bodyPr wrap="square" lIns="0" tIns="0" rIns="0" bIns="0" rtlCol="0" anchor="t"/>
-          <a:lstStyle/>
-          <a:p>
-            <a:pPr marL="0" indent="0">
-              <a:spcAft>
-                <a:spcPts val="800"/>
-              </a:spcAft>
-              <a:buNone/>
-            </a:pPr>
-            <a:r>
-              <a:rPr lang="en-US" sz="2200" b="1" dirty="0">
-                <a:solidFill>
-                  <a:schemeClr val="accent4"/>
-                </a:solidFill>
-              </a:rPr>
-              <a:t>Methods</a:t>
-            </a:r>
-            <a:endParaRPr lang="en-US" sz="1800" dirty="0"/>
-          </a:p>
-          <a:p>
-            <a:pPr marL="0" indent="0">
-              <a:spcAft>
-                <a:spcPts val="800"/>
-              </a:spcAft>
-              <a:buNone/>
-            </a:pPr>
-            <a:r>
-              <a:rPr lang="en-US" sz="1800" dirty="0">
-                <a:solidFill>
-                  <a:schemeClr val="bg1"/>
-                </a:solidFill>
-              </a:rPr>
-              <a:t>Video stimuli and norming</a:t>
-            </a:r>
-            <a:endParaRPr lang="en-US" sz="1800" dirty="0"/>
-          </a:p>
-          <a:p>
-            <a:pPr marL="0" indent="0">
-              <a:spcAft>
-                <a:spcPts val="800"/>
-              </a:spcAft>
-              <a:buNone/>
-            </a:pPr>
-            <a:r>
-              <a:rPr lang="en-US" sz="1800" dirty="0">
-                <a:solidFill>
-                  <a:schemeClr val="bg1"/>
-                </a:solidFill>
-              </a:rPr>
-              <a:t>Child testing</a:t>
-            </a:r>
-            <a:endParaRPr lang="en-US" sz="1800" dirty="0"/>
-          </a:p>
-          <a:p>
-            <a:pPr marL="0" indent="0">
-              <a:spcAft>
-                <a:spcPts val="800"/>
-              </a:spcAft>
-              <a:buNone/>
-            </a:pPr>
-            <a:r>
-              <a:rPr lang="en-US" sz="1800" dirty="0">
-                <a:solidFill>
-                  <a:schemeClr val="bg1"/>
-                </a:solidFill>
-              </a:rPr>
-              <a:t>Bayesian GLMMs, R, Python</a:t>
-            </a:r>
-            <a:endParaRPr lang="en-US" sz="1800" dirty="0"/>
-          </a:p>
-        </p:txBody>
-      </p:sp>
-      <p:sp>
-        <p:nvSpPr>
-          <p:cNvPr id="5" name="Text 2"/>
-          <p:cNvSpPr txBox="1"/>
-          <p:nvPr/>
-        </p:nvSpPr>
-        <p:spPr>
-          <a:xfrm>
-            <a:off x="4383938" y="1600200"/>
-            <a:ext cx="3423818" cy="2377440"/>
-          </a:xfrm>
-          <a:prstGeom prst="rect">
-            <a:avLst/>
-          </a:prstGeom>
-          <a:noFill/>
-        </p:spPr>
-        <p:txBody>
-          <a:bodyPr wrap="square" lIns="0" tIns="0" rIns="0" bIns="0" rtlCol="0" anchor="t"/>
-          <a:lstStyle/>
-          <a:p>
-            <a:pPr marL="0" indent="0">
-              <a:spcAft>
-                <a:spcPts val="800"/>
-              </a:spcAft>
-              <a:buNone/>
-            </a:pPr>
-            <a:r>
-              <a:rPr lang="en-US" sz="2200" b="1" dirty="0">
-                <a:solidFill>
-                  <a:schemeClr val="accent4"/>
-                </a:solidFill>
-              </a:rPr>
-              <a:t>Projects</a:t>
-            </a:r>
-            <a:endParaRPr lang="en-US" sz="1800" dirty="0"/>
-          </a:p>
-          <a:p>
-            <a:pPr marL="0" indent="0">
-              <a:spcAft>
-                <a:spcPts val="800"/>
-              </a:spcAft>
-              <a:buNone/>
-            </a:pPr>
-            <a:r>
-              <a:rPr lang="en-US" sz="1800" dirty="0">
-                <a:solidFill>
-                  <a:schemeClr val="bg1"/>
-                </a:solidFill>
-              </a:rPr>
-              <a:t>Led a CAS field project</a:t>
-            </a:r>
-            <a:endParaRPr lang="en-US" sz="1800" dirty="0"/>
-          </a:p>
-          <a:p>
-            <a:pPr marL="0" indent="0">
-              <a:spcAft>
-                <a:spcPts val="800"/>
-              </a:spcAft>
-              <a:buNone/>
-            </a:pPr>
-            <a:r>
-              <a:rPr lang="en-US" sz="1800" dirty="0">
-                <a:solidFill>
-                  <a:schemeClr val="bg1"/>
-                </a:solidFill>
-              </a:rPr>
-              <a:t>Preregistered experiments</a:t>
-            </a:r>
-            <a:endParaRPr lang="en-US" sz="1800" dirty="0"/>
-          </a:p>
-          <a:p>
-            <a:pPr marL="0" indent="0">
-              <a:spcAft>
-                <a:spcPts val="800"/>
-              </a:spcAft>
-              <a:buNone/>
-            </a:pPr>
-            <a:r>
-              <a:rPr lang="en-US" sz="1800" dirty="0">
-                <a:solidFill>
-                  <a:schemeClr val="bg1"/>
-                </a:solidFill>
-              </a:rPr>
-              <a:t>Teaching research methods</a:t>
-            </a:r>
-            <a:endParaRPr lang="en-US" sz="1800" dirty="0"/>
-          </a:p>
-        </p:txBody>
-      </p:sp>
-      <p:sp>
-        <p:nvSpPr>
-          <p:cNvPr id="6" name="Text 3"/>
-          <p:cNvSpPr txBox="1"/>
-          <p:nvPr/>
-        </p:nvSpPr>
-        <p:spPr>
-          <a:xfrm>
-            <a:off x="8219237" y="1600200"/>
-            <a:ext cx="3423818" cy="2377440"/>
-          </a:xfrm>
-          <a:prstGeom prst="rect">
-            <a:avLst/>
-          </a:prstGeom>
-          <a:noFill/>
-        </p:spPr>
-        <p:txBody>
-          <a:bodyPr wrap="square" lIns="0" tIns="0" rIns="0" bIns="0" rtlCol="0" anchor="t"/>
-          <a:lstStyle/>
-          <a:p>
-            <a:pPr marL="0" indent="0">
-              <a:spcAft>
-                <a:spcPts val="800"/>
-              </a:spcAft>
-              <a:buNone/>
-            </a:pPr>
-            <a:r>
-              <a:rPr lang="en-US" sz="2200" b="1" dirty="0">
-                <a:solidFill>
-                  <a:schemeClr val="accent4"/>
-                </a:solidFill>
-              </a:rPr>
-              <a:t>Fit</a:t>
-            </a:r>
-            <a:endParaRPr lang="en-US" sz="1800" dirty="0"/>
-          </a:p>
-          <a:p>
-            <a:pPr marL="0" indent="0">
-              <a:spcAft>
-                <a:spcPts val="800"/>
-              </a:spcAft>
-              <a:buNone/>
-            </a:pPr>
-            <a:r>
-              <a:rPr lang="en-US" sz="1800" dirty="0">
-                <a:solidFill>
-                  <a:schemeClr val="bg1"/>
-                </a:solidFill>
-              </a:rPr>
-              <a:t>Event language in development</a:t>
-            </a:r>
-            <a:endParaRPr lang="en-US" sz="1800" dirty="0"/>
-          </a:p>
-          <a:p>
-            <a:pPr marL="0" indent="0">
-              <a:spcAft>
-                <a:spcPts val="800"/>
-              </a:spcAft>
-              <a:buNone/>
-            </a:pPr>
-            <a:r>
-              <a:rPr lang="en-US" sz="1800" dirty="0">
-                <a:solidFill>
-                  <a:schemeClr val="bg1"/>
-                </a:solidFill>
-              </a:rPr>
-              <a:t>Mandarin–English expertise</a:t>
-            </a:r>
-            <a:endParaRPr lang="en-US" sz="1800" dirty="0"/>
-          </a:p>
-          <a:p>
-            <a:pPr marL="0" indent="0">
-              <a:spcAft>
-                <a:spcPts val="800"/>
-              </a:spcAft>
-              <a:buNone/>
-            </a:pPr>
-            <a:r>
-              <a:rPr lang="en-US" sz="1800" dirty="0">
-                <a:solidFill>
-                  <a:schemeClr val="bg1"/>
-                </a:solidFill>
-              </a:rPr>
-              <a:t>Experiments and models</a:t>
-            </a:r>
-            <a:endParaRPr lang="en-US" sz="1800" dirty="0"/>
-          </a:p>
-        </p:txBody>
-      </p:sp>
-      <p:sp>
-        <p:nvSpPr>
-          <p:cNvPr id="7" name="Text 4"/>
-          <p:cNvSpPr txBox="1"/>
-          <p:nvPr/>
-        </p:nvSpPr>
-        <p:spPr>
-          <a:xfrm>
-            <a:off x="548640" y="4480560"/>
-            <a:ext cx="11094415" cy="1371600"/>
-          </a:xfrm>
-          <a:prstGeom prst="rect">
-            <a:avLst/>
-          </a:prstGeom>
-          <a:noFill/>
-        </p:spPr>
-        <p:txBody>
-          <a:bodyPr wrap="square" lIns="0" tIns="0" rIns="0" bIns="0" rtlCol="0" anchor="t"/>
-          <a:lstStyle/>
-          <a:p>
-            <a:pPr marL="0" indent="0">
-              <a:buNone/>
-            </a:pPr>
-            <a:r>
-              <a:rPr lang="en-US" sz="3600" b="1" dirty="0">
-                <a:solidFill>
-                  <a:schemeClr val="bg1"/>
-                </a:solidFill>
-              </a:rPr>
-              <a:t>Thank you</a:t>
-            </a:r>
-            <a:endParaRPr lang="en-US" sz="1800" dirty="0"/>
-          </a:p>
-          <a:p>
-            <a:pPr marL="0" indent="0">
-              <a:buNone/>
-            </a:pPr>
-            <a:r>
-              <a:rPr lang="en-US" sz="1800" dirty="0">
-                <a:solidFill>
-                  <a:schemeClr val="accent5"/>
-                </a:solidFill>
-              </a:rPr>
-              <a:t>xtliu0516@yeah.net  ·  xiaotaoliu.owlstown.net</a:t>
-            </a:r>
-            <a:endParaRPr lang="en-US" sz="1800" dirty="0"/>
-          </a:p>
-        </p:txBody>
-      </p:sp>
-      <p:sp>
-        <p:nvSpPr>
-          <p:cNvPr id="8" name="Text 0"/>
-          <p:cNvSpPr/>
-          <p:nvPr>
-            <p:ph type="title" idx="100" hasCustomPrompt="1"/>
-          </p:nvPr>
-        </p:nvSpPr>
-        <p:spPr>
-          <a:xfrm>
-            <a:off x="548640" y="1737360"/>
-            <a:ext cx="11094415" cy="1188720"/>
-          </a:xfrm>
-          <a:prstGeom prst="rect">
-            <a:avLst/>
-          </a:prstGeom>
-          <a:noFill/>
-        </p:spPr>
-        <p:txBody>
-          <a:bodyPr wrap="square" lIns="0" tIns="0" rIns="0" bIns="0" rtlCol="0" anchor="b"/>
-          <a:lstStyle/>
-          <a:p>
-            <a:pPr marL="0" indent="0" algn="l">
-              <a:buNone/>
-            </a:pPr>
-            <a:endParaRPr lang="en-US" sz="3600" dirty="0"/>
-          </a:p>
-        </p:txBody>
-      </p:sp>
-      <p:sp>
-        <p:nvSpPr>
-          <p:cNvPr id="9" name="Text 0"/>
-          <p:cNvSpPr/>
-          <p:nvPr>
-            <p:ph type="body" idx="101" hasCustomPrompt="1"/>
-          </p:nvPr>
-        </p:nvSpPr>
-        <p:spPr>
-          <a:xfrm>
-            <a:off x="548640" y="3108960"/>
-            <a:ext cx="11094415" cy="822960"/>
-          </a:xfrm>
-          <a:prstGeom prst="rect">
-            <a:avLst/>
-          </a:prstGeom>
-          <a:noFill/>
-        </p:spPr>
-        <p:txBody>
-          <a:bodyPr wrap="square" lIns="0" tIns="0" rIns="0" bIns="0" rtlCol="0" anchor="t"/>
-          <a:lstStyle/>
-          <a:p>
-            <a:pPr marL="0" indent="0" algn="l">
-              <a:buNone/>
-            </a:pPr>
-            <a:endParaRPr lang="en-US" sz="2200" dirty="0"/>
-          </a:p>
-        </p:txBody>
-      </p:sp>
-      <p:sp>
-        <p:nvSpPr>
-          <p:cNvPr id="10" name="Text 0"/>
-          <p:cNvSpPr/>
-          <p:nvPr>
-            <p:ph type="body" idx="102" hasCustomPrompt="1"/>
-          </p:nvPr>
-        </p:nvSpPr>
-        <p:spPr>
-          <a:xfrm>
-            <a:off x="548640" y="4663440"/>
-            <a:ext cx="11094415" cy="1371600"/>
-          </a:xfrm>
-          <a:prstGeom prst="rect">
-            <a:avLst/>
-          </a:prstGeom>
-          <a:noFill/>
-        </p:spPr>
-        <p:txBody>
-          <a:bodyPr wrap="square" lIns="0" tIns="0" rIns="0" bIns="0" rtlCol="0" anchor="t"/>
-          <a:lstStyle/>
-          <a:p>
-            <a:pPr marL="0" indent="0" algn="l">
-              <a:buNone/>
-            </a:pPr>
-            <a:endParaRPr lang="en-US" sz="1800" dirty="0"/>
-          </a:p>
-        </p:txBody>
-      </p:sp>
-    </p:spTree>
-  </p:cSld>
-  <p:clrMapOvr>
-    <a:masterClrMapping/>
-  </p:clrMapOvr>
-</p:sld>
-</file>
-
 <file path=ppt/slides/slide2.xml><?xml version="1.0" encoding="utf-8"?>
 <p:sld xmlns:a="http://schemas.openxmlformats.org/drawingml/2006/main" xmlns:r="http://schemas.openxmlformats.org/officeDocument/2006/relationships" xmlns:p="http://schemas.openxmlformats.org/presentationml/2006/main">
   <p:cSld>
@@ -3343,7 +2276,7 @@
             <a:avLst/>
           </a:prstGeom>
           <a:solidFill>
-            <a:schemeClr val="accent2"/>
+            <a:schemeClr val="tx2"/>
           </a:solidFill>
         </p:spPr>
       </p:sp>
@@ -4111,8 +3044,8 @@
         </p:nvSpPr>
         <p:spPr>
           <a:xfrm>
-            <a:off x="5920105" y="3400425"/>
-            <a:ext cx="2287270" cy="777240"/>
+            <a:off x="5914390" y="3383280"/>
+            <a:ext cx="2353945" cy="777240"/>
           </a:xfrm>
           <a:prstGeom prst="rect">
             <a:avLst/>
@@ -4543,7 +3476,15 @@
                   <a:schemeClr val="tx1"/>
                 </a:solidFill>
               </a:rPr>
-              <a:t>10 action pairs, result attained or not; 72 ages 4–5 and 40 adults</a:t>
+              <a:t>10 action </a:t>
+            </a:r>
+            <a:r>
+              <a:rPr lang="en-US" sz="1800" dirty="0">
+                <a:solidFill>
+                  <a:schemeClr val="tx1"/>
+                </a:solidFill>
+              </a:rPr>
+              <a:t>video pairs, result attained or not; 72 ages 4–5 and 40 adults</a:t>
             </a:r>
             <a:endParaRPr lang="en-US" sz="1800" dirty="0"/>
           </a:p>
@@ -4588,7 +3529,21 @@
             </a:pPr>
             <a:r>
               <a:rPr lang="en-US" altLang="zh-CN" sz="1800" dirty="0"/>
-              <a:t>the more likely the result, the more they reject the verb when it fails.</a:t>
+              <a:t>1. the more likely the result, the more </a:t>
+            </a:r>
+            <a:r>
+              <a:rPr lang="en-US" altLang="zh-CN" sz="1800" dirty="0"/>
+              <a:t>children reject the verb when it fails.</a:t>
+            </a:r>
+            <a:endParaRPr lang="en-US" altLang="zh-CN" sz="1800" dirty="0"/>
+          </a:p>
+          <a:p>
+            <a:pPr marL="0" indent="0">
+              <a:buNone/>
+            </a:pPr>
+            <a:r>
+              <a:rPr lang="en-US" altLang="zh-CN" sz="1800" dirty="0"/>
+              <a:t>2. This effect is stronger in children than in adults.</a:t>
             </a:r>
             <a:endParaRPr lang="en-US" altLang="zh-CN" sz="1800" dirty="0"/>
           </a:p>
@@ -5791,7 +4746,11 @@
         <p:nvSpPr>
           <p:cNvPr id="101" name="Shape 1"/>
           <p:cNvSpPr/>
-          <p:nvPr/>
+          <p:nvPr>
+            <p:custDataLst>
+              <p:tags r:id="rId1"/>
+            </p:custDataLst>
+          </p:nvPr>
         </p:nvSpPr>
         <p:spPr>
           <a:xfrm>
@@ -5806,14 +4765,17 @@
           <a:solidFill>
             <a:schemeClr val="bg2"/>
           </a:solidFill>
-          <a:ln/>
         </p:spPr>
       </p:sp>
       <p:sp>
         <p:nvSpPr>
           <p:cNvPr id="102" name="Shape 2"/>
           <p:cNvSpPr/>
-          <p:nvPr/>
+          <p:nvPr>
+            <p:custDataLst>
+              <p:tags r:id="rId2"/>
+            </p:custDataLst>
+          </p:nvPr>
         </p:nvSpPr>
         <p:spPr>
           <a:xfrm>
@@ -5826,14 +4788,17 @@
           <a:solidFill>
             <a:schemeClr val="accent1"/>
           </a:solidFill>
-          <a:ln/>
         </p:spPr>
       </p:sp>
       <p:sp>
         <p:nvSpPr>
           <p:cNvPr id="103" name="Text 3"/>
           <p:cNvSpPr txBox="1"/>
-          <p:nvPr/>
+          <p:nvPr>
+            <p:custDataLst>
+              <p:tags r:id="rId3"/>
+            </p:custDataLst>
+          </p:nvPr>
         </p:nvSpPr>
         <p:spPr>
           <a:xfrm>
@@ -5844,13 +4809,12 @@
             <a:avLst/>
           </a:prstGeom>
           <a:noFill/>
-          <a:ln/>
         </p:spPr>
         <p:txBody>
           <a:bodyPr wrap="square" lIns="0" tIns="0" rIns="0" bIns="0" rtlCol="0" anchor="ctr"/>
           <a:lstStyle/>
           <a:p>
-            <a:pPr algn="ctr" indent="0" marL="0">
+            <a:pPr marL="0" indent="0" algn="ctr">
               <a:buNone/>
             </a:pPr>
             <a:r>
@@ -5869,7 +4833,11 @@
         <p:nvSpPr>
           <p:cNvPr id="104" name="Text 4"/>
           <p:cNvSpPr txBox="1"/>
-          <p:nvPr/>
+          <p:nvPr>
+            <p:custDataLst>
+              <p:tags r:id="rId4"/>
+            </p:custDataLst>
+          </p:nvPr>
         </p:nvSpPr>
         <p:spPr>
           <a:xfrm>
@@ -5880,13 +4848,12 @@
             <a:avLst/>
           </a:prstGeom>
           <a:noFill/>
-          <a:ln/>
         </p:spPr>
         <p:txBody>
           <a:bodyPr wrap="square" lIns="0" tIns="0" rIns="0" bIns="0" rtlCol="0" anchor="t"/>
           <a:lstStyle/>
           <a:p>
-            <a:pPr indent="0" marL="0">
+            <a:pPr marL="0" indent="0">
               <a:buNone/>
             </a:pPr>
             <a:r>
@@ -5905,7 +4872,11 @@
         <p:nvSpPr>
           <p:cNvPr id="105" name="Text 5"/>
           <p:cNvSpPr txBox="1"/>
-          <p:nvPr/>
+          <p:nvPr>
+            <p:custDataLst>
+              <p:tags r:id="rId5"/>
+            </p:custDataLst>
+          </p:nvPr>
         </p:nvSpPr>
         <p:spPr>
           <a:xfrm>
@@ -5916,13 +4887,12 @@
             <a:avLst/>
           </a:prstGeom>
           <a:noFill/>
-          <a:ln/>
         </p:spPr>
         <p:txBody>
           <a:bodyPr wrap="square" lIns="0" tIns="0" rIns="0" bIns="0" rtlCol="0" anchor="t"/>
           <a:lstStyle/>
           <a:p>
-            <a:pPr indent="0" marL="0">
+            <a:pPr marL="0" indent="0">
               <a:spcAft>
                 <a:spcPts val="600"/>
               </a:spcAft>
@@ -5939,7 +4909,7 @@
             <a:endParaRPr lang="en-US" sz="1800" dirty="0"/>
           </a:p>
           <a:p>
-            <a:pPr indent="0" marL="0">
+            <a:pPr marL="0" indent="0">
               <a:spcAft>
                 <a:spcPts val="600"/>
               </a:spcAft>
@@ -5951,12 +4921,20 @@
                   <a:schemeClr val="tx1"/>
                 </a:solidFill>
               </a:rPr>
-              <a:t>Children (3–6) describe new events and do both of my tasks</a:t>
-            </a:r>
-            <a:endParaRPr lang="en-US" sz="1800" dirty="0"/>
-          </a:p>
-          <a:p>
-            <a:pPr indent="0" marL="0">
+              <a:t>Mandarin and English-</a:t>
+            </a:r>
+            <a:r>
+              <a:rPr lang="en-US" sz="1800" dirty="0">
+                <a:solidFill>
+                  <a:schemeClr val="tx1"/>
+                </a:solidFill>
+              </a:rPr>
+              <a:t>speaking Children (3–6) describe new events and do both of my tasks</a:t>
+            </a:r>
+            <a:endParaRPr lang="en-US" sz="1800" dirty="0"/>
+          </a:p>
+          <a:p>
+            <a:pPr marL="0" indent="0">
               <a:spcAft>
                 <a:spcPts val="600"/>
               </a:spcAft>
@@ -5973,7 +4951,7 @@
             <a:endParaRPr lang="en-US" sz="1800" dirty="0"/>
           </a:p>
           <a:p>
-            <a:pPr indent="0" marL="0">
+            <a:pPr marL="0" indent="0">
               <a:spcAft>
                 <a:spcPts val="600"/>
               </a:spcAft>
@@ -5985,9 +4963,21 @@
                   <a:schemeClr val="tx1"/>
                 </a:solidFill>
               </a:rPr>
-              <a:t>Lexical encoding predicts phases; predicate encoding, endpoints</a:t>
-            </a:r>
-            <a:endParaRPr lang="en-US" sz="1800" dirty="0"/>
+              <a:t>Lexical encoding predicts phases; predicate encoding, </a:t>
+            </a:r>
+            <a:r>
+              <a:rPr lang="en-US" sz="1800" dirty="0">
+                <a:solidFill>
+                  <a:schemeClr val="tx1"/>
+                </a:solidFill>
+              </a:rPr>
+              <a:t>boundaries</a:t>
+            </a:r>
+            <a:endParaRPr lang="en-US" sz="1800" dirty="0">
+              <a:solidFill>
+                <a:schemeClr val="tx1"/>
+              </a:solidFill>
+            </a:endParaRPr>
           </a:p>
         </p:txBody>
       </p:sp>
@@ -5995,7 +4985,11 @@
         <p:nvSpPr>
           <p:cNvPr id="106" name="Shape 6"/>
           <p:cNvSpPr/>
-          <p:nvPr/>
+          <p:nvPr>
+            <p:custDataLst>
+              <p:tags r:id="rId6"/>
+            </p:custDataLst>
+          </p:nvPr>
         </p:nvSpPr>
         <p:spPr>
           <a:xfrm>
@@ -6010,14 +5004,17 @@
           <a:solidFill>
             <a:schemeClr val="bg2"/>
           </a:solidFill>
-          <a:ln/>
         </p:spPr>
       </p:sp>
       <p:sp>
         <p:nvSpPr>
           <p:cNvPr id="107" name="Shape 7"/>
           <p:cNvSpPr/>
-          <p:nvPr/>
+          <p:nvPr>
+            <p:custDataLst>
+              <p:tags r:id="rId7"/>
+            </p:custDataLst>
+          </p:nvPr>
         </p:nvSpPr>
         <p:spPr>
           <a:xfrm>
@@ -6030,14 +5027,17 @@
           <a:solidFill>
             <a:schemeClr val="accent1"/>
           </a:solidFill>
-          <a:ln/>
         </p:spPr>
       </p:sp>
       <p:sp>
         <p:nvSpPr>
           <p:cNvPr id="108" name="Text 8"/>
           <p:cNvSpPr txBox="1"/>
-          <p:nvPr/>
+          <p:nvPr>
+            <p:custDataLst>
+              <p:tags r:id="rId8"/>
+            </p:custDataLst>
+          </p:nvPr>
         </p:nvSpPr>
         <p:spPr>
           <a:xfrm>
@@ -6048,13 +5048,12 @@
             <a:avLst/>
           </a:prstGeom>
           <a:noFill/>
-          <a:ln/>
         </p:spPr>
         <p:txBody>
           <a:bodyPr wrap="square" lIns="0" tIns="0" rIns="0" bIns="0" rtlCol="0" anchor="ctr"/>
           <a:lstStyle/>
           <a:p>
-            <a:pPr algn="ctr" indent="0" marL="0">
+            <a:pPr marL="0" indent="0" algn="ctr">
               <a:buNone/>
             </a:pPr>
             <a:r>
@@ -6073,7 +5072,11 @@
         <p:nvSpPr>
           <p:cNvPr id="109" name="Text 9"/>
           <p:cNvSpPr txBox="1"/>
-          <p:nvPr/>
+          <p:nvPr>
+            <p:custDataLst>
+              <p:tags r:id="rId9"/>
+            </p:custDataLst>
+          </p:nvPr>
         </p:nvSpPr>
         <p:spPr>
           <a:xfrm>
@@ -6084,13 +5087,12 @@
             <a:avLst/>
           </a:prstGeom>
           <a:noFill/>
-          <a:ln/>
         </p:spPr>
         <p:txBody>
           <a:bodyPr wrap="square" lIns="0" tIns="0" rIns="0" bIns="0" rtlCol="0" anchor="t"/>
           <a:lstStyle/>
           <a:p>
-            <a:pPr indent="0" marL="0">
+            <a:pPr marL="0" indent="0">
               <a:buNone/>
             </a:pPr>
             <a:r>
@@ -6109,7 +5111,11 @@
         <p:nvSpPr>
           <p:cNvPr id="110" name="Text 10"/>
           <p:cNvSpPr txBox="1"/>
-          <p:nvPr/>
+          <p:nvPr>
+            <p:custDataLst>
+              <p:tags r:id="rId10"/>
+            </p:custDataLst>
+          </p:nvPr>
         </p:nvSpPr>
         <p:spPr>
           <a:xfrm>
@@ -6120,13 +5126,12 @@
             <a:avLst/>
           </a:prstGeom>
           <a:noFill/>
-          <a:ln/>
         </p:spPr>
         <p:txBody>
           <a:bodyPr wrap="square" lIns="0" tIns="0" rIns="0" bIns="0" rtlCol="0" anchor="t"/>
           <a:lstStyle/>
           <a:p>
-            <a:pPr indent="0" marL="0">
+            <a:pPr marL="0" indent="0">
               <a:spcAft>
                 <a:spcPts val="600"/>
               </a:spcAft>
@@ -6143,7 +5148,7 @@
             <a:endParaRPr lang="en-US" sz="1800" dirty="0"/>
           </a:p>
           <a:p>
-            <a:pPr indent="0" marL="0">
+            <a:pPr marL="0" indent="0">
               <a:spcAft>
                 <a:spcPts val="600"/>
               </a:spcAft>
@@ -6155,77 +5160,57 @@
                   <a:schemeClr val="tx1"/>
                 </a:solidFill>
               </a:rPr>
-              <a:t>Training with cues</a:t>
-            </a:r>
-            <a:endParaRPr lang="en-US" sz="1800" dirty="0"/>
-          </a:p>
-          <a:p>
-            <a:pPr indent="0" marL="0">
+              <a:t>Training with lexical and predicate cues </a:t>
+            </a:r>
+            <a:endParaRPr lang="en-US" sz="1800" dirty="0"/>
+          </a:p>
+          <a:p>
+            <a:pPr marL="0" indent="0">
               <a:spcAft>
                 <a:spcPts val="600"/>
               </a:spcAft>
               <a:buNone/>
             </a:pPr>
             <a:r>
-              <a:rPr lang="en-US" sz="1800" dirty="0">
-                <a:solidFill>
-                  <a:schemeClr val="tx1"/>
-                </a:solidFill>
-              </a:rPr>
-              <a:t>Lexical: 切成两块</a:t>
-            </a:r>
-            <a:endParaRPr lang="en-US" sz="1800" dirty="0"/>
-          </a:p>
-          <a:p>
-            <a:pPr indent="0" marL="0">
+              <a:rPr lang="en-US" sz="1800" b="1" dirty="0">
+                <a:solidFill>
+                  <a:schemeClr val="accent2"/>
+                </a:solidFill>
+              </a:rPr>
+              <a:t>Prediction</a:t>
+            </a:r>
+            <a:endParaRPr lang="en-US" sz="1800" dirty="0"/>
+          </a:p>
+          <a:p>
+            <a:pPr marL="0" indent="0">
               <a:spcAft>
                 <a:spcPts val="600"/>
               </a:spcAft>
               <a:buNone/>
             </a:pPr>
             <a:r>
-              <a:rPr lang="en-US" sz="1800" dirty="0">
-                <a:solidFill>
-                  <a:schemeClr val="tx1"/>
-                </a:solidFill>
-              </a:rPr>
-              <a:t>Predicate: 切开 vs. 切一切</a:t>
-            </a:r>
-            <a:endParaRPr lang="en-US" sz="1800" dirty="0"/>
-          </a:p>
-          <a:p>
-            <a:pPr indent="0" marL="0">
+              <a:rPr lang="en-US" altLang="zh-CN" sz="1800" dirty="0"/>
+              <a:t>Training gains transfer to new events, each at its own level</a:t>
+            </a:r>
+            <a:endParaRPr lang="en-US" altLang="zh-CN" sz="1800" dirty="0"/>
+          </a:p>
+          <a:p>
+            <a:pPr marL="0" indent="0">
               <a:spcAft>
                 <a:spcPts val="600"/>
               </a:spcAft>
               <a:buNone/>
             </a:pPr>
-            <a:r>
-              <a:rPr lang="en-US" sz="1800" b="1" dirty="0">
-                <a:solidFill>
-                  <a:schemeClr val="accent2"/>
-                </a:solidFill>
-              </a:rPr>
-              <a:t>Prediction</a:t>
-            </a:r>
-            <a:endParaRPr lang="en-US" sz="1800" dirty="0"/>
-          </a:p>
-          <a:p>
-            <a:pPr indent="0" marL="0">
+            <a:endParaRPr lang="en-US" altLang="zh-CN" sz="1800" dirty="0"/>
+          </a:p>
+          <a:p>
+            <a:pPr marL="0" indent="0">
               <a:spcAft>
                 <a:spcPts val="600"/>
               </a:spcAft>
               <a:buNone/>
             </a:pPr>
-            <a:r>
-              <a:rPr lang="en-US" sz="1800" dirty="0">
-                <a:solidFill>
-                  <a:schemeClr val="tx1"/>
-                </a:solidFill>
-              </a:rPr>
-              <a:t>Lexical training shifts phases; predicate training, endpoints</a:t>
-            </a:r>
-            <a:endParaRPr lang="en-US" sz="1800" dirty="0"/>
+            <a:endParaRPr lang="en-US" altLang="zh-CN" sz="1800" dirty="0"/>
           </a:p>
         </p:txBody>
       </p:sp>
@@ -6233,7 +5218,11 @@
         <p:nvSpPr>
           <p:cNvPr id="111" name="Shape 11"/>
           <p:cNvSpPr/>
-          <p:nvPr/>
+          <p:nvPr>
+            <p:custDataLst>
+              <p:tags r:id="rId11"/>
+            </p:custDataLst>
+          </p:nvPr>
         </p:nvSpPr>
         <p:spPr>
           <a:xfrm>
@@ -6248,14 +5237,17 @@
           <a:solidFill>
             <a:schemeClr val="bg2"/>
           </a:solidFill>
-          <a:ln/>
         </p:spPr>
       </p:sp>
       <p:sp>
         <p:nvSpPr>
           <p:cNvPr id="112" name="Shape 12"/>
           <p:cNvSpPr/>
-          <p:nvPr/>
+          <p:nvPr>
+            <p:custDataLst>
+              <p:tags r:id="rId12"/>
+            </p:custDataLst>
+          </p:nvPr>
         </p:nvSpPr>
         <p:spPr>
           <a:xfrm>
@@ -6266,16 +5258,19 @@
             <a:avLst/>
           </a:prstGeom>
           <a:solidFill>
-            <a:schemeClr val="accent2"/>
+            <a:schemeClr val="tx2"/>
           </a:solidFill>
-          <a:ln/>
         </p:spPr>
       </p:sp>
       <p:sp>
         <p:nvSpPr>
           <p:cNvPr id="113" name="Text 13"/>
           <p:cNvSpPr txBox="1"/>
-          <p:nvPr/>
+          <p:nvPr>
+            <p:custDataLst>
+              <p:tags r:id="rId13"/>
+            </p:custDataLst>
+          </p:nvPr>
         </p:nvSpPr>
         <p:spPr>
           <a:xfrm>
@@ -6286,13 +5281,12 @@
             <a:avLst/>
           </a:prstGeom>
           <a:noFill/>
-          <a:ln/>
         </p:spPr>
         <p:txBody>
           <a:bodyPr wrap="square" lIns="0" tIns="0" rIns="0" bIns="0" rtlCol="0" anchor="ctr"/>
           <a:lstStyle/>
           <a:p>
-            <a:pPr algn="ctr" indent="0" marL="0">
+            <a:pPr marL="0" indent="0" algn="ctr">
               <a:buNone/>
             </a:pPr>
             <a:r>
@@ -6311,7 +5305,11 @@
         <p:nvSpPr>
           <p:cNvPr id="114" name="Text 14"/>
           <p:cNvSpPr txBox="1"/>
-          <p:nvPr/>
+          <p:nvPr>
+            <p:custDataLst>
+              <p:tags r:id="rId14"/>
+            </p:custDataLst>
+          </p:nvPr>
         </p:nvSpPr>
         <p:spPr>
           <a:xfrm>
@@ -6322,13 +5320,12 @@
             <a:avLst/>
           </a:prstGeom>
           <a:noFill/>
-          <a:ln/>
         </p:spPr>
         <p:txBody>
           <a:bodyPr wrap="square" lIns="0" tIns="0" rIns="0" bIns="0" rtlCol="0" anchor="t"/>
           <a:lstStyle/>
           <a:p>
-            <a:pPr indent="0" marL="0">
+            <a:pPr marL="0" indent="0">
               <a:buNone/>
             </a:pPr>
             <a:r>
@@ -6347,7 +5344,11 @@
         <p:nvSpPr>
           <p:cNvPr id="115" name="Text 15"/>
           <p:cNvSpPr txBox="1"/>
-          <p:nvPr/>
+          <p:nvPr>
+            <p:custDataLst>
+              <p:tags r:id="rId15"/>
+            </p:custDataLst>
+          </p:nvPr>
         </p:nvSpPr>
         <p:spPr>
           <a:xfrm>
@@ -6358,13 +5359,12 @@
             <a:avLst/>
           </a:prstGeom>
           <a:noFill/>
-          <a:ln/>
         </p:spPr>
         <p:txBody>
           <a:bodyPr wrap="square" lIns="0" tIns="0" rIns="0" bIns="0" rtlCol="0" anchor="t"/>
           <a:lstStyle/>
           <a:p>
-            <a:pPr indent="0" marL="0">
+            <a:pPr marL="0" indent="0">
               <a:spcAft>
                 <a:spcPts val="600"/>
               </a:spcAft>
@@ -6381,7 +5381,7 @@
             <a:endParaRPr lang="en-US" sz="1800" dirty="0"/>
           </a:p>
           <a:p>
-            <a:pPr indent="0" marL="0">
+            <a:pPr marL="0" indent="0">
               <a:spcAft>
                 <a:spcPts val="600"/>
               </a:spcAft>
@@ -6398,7 +5398,7 @@
             <a:endParaRPr lang="en-US" sz="1800" dirty="0"/>
           </a:p>
           <a:p>
-            <a:pPr indent="0" marL="0">
+            <a:pPr marL="0" indent="0">
               <a:spcAft>
                 <a:spcPts val="600"/>
               </a:spcAft>
@@ -6415,7 +5415,7 @@
             <a:endParaRPr lang="en-US" sz="1800" dirty="0"/>
           </a:p>
           <a:p>
-            <a:pPr indent="0" marL="0">
+            <a:pPr marL="0" indent="0">
               <a:spcAft>
                 <a:spcPts val="600"/>
               </a:spcAft>
@@ -6429,6 +5429,1276 @@
               </a:rPr>
               <a:t>Lexical prompts shift phases; predicate prompts, endpoints</a:t>
             </a:r>
+            <a:endParaRPr lang="en-US" sz="1800" dirty="0"/>
+          </a:p>
+        </p:txBody>
+      </p:sp>
+    </p:spTree>
+  </p:cSld>
+  <p:clrMapOvr>
+    <a:masterClrMapping/>
+  </p:clrMapOvr>
+</p:sld>
+</file>
+
+<file path=ppt/slides/slide7.xml><?xml version="1.0" encoding="utf-8"?>
+<p:sld xmlns:a="http://schemas.openxmlformats.org/drawingml/2006/main" xmlns:r="http://schemas.openxmlformats.org/officeDocument/2006/relationships" xmlns:p="http://schemas.openxmlformats.org/presentationml/2006/main">
+  <p:cSld>
+    <p:spTree>
+      <p:nvGrpSpPr>
+        <p:cNvPr id="1" name=""/>
+        <p:cNvGrpSpPr/>
+        <p:nvPr/>
+      </p:nvGrpSpPr>
+      <p:grpSpPr>
+        <a:xfrm>
+          <a:off x="0" y="0"/>
+          <a:ext cx="0" cy="0"/>
+          <a:chOff x="0" y="0"/>
+          <a:chExt cx="0" cy="0"/>
+        </a:xfrm>
+      </p:grpSpPr>
+      <p:sp>
+        <p:nvSpPr>
+          <p:cNvPr id="2" name="Text 0"/>
+          <p:cNvSpPr/>
+          <p:nvPr>
+            <p:ph type="title" idx="100" hasCustomPrompt="1"/>
+          </p:nvPr>
+        </p:nvSpPr>
+        <p:spPr>
+          <a:xfrm>
+            <a:off x="548640" y="365760"/>
+            <a:ext cx="11094415" cy="731520"/>
+          </a:xfrm>
+          <a:prstGeom prst="rect">
+            <a:avLst/>
+          </a:prstGeom>
+          <a:noFill/>
+        </p:spPr>
+        <p:txBody>
+          <a:bodyPr wrap="square" lIns="0" tIns="0" rIns="0" bIns="0" rtlCol="0" anchor="ctr"/>
+          <a:lstStyle/>
+          <a:p>
+            <a:pPr marL="0" indent="0" algn="l">
+              <a:buNone/>
+            </a:pPr>
+            <a:r>
+              <a:rPr lang="en-US" sz="3000" b="1" dirty="0">
+                <a:solidFill>
+                  <a:schemeClr val="tx2"/>
+                </a:solidFill>
+              </a:rPr>
+              <a:t>A two-year plan</a:t>
+            </a:r>
+            <a:endParaRPr lang="en-US" sz="3000" dirty="0"/>
+          </a:p>
+        </p:txBody>
+      </p:sp>
+      <p:sp>
+        <p:nvSpPr>
+          <p:cNvPr id="201" name="Shape 1"/>
+          <p:cNvSpPr/>
+          <p:nvPr/>
+        </p:nvSpPr>
+        <p:spPr>
+          <a:xfrm>
+            <a:off x="548640" y="1280160"/>
+            <a:ext cx="3454298" cy="3794760"/>
+          </a:xfrm>
+          <a:prstGeom prst="roundRect">
+            <a:avLst>
+              <a:gd name="adj" fmla="val 2647"/>
+            </a:avLst>
+          </a:prstGeom>
+          <a:solidFill>
+            <a:schemeClr val="bg2"/>
+          </a:solidFill>
+          <a:ln/>
+        </p:spPr>
+      </p:sp>
+      <p:sp>
+        <p:nvSpPr>
+          <p:cNvPr id="202" name="Text 2"/>
+          <p:cNvSpPr txBox="1"/>
+          <p:nvPr/>
+        </p:nvSpPr>
+        <p:spPr>
+          <a:xfrm>
+            <a:off x="777240" y="1463040"/>
+            <a:ext cx="2997098" cy="777240"/>
+          </a:xfrm>
+          <a:prstGeom prst="rect">
+            <a:avLst/>
+          </a:prstGeom>
+          <a:noFill/>
+          <a:ln/>
+        </p:spPr>
+        <p:txBody>
+          <a:bodyPr wrap="square" lIns="0" tIns="0" rIns="0" bIns="0" rtlCol="0" anchor="t"/>
+          <a:lstStyle/>
+          <a:p>
+            <a:pPr indent="0" marL="0">
+              <a:buNone/>
+            </a:pPr>
+            <a:r>
+              <a:rPr lang="en-US" sz="2200" b="1" dirty="0">
+                <a:solidFill>
+                  <a:schemeClr val="tx2"/>
+                </a:solidFill>
+              </a:rPr>
+              <a:t>Year 1</a:t>
+            </a:r>
+            <a:endParaRPr lang="en-US" sz="1800" dirty="0"/>
+          </a:p>
+          <a:p>
+            <a:pPr indent="0" marL="0">
+              <a:buNone/>
+            </a:pPr>
+            <a:r>
+              <a:rPr lang="en-US" sz="1800" i="1" dirty="0">
+                <a:solidFill>
+                  <a:schemeClr val="accent3"/>
+                </a:solidFill>
+              </a:rPr>
+              <a:t>Build and validate</a:t>
+            </a:r>
+            <a:endParaRPr lang="en-US" sz="1800" dirty="0"/>
+          </a:p>
+        </p:txBody>
+      </p:sp>
+      <p:sp>
+        <p:nvSpPr>
+          <p:cNvPr id="203" name="Text 3"/>
+          <p:cNvSpPr txBox="1"/>
+          <p:nvPr/>
+        </p:nvSpPr>
+        <p:spPr>
+          <a:xfrm>
+            <a:off x="777240" y="2331720"/>
+            <a:ext cx="2997098" cy="1965960"/>
+          </a:xfrm>
+          <a:prstGeom prst="rect">
+            <a:avLst/>
+          </a:prstGeom>
+          <a:noFill/>
+          <a:ln/>
+        </p:spPr>
+        <p:txBody>
+          <a:bodyPr wrap="square" lIns="0" tIns="0" rIns="0" bIns="0" rtlCol="0" anchor="t"/>
+          <a:lstStyle/>
+          <a:p>
+            <a:pPr marL="342900" indent="-342900">
+              <a:spcAft>
+                <a:spcPts val="800"/>
+              </a:spcAft>
+              <a:buSzPct val="100000"/>
+              <a:buChar char="•"/>
+            </a:pPr>
+            <a:r>
+              <a:rPr lang="en-US" sz="1800" dirty="0">
+                <a:solidFill>
+                  <a:schemeClr val="tx1"/>
+                </a:solidFill>
+              </a:rPr>
+              <a:t>Film and norm new event pairs</a:t>
+            </a:r>
+            <a:endParaRPr lang="en-US" sz="1800" dirty="0"/>
+          </a:p>
+          <a:p>
+            <a:pPr marL="342900" indent="-342900">
+              <a:spcAft>
+                <a:spcPts val="800"/>
+              </a:spcAft>
+              <a:buSzPct val="100000"/>
+              <a:buChar char="•"/>
+            </a:pPr>
+            <a:r>
+              <a:rPr lang="en-US" sz="1800" dirty="0">
+                <a:solidFill>
+                  <a:schemeClr val="tx1"/>
+                </a:solidFill>
+              </a:rPr>
+              <a:t>Adults: replicate both levels</a:t>
+            </a:r>
+            <a:endParaRPr lang="en-US" sz="1800" dirty="0"/>
+          </a:p>
+          <a:p>
+            <a:pPr marL="342900" indent="-342900">
+              <a:spcAft>
+                <a:spcPts val="800"/>
+              </a:spcAft>
+              <a:buSzPct val="100000"/>
+              <a:buChar char="•"/>
+            </a:pPr>
+            <a:r>
+              <a:rPr lang="en-US" sz="1800" dirty="0">
+                <a:solidFill>
+                  <a:schemeClr val="tx1"/>
+                </a:solidFill>
+              </a:rPr>
+              <a:t>Direction 3: model study</a:t>
+            </a:r>
+            <a:endParaRPr lang="en-US" sz="1800" dirty="0"/>
+          </a:p>
+          <a:p>
+            <a:pPr marL="342900" indent="-342900">
+              <a:spcAft>
+                <a:spcPts val="800"/>
+              </a:spcAft>
+              <a:buSzPct val="100000"/>
+              <a:buChar char="•"/>
+            </a:pPr>
+            <a:r>
+              <a:rPr lang="en-US" sz="1800" dirty="0">
+                <a:solidFill>
+                  <a:schemeClr val="tx1"/>
+                </a:solidFill>
+              </a:rPr>
+              <a:t>Pilot child tasks; ethics</a:t>
+            </a:r>
+            <a:endParaRPr lang="en-US" sz="1800" dirty="0"/>
+          </a:p>
+        </p:txBody>
+      </p:sp>
+      <p:sp>
+        <p:nvSpPr>
+          <p:cNvPr id="204" name="Text 4"/>
+          <p:cNvSpPr txBox="1"/>
+          <p:nvPr/>
+        </p:nvSpPr>
+        <p:spPr>
+          <a:xfrm>
+            <a:off x="777240" y="4343400"/>
+            <a:ext cx="2997098" cy="548640"/>
+          </a:xfrm>
+          <a:prstGeom prst="rect">
+            <a:avLst/>
+          </a:prstGeom>
+          <a:noFill/>
+          <a:ln/>
+        </p:spPr>
+        <p:txBody>
+          <a:bodyPr wrap="square" lIns="0" tIns="0" rIns="0" bIns="0" rtlCol="0" anchor="ctr"/>
+          <a:lstStyle/>
+          <a:p>
+            <a:pPr indent="0" marL="0">
+              <a:buNone/>
+            </a:pPr>
+            <a:r>
+              <a:rPr lang="en-US" sz="1800" b="1" dirty="0">
+                <a:solidFill>
+                  <a:schemeClr val="accent2"/>
+                </a:solidFill>
+              </a:rPr>
+              <a:t>Output: adult paper, CogSci paper</a:t>
+            </a:r>
+            <a:endParaRPr lang="en-US" sz="1800" dirty="0"/>
+          </a:p>
+        </p:txBody>
+      </p:sp>
+      <p:sp>
+        <p:nvSpPr>
+          <p:cNvPr id="205" name="Shape 5"/>
+          <p:cNvSpPr/>
+          <p:nvPr/>
+        </p:nvSpPr>
+        <p:spPr>
+          <a:xfrm>
+            <a:off x="4368698" y="1280160"/>
+            <a:ext cx="3454298" cy="3794760"/>
+          </a:xfrm>
+          <a:prstGeom prst="roundRect">
+            <a:avLst>
+              <a:gd name="adj" fmla="val 2647"/>
+            </a:avLst>
+          </a:prstGeom>
+          <a:solidFill>
+            <a:schemeClr val="bg2"/>
+          </a:solidFill>
+          <a:ln/>
+        </p:spPr>
+      </p:sp>
+      <p:sp>
+        <p:nvSpPr>
+          <p:cNvPr id="206" name="Text 6"/>
+          <p:cNvSpPr txBox="1"/>
+          <p:nvPr/>
+        </p:nvSpPr>
+        <p:spPr>
+          <a:xfrm>
+            <a:off x="4597298" y="1463040"/>
+            <a:ext cx="2997098" cy="777240"/>
+          </a:xfrm>
+          <a:prstGeom prst="rect">
+            <a:avLst/>
+          </a:prstGeom>
+          <a:noFill/>
+          <a:ln/>
+        </p:spPr>
+        <p:txBody>
+          <a:bodyPr wrap="square" lIns="0" tIns="0" rIns="0" bIns="0" rtlCol="0" anchor="t"/>
+          <a:lstStyle/>
+          <a:p>
+            <a:pPr indent="0" marL="0">
+              <a:buNone/>
+            </a:pPr>
+            <a:r>
+              <a:rPr lang="en-US" sz="2200" b="1" dirty="0">
+                <a:solidFill>
+                  <a:schemeClr val="tx2"/>
+                </a:solidFill>
+              </a:rPr>
+              <a:t>Year 2</a:t>
+            </a:r>
+            <a:endParaRPr lang="en-US" sz="1800" dirty="0"/>
+          </a:p>
+          <a:p>
+            <a:pPr indent="0" marL="0">
+              <a:buNone/>
+            </a:pPr>
+            <a:r>
+              <a:rPr lang="en-US" sz="1800" i="1" dirty="0">
+                <a:solidFill>
+                  <a:schemeClr val="accent3"/>
+                </a:solidFill>
+              </a:rPr>
+              <a:t>Test children</a:t>
+            </a:r>
+            <a:endParaRPr lang="en-US" sz="1800" dirty="0"/>
+          </a:p>
+        </p:txBody>
+      </p:sp>
+      <p:sp>
+        <p:nvSpPr>
+          <p:cNvPr id="207" name="Text 7"/>
+          <p:cNvSpPr txBox="1"/>
+          <p:nvPr/>
+        </p:nvSpPr>
+        <p:spPr>
+          <a:xfrm>
+            <a:off x="4597298" y="2331720"/>
+            <a:ext cx="2997098" cy="1965960"/>
+          </a:xfrm>
+          <a:prstGeom prst="rect">
+            <a:avLst/>
+          </a:prstGeom>
+          <a:noFill/>
+          <a:ln/>
+        </p:spPr>
+        <p:txBody>
+          <a:bodyPr wrap="square" lIns="0" tIns="0" rIns="0" bIns="0" rtlCol="0" anchor="t"/>
+          <a:lstStyle/>
+          <a:p>
+            <a:pPr marL="342900" indent="-342900">
+              <a:spcAft>
+                <a:spcPts val="800"/>
+              </a:spcAft>
+              <a:buSzPct val="100000"/>
+              <a:buChar char="•"/>
+            </a:pPr>
+            <a:r>
+              <a:rPr lang="en-US" sz="1800" dirty="0">
+                <a:solidFill>
+                  <a:schemeClr val="tx1"/>
+                </a:solidFill>
+              </a:rPr>
+              <a:t>Direction 1: children 3–6</a:t>
+            </a:r>
+            <a:endParaRPr lang="en-US" sz="1800" dirty="0"/>
+          </a:p>
+          <a:p>
+            <a:pPr marL="342900" indent="-342900">
+              <a:spcAft>
+                <a:spcPts val="800"/>
+              </a:spcAft>
+              <a:buSzPct val="100000"/>
+              <a:buChar char="•"/>
+            </a:pPr>
+            <a:r>
+              <a:rPr lang="en-US" sz="1800" dirty="0">
+                <a:solidFill>
+                  <a:schemeClr val="tx1"/>
+                </a:solidFill>
+              </a:rPr>
+              <a:t>English sample with partners</a:t>
+            </a:r>
+            <a:endParaRPr lang="en-US" sz="1800" dirty="0"/>
+          </a:p>
+          <a:p>
+            <a:pPr marL="342900" indent="-342900">
+              <a:spcAft>
+                <a:spcPts val="800"/>
+              </a:spcAft>
+              <a:buSzPct val="100000"/>
+              <a:buChar char="•"/>
+            </a:pPr>
+            <a:r>
+              <a:rPr lang="en-US" sz="1800" dirty="0">
+                <a:solidFill>
+                  <a:schemeClr val="tx1"/>
+                </a:solidFill>
+              </a:rPr>
+              <a:t>Direction 2: training study</a:t>
+            </a:r>
+            <a:endParaRPr lang="en-US" sz="1800" dirty="0"/>
+          </a:p>
+          <a:p>
+            <a:pPr marL="342900" indent="-342900">
+              <a:spcAft>
+                <a:spcPts val="800"/>
+              </a:spcAft>
+              <a:buSzPct val="100000"/>
+              <a:buChar char="•"/>
+            </a:pPr>
+            <a:r>
+              <a:rPr lang="en-US" sz="1800" dirty="0">
+                <a:solidFill>
+                  <a:schemeClr val="tx1"/>
+                </a:solidFill>
+              </a:rPr>
+              <a:t>6-month follow-up</a:t>
+            </a:r>
+            <a:endParaRPr lang="en-US" sz="1800" dirty="0"/>
+          </a:p>
+        </p:txBody>
+      </p:sp>
+      <p:sp>
+        <p:nvSpPr>
+          <p:cNvPr id="208" name="Text 8"/>
+          <p:cNvSpPr txBox="1"/>
+          <p:nvPr/>
+        </p:nvSpPr>
+        <p:spPr>
+          <a:xfrm>
+            <a:off x="4597298" y="4343400"/>
+            <a:ext cx="2997098" cy="548640"/>
+          </a:xfrm>
+          <a:prstGeom prst="rect">
+            <a:avLst/>
+          </a:prstGeom>
+          <a:noFill/>
+          <a:ln/>
+        </p:spPr>
+        <p:txBody>
+          <a:bodyPr wrap="square" lIns="0" tIns="0" rIns="0" bIns="0" rtlCol="0" anchor="ctr"/>
+          <a:lstStyle/>
+          <a:p>
+            <a:pPr indent="0" marL="0">
+              <a:buNone/>
+            </a:pPr>
+            <a:r>
+              <a:rPr lang="en-US" sz="1800" b="1" dirty="0">
+                <a:solidFill>
+                  <a:schemeClr val="accent2"/>
+                </a:solidFill>
+              </a:rPr>
+              <a:t>Output: two child papers</a:t>
+            </a:r>
+            <a:endParaRPr lang="en-US" sz="1800" dirty="0"/>
+          </a:p>
+        </p:txBody>
+      </p:sp>
+      <p:sp>
+        <p:nvSpPr>
+          <p:cNvPr id="209" name="Shape 9"/>
+          <p:cNvSpPr/>
+          <p:nvPr/>
+        </p:nvSpPr>
+        <p:spPr>
+          <a:xfrm>
+            <a:off x="8188757" y="1280160"/>
+            <a:ext cx="3454298" cy="3794760"/>
+          </a:xfrm>
+          <a:prstGeom prst="roundRect">
+            <a:avLst>
+              <a:gd name="adj" fmla="val 2647"/>
+            </a:avLst>
+          </a:prstGeom>
+          <a:solidFill>
+            <a:schemeClr val="bg2"/>
+          </a:solidFill>
+          <a:ln/>
+        </p:spPr>
+      </p:sp>
+      <p:sp>
+        <p:nvSpPr>
+          <p:cNvPr id="210" name="Text 10"/>
+          <p:cNvSpPr txBox="1"/>
+          <p:nvPr/>
+        </p:nvSpPr>
+        <p:spPr>
+          <a:xfrm>
+            <a:off x="8417357" y="1463040"/>
+            <a:ext cx="2997098" cy="777240"/>
+          </a:xfrm>
+          <a:prstGeom prst="rect">
+            <a:avLst/>
+          </a:prstGeom>
+          <a:noFill/>
+          <a:ln/>
+        </p:spPr>
+        <p:txBody>
+          <a:bodyPr wrap="square" lIns="0" tIns="0" rIns="0" bIns="0" rtlCol="0" anchor="t"/>
+          <a:lstStyle/>
+          <a:p>
+            <a:pPr indent="0" marL="0">
+              <a:buNone/>
+            </a:pPr>
+            <a:r>
+              <a:rPr lang="en-US" sz="2200" b="1" dirty="0">
+                <a:solidFill>
+                  <a:schemeClr val="accent2"/>
+                </a:solidFill>
+              </a:rPr>
+              <a:t>Throughout</a:t>
+            </a:r>
+            <a:endParaRPr lang="en-US" sz="1800" dirty="0"/>
+          </a:p>
+          <a:p>
+            <a:pPr indent="0" marL="0">
+              <a:buNone/>
+            </a:pPr>
+            <a:r>
+              <a:rPr lang="en-US" sz="1800" i="1" dirty="0">
+                <a:solidFill>
+                  <a:schemeClr val="accent3"/>
+                </a:solidFill>
+              </a:rPr>
+              <a:t>Publish and fund</a:t>
+            </a:r>
+            <a:endParaRPr lang="en-US" sz="1800" dirty="0"/>
+          </a:p>
+        </p:txBody>
+      </p:sp>
+      <p:sp>
+        <p:nvSpPr>
+          <p:cNvPr id="211" name="Text 11"/>
+          <p:cNvSpPr txBox="1"/>
+          <p:nvPr/>
+        </p:nvSpPr>
+        <p:spPr>
+          <a:xfrm>
+            <a:off x="8417357" y="2331720"/>
+            <a:ext cx="2997098" cy="1965960"/>
+          </a:xfrm>
+          <a:prstGeom prst="rect">
+            <a:avLst/>
+          </a:prstGeom>
+          <a:noFill/>
+          <a:ln/>
+        </p:spPr>
+        <p:txBody>
+          <a:bodyPr wrap="square" lIns="0" tIns="0" rIns="0" bIns="0" rtlCol="0" anchor="t"/>
+          <a:lstStyle/>
+          <a:p>
+            <a:pPr marL="342900" indent="-342900">
+              <a:spcAft>
+                <a:spcPts val="800"/>
+              </a:spcAft>
+              <a:buSzPct val="100000"/>
+              <a:buChar char="•"/>
+            </a:pPr>
+            <a:r>
+              <a:rPr lang="en-US" sz="1800" dirty="0">
+                <a:solidFill>
+                  <a:schemeClr val="tx1"/>
+                </a:solidFill>
+              </a:rPr>
+              <a:t>Thesis and child papers</a:t>
+            </a:r>
+            <a:endParaRPr lang="en-US" sz="1800" dirty="0"/>
+          </a:p>
+          <a:p>
+            <a:pPr marL="342900" indent="-342900">
+              <a:spcAft>
+                <a:spcPts val="800"/>
+              </a:spcAft>
+              <a:buSzPct val="100000"/>
+              <a:buChar char="•"/>
+            </a:pPr>
+            <a:r>
+              <a:rPr lang="en-US" sz="1800" dirty="0">
+                <a:solidFill>
+                  <a:schemeClr val="tx1"/>
+                </a:solidFill>
+              </a:rPr>
+              <a:t>China Postdoctoral Science Foundation</a:t>
+            </a:r>
+            <a:endParaRPr lang="en-US" sz="1800" dirty="0"/>
+          </a:p>
+          <a:p>
+            <a:pPr marL="342900" indent="-342900">
+              <a:spcAft>
+                <a:spcPts val="800"/>
+              </a:spcAft>
+              <a:buSzPct val="100000"/>
+              <a:buChar char="•"/>
+            </a:pPr>
+            <a:r>
+              <a:rPr lang="en-US" sz="1800" dirty="0">
+                <a:solidFill>
+                  <a:schemeClr val="tx1"/>
+                </a:solidFill>
+              </a:rPr>
+              <a:t>NSFC Young Scientists Fund</a:t>
+            </a:r>
+            <a:endParaRPr lang="en-US" sz="1800" dirty="0"/>
+          </a:p>
+          <a:p>
+            <a:pPr marL="342900" indent="-342900">
+              <a:spcAft>
+                <a:spcPts val="800"/>
+              </a:spcAft>
+              <a:buSzPct val="100000"/>
+              <a:buChar char="•"/>
+            </a:pPr>
+            <a:r>
+              <a:rPr lang="en-US" sz="1800" dirty="0">
+                <a:solidFill>
+                  <a:schemeClr val="tx1"/>
+                </a:solidFill>
+              </a:rPr>
+              <a:t>Mentor students; open data</a:t>
+            </a:r>
+            <a:endParaRPr lang="en-US" sz="1800" dirty="0"/>
+          </a:p>
+        </p:txBody>
+      </p:sp>
+      <p:sp>
+        <p:nvSpPr>
+          <p:cNvPr id="212" name="Text 12"/>
+          <p:cNvSpPr txBox="1"/>
+          <p:nvPr/>
+        </p:nvSpPr>
+        <p:spPr>
+          <a:xfrm>
+            <a:off x="8417357" y="4343400"/>
+            <a:ext cx="2997098" cy="548640"/>
+          </a:xfrm>
+          <a:prstGeom prst="rect">
+            <a:avLst/>
+          </a:prstGeom>
+          <a:noFill/>
+          <a:ln/>
+        </p:spPr>
+        <p:txBody>
+          <a:bodyPr wrap="square" lIns="0" tIns="0" rIns="0" bIns="0" rtlCol="0" anchor="ctr"/>
+          <a:lstStyle/>
+          <a:p>
+            <a:pPr indent="0" marL="0">
+              <a:buNone/>
+            </a:pPr>
+            <a:r>
+              <a:rPr lang="en-US" sz="1800" b="1" dirty="0">
+                <a:solidFill>
+                  <a:schemeClr val="accent2"/>
+                </a:solidFill>
+              </a:rPr>
+              <a:t>Output: two grant applications</a:t>
+            </a:r>
+            <a:endParaRPr lang="en-US" sz="1800" dirty="0"/>
+          </a:p>
+        </p:txBody>
+      </p:sp>
+      <p:sp>
+        <p:nvSpPr>
+          <p:cNvPr id="213" name="Shape 13"/>
+          <p:cNvSpPr/>
+          <p:nvPr/>
+        </p:nvSpPr>
+        <p:spPr>
+          <a:xfrm>
+            <a:off x="548640" y="5349240"/>
+            <a:ext cx="11094415" cy="685800"/>
+          </a:xfrm>
+          <a:prstGeom prst="roundRect">
+            <a:avLst>
+              <a:gd name="adj" fmla="val 10667"/>
+            </a:avLst>
+          </a:prstGeom>
+          <a:solidFill>
+            <a:schemeClr val="bg2"/>
+          </a:solidFill>
+          <a:ln/>
+        </p:spPr>
+      </p:sp>
+      <p:sp>
+        <p:nvSpPr>
+          <p:cNvPr id="214" name="Text 14"/>
+          <p:cNvSpPr txBox="1"/>
+          <p:nvPr/>
+        </p:nvSpPr>
+        <p:spPr>
+          <a:xfrm>
+            <a:off x="777240" y="5349240"/>
+            <a:ext cx="10637215" cy="685800"/>
+          </a:xfrm>
+          <a:prstGeom prst="rect">
+            <a:avLst/>
+          </a:prstGeom>
+          <a:noFill/>
+          <a:ln/>
+        </p:spPr>
+        <p:txBody>
+          <a:bodyPr wrap="square" lIns="0" tIns="0" rIns="0" bIns="0" rtlCol="0" anchor="ctr"/>
+          <a:lstStyle/>
+          <a:p>
+            <a:pPr indent="0" marL="0">
+              <a:buNone/>
+            </a:pPr>
+            <a:r>
+              <a:rPr lang="en-US" sz="1800" b="1" dirty="0">
+                <a:solidFill>
+                  <a:schemeClr val="accent2"/>
+                </a:solidFill>
+              </a:rPr>
+              <a:t>Takeaway   </a:t>
+            </a:r>
+            <a:pPr indent="0" marL="0">
+              <a:buNone/>
+            </a:pPr>
+            <a:r>
+              <a:rPr lang="en-US" sz="1800" dirty="0">
+                <a:solidFill>
+                  <a:schemeClr val="tx1"/>
+                </a:solidFill>
+              </a:rPr>
+              <a:t>Year 1 builds validated materials and models; Year 2 tests children with them.</a:t>
+            </a:r>
+            <a:endParaRPr lang="en-US" sz="1800" dirty="0"/>
+          </a:p>
+        </p:txBody>
+      </p:sp>
+    </p:spTree>
+  </p:cSld>
+  <p:clrMapOvr>
+    <a:masterClrMapping/>
+  </p:clrMapOvr>
+</p:sld>
+</file>
+
+<file path=ppt/slides/slide8.xml><?xml version="1.0" encoding="utf-8"?>
+<p:sld xmlns:a="http://schemas.openxmlformats.org/drawingml/2006/main" xmlns:r="http://schemas.openxmlformats.org/officeDocument/2006/relationships" xmlns:p="http://schemas.openxmlformats.org/presentationml/2006/main">
+  <p:cSld>
+    <p:spTree>
+      <p:nvGrpSpPr>
+        <p:cNvPr id="1" name=""/>
+        <p:cNvGrpSpPr/>
+        <p:nvPr/>
+      </p:nvGrpSpPr>
+      <p:grpSpPr>
+        <a:xfrm>
+          <a:off x="0" y="0"/>
+          <a:ext cx="0" cy="0"/>
+          <a:chOff x="0" y="0"/>
+          <a:chExt cx="0" cy="0"/>
+        </a:xfrm>
+      </p:grpSpPr>
+      <p:sp>
+        <p:nvSpPr>
+          <p:cNvPr id="8" name="Text 0"/>
+          <p:cNvSpPr/>
+          <p:nvPr>
+            <p:ph type="title" idx="100" hasCustomPrompt="1"/>
+          </p:nvPr>
+        </p:nvSpPr>
+        <p:spPr>
+          <a:xfrm>
+            <a:off x="548640" y="1737360"/>
+            <a:ext cx="11094415" cy="1188720"/>
+          </a:xfrm>
+          <a:prstGeom prst="rect">
+            <a:avLst/>
+          </a:prstGeom>
+          <a:noFill/>
+        </p:spPr>
+        <p:txBody>
+          <a:bodyPr wrap="square" lIns="0" tIns="0" rIns="0" bIns="0" rtlCol="0" anchor="b"/>
+          <a:lstStyle/>
+          <a:p>
+            <a:pPr marL="0" indent="0" algn="l">
+              <a:buNone/>
+            </a:pPr>
+            <a:endParaRPr lang="en-US" sz="3600" dirty="0"/>
+          </a:p>
+        </p:txBody>
+      </p:sp>
+      <p:sp>
+        <p:nvSpPr>
+          <p:cNvPr id="201" name="Text 0"/>
+          <p:cNvSpPr txBox="1"/>
+          <p:nvPr/>
+        </p:nvSpPr>
+        <p:spPr>
+          <a:xfrm>
+            <a:off x="548640" y="457200"/>
+            <a:ext cx="11094415" cy="731520"/>
+          </a:xfrm>
+          <a:prstGeom prst="rect">
+            <a:avLst/>
+          </a:prstGeom>
+          <a:noFill/>
+          <a:ln/>
+        </p:spPr>
+        <p:txBody>
+          <a:bodyPr wrap="square" lIns="0" tIns="0" rIns="0" bIns="0" rtlCol="0" anchor="ctr"/>
+          <a:lstStyle/>
+          <a:p>
+            <a:pPr indent="0" marL="0">
+              <a:buNone/>
+            </a:pPr>
+            <a:r>
+              <a:rPr lang="en-US" sz="3000" b="1" dirty="0">
+                <a:solidFill>
+                  <a:schemeClr val="bg1"/>
+                </a:solidFill>
+              </a:rPr>
+              <a:t>What I would bring</a:t>
+            </a:r>
+            <a:endParaRPr lang="en-US" sz="3000" dirty="0"/>
+          </a:p>
+        </p:txBody>
+      </p:sp>
+      <p:sp>
+        <p:nvSpPr>
+          <p:cNvPr id="202" name="Text 1"/>
+          <p:cNvSpPr txBox="1"/>
+          <p:nvPr/>
+        </p:nvSpPr>
+        <p:spPr>
+          <a:xfrm>
+            <a:off x="548640" y="1371600"/>
+            <a:ext cx="3423818" cy="3383280"/>
+          </a:xfrm>
+          <a:prstGeom prst="rect">
+            <a:avLst/>
+          </a:prstGeom>
+          <a:noFill/>
+          <a:ln/>
+        </p:spPr>
+        <p:txBody>
+          <a:bodyPr wrap="square" lIns="0" tIns="0" rIns="0" bIns="0" rtlCol="0" anchor="t"/>
+          <a:lstStyle/>
+          <a:p>
+            <a:pPr indent="0" marL="0">
+              <a:spcAft>
+                <a:spcPts val="800"/>
+              </a:spcAft>
+              <a:buNone/>
+            </a:pPr>
+            <a:r>
+              <a:rPr lang="en-US" sz="2200" b="1" dirty="0">
+                <a:solidFill>
+                  <a:schemeClr val="accent4"/>
+                </a:solidFill>
+              </a:rPr>
+              <a:t>Research skills</a:t>
+            </a:r>
+            <a:endParaRPr lang="en-US" sz="1800" dirty="0"/>
+          </a:p>
+          <a:p>
+            <a:pPr marL="342900" indent="-342900">
+              <a:spcAft>
+                <a:spcPts val="800"/>
+              </a:spcAft>
+              <a:buSzPct val="100000"/>
+              <a:buChar char="•"/>
+            </a:pPr>
+            <a:r>
+              <a:rPr lang="en-US" sz="1800" dirty="0">
+                <a:solidFill>
+                  <a:schemeClr val="bg1"/>
+                </a:solidFill>
+              </a:rPr>
+              <a:t>Event videos and online tasks</a:t>
+            </a:r>
+            <a:endParaRPr lang="en-US" sz="1800" dirty="0"/>
+          </a:p>
+          <a:p>
+            <a:pPr marL="342900" indent="-342900">
+              <a:spcAft>
+                <a:spcPts val="800"/>
+              </a:spcAft>
+              <a:buSzPct val="100000"/>
+              <a:buChar char="•"/>
+            </a:pPr>
+            <a:r>
+              <a:rPr lang="en-US" sz="1800" dirty="0">
+                <a:solidFill>
+                  <a:schemeClr val="bg1"/>
+                </a:solidFill>
+              </a:rPr>
+              <a:t>Child testing in kindergartens</a:t>
+            </a:r>
+            <a:endParaRPr lang="en-US" sz="1800" dirty="0"/>
+          </a:p>
+          <a:p>
+            <a:pPr marL="342900" indent="-342900">
+              <a:spcAft>
+                <a:spcPts val="800"/>
+              </a:spcAft>
+              <a:buSzPct val="100000"/>
+              <a:buChar char="•"/>
+            </a:pPr>
+            <a:r>
+              <a:rPr lang="en-US" sz="1800" dirty="0">
+                <a:solidFill>
+                  <a:schemeClr val="bg1"/>
+                </a:solidFill>
+              </a:rPr>
+              <a:t>Corpus analysis (CHILDES)</a:t>
+            </a:r>
+            <a:endParaRPr lang="en-US" sz="1800" dirty="0"/>
+          </a:p>
+          <a:p>
+            <a:pPr marL="342900" indent="-342900">
+              <a:spcAft>
+                <a:spcPts val="800"/>
+              </a:spcAft>
+              <a:buSzPct val="100000"/>
+              <a:buChar char="•"/>
+            </a:pPr>
+            <a:r>
+              <a:rPr lang="en-US" sz="1800" dirty="0">
+                <a:solidFill>
+                  <a:schemeClr val="bg1"/>
+                </a:solidFill>
+              </a:rPr>
+              <a:t>Bayesian GLMMs, SEM, R, Python</a:t>
+            </a:r>
+            <a:endParaRPr lang="en-US" sz="1800" dirty="0"/>
+          </a:p>
+        </p:txBody>
+      </p:sp>
+      <p:sp>
+        <p:nvSpPr>
+          <p:cNvPr id="203" name="Text 2"/>
+          <p:cNvSpPr txBox="1"/>
+          <p:nvPr/>
+        </p:nvSpPr>
+        <p:spPr>
+          <a:xfrm>
+            <a:off x="4383938" y="1371600"/>
+            <a:ext cx="3423818" cy="3383280"/>
+          </a:xfrm>
+          <a:prstGeom prst="rect">
+            <a:avLst/>
+          </a:prstGeom>
+          <a:noFill/>
+          <a:ln/>
+        </p:spPr>
+        <p:txBody>
+          <a:bodyPr wrap="square" lIns="0" tIns="0" rIns="0" bIns="0" rtlCol="0" anchor="t"/>
+          <a:lstStyle/>
+          <a:p>
+            <a:pPr indent="0" marL="0">
+              <a:spcAft>
+                <a:spcPts val="800"/>
+              </a:spcAft>
+              <a:buNone/>
+            </a:pPr>
+            <a:r>
+              <a:rPr lang="en-US" sz="2200" b="1" dirty="0">
+                <a:solidFill>
+                  <a:schemeClr val="accent4"/>
+                </a:solidFill>
+              </a:rPr>
+              <a:t>Track record</a:t>
+            </a:r>
+            <a:endParaRPr lang="en-US" sz="1800" dirty="0"/>
+          </a:p>
+          <a:p>
+            <a:pPr marL="342900" indent="-342900">
+              <a:spcAft>
+                <a:spcPts val="800"/>
+              </a:spcAft>
+              <a:buSzPct val="100000"/>
+              <a:buChar char="•"/>
+            </a:pPr>
+            <a:r>
+              <a:rPr lang="en-US" sz="1800" dirty="0">
+                <a:solidFill>
+                  <a:schemeClr val="bg1"/>
+                </a:solidFill>
+              </a:rPr>
+              <a:t>Sole-authored paper, Language and Cognition</a:t>
+            </a:r>
+            <a:endParaRPr lang="en-US" sz="1800" dirty="0"/>
+          </a:p>
+          <a:p>
+            <a:pPr marL="342900" indent="-342900">
+              <a:spcAft>
+                <a:spcPts val="800"/>
+              </a:spcAft>
+              <a:buSzPct val="100000"/>
+              <a:buChar char="•"/>
+            </a:pPr>
+            <a:r>
+              <a:rPr lang="en-US" sz="1800" dirty="0">
+                <a:solidFill>
+                  <a:schemeClr val="bg1"/>
+                </a:solidFill>
+              </a:rPr>
+              <a:t>CogSci 2026; HSP 2026 at MIT</a:t>
+            </a:r>
+            <a:endParaRPr lang="en-US" sz="1800" dirty="0"/>
+          </a:p>
+          <a:p>
+            <a:pPr marL="342900" indent="-342900">
+              <a:spcAft>
+                <a:spcPts val="800"/>
+              </a:spcAft>
+              <a:buSzPct val="100000"/>
+              <a:buChar char="•"/>
+            </a:pPr>
+            <a:r>
+              <a:rPr lang="en-US" sz="1800" dirty="0">
+                <a:solidFill>
+                  <a:schemeClr val="bg1"/>
+                </a:solidFill>
+              </a:rPr>
+              <a:t>CSC and Auckland funding</a:t>
+            </a:r>
+            <a:endParaRPr lang="en-US" sz="1800" dirty="0"/>
+          </a:p>
+          <a:p>
+            <a:pPr marL="342900" indent="-342900">
+              <a:spcAft>
+                <a:spcPts val="800"/>
+              </a:spcAft>
+              <a:buSzPct val="100000"/>
+              <a:buChar char="•"/>
+            </a:pPr>
+            <a:r>
+              <a:rPr lang="en-US" sz="1800" dirty="0">
+                <a:solidFill>
+                  <a:schemeClr val="bg1"/>
+                </a:solidFill>
+              </a:rPr>
+              <a:t>Reviewer for CogSci and JMMD</a:t>
+            </a:r>
+            <a:endParaRPr lang="en-US" sz="1800" dirty="0"/>
+          </a:p>
+        </p:txBody>
+      </p:sp>
+      <p:sp>
+        <p:nvSpPr>
+          <p:cNvPr id="204" name="Text 3"/>
+          <p:cNvSpPr txBox="1"/>
+          <p:nvPr/>
+        </p:nvSpPr>
+        <p:spPr>
+          <a:xfrm>
+            <a:off x="8219237" y="1371600"/>
+            <a:ext cx="3423818" cy="3383280"/>
+          </a:xfrm>
+          <a:prstGeom prst="rect">
+            <a:avLst/>
+          </a:prstGeom>
+          <a:noFill/>
+          <a:ln/>
+        </p:spPr>
+        <p:txBody>
+          <a:bodyPr wrap="square" lIns="0" tIns="0" rIns="0" bIns="0" rtlCol="0" anchor="t"/>
+          <a:lstStyle/>
+          <a:p>
+            <a:pPr indent="0" marL="0">
+              <a:spcAft>
+                <a:spcPts val="800"/>
+              </a:spcAft>
+              <a:buNone/>
+            </a:pPr>
+            <a:r>
+              <a:rPr lang="en-US" sz="2200" b="1" dirty="0">
+                <a:solidFill>
+                  <a:schemeClr val="accent4"/>
+                </a:solidFill>
+              </a:rPr>
+              <a:t>Teamwork</a:t>
+            </a:r>
+            <a:endParaRPr lang="en-US" sz="1800" dirty="0"/>
+          </a:p>
+          <a:p>
+            <a:pPr marL="342900" indent="-342900">
+              <a:spcAft>
+                <a:spcPts val="800"/>
+              </a:spcAft>
+              <a:buSzPct val="100000"/>
+              <a:buChar char="•"/>
+            </a:pPr>
+            <a:r>
+              <a:rPr lang="en-US" sz="1800" dirty="0">
+                <a:solidFill>
+                  <a:schemeClr val="bg1"/>
+                </a:solidFill>
+              </a:rPr>
+              <a:t>Led a CAS project on migrant families</a:t>
+            </a:r>
+            <a:endParaRPr lang="en-US" sz="1800" dirty="0"/>
+          </a:p>
+          <a:p>
+            <a:pPr marL="342900" indent="-342900">
+              <a:spcAft>
+                <a:spcPts val="800"/>
+              </a:spcAft>
+              <a:buSzPct val="100000"/>
+              <a:buChar char="•"/>
+            </a:pPr>
+            <a:r>
+              <a:rPr lang="en-US" sz="1800" dirty="0">
+                <a:solidFill>
+                  <a:schemeClr val="bg1"/>
+                </a:solidFill>
+              </a:rPr>
+              <a:t>TA in experimental methods</a:t>
+            </a:r>
+            <a:endParaRPr lang="en-US" sz="1800" dirty="0"/>
+          </a:p>
+          <a:p>
+            <a:pPr marL="342900" indent="-342900">
+              <a:spcAft>
+                <a:spcPts val="800"/>
+              </a:spcAft>
+              <a:buSzPct val="100000"/>
+              <a:buChar char="•"/>
+            </a:pPr>
+            <a:r>
+              <a:rPr lang="en-US" sz="1800" dirty="0">
+                <a:solidFill>
+                  <a:schemeClr val="bg1"/>
+                </a:solidFill>
+              </a:rPr>
+              <a:t>Mandarin, Xiang, English</a:t>
+            </a:r>
+            <a:endParaRPr lang="en-US" sz="1800" dirty="0"/>
+          </a:p>
+          <a:p>
+            <a:pPr marL="342900" indent="-342900">
+              <a:spcAft>
+                <a:spcPts val="800"/>
+              </a:spcAft>
+              <a:buSzPct val="100000"/>
+              <a:buChar char="•"/>
+            </a:pPr>
+            <a:r>
+              <a:rPr lang="en-US" sz="1800" dirty="0">
+                <a:solidFill>
+                  <a:schemeClr val="bg1"/>
+                </a:solidFill>
+              </a:rPr>
+              <a:t>Kindergarten links in Hunan</a:t>
+            </a:r>
+            <a:endParaRPr lang="en-US" sz="1800" dirty="0"/>
+          </a:p>
+        </p:txBody>
+      </p:sp>
+      <p:sp>
+        <p:nvSpPr>
+          <p:cNvPr id="205" name="Text 4"/>
+          <p:cNvSpPr txBox="1"/>
+          <p:nvPr/>
+        </p:nvSpPr>
+        <p:spPr>
+          <a:xfrm>
+            <a:off x="548640" y="4663440"/>
+            <a:ext cx="11094415" cy="1280160"/>
+          </a:xfrm>
+          <a:prstGeom prst="rect">
+            <a:avLst/>
+          </a:prstGeom>
+          <a:noFill/>
+          <a:ln/>
+        </p:spPr>
+        <p:txBody>
+          <a:bodyPr wrap="square" lIns="0" tIns="0" rIns="0" bIns="0" rtlCol="0" anchor="t"/>
+          <a:lstStyle/>
+          <a:p>
+            <a:pPr indent="0" marL="0">
+              <a:buNone/>
+            </a:pPr>
+            <a:r>
+              <a:rPr lang="en-US" sz="3600" b="1" dirty="0">
+                <a:solidFill>
+                  <a:schemeClr val="bg1"/>
+                </a:solidFill>
+              </a:rPr>
+              <a:t>Thank you</a:t>
+            </a:r>
+            <a:endParaRPr lang="en-US" sz="1800" dirty="0"/>
+          </a:p>
+          <a:p>
+            <a:pPr indent="0" marL="0">
+              <a:buNone/>
+            </a:pPr>
+            <a:r>
+              <a:rPr lang="en-US" sz="1800" dirty="0">
+                <a:solidFill>
+                  <a:schemeClr val="accent5"/>
+                </a:solidFill>
+              </a:rPr>
+              <a:t>xtliu0516@yeah.net  ·  xiaotaoliu.owlstown.net</a:t>
+            </a:r>
+            <a:endParaRPr lang="en-US" sz="1800" dirty="0"/>
+          </a:p>
+        </p:txBody>
+      </p:sp>
+      <p:sp>
+        <p:nvSpPr>
+          <p:cNvPr id="206" name="Text 0"/>
+          <p:cNvSpPr/>
+          <p:nvPr>
+            <p:ph idx="101" type="body" hasCustomPrompt="1"/>
+          </p:nvPr>
+        </p:nvSpPr>
+        <p:spPr>
+          <a:xfrm>
+            <a:off x="548640" y="3108960"/>
+            <a:ext cx="11094415" cy="822960"/>
+          </a:xfrm>
+          <a:prstGeom prst="rect">
+            <a:avLst/>
+          </a:prstGeom>
+          <a:noFill/>
+          <a:ln/>
+        </p:spPr>
+        <p:txBody>
+          <a:bodyPr wrap="square" lIns="0" tIns="0" rIns="0" bIns="0" rtlCol="0" anchor="t"/>
+          <a:lstStyle/>
+          <a:p>
+            <a:pPr algn="l" indent="0" marL="0">
+              <a:buNone/>
+            </a:pPr>
+            <a:endParaRPr lang="en-US" sz="2200" dirty="0"/>
+          </a:p>
+        </p:txBody>
+      </p:sp>
+      <p:sp>
+        <p:nvSpPr>
+          <p:cNvPr id="207" name="Text 0"/>
+          <p:cNvSpPr/>
+          <p:nvPr>
+            <p:ph idx="102" type="body" hasCustomPrompt="1"/>
+          </p:nvPr>
+        </p:nvSpPr>
+        <p:spPr>
+          <a:xfrm>
+            <a:off x="548640" y="4663440"/>
+            <a:ext cx="11094415" cy="1371600"/>
+          </a:xfrm>
+          <a:prstGeom prst="rect">
+            <a:avLst/>
+          </a:prstGeom>
+          <a:noFill/>
+          <a:ln/>
+        </p:spPr>
+        <p:txBody>
+          <a:bodyPr wrap="square" lIns="0" tIns="0" rIns="0" bIns="0" rtlCol="0" anchor="t"/>
+          <a:lstStyle/>
+          <a:p>
+            <a:pPr algn="l" indent="0" marL="0">
+              <a:buNone/>
+            </a:pPr>
             <a:endParaRPr lang="en-US" sz="1800" dirty="0"/>
           </a:p>
         </p:txBody>
@@ -6447,15 +6717,177 @@
 </p:tagLst>
 </file>
 
+<file path=ppt/tags/tag10.xml><?xml version="1.0" encoding="utf-8"?>
+<p:tagLst xmlns:p="http://schemas.openxmlformats.org/presentationml/2006/main">
+  <p:tag name="KSO_WM_DIAGRAM_VIRTUALLY_FRAME" val="{&quot;height&quot;:378,&quot;left&quot;:43.2,&quot;top&quot;:97.2,&quot;width&quot;:873.5759842519685}"/>
+</p:tagLst>
+</file>
+
+<file path=ppt/tags/tag11.xml><?xml version="1.0" encoding="utf-8"?>
+<p:tagLst xmlns:p="http://schemas.openxmlformats.org/presentationml/2006/main">
+  <p:tag name="KSO_WM_DIAGRAM_VIRTUALLY_FRAME" val="{&quot;height&quot;:378,&quot;left&quot;:43.2,&quot;top&quot;:97.2,&quot;width&quot;:873.5759842519685}"/>
+</p:tagLst>
+</file>
+
+<file path=ppt/tags/tag12.xml><?xml version="1.0" encoding="utf-8"?>
+<p:tagLst xmlns:p="http://schemas.openxmlformats.org/presentationml/2006/main">
+  <p:tag name="KSO_WM_DIAGRAM_VIRTUALLY_FRAME" val="{&quot;height&quot;:378,&quot;left&quot;:43.2,&quot;top&quot;:97.2,&quot;width&quot;:873.5759842519685}"/>
+</p:tagLst>
+</file>
+
+<file path=ppt/tags/tag13.xml><?xml version="1.0" encoding="utf-8"?>
+<p:tagLst xmlns:p="http://schemas.openxmlformats.org/presentationml/2006/main">
+  <p:tag name="KSO_WM_DIAGRAM_VIRTUALLY_FRAME" val="{&quot;height&quot;:378,&quot;left&quot;:43.2,&quot;top&quot;:97.2,&quot;width&quot;:873.5759842519685}"/>
+</p:tagLst>
+</file>
+
+<file path=ppt/tags/tag14.xml><?xml version="1.0" encoding="utf-8"?>
+<p:tagLst xmlns:p="http://schemas.openxmlformats.org/presentationml/2006/main">
+  <p:tag name="KSO_WM_DIAGRAM_VIRTUALLY_FRAME" val="{&quot;height&quot;:378,&quot;left&quot;:43.2,&quot;top&quot;:97.2,&quot;width&quot;:873.5759842519685}"/>
+</p:tagLst>
+</file>
+
+<file path=ppt/tags/tag15.xml><?xml version="1.0" encoding="utf-8"?>
+<p:tagLst xmlns:p="http://schemas.openxmlformats.org/presentationml/2006/main">
+  <p:tag name="KSO_WM_DIAGRAM_VIRTUALLY_FRAME" val="{&quot;height&quot;:378,&quot;left&quot;:43.2,&quot;top&quot;:97.2,&quot;width&quot;:873.5759842519685}"/>
+</p:tagLst>
+</file>
+
+<file path=ppt/tags/tag16.xml><?xml version="1.0" encoding="utf-8"?>
+<p:tagLst xmlns:p="http://schemas.openxmlformats.org/presentationml/2006/main">
+  <p:tag name="KSO_WM_DIAGRAM_VIRTUALLY_FRAME" val="{&quot;height&quot;:378,&quot;left&quot;:43.2,&quot;top&quot;:97.2,&quot;width&quot;:873.5759842519685}"/>
+</p:tagLst>
+</file>
+
+<file path=ppt/tags/tag17.xml><?xml version="1.0" encoding="utf-8"?>
+<p:tagLst xmlns:p="http://schemas.openxmlformats.org/presentationml/2006/main">
+  <p:tag name="KSO_WM_DIAGRAM_VIRTUALLY_FRAME" val="{&quot;height&quot;:378,&quot;left&quot;:43.2,&quot;top&quot;:97.2,&quot;width&quot;:873.5759842519685}"/>
+</p:tagLst>
+</file>
+
+<file path=ppt/tags/tag18.xml><?xml version="1.0" encoding="utf-8"?>
+<p:tagLst xmlns:p="http://schemas.openxmlformats.org/presentationml/2006/main">
+  <p:tag name="KSO_WM_DIAGRAM_VIRTUALLY_FRAME" val="{&quot;height&quot;:378,&quot;left&quot;:43.2,&quot;top&quot;:97.2,&quot;width&quot;:873.5759842519685}"/>
+</p:tagLst>
+</file>
+
+<file path=ppt/tags/tag19.xml><?xml version="1.0" encoding="utf-8"?>
+<p:tagLst xmlns:p="http://schemas.openxmlformats.org/presentationml/2006/main">
+  <p:tag name="KSO_WM_DIAGRAM_VIRTUALLY_FRAME" val="{&quot;height&quot;:378,&quot;left&quot;:43.2,&quot;top&quot;:97.2,&quot;width&quot;:873.5759842519685}"/>
+</p:tagLst>
+</file>
+
 <file path=ppt/tags/tag2.xml><?xml version="1.0" encoding="utf-8"?>
 <p:tagLst xmlns:p="http://schemas.openxmlformats.org/presentationml/2006/main">
   <p:tag name="KSO_WM_DIAGRAM_VIRTUALLY_FRAME" val="{&quot;height&quot;:324,&quot;left&quot;:518.4,&quot;top&quot;:115.2,&quot;width&quot;:398.3759842519685}"/>
 </p:tagLst>
 </file>
 
+<file path=ppt/tags/tag20.xml><?xml version="1.0" encoding="utf-8"?>
+<p:tagLst xmlns:p="http://schemas.openxmlformats.org/presentationml/2006/main">
+  <p:tag name="KSO_WM_DIAGRAM_VIRTUALLY_FRAME" val="{&quot;height&quot;:378,&quot;left&quot;:43.2,&quot;top&quot;:97.2,&quot;width&quot;:873.5759842519685}"/>
+</p:tagLst>
+</file>
+
+<file path=ppt/tags/tag21.xml><?xml version="1.0" encoding="utf-8"?>
+<p:tagLst xmlns:p="http://schemas.openxmlformats.org/presentationml/2006/main">
+  <p:tag name="KSO_WM_DIAGRAM_VIRTUALLY_FRAME" val="{&quot;height&quot;:378,&quot;left&quot;:43.2,&quot;top&quot;:97.2,&quot;width&quot;:873.5759842519685}"/>
+</p:tagLst>
+</file>
+
+<file path=ppt/tags/tag22.xml><?xml version="1.0" encoding="utf-8"?>
+<p:tagLst xmlns:p="http://schemas.openxmlformats.org/presentationml/2006/main">
+  <p:tag name="KSO_WM_DIAGRAM_VIRTUALLY_FRAME" val="{&quot;height&quot;:378,&quot;left&quot;:43.2,&quot;top&quot;:97.2,&quot;width&quot;:873.5759842519685}"/>
+</p:tagLst>
+</file>
+
+<file path=ppt/tags/tag23.xml><?xml version="1.0" encoding="utf-8"?>
+<p:tagLst xmlns:p="http://schemas.openxmlformats.org/presentationml/2006/main">
+  <p:tag name="KSO_WM_DIAGRAM_VIRTUALLY_FRAME" val="{&quot;height&quot;:378,&quot;left&quot;:43.2,&quot;top&quot;:97.2,&quot;width&quot;:873.5759842519685}"/>
+</p:tagLst>
+</file>
+
+<file path=ppt/tags/tag24.xml><?xml version="1.0" encoding="utf-8"?>
+<p:tagLst xmlns:p="http://schemas.openxmlformats.org/presentationml/2006/main">
+  <p:tag name="KSO_WM_DIAGRAM_VIRTUALLY_FRAME" val="{&quot;height&quot;:378,&quot;left&quot;:43.2,&quot;top&quot;:97.2,&quot;width&quot;:873.5759842519685}"/>
+</p:tagLst>
+</file>
+
+<file path=ppt/tags/tag25.xml><?xml version="1.0" encoding="utf-8"?>
+<p:tagLst xmlns:p="http://schemas.openxmlformats.org/presentationml/2006/main">
+  <p:tag name="KSO_WM_DIAGRAM_VIRTUALLY_FRAME" val="{&quot;height&quot;:244.8,&quot;left&quot;:43.2,&quot;top&quot;:115.2,&quot;width&quot;:873.5759842519685}"/>
+</p:tagLst>
+</file>
+
+<file path=ppt/tags/tag26.xml><?xml version="1.0" encoding="utf-8"?>
+<p:tagLst xmlns:p="http://schemas.openxmlformats.org/presentationml/2006/main">
+  <p:tag name="KSO_WM_DIAGRAM_VIRTUALLY_FRAME" val="{&quot;height&quot;:244.8,&quot;left&quot;:43.2,&quot;top&quot;:115.2,&quot;width&quot;:873.5759842519685}"/>
+</p:tagLst>
+</file>
+
+<file path=ppt/tags/tag27.xml><?xml version="1.0" encoding="utf-8"?>
+<p:tagLst xmlns:p="http://schemas.openxmlformats.org/presentationml/2006/main">
+  <p:tag name="KSO_WM_DIAGRAM_VIRTUALLY_FRAME" val="{&quot;height&quot;:244.8,&quot;left&quot;:43.2,&quot;top&quot;:115.2,&quot;width&quot;:873.5759842519685}"/>
+</p:tagLst>
+</file>
+
+<file path=ppt/tags/tag28.xml><?xml version="1.0" encoding="utf-8"?>
+<p:tagLst xmlns:p="http://schemas.openxmlformats.org/presentationml/2006/main">
+  <p:tag name="KSO_WM_DIAGRAM_VIRTUALLY_FRAME" val="{&quot;height&quot;:244.8,&quot;left&quot;:43.2,&quot;top&quot;:115.2,&quot;width&quot;:873.5759842519685}"/>
+</p:tagLst>
+</file>
+
+<file path=ppt/tags/tag29.xml><?xml version="1.0" encoding="utf-8"?>
+<p:tagLst xmlns:p="http://schemas.openxmlformats.org/presentationml/2006/main">
+  <p:tag name="KSO_WM_DIAGRAM_VIRTUALLY_FRAME" val="{&quot;height&quot;:244.8,&quot;left&quot;:43.2,&quot;top&quot;:115.2,&quot;width&quot;:873.5759842519685}"/>
+</p:tagLst>
+</file>
+
 <file path=ppt/tags/tag3.xml><?xml version="1.0" encoding="utf-8"?>
 <p:tagLst xmlns:p="http://schemas.openxmlformats.org/presentationml/2006/main">
   <p:tag name="KSO_WM_DIAGRAM_VIRTUALLY_FRAME" val="{&quot;height&quot;:324,&quot;left&quot;:518.4,&quot;top&quot;:115.2,&quot;width&quot;:398.3759842519685}"/>
+</p:tagLst>
+</file>
+
+<file path=ppt/tags/tag30.xml><?xml version="1.0" encoding="utf-8"?>
+<p:tagLst xmlns:p="http://schemas.openxmlformats.org/presentationml/2006/main">
+  <p:tag name="KSO_WM_DIAGRAM_VIRTUALLY_FRAME" val="{&quot;height&quot;:244.8,&quot;left&quot;:43.2,&quot;top&quot;:115.2,&quot;width&quot;:873.5759842519685}"/>
+</p:tagLst>
+</file>
+
+<file path=ppt/tags/tag31.xml><?xml version="1.0" encoding="utf-8"?>
+<p:tagLst xmlns:p="http://schemas.openxmlformats.org/presentationml/2006/main">
+  <p:tag name="KSO_WM_DIAGRAM_VIRTUALLY_FRAME" val="{&quot;height&quot;:244.8,&quot;left&quot;:43.2,&quot;top&quot;:115.2,&quot;width&quot;:873.5759842519685}"/>
+</p:tagLst>
+</file>
+
+<file path=ppt/tags/tag32.xml><?xml version="1.0" encoding="utf-8"?>
+<p:tagLst xmlns:p="http://schemas.openxmlformats.org/presentationml/2006/main">
+  <p:tag name="KSO_WM_DIAGRAM_VIRTUALLY_FRAME" val="{&quot;height&quot;:244.8,&quot;left&quot;:43.2,&quot;top&quot;:115.2,&quot;width&quot;:873.5759842519685}"/>
+</p:tagLst>
+</file>
+
+<file path=ppt/tags/tag33.xml><?xml version="1.0" encoding="utf-8"?>
+<p:tagLst xmlns:p="http://schemas.openxmlformats.org/presentationml/2006/main">
+  <p:tag name="KSO_WM_DIAGRAM_VIRTUALLY_FRAME" val="{&quot;height&quot;:244.8,&quot;left&quot;:43.2,&quot;top&quot;:115.2,&quot;width&quot;:873.5759842519685}"/>
+</p:tagLst>
+</file>
+
+<file path=ppt/tags/tag34.xml><?xml version="1.0" encoding="utf-8"?>
+<p:tagLst xmlns:p="http://schemas.openxmlformats.org/presentationml/2006/main">
+  <p:tag name="KSO_WM_DIAGRAM_VIRTUALLY_FRAME" val="{&quot;height&quot;:244.8,&quot;left&quot;:43.2,&quot;top&quot;:115.2,&quot;width&quot;:873.5759842519685}"/>
+</p:tagLst>
+</file>
+
+<file path=ppt/tags/tag35.xml><?xml version="1.0" encoding="utf-8"?>
+<p:tagLst xmlns:p="http://schemas.openxmlformats.org/presentationml/2006/main">
+  <p:tag name="KSO_WM_DIAGRAM_VIRTUALLY_FRAME" val="{&quot;height&quot;:244.8,&quot;left&quot;:43.2,&quot;top&quot;:115.2,&quot;width&quot;:873.5759842519685}"/>
+</p:tagLst>
+</file>
+
+<file path=ppt/tags/tag36.xml><?xml version="1.0" encoding="utf-8"?>
+<p:tagLst xmlns:p="http://schemas.openxmlformats.org/presentationml/2006/main">
+  <p:tag name="KSO_WM_DIAGRAM_VIRTUALLY_FRAME" val="{&quot;height&quot;:244.8,&quot;left&quot;:43.2,&quot;top&quot;:115.2,&quot;width&quot;:873.5759842519685}"/>
 </p:tagLst>
 </file>
 

</xml_diff>